<commit_message>
Embed real ECG photo on slide 14
Replace the generated ECG graphic with the patient's actual 12-lead ECG
photo (cropped and contrast-enhanced) on the ECG investigation slide;
redesign the slide as photo-left / diagnosis + parameters-right to suit
the photo's 4:3 aspect. Updates standalone and combined decks.

Co-Authored-By: Claude Opus 4.8 <noreply@anthropic.com>
Claude-Session: https://claude.ai/code/session_01S7QW8AwqyMReKwuqyBkBBv
</commit_message>
<xml_diff>
--- a/presentations/Clinicopathological-Conference-COMPLETE.pptx
+++ b/presentations/Clinicopathological-Conference-COMPLETE.pptx
@@ -8065,177 +8065,12 @@
         </p:nvSpPr>
         <p:spPr>
           <a:xfrm>
-            <a:off x="502920" y="1600200"/>
-            <a:ext cx="11183112" cy="896112"/>
+            <a:off x="502920" y="1737360"/>
+            <a:ext cx="5669280" cy="4279392"/>
           </a:xfrm>
           <a:prstGeom prst="roundRect">
             <a:avLst>
-              <a:gd name="adj" fmla="val 12245"/>
-            </a:avLst>
-          </a:prstGeom>
-          <a:solidFill>
-            <a:srgbClr val="590D22"/>
-          </a:solidFill>
-          <a:ln/>
-          <a:effectLst>
-            <a:outerShdw sx="100000" sy="100000" kx="0" ky="0" algn="bl" rotWithShape="0" blurRad="127000" dist="50800" dir="5400000">
-              <a:srgbClr val="C9A3AC">
-                <a:alpha val="45000"/>
-              </a:srgbClr>
-            </a:outerShdw>
-          </a:effectLst>
-        </p:spPr>
-      </p:sp>
-      <p:sp>
-        <p:nvSpPr>
-          <p:cNvPr id="7" name="Shape 4"/>
-          <p:cNvSpPr/>
-          <p:nvPr/>
-        </p:nvSpPr>
-        <p:spPr>
-          <a:xfrm>
-            <a:off x="749808" y="1801368"/>
-            <a:ext cx="512064" cy="512064"/>
-          </a:xfrm>
-          <a:prstGeom prst="ellipse">
-            <a:avLst/>
-          </a:prstGeom>
-          <a:solidFill>
-            <a:srgbClr val="A4133C"/>
-          </a:solidFill>
-          <a:ln/>
-        </p:spPr>
-      </p:sp>
-      <p:pic>
-        <p:nvPicPr>
-          <p:cNvPr id="8" name="Image 1" descr="preencoded.png">    </p:cNvPr>
-          <p:cNvPicPr>
-            <a:picLocks noChangeAspect="1"/>
-          </p:cNvPicPr>
-          <p:nvPr/>
-        </p:nvPicPr>
-        <p:blipFill>
-          <a:blip r:embed="rId2"/>
-          <a:stretch>
-            <a:fillRect/>
-          </a:stretch>
-        </p:blipFill>
-        <p:spPr>
-          <a:xfrm>
-            <a:off x="877824" y="1929384"/>
-            <a:ext cx="256032" cy="256032"/>
-          </a:xfrm>
-          <a:prstGeom prst="rect">
-            <a:avLst/>
-          </a:prstGeom>
-        </p:spPr>
-      </p:pic>
-      <p:sp>
-        <p:nvSpPr>
-          <p:cNvPr id="9" name="Text 5"/>
-          <p:cNvSpPr/>
-          <p:nvPr/>
-        </p:nvSpPr>
-        <p:spPr>
-          <a:xfrm>
-            <a:off x="1463040" y="1600200"/>
-            <a:ext cx="7498080" cy="896112"/>
-          </a:xfrm>
-          <a:prstGeom prst="rect">
-            <a:avLst/>
-          </a:prstGeom>
-          <a:noFill/>
-          <a:ln/>
-        </p:spPr>
-        <p:txBody>
-          <a:bodyPr wrap="square" lIns="0" tIns="0" rIns="0" bIns="0" rtlCol="0" anchor="ctr"/>
-          <a:lstStyle/>
-          <a:p>
-            <a:pPr algn="l" indent="0" marL="0">
-              <a:buNone/>
-            </a:pPr>
-            <a:r>
-              <a:rPr lang="en-US" sz="2200" b="1" dirty="0">
-                <a:solidFill>
-                  <a:srgbClr val="FFFFFF"/>
-                </a:solidFill>
-                <a:latin typeface="Cambria" pitchFamily="34" charset="0"/>
-                <a:ea typeface="Cambria" pitchFamily="34" charset="-122"/>
-                <a:cs typeface="Cambria" pitchFamily="34" charset="-120"/>
-              </a:rPr>
-              <a:t>Atrial Fibrillation with Rapid Ventricular Response</a:t>
-            </a:r>
-            <a:endParaRPr lang="en-US" sz="2200" dirty="0"/>
-          </a:p>
-        </p:txBody>
-      </p:sp>
-      <p:sp>
-        <p:nvSpPr>
-          <p:cNvPr id="10" name="Text 6"/>
-          <p:cNvSpPr/>
-          <p:nvPr/>
-        </p:nvSpPr>
-        <p:spPr>
-          <a:xfrm>
-            <a:off x="8869680" y="1600200"/>
-            <a:ext cx="2697480" cy="896112"/>
-          </a:xfrm>
-          <a:prstGeom prst="rect">
-            <a:avLst/>
-          </a:prstGeom>
-          <a:noFill/>
-          <a:ln/>
-        </p:spPr>
-        <p:txBody>
-          <a:bodyPr wrap="square" lIns="0" tIns="0" rIns="0" bIns="0" rtlCol="0" anchor="ctr"/>
-          <a:lstStyle/>
-          <a:p>
-            <a:pPr algn="r" indent="0" marL="0">
-              <a:buNone/>
-            </a:pPr>
-            <a:r>
-              <a:rPr lang="en-US" sz="1250" dirty="0">
-                <a:solidFill>
-                  <a:srgbClr val="FBD8DF"/>
-                </a:solidFill>
-                <a:latin typeface="Calibri" pitchFamily="34" charset="0"/>
-                <a:ea typeface="Calibri" pitchFamily="34" charset="-122"/>
-                <a:cs typeface="Calibri" pitchFamily="34" charset="-120"/>
-              </a:rPr>
-              <a:t>Abnormal rhythm ECG · </a:t>
-            </a:r>
-            <a:pPr algn="r" indent="0" marL="0">
-              <a:buNone/>
-            </a:pPr>
-            <a:r>
-              <a:rPr lang="en-US" sz="1250" b="1" dirty="0">
-                <a:solidFill>
-                  <a:srgbClr val="FF4D6D"/>
-                </a:solidFill>
-                <a:latin typeface="Calibri" pitchFamily="34" charset="0"/>
-                <a:ea typeface="Calibri" pitchFamily="34" charset="-122"/>
-                <a:cs typeface="Calibri" pitchFamily="34" charset="-120"/>
-              </a:rPr>
-              <a:t>06-Jul-2026</a:t>
-            </a:r>
-            <a:endParaRPr lang="en-US" sz="1250" dirty="0"/>
-          </a:p>
-        </p:txBody>
-      </p:sp>
-      <p:sp>
-        <p:nvSpPr>
-          <p:cNvPr id="11" name="Shape 7"/>
-          <p:cNvSpPr/>
-          <p:nvPr/>
-        </p:nvSpPr>
-        <p:spPr>
-          <a:xfrm>
-            <a:off x="502920" y="2651760"/>
-            <a:ext cx="7973568" cy="3355848"/>
-          </a:xfrm>
-          <a:prstGeom prst="roundRect">
-            <a:avLst>
-              <a:gd name="adj" fmla="val 3270"/>
+              <a:gd name="adj" fmla="val 2564"/>
             </a:avLst>
           </a:prstGeom>
           <a:solidFill>
@@ -8258,7 +8093,80 @@
       </p:sp>
       <p:pic>
         <p:nvPicPr>
-          <p:cNvPr id="12" name="Image 2" descr="preencoded.png">    </p:cNvPr>
+          <p:cNvPr id="7" name="Image 1" descr="preencoded.png">    </p:cNvPr>
+          <p:cNvPicPr>
+            <a:picLocks noChangeAspect="1"/>
+          </p:cNvPicPr>
+          <p:nvPr/>
+        </p:nvPicPr>
+        <p:blipFill>
+          <a:blip r:embed="rId2"/>
+          <a:stretch>
+            <a:fillRect/>
+          </a:stretch>
+        </p:blipFill>
+        <p:spPr>
+          <a:xfrm>
+            <a:off x="612648" y="1819656"/>
+            <a:ext cx="5458968" cy="4114800"/>
+          </a:xfrm>
+          <a:prstGeom prst="rect">
+            <a:avLst/>
+          </a:prstGeom>
+        </p:spPr>
+      </p:pic>
+      <p:sp>
+        <p:nvSpPr>
+          <p:cNvPr id="8" name="Shape 4"/>
+          <p:cNvSpPr/>
+          <p:nvPr/>
+        </p:nvSpPr>
+        <p:spPr>
+          <a:xfrm>
+            <a:off x="6355080" y="1737360"/>
+            <a:ext cx="5349240" cy="1481328"/>
+          </a:xfrm>
+          <a:prstGeom prst="roundRect">
+            <a:avLst>
+              <a:gd name="adj" fmla="val 7407"/>
+            </a:avLst>
+          </a:prstGeom>
+          <a:solidFill>
+            <a:srgbClr val="590D22"/>
+          </a:solidFill>
+          <a:ln/>
+          <a:effectLst>
+            <a:outerShdw sx="100000" sy="100000" kx="0" ky="0" algn="bl" rotWithShape="0" blurRad="127000" dist="50800" dir="5400000">
+              <a:srgbClr val="C9A3AC">
+                <a:alpha val="45000"/>
+              </a:srgbClr>
+            </a:outerShdw>
+          </a:effectLst>
+        </p:spPr>
+      </p:sp>
+      <p:sp>
+        <p:nvSpPr>
+          <p:cNvPr id="9" name="Shape 5"/>
+          <p:cNvSpPr/>
+          <p:nvPr/>
+        </p:nvSpPr>
+        <p:spPr>
+          <a:xfrm>
+            <a:off x="6611112" y="1956816"/>
+            <a:ext cx="548640" cy="548640"/>
+          </a:xfrm>
+          <a:prstGeom prst="ellipse">
+            <a:avLst/>
+          </a:prstGeom>
+          <a:solidFill>
+            <a:srgbClr val="A4133C"/>
+          </a:solidFill>
+          <a:ln/>
+        </p:spPr>
+      </p:sp>
+      <p:pic>
+        <p:nvPicPr>
+          <p:cNvPr id="10" name="Image 2" descr="preencoded.png">    </p:cNvPr>
           <p:cNvPicPr>
             <a:picLocks noChangeAspect="1"/>
           </p:cNvPicPr>
@@ -8272,8 +8180,8 @@
         </p:blipFill>
         <p:spPr>
           <a:xfrm>
-            <a:off x="621792" y="2724912"/>
-            <a:ext cx="7735824" cy="3227832"/>
+            <a:off x="6748272" y="2093976"/>
+            <a:ext cx="274320" cy="274320"/>
           </a:xfrm>
           <a:prstGeom prst="rect">
             <a:avLst/>
@@ -8282,18 +8190,113 @@
       </p:pic>
       <p:sp>
         <p:nvSpPr>
+          <p:cNvPr id="11" name="Text 6"/>
+          <p:cNvSpPr/>
+          <p:nvPr/>
+        </p:nvSpPr>
+        <p:spPr>
+          <a:xfrm>
+            <a:off x="7287768" y="1828800"/>
+            <a:ext cx="4251960" cy="960120"/>
+          </a:xfrm>
+          <a:prstGeom prst="rect">
+            <a:avLst/>
+          </a:prstGeom>
+          <a:noFill/>
+          <a:ln/>
+        </p:spPr>
+        <p:txBody>
+          <a:bodyPr wrap="square" lIns="0" tIns="0" rIns="0" bIns="0" rtlCol="0" anchor="t"/>
+          <a:lstStyle/>
+          <a:p>
+            <a:pPr algn="l" indent="0" marL="0">
+              <a:lnSpc>
+                <a:spcPct val="100000"/>
+              </a:lnSpc>
+              <a:buNone/>
+            </a:pPr>
+            <a:r>
+              <a:rPr lang="en-US" sz="1900" b="1" dirty="0">
+                <a:solidFill>
+                  <a:srgbClr val="FFFFFF"/>
+                </a:solidFill>
+                <a:latin typeface="Cambria" pitchFamily="34" charset="0"/>
+                <a:ea typeface="Cambria" pitchFamily="34" charset="-122"/>
+                <a:cs typeface="Cambria" pitchFamily="34" charset="-120"/>
+              </a:rPr>
+              <a:t>Atrial Fibrillation with Rapid Ventricular Response</a:t>
+            </a:r>
+            <a:endParaRPr lang="en-US" sz="1900" dirty="0"/>
+          </a:p>
+        </p:txBody>
+      </p:sp>
+      <p:sp>
+        <p:nvSpPr>
+          <p:cNvPr id="12" name="Text 7"/>
+          <p:cNvSpPr/>
+          <p:nvPr/>
+        </p:nvSpPr>
+        <p:spPr>
+          <a:xfrm>
+            <a:off x="7287768" y="2798064"/>
+            <a:ext cx="4206240" cy="310896"/>
+          </a:xfrm>
+          <a:prstGeom prst="rect">
+            <a:avLst/>
+          </a:prstGeom>
+          <a:noFill/>
+          <a:ln/>
+        </p:spPr>
+        <p:txBody>
+          <a:bodyPr wrap="square" lIns="0" tIns="0" rIns="0" bIns="0" rtlCol="0" anchor="t"/>
+          <a:lstStyle/>
+          <a:p>
+            <a:pPr algn="l" indent="0" marL="0">
+              <a:buNone/>
+            </a:pPr>
+            <a:r>
+              <a:rPr lang="en-US" sz="1250" dirty="0">
+                <a:solidFill>
+                  <a:srgbClr val="FBD8DF"/>
+                </a:solidFill>
+                <a:latin typeface="Calibri" pitchFamily="34" charset="0"/>
+                <a:ea typeface="Calibri" pitchFamily="34" charset="-122"/>
+                <a:cs typeface="Calibri" pitchFamily="34" charset="-120"/>
+              </a:rPr>
+              <a:t>Abnormal rhythm ECG · </a:t>
+            </a:r>
+            <a:pPr algn="l" indent="0" marL="0">
+              <a:buNone/>
+            </a:pPr>
+            <a:r>
+              <a:rPr lang="en-US" sz="1250" b="1" dirty="0">
+                <a:solidFill>
+                  <a:srgbClr val="FF4D6D"/>
+                </a:solidFill>
+                <a:latin typeface="Calibri" pitchFamily="34" charset="0"/>
+                <a:ea typeface="Calibri" pitchFamily="34" charset="-122"/>
+                <a:cs typeface="Calibri" pitchFamily="34" charset="-120"/>
+              </a:rPr>
+              <a:t>06-Jul-2026</a:t>
+            </a:r>
+            <a:endParaRPr lang="en-US" sz="1250" dirty="0"/>
+          </a:p>
+        </p:txBody>
+      </p:sp>
+      <p:sp>
+        <p:nvSpPr>
           <p:cNvPr id="13" name="Shape 8"/>
           <p:cNvSpPr/>
           <p:nvPr/>
         </p:nvSpPr>
         <p:spPr>
           <a:xfrm>
-            <a:off x="8613648" y="2651760"/>
-            <a:ext cx="3072384" cy="1078992"/>
+            <a:off x="6355080" y="3364992"/>
+            <a:ext cx="5349240" cy="914400"/>
           </a:xfrm>
           <a:prstGeom prst="roundRect">
             <a:avLst>
-              <a:gd name="adj" fmla="val 10169"/>
+              <a:gd name="adj" fmla="val 12000"/>
             </a:avLst>
           </a:prstGeom>
           <a:solidFill>
@@ -8322,8 +8325,8 @@
         </p:nvSpPr>
         <p:spPr>
           <a:xfrm>
-            <a:off x="8833104" y="2779776"/>
-            <a:ext cx="2194560" cy="256032"/>
+            <a:off x="6611112" y="3493008"/>
+            <a:ext cx="2377440" cy="256032"/>
           </a:xfrm>
           <a:prstGeom prst="rect">
             <a:avLst/>
@@ -8350,12 +8353,65 @@
               <a:t>VENTRICULAR RATE</a:t>
             </a:r>
             <a:endParaRPr lang="en-US" sz="1100" dirty="0"/>
+          </a:p>
+        </p:txBody>
+      </p:sp>
+      <p:sp>
+        <p:nvSpPr>
+          <p:cNvPr id="15" name="Text 10"/>
+          <p:cNvSpPr/>
+          <p:nvPr/>
+        </p:nvSpPr>
+        <p:spPr>
+          <a:xfrm>
+            <a:off x="6611112" y="3767328"/>
+            <a:ext cx="2194560" cy="475488"/>
+          </a:xfrm>
+          <a:prstGeom prst="rect">
+            <a:avLst/>
+          </a:prstGeom>
+          <a:noFill/>
+          <a:ln/>
+        </p:spPr>
+        <p:txBody>
+          <a:bodyPr wrap="square" lIns="0" tIns="0" rIns="0" bIns="0" rtlCol="0" anchor="ctr"/>
+          <a:lstStyle/>
+          <a:p>
+            <a:pPr algn="l" indent="0" marL="0">
+              <a:buNone/>
+            </a:pPr>
+            <a:r>
+              <a:rPr lang="en-US" sz="3400" b="1" dirty="0">
+                <a:solidFill>
+                  <a:srgbClr val="FF4D6D"/>
+                </a:solidFill>
+                <a:latin typeface="Cambria" pitchFamily="34" charset="0"/>
+                <a:ea typeface="Cambria" pitchFamily="34" charset="-122"/>
+                <a:cs typeface="Cambria" pitchFamily="34" charset="-120"/>
+              </a:rPr>
+              <a:t>146</a:t>
+            </a:r>
+            <a:pPr algn="l" indent="0" marL="0">
+              <a:buNone/>
+            </a:pPr>
+            <a:r>
+              <a:rPr lang="en-US" sz="1500" b="1" dirty="0">
+                <a:solidFill>
+                  <a:srgbClr val="6B6B76"/>
+                </a:solidFill>
+                <a:latin typeface="Calibri" pitchFamily="34" charset="0"/>
+                <a:ea typeface="Calibri" pitchFamily="34" charset="-122"/>
+                <a:cs typeface="Calibri" pitchFamily="34" charset="-120"/>
+              </a:rPr>
+              <a:t> bpm</a:t>
+            </a:r>
+            <a:endParaRPr lang="en-US" sz="3400" dirty="0"/>
           </a:p>
         </p:txBody>
       </p:sp>
       <p:pic>
         <p:nvPicPr>
-          <p:cNvPr id="15" name="Image 3" descr="preencoded.png">    </p:cNvPr>
+          <p:cNvPr id="16" name="Image 3" descr="preencoded.png">    </p:cNvPr>
           <p:cNvPicPr>
             <a:picLocks noChangeAspect="1"/>
           </p:cNvPicPr>
@@ -8369,8 +8425,8 @@
         </p:blipFill>
         <p:spPr>
           <a:xfrm>
-            <a:off x="11228832" y="2761488"/>
-            <a:ext cx="274320" cy="274320"/>
+            <a:off x="11201400" y="3493008"/>
+            <a:ext cx="292608" cy="292608"/>
           </a:xfrm>
           <a:prstGeom prst="rect">
             <a:avLst/>
@@ -8379,67 +8435,14 @@
       </p:pic>
       <p:sp>
         <p:nvSpPr>
-          <p:cNvPr id="16" name="Text 10"/>
-          <p:cNvSpPr/>
-          <p:nvPr/>
-        </p:nvSpPr>
-        <p:spPr>
-          <a:xfrm>
-            <a:off x="8833104" y="3072384"/>
-            <a:ext cx="1828800" cy="548640"/>
-          </a:xfrm>
-          <a:prstGeom prst="rect">
-            <a:avLst/>
-          </a:prstGeom>
-          <a:noFill/>
-          <a:ln/>
-        </p:spPr>
-        <p:txBody>
-          <a:bodyPr wrap="square" lIns="0" tIns="0" rIns="0" bIns="0" rtlCol="0" anchor="ctr"/>
-          <a:lstStyle/>
-          <a:p>
-            <a:pPr algn="l" indent="0" marL="0">
-              <a:buNone/>
-            </a:pPr>
-            <a:r>
-              <a:rPr lang="en-US" sz="3600" b="1" dirty="0">
-                <a:solidFill>
-                  <a:srgbClr val="FF4D6D"/>
-                </a:solidFill>
-                <a:latin typeface="Cambria" pitchFamily="34" charset="0"/>
-                <a:ea typeface="Cambria" pitchFamily="34" charset="-122"/>
-                <a:cs typeface="Cambria" pitchFamily="34" charset="-120"/>
-              </a:rPr>
-              <a:t>146</a:t>
-            </a:r>
-            <a:pPr algn="l" indent="0" marL="0">
-              <a:buNone/>
-            </a:pPr>
-            <a:r>
-              <a:rPr lang="en-US" sz="1500" b="1" dirty="0">
-                <a:solidFill>
-                  <a:srgbClr val="6B6B76"/>
-                </a:solidFill>
-                <a:latin typeface="Calibri" pitchFamily="34" charset="0"/>
-                <a:ea typeface="Calibri" pitchFamily="34" charset="-122"/>
-                <a:cs typeface="Calibri" pitchFamily="34" charset="-120"/>
-              </a:rPr>
-              <a:t> bpm</a:t>
-            </a:r>
-            <a:endParaRPr lang="en-US" sz="3600" dirty="0"/>
-          </a:p>
-        </p:txBody>
-      </p:sp>
-      <p:sp>
-        <p:nvSpPr>
           <p:cNvPr id="17" name="Shape 11"/>
           <p:cNvSpPr/>
           <p:nvPr/>
         </p:nvSpPr>
         <p:spPr>
           <a:xfrm>
-            <a:off x="10543032" y="3163824"/>
-            <a:ext cx="960120" cy="402336"/>
+            <a:off x="10424160" y="3785616"/>
+            <a:ext cx="1051560" cy="420624"/>
           </a:xfrm>
           <a:prstGeom prst="roundRect">
             <a:avLst>
@@ -8460,8 +8463,8 @@
         </p:nvSpPr>
         <p:spPr>
           <a:xfrm>
-            <a:off x="10543032" y="3163824"/>
-            <a:ext cx="960120" cy="402336"/>
+            <a:off x="10424160" y="3785616"/>
+            <a:ext cx="1051560" cy="420624"/>
           </a:xfrm>
           <a:prstGeom prst="rect">
             <a:avLst/>
@@ -8477,7 +8480,7 @@
               <a:buNone/>
             </a:pPr>
             <a:r>
-              <a:rPr lang="en-US" sz="1200" b="1" spc="100" kern="0" dirty="0">
+              <a:rPr lang="en-US" sz="1250" b="1" spc="100" kern="0" dirty="0">
                 <a:solidFill>
                   <a:srgbClr val="FFFFFF"/>
                 </a:solidFill>
@@ -8487,7 +8490,7 @@
               </a:rPr>
               <a:t>RAPID</a:t>
             </a:r>
-            <a:endParaRPr lang="en-US" sz="1200" dirty="0"/>
+            <a:endParaRPr lang="en-US" sz="1250" dirty="0"/>
           </a:p>
         </p:txBody>
       </p:sp>
@@ -8499,12 +8502,12 @@
         </p:nvSpPr>
         <p:spPr>
           <a:xfrm>
-            <a:off x="8613648" y="3840480"/>
-            <a:ext cx="3072384" cy="493776"/>
+            <a:off x="6355080" y="4389120"/>
+            <a:ext cx="2615184" cy="749808"/>
           </a:xfrm>
           <a:prstGeom prst="roundRect">
             <a:avLst>
-              <a:gd name="adj" fmla="val 16667"/>
+              <a:gd name="adj" fmla="val 12195"/>
             </a:avLst>
           </a:prstGeom>
           <a:solidFill>
@@ -8526,8 +8529,8 @@
         </p:nvSpPr>
         <p:spPr>
           <a:xfrm>
-            <a:off x="8814816" y="3904488"/>
-            <a:ext cx="2706624" cy="182880"/>
+            <a:off x="6556248" y="4517136"/>
+            <a:ext cx="2249424" cy="219456"/>
           </a:xfrm>
           <a:prstGeom prst="rect">
             <a:avLst/>
@@ -8543,7 +8546,7 @@
               <a:buNone/>
             </a:pPr>
             <a:r>
-              <a:rPr lang="en-US" sz="950" b="1" spc="100" kern="0" dirty="0">
+              <a:rPr lang="en-US" sz="1000" b="1" spc="80" kern="0" dirty="0">
                 <a:solidFill>
                   <a:srgbClr val="A4133C"/>
                 </a:solidFill>
@@ -8553,7 +8556,7 @@
               </a:rPr>
               <a:t>RHYTHM</a:t>
             </a:r>
-            <a:endParaRPr lang="en-US" sz="950" dirty="0"/>
+            <a:endParaRPr lang="en-US" sz="1000" dirty="0"/>
           </a:p>
         </p:txBody>
       </p:sp>
@@ -8565,8 +8568,8 @@
         </p:nvSpPr>
         <p:spPr>
           <a:xfrm>
-            <a:off x="8814816" y="4078224"/>
-            <a:ext cx="2706624" cy="237744"/>
+            <a:off x="6556248" y="4773168"/>
+            <a:ext cx="2249424" cy="274320"/>
           </a:xfrm>
           <a:prstGeom prst="rect">
             <a:avLst/>
@@ -8582,7 +8585,7 @@
               <a:buNone/>
             </a:pPr>
             <a:r>
-              <a:rPr lang="en-US" sz="1250" b="1" dirty="0">
+              <a:rPr lang="en-US" sz="1300" b="1" dirty="0">
                 <a:solidFill>
                   <a:srgbClr val="2B2B33"/>
                 </a:solidFill>
@@ -8590,9 +8593,9 @@
                 <a:ea typeface="Calibri" pitchFamily="34" charset="-122"/>
                 <a:cs typeface="Calibri" pitchFamily="34" charset="-120"/>
               </a:rPr>
-              <a:t>Atrial fibrillation (irregular)</a:t>
-            </a:r>
-            <a:endParaRPr lang="en-US" sz="1250" dirty="0"/>
+              <a:t>Atrial fibrillation</a:t>
+            </a:r>
+            <a:endParaRPr lang="en-US" sz="1300" dirty="0"/>
           </a:p>
         </p:txBody>
       </p:sp>
@@ -8604,12 +8607,12 @@
         </p:nvSpPr>
         <p:spPr>
           <a:xfrm>
-            <a:off x="8613648" y="4389120"/>
-            <a:ext cx="3072384" cy="493776"/>
+            <a:off x="9089136" y="4389120"/>
+            <a:ext cx="2615184" cy="749808"/>
           </a:xfrm>
           <a:prstGeom prst="roundRect">
             <a:avLst>
-              <a:gd name="adj" fmla="val 16667"/>
+              <a:gd name="adj" fmla="val 12195"/>
             </a:avLst>
           </a:prstGeom>
           <a:solidFill>
@@ -8631,8 +8634,8 @@
         </p:nvSpPr>
         <p:spPr>
           <a:xfrm>
-            <a:off x="8814816" y="4453128"/>
-            <a:ext cx="2706624" cy="182880"/>
+            <a:off x="9290304" y="4517136"/>
+            <a:ext cx="2249424" cy="219456"/>
           </a:xfrm>
           <a:prstGeom prst="rect">
             <a:avLst/>
@@ -8648,7 +8651,7 @@
               <a:buNone/>
             </a:pPr>
             <a:r>
-              <a:rPr lang="en-US" sz="950" b="1" spc="100" kern="0" dirty="0">
+              <a:rPr lang="en-US" sz="1000" b="1" spc="80" kern="0" dirty="0">
                 <a:solidFill>
                   <a:srgbClr val="A4133C"/>
                 </a:solidFill>
@@ -8658,7 +8661,7 @@
               </a:rPr>
               <a:t>P WAVES</a:t>
             </a:r>
-            <a:endParaRPr lang="en-US" sz="950" dirty="0"/>
+            <a:endParaRPr lang="en-US" sz="1000" dirty="0"/>
           </a:p>
         </p:txBody>
       </p:sp>
@@ -8670,8 +8673,8 @@
         </p:nvSpPr>
         <p:spPr>
           <a:xfrm>
-            <a:off x="8814816" y="4626864"/>
-            <a:ext cx="2706624" cy="237744"/>
+            <a:off x="9290304" y="4773168"/>
+            <a:ext cx="2249424" cy="274320"/>
           </a:xfrm>
           <a:prstGeom prst="rect">
             <a:avLst/>
@@ -8687,7 +8690,7 @@
               <a:buNone/>
             </a:pPr>
             <a:r>
-              <a:rPr lang="en-US" sz="1250" b="1" dirty="0">
+              <a:rPr lang="en-US" sz="1300" b="1" dirty="0">
                 <a:solidFill>
                   <a:srgbClr val="2B2B33"/>
                 </a:solidFill>
@@ -8697,7 +8700,7 @@
               </a:rPr>
               <a:t>Absent</a:t>
             </a:r>
-            <a:endParaRPr lang="en-US" sz="1250" dirty="0"/>
+            <a:endParaRPr lang="en-US" sz="1300" dirty="0"/>
           </a:p>
         </p:txBody>
       </p:sp>
@@ -8709,12 +8712,12 @@
         </p:nvSpPr>
         <p:spPr>
           <a:xfrm>
-            <a:off x="8613648" y="4937760"/>
-            <a:ext cx="3072384" cy="493776"/>
+            <a:off x="6355080" y="5239512"/>
+            <a:ext cx="2615184" cy="749808"/>
           </a:xfrm>
           <a:prstGeom prst="roundRect">
             <a:avLst>
-              <a:gd name="adj" fmla="val 16667"/>
+              <a:gd name="adj" fmla="val 12195"/>
             </a:avLst>
           </a:prstGeom>
           <a:solidFill>
@@ -8736,8 +8739,8 @@
         </p:nvSpPr>
         <p:spPr>
           <a:xfrm>
-            <a:off x="8814816" y="5001768"/>
-            <a:ext cx="2706624" cy="182880"/>
+            <a:off x="6556248" y="5367528"/>
+            <a:ext cx="2249424" cy="219456"/>
           </a:xfrm>
           <a:prstGeom prst="rect">
             <a:avLst/>
@@ -8753,7 +8756,7 @@
               <a:buNone/>
             </a:pPr>
             <a:r>
-              <a:rPr lang="en-US" sz="950" b="1" spc="100" kern="0" dirty="0">
+              <a:rPr lang="en-US" sz="1000" b="1" spc="80" kern="0" dirty="0">
                 <a:solidFill>
                   <a:srgbClr val="A4133C"/>
                 </a:solidFill>
@@ -8763,7 +8766,7 @@
               </a:rPr>
               <a:t>PR · QRS</a:t>
             </a:r>
-            <a:endParaRPr lang="en-US" sz="950" dirty="0"/>
+            <a:endParaRPr lang="en-US" sz="1000" dirty="0"/>
           </a:p>
         </p:txBody>
       </p:sp>
@@ -8775,8 +8778,8 @@
         </p:nvSpPr>
         <p:spPr>
           <a:xfrm>
-            <a:off x="8814816" y="5175504"/>
-            <a:ext cx="2706624" cy="237744"/>
+            <a:off x="6556248" y="5623560"/>
+            <a:ext cx="2249424" cy="274320"/>
           </a:xfrm>
           <a:prstGeom prst="rect">
             <a:avLst/>
@@ -8792,7 +8795,7 @@
               <a:buNone/>
             </a:pPr>
             <a:r>
-              <a:rPr lang="en-US" sz="1250" b="1" dirty="0">
+              <a:rPr lang="en-US" sz="1300" b="1" dirty="0">
                 <a:solidFill>
                   <a:srgbClr val="2B2B33"/>
                 </a:solidFill>
@@ -8800,9 +8803,9 @@
                 <a:ea typeface="Calibri" pitchFamily="34" charset="-122"/>
                 <a:cs typeface="Calibri" pitchFamily="34" charset="-120"/>
               </a:rPr>
-              <a:t>Not measurable · 80 ms</a:t>
-            </a:r>
-            <a:endParaRPr lang="en-US" sz="1250" dirty="0"/>
+              <a:t>– · 80 ms</a:t>
+            </a:r>
+            <a:endParaRPr lang="en-US" sz="1300" dirty="0"/>
           </a:p>
         </p:txBody>
       </p:sp>
@@ -8814,12 +8817,12 @@
         </p:nvSpPr>
         <p:spPr>
           <a:xfrm>
-            <a:off x="8613648" y="5486400"/>
-            <a:ext cx="3072384" cy="493776"/>
+            <a:off x="9089136" y="5239512"/>
+            <a:ext cx="2615184" cy="749808"/>
           </a:xfrm>
           <a:prstGeom prst="roundRect">
             <a:avLst>
-              <a:gd name="adj" fmla="val 16667"/>
+              <a:gd name="adj" fmla="val 12195"/>
             </a:avLst>
           </a:prstGeom>
           <a:solidFill>
@@ -8841,8 +8844,8 @@
         </p:nvSpPr>
         <p:spPr>
           <a:xfrm>
-            <a:off x="8814816" y="5550408"/>
-            <a:ext cx="2706624" cy="182880"/>
+            <a:off x="9290304" y="5367528"/>
+            <a:ext cx="2249424" cy="219456"/>
           </a:xfrm>
           <a:prstGeom prst="rect">
             <a:avLst/>
@@ -8858,7 +8861,7 @@
               <a:buNone/>
             </a:pPr>
             <a:r>
-              <a:rPr lang="en-US" sz="950" b="1" spc="100" kern="0" dirty="0">
+              <a:rPr lang="en-US" sz="1000" b="1" spc="80" kern="0" dirty="0">
                 <a:solidFill>
                   <a:srgbClr val="A4133C"/>
                 </a:solidFill>
@@ -8866,9 +8869,9 @@
                 <a:ea typeface="Calibri" pitchFamily="34" charset="-122"/>
                 <a:cs typeface="Calibri" pitchFamily="34" charset="-120"/>
               </a:rPr>
-              <a:t>QTC · AXIS</a:t>
-            </a:r>
-            <a:endParaRPr lang="en-US" sz="950" dirty="0"/>
+              <a:t>QT / QTC · AXIS</a:t>
+            </a:r>
+            <a:endParaRPr lang="en-US" sz="1000" dirty="0"/>
           </a:p>
         </p:txBody>
       </p:sp>
@@ -8880,8 +8883,8 @@
         </p:nvSpPr>
         <p:spPr>
           <a:xfrm>
-            <a:off x="8814816" y="5724144"/>
-            <a:ext cx="2706624" cy="237744"/>
+            <a:off x="9290304" y="5623560"/>
+            <a:ext cx="2249424" cy="274320"/>
           </a:xfrm>
           <a:prstGeom prst="rect">
             <a:avLst/>
@@ -8897,7 +8900,7 @@
               <a:buNone/>
             </a:pPr>
             <a:r>
-              <a:rPr lang="en-US" sz="1250" b="1" dirty="0">
+              <a:rPr lang="en-US" sz="1300" b="1" dirty="0">
                 <a:solidFill>
                   <a:srgbClr val="2B2B33"/>
                 </a:solidFill>
@@ -8905,9 +8908,9 @@
                 <a:ea typeface="Calibri" pitchFamily="34" charset="-122"/>
                 <a:cs typeface="Calibri" pitchFamily="34" charset="-120"/>
               </a:rPr>
-              <a:t>382 ms · 38°</a:t>
-            </a:r>
-            <a:endParaRPr lang="en-US" sz="1250" dirty="0"/>
+              <a:t>298 / 382 ms · 38°</a:t>
+            </a:r>
+            <a:endParaRPr lang="en-US" sz="1300" dirty="0"/>
           </a:p>
         </p:txBody>
       </p:sp>

</xml_diff>

<commit_message>
Detail CVS exam findings; redesign hospital course slide
- CVS slide: Palpation now 'Normal'; Auscultation lists the three heart-
  sound findings (S1 & both S2 audible; S1 variable / S2 normal intensity;
  no added sounds)
- Hospital Course slide redesigned as a 4-step admission journey timeline
  (Admitted -> Treated -> Improved -> Discharged) on the dark theme

Co-Authored-By: Claude Opus 4.8 <noreply@anthropic.com>
Claude-Session: https://claude.ai/code/session_01S7QW8AwqyMReKwuqyBkBBv
</commit_message>
<xml_diff>
--- a/presentations/Clinicopathological-Conference-COMPLETE.pptx
+++ b/presentations/Clinicopathological-Conference-COMPLETE.pptx
@@ -6399,11 +6399,11 @@
         <p:spPr>
           <a:xfrm>
             <a:off x="4937760" y="1783080"/>
-            <a:ext cx="6766560" cy="1280160"/>
+            <a:ext cx="6766560" cy="822960"/>
           </a:xfrm>
           <a:prstGeom prst="roundRect">
             <a:avLst>
-              <a:gd name="adj" fmla="val 7143"/>
+              <a:gd name="adj" fmla="val 11111"/>
             </a:avLst>
           </a:prstGeom>
           <a:solidFill>
@@ -6432,8 +6432,8 @@
         </p:nvSpPr>
         <p:spPr>
           <a:xfrm>
-            <a:off x="5257800" y="2075688"/>
-            <a:ext cx="694944" cy="694944"/>
+            <a:off x="5212080" y="1920240"/>
+            <a:ext cx="548640" cy="548640"/>
           </a:xfrm>
           <a:prstGeom prst="ellipse">
             <a:avLst/>
@@ -6465,8 +6465,8 @@
         </p:blipFill>
         <p:spPr>
           <a:xfrm>
-            <a:off x="5431536" y="2249424"/>
-            <a:ext cx="347472" cy="347472"/>
+            <a:off x="5349240" y="2057400"/>
+            <a:ext cx="274320" cy="274320"/>
           </a:xfrm>
           <a:prstGeom prst="rect">
             <a:avLst/>
@@ -6481,8 +6481,8 @@
         </p:nvSpPr>
         <p:spPr>
           <a:xfrm>
-            <a:off x="6172200" y="2002536"/>
-            <a:ext cx="5212080" cy="292608"/>
+            <a:off x="5925312" y="1929384"/>
+            <a:ext cx="5486400" cy="256032"/>
           </a:xfrm>
           <a:prstGeom prst="rect">
             <a:avLst/>
@@ -6498,7 +6498,7 @@
               <a:buNone/>
             </a:pPr>
             <a:r>
-              <a:rPr lang="en-US" sz="1250" b="1" spc="120" kern="0" dirty="0">
+              <a:rPr lang="en-US" sz="1200" b="1" spc="120" kern="0" dirty="0">
                 <a:solidFill>
                   <a:srgbClr val="A4133C"/>
                 </a:solidFill>
@@ -6508,7 +6508,7 @@
               </a:rPr>
               <a:t>INSPECTION</a:t>
             </a:r>
-            <a:endParaRPr lang="en-US" sz="1250" dirty="0"/>
+            <a:endParaRPr lang="en-US" sz="1200" dirty="0"/>
           </a:p>
         </p:txBody>
       </p:sp>
@@ -6520,24 +6520,24 @@
         </p:nvSpPr>
         <p:spPr>
           <a:xfrm>
-            <a:off x="6172200" y="2331720"/>
-            <a:ext cx="5166360" cy="548640"/>
-          </a:xfrm>
-          <a:prstGeom prst="rect">
-            <a:avLst/>
-          </a:prstGeom>
-          <a:noFill/>
-          <a:ln/>
-        </p:spPr>
-        <p:txBody>
-          <a:bodyPr wrap="square" lIns="0" tIns="0" rIns="0" bIns="0" rtlCol="0" anchor="t"/>
-          <a:lstStyle/>
-          <a:p>
-            <a:pPr algn="l" indent="0" marL="0">
-              <a:buNone/>
-            </a:pPr>
-            <a:r>
-              <a:rPr lang="en-US" sz="1900" b="1" dirty="0">
+            <a:off x="5925312" y="2185416"/>
+            <a:ext cx="5486400" cy="310896"/>
+          </a:xfrm>
+          <a:prstGeom prst="rect">
+            <a:avLst/>
+          </a:prstGeom>
+          <a:noFill/>
+          <a:ln/>
+        </p:spPr>
+        <p:txBody>
+          <a:bodyPr wrap="square" lIns="0" tIns="0" rIns="0" bIns="0" rtlCol="0" anchor="ctr"/>
+          <a:lstStyle/>
+          <a:p>
+            <a:pPr algn="l" indent="0" marL="0">
+              <a:buNone/>
+            </a:pPr>
+            <a:r>
+              <a:rPr lang="en-US" sz="1700" b="1" dirty="0">
                 <a:solidFill>
                   <a:srgbClr val="2B2B33"/>
                 </a:solidFill>
@@ -6547,7 +6547,7 @@
               </a:rPr>
               <a:t>No visible pulsations or striae marks</a:t>
             </a:r>
-            <a:endParaRPr lang="en-US" sz="1900" dirty="0"/>
+            <a:endParaRPr lang="en-US" sz="1700" dirty="0"/>
           </a:p>
         </p:txBody>
       </p:sp>
@@ -6559,12 +6559,12 @@
         </p:nvSpPr>
         <p:spPr>
           <a:xfrm>
-            <a:off x="4937760" y="3246120"/>
-            <a:ext cx="6766560" cy="1280160"/>
+            <a:off x="4937760" y="2715768"/>
+            <a:ext cx="6766560" cy="822960"/>
           </a:xfrm>
           <a:prstGeom prst="roundRect">
             <a:avLst>
-              <a:gd name="adj" fmla="val 7143"/>
+              <a:gd name="adj" fmla="val 11111"/>
             </a:avLst>
           </a:prstGeom>
           <a:solidFill>
@@ -6593,8 +6593,8 @@
         </p:nvSpPr>
         <p:spPr>
           <a:xfrm>
-            <a:off x="5257800" y="3538728"/>
-            <a:ext cx="694944" cy="694944"/>
+            <a:off x="5212080" y="2852928"/>
+            <a:ext cx="548640" cy="548640"/>
           </a:xfrm>
           <a:prstGeom prst="ellipse">
             <a:avLst/>
@@ -6626,8 +6626,8 @@
         </p:blipFill>
         <p:spPr>
           <a:xfrm>
-            <a:off x="5431536" y="3712464"/>
-            <a:ext cx="347472" cy="347472"/>
+            <a:off x="5349240" y="2990088"/>
+            <a:ext cx="274320" cy="274320"/>
           </a:xfrm>
           <a:prstGeom prst="rect">
             <a:avLst/>
@@ -6642,8 +6642,8 @@
         </p:nvSpPr>
         <p:spPr>
           <a:xfrm>
-            <a:off x="6172200" y="3465576"/>
-            <a:ext cx="5212080" cy="292608"/>
+            <a:off x="5925312" y="2862072"/>
+            <a:ext cx="5486400" cy="256032"/>
           </a:xfrm>
           <a:prstGeom prst="rect">
             <a:avLst/>
@@ -6659,7 +6659,7 @@
               <a:buNone/>
             </a:pPr>
             <a:r>
-              <a:rPr lang="en-US" sz="1250" b="1" spc="120" kern="0" dirty="0">
+              <a:rPr lang="en-US" sz="1200" b="1" spc="120" kern="0" dirty="0">
                 <a:solidFill>
                   <a:srgbClr val="A4133C"/>
                 </a:solidFill>
@@ -6669,7 +6669,7 @@
               </a:rPr>
               <a:t>PALPATION</a:t>
             </a:r>
-            <a:endParaRPr lang="en-US" sz="1250" dirty="0"/>
+            <a:endParaRPr lang="en-US" sz="1200" dirty="0"/>
           </a:p>
         </p:txBody>
       </p:sp>
@@ -6681,24 +6681,24 @@
         </p:nvSpPr>
         <p:spPr>
           <a:xfrm>
-            <a:off x="6172200" y="3794760"/>
-            <a:ext cx="5166360" cy="548640"/>
-          </a:xfrm>
-          <a:prstGeom prst="rect">
-            <a:avLst/>
-          </a:prstGeom>
-          <a:noFill/>
-          <a:ln/>
-        </p:spPr>
-        <p:txBody>
-          <a:bodyPr wrap="square" lIns="0" tIns="0" rIns="0" bIns="0" rtlCol="0" anchor="t"/>
-          <a:lstStyle/>
-          <a:p>
-            <a:pPr algn="l" indent="0" marL="0">
-              <a:buNone/>
-            </a:pPr>
-            <a:r>
-              <a:rPr lang="en-US" sz="1900" b="1" dirty="0">
+            <a:off x="5925312" y="3118104"/>
+            <a:ext cx="5486400" cy="310896"/>
+          </a:xfrm>
+          <a:prstGeom prst="rect">
+            <a:avLst/>
+          </a:prstGeom>
+          <a:noFill/>
+          <a:ln/>
+        </p:spPr>
+        <p:txBody>
+          <a:bodyPr wrap="square" lIns="0" tIns="0" rIns="0" bIns="0" rtlCol="0" anchor="ctr"/>
+          <a:lstStyle/>
+          <a:p>
+            <a:pPr algn="l" indent="0" marL="0">
+              <a:buNone/>
+            </a:pPr>
+            <a:r>
+              <a:rPr lang="en-US" sz="1700" b="1" dirty="0">
                 <a:solidFill>
                   <a:srgbClr val="2B2B33"/>
                 </a:solidFill>
@@ -6706,9 +6706,9 @@
                 <a:ea typeface="Cambria" pitchFamily="34" charset="-122"/>
                 <a:cs typeface="Cambria" pitchFamily="34" charset="-120"/>
               </a:rPr>
-              <a:t>Examined</a:t>
-            </a:r>
-            <a:endParaRPr lang="en-US" sz="1900" dirty="0"/>
+              <a:t>Normal</a:t>
+            </a:r>
+            <a:endParaRPr lang="en-US" sz="1700" dirty="0"/>
           </a:p>
         </p:txBody>
       </p:sp>
@@ -6720,12 +6720,12 @@
         </p:nvSpPr>
         <p:spPr>
           <a:xfrm>
-            <a:off x="4937760" y="4709160"/>
-            <a:ext cx="6766560" cy="1280160"/>
+            <a:off x="4937760" y="3703320"/>
+            <a:ext cx="6766560" cy="2286000"/>
           </a:xfrm>
           <a:prstGeom prst="roundRect">
             <a:avLst>
-              <a:gd name="adj" fmla="val 7143"/>
+              <a:gd name="adj" fmla="val 4000"/>
             </a:avLst>
           </a:prstGeom>
           <a:solidFill>
@@ -6754,8 +6754,8 @@
         </p:nvSpPr>
         <p:spPr>
           <a:xfrm>
-            <a:off x="5257800" y="5001768"/>
-            <a:ext cx="694944" cy="694944"/>
+            <a:off x="5212080" y="3941064"/>
+            <a:ext cx="603504" cy="603504"/>
           </a:xfrm>
           <a:prstGeom prst="ellipse">
             <a:avLst/>
@@ -6787,8 +6787,8 @@
         </p:blipFill>
         <p:spPr>
           <a:xfrm>
-            <a:off x="5431536" y="5175504"/>
-            <a:ext cx="347472" cy="347472"/>
+            <a:off x="5367528" y="4096512"/>
+            <a:ext cx="292608" cy="292608"/>
           </a:xfrm>
           <a:prstGeom prst="rect">
             <a:avLst/>
@@ -6803,8 +6803,8 @@
         </p:nvSpPr>
         <p:spPr>
           <a:xfrm>
-            <a:off x="6172200" y="4928616"/>
-            <a:ext cx="5212080" cy="292608"/>
+            <a:off x="5961888" y="4041648"/>
+            <a:ext cx="5486400" cy="292608"/>
           </a:xfrm>
           <a:prstGeom prst="rect">
             <a:avLst/>
@@ -6836,14 +6836,34 @@
       </p:sp>
       <p:sp>
         <p:nvSpPr>
-          <p:cNvPr id="31" name="Text 24"/>
-          <p:cNvSpPr/>
-          <p:nvPr/>
-        </p:nvSpPr>
-        <p:spPr>
-          <a:xfrm>
-            <a:off x="6172200" y="5257800"/>
-            <a:ext cx="5166360" cy="548640"/>
+          <p:cNvPr id="31" name="Shape 24"/>
+          <p:cNvSpPr/>
+          <p:nvPr/>
+        </p:nvSpPr>
+        <p:spPr>
+          <a:xfrm>
+            <a:off x="5394960" y="4718304"/>
+            <a:ext cx="128016" cy="128016"/>
+          </a:xfrm>
+          <a:prstGeom prst="ellipse">
+            <a:avLst/>
+          </a:prstGeom>
+          <a:solidFill>
+            <a:srgbClr val="FF4D6D"/>
+          </a:solidFill>
+          <a:ln/>
+        </p:spPr>
+      </p:sp>
+      <p:sp>
+        <p:nvSpPr>
+          <p:cNvPr id="32" name="Text 25"/>
+          <p:cNvSpPr/>
+          <p:nvPr/>
+        </p:nvSpPr>
+        <p:spPr>
+          <a:xfrm>
+            <a:off x="5687568" y="4636008"/>
+            <a:ext cx="5596128" cy="457200"/>
           </a:xfrm>
           <a:prstGeom prst="rect">
             <a:avLst/>
@@ -6856,26 +6876,153 @@
           <a:lstStyle/>
           <a:p>
             <a:pPr algn="l" indent="0" marL="0">
-              <a:buNone/>
-            </a:pPr>
-            <a:r>
-              <a:rPr lang="en-US" sz="1900" b="1" dirty="0">
+              <a:lnSpc>
+                <a:spcPct val="100000"/>
+              </a:lnSpc>
+              <a:buNone/>
+            </a:pPr>
+            <a:r>
+              <a:rPr lang="en-US" sz="1250" dirty="0">
                 <a:solidFill>
                   <a:srgbClr val="2B2B33"/>
                 </a:solidFill>
-                <a:latin typeface="Cambria" pitchFamily="34" charset="0"/>
-                <a:ea typeface="Cambria" pitchFamily="34" charset="-122"/>
-                <a:cs typeface="Cambria" pitchFamily="34" charset="-120"/>
-              </a:rPr>
-              <a:t>Examined</a:t>
-            </a:r>
-            <a:endParaRPr lang="en-US" sz="1900" dirty="0"/>
-          </a:p>
-        </p:txBody>
-      </p:sp>
-      <p:sp>
-        <p:nvSpPr>
-          <p:cNvPr id="32" name="Text 25"/>
+                <a:latin typeface="Calibri" pitchFamily="34" charset="0"/>
+                <a:ea typeface="Calibri" pitchFamily="34" charset="-122"/>
+                <a:cs typeface="Calibri" pitchFamily="34" charset="-120"/>
+              </a:rPr>
+              <a:t>1st heart sound &amp; both components of 2nd heart sound audible at their respective areas</a:t>
+            </a:r>
+            <a:endParaRPr lang="en-US" sz="1250" dirty="0"/>
+          </a:p>
+        </p:txBody>
+      </p:sp>
+      <p:sp>
+        <p:nvSpPr>
+          <p:cNvPr id="33" name="Shape 26"/>
+          <p:cNvSpPr/>
+          <p:nvPr/>
+        </p:nvSpPr>
+        <p:spPr>
+          <a:xfrm>
+            <a:off x="5394960" y="5175504"/>
+            <a:ext cx="128016" cy="128016"/>
+          </a:xfrm>
+          <a:prstGeom prst="ellipse">
+            <a:avLst/>
+          </a:prstGeom>
+          <a:solidFill>
+            <a:srgbClr val="FF4D6D"/>
+          </a:solidFill>
+          <a:ln/>
+        </p:spPr>
+      </p:sp>
+      <p:sp>
+        <p:nvSpPr>
+          <p:cNvPr id="34" name="Text 27"/>
+          <p:cNvSpPr/>
+          <p:nvPr/>
+        </p:nvSpPr>
+        <p:spPr>
+          <a:xfrm>
+            <a:off x="5687568" y="5093208"/>
+            <a:ext cx="5596128" cy="457200"/>
+          </a:xfrm>
+          <a:prstGeom prst="rect">
+            <a:avLst/>
+          </a:prstGeom>
+          <a:noFill/>
+          <a:ln/>
+        </p:spPr>
+        <p:txBody>
+          <a:bodyPr wrap="square" lIns="0" tIns="0" rIns="0" bIns="0" rtlCol="0" anchor="t"/>
+          <a:lstStyle/>
+          <a:p>
+            <a:pPr algn="l" indent="0" marL="0">
+              <a:lnSpc>
+                <a:spcPct val="100000"/>
+              </a:lnSpc>
+              <a:buNone/>
+            </a:pPr>
+            <a:r>
+              <a:rPr lang="en-US" sz="1250" dirty="0">
+                <a:solidFill>
+                  <a:srgbClr val="2B2B33"/>
+                </a:solidFill>
+                <a:latin typeface="Calibri" pitchFamily="34" charset="0"/>
+                <a:ea typeface="Calibri" pitchFamily="34" charset="-122"/>
+                <a:cs typeface="Calibri" pitchFamily="34" charset="-120"/>
+              </a:rPr>
+              <a:t>1st heart sound of variable intensity; both components of 2nd heart sound of normal intensity</a:t>
+            </a:r>
+            <a:endParaRPr lang="en-US" sz="1250" dirty="0"/>
+          </a:p>
+        </p:txBody>
+      </p:sp>
+      <p:sp>
+        <p:nvSpPr>
+          <p:cNvPr id="35" name="Shape 28"/>
+          <p:cNvSpPr/>
+          <p:nvPr/>
+        </p:nvSpPr>
+        <p:spPr>
+          <a:xfrm>
+            <a:off x="5394960" y="5632704"/>
+            <a:ext cx="128016" cy="128016"/>
+          </a:xfrm>
+          <a:prstGeom prst="ellipse">
+            <a:avLst/>
+          </a:prstGeom>
+          <a:solidFill>
+            <a:srgbClr val="FF4D6D"/>
+          </a:solidFill>
+          <a:ln/>
+        </p:spPr>
+      </p:sp>
+      <p:sp>
+        <p:nvSpPr>
+          <p:cNvPr id="36" name="Text 29"/>
+          <p:cNvSpPr/>
+          <p:nvPr/>
+        </p:nvSpPr>
+        <p:spPr>
+          <a:xfrm>
+            <a:off x="5687568" y="5550408"/>
+            <a:ext cx="5596128" cy="457200"/>
+          </a:xfrm>
+          <a:prstGeom prst="rect">
+            <a:avLst/>
+          </a:prstGeom>
+          <a:noFill/>
+          <a:ln/>
+        </p:spPr>
+        <p:txBody>
+          <a:bodyPr wrap="square" lIns="0" tIns="0" rIns="0" bIns="0" rtlCol="0" anchor="t"/>
+          <a:lstStyle/>
+          <a:p>
+            <a:pPr algn="l" indent="0" marL="0">
+              <a:lnSpc>
+                <a:spcPct val="100000"/>
+              </a:lnSpc>
+              <a:buNone/>
+            </a:pPr>
+            <a:r>
+              <a:rPr lang="en-US" sz="1250" dirty="0">
+                <a:solidFill>
+                  <a:srgbClr val="2B2B33"/>
+                </a:solidFill>
+                <a:latin typeface="Calibri" pitchFamily="34" charset="0"/>
+                <a:ea typeface="Calibri" pitchFamily="34" charset="-122"/>
+                <a:cs typeface="Calibri" pitchFamily="34" charset="-120"/>
+              </a:rPr>
+              <a:t>No added sounds audible</a:t>
+            </a:r>
+            <a:endParaRPr lang="en-US" sz="1250" dirty="0"/>
+          </a:p>
+        </p:txBody>
+      </p:sp>
+      <p:sp>
+        <p:nvSpPr>
+          <p:cNvPr id="37" name="Text 30"/>
           <p:cNvSpPr/>
           <p:nvPr/>
         </p:nvSpPr>
@@ -6914,7 +7061,7 @@
       </p:sp>
       <p:sp>
         <p:nvSpPr>
-          <p:cNvPr id="33" name="Text 26"/>
+          <p:cNvPr id="38" name="Text 31"/>
           <p:cNvSpPr/>
           <p:nvPr/>
         </p:nvSpPr>
@@ -23258,7 +23405,7 @@
           </a:prstGeom>
           <a:solidFill>
             <a:srgbClr val="3A0A17">
-              <a:alpha val="65000"/>
+              <a:alpha val="68000"/>
             </a:srgbClr>
           </a:solidFill>
           <a:ln/>
@@ -23274,7 +23421,7 @@
         </p:nvPicPr>
         <p:blipFill>
           <a:blip r:embed="rId1">
-            <a:alphaModFix amt="10000"/>
+            <a:alphaModFix amt="7000"/>
           </a:blip>
           <a:stretch>
             <a:fillRect/>
@@ -23282,52 +23429,34 @@
         </p:blipFill>
         <p:spPr>
           <a:xfrm>
-            <a:off x="7863840" y="3108960"/>
-            <a:ext cx="4754880" cy="4754880"/>
+            <a:off x="8321040" y="-960120"/>
+            <a:ext cx="4114800" cy="4114800"/>
           </a:xfrm>
           <a:prstGeom prst="rect">
             <a:avLst/>
           </a:prstGeom>
         </p:spPr>
       </p:pic>
-      <p:sp>
-        <p:nvSpPr>
-          <p:cNvPr id="4" name="Shape 1"/>
-          <p:cNvSpPr/>
-          <p:nvPr/>
-        </p:nvSpPr>
-        <p:spPr>
-          <a:xfrm>
-            <a:off x="685800" y="777240"/>
-            <a:ext cx="960120" cy="960120"/>
-          </a:xfrm>
-          <a:prstGeom prst="ellipse">
-            <a:avLst/>
-          </a:prstGeom>
-          <a:solidFill>
-            <a:srgbClr val="A4133C"/>
-          </a:solidFill>
-          <a:ln/>
-        </p:spPr>
-      </p:sp>
       <p:pic>
         <p:nvPicPr>
-          <p:cNvPr id="5" name="Image 1" descr="preencoded.png">    </p:cNvPr>
+          <p:cNvPr id="4" name="Image 1" descr="preencoded.png">    </p:cNvPr>
           <p:cNvPicPr>
             <a:picLocks noChangeAspect="1"/>
           </p:cNvPicPr>
           <p:nvPr/>
         </p:nvPicPr>
         <p:blipFill>
-          <a:blip r:embed="rId2"/>
+          <a:blip r:embed="rId2">
+            <a:alphaModFix amt="7000"/>
+          </a:blip>
           <a:stretch>
             <a:fillRect/>
           </a:stretch>
         </p:blipFill>
         <p:spPr>
           <a:xfrm>
-            <a:off x="896112" y="987552"/>
-            <a:ext cx="548640" cy="548640"/>
+            <a:off x="8046720" y="3749040"/>
+            <a:ext cx="4663440" cy="4663440"/>
           </a:xfrm>
           <a:prstGeom prst="rect">
             <a:avLst/>
@@ -23336,141 +23465,27 @@
       </p:pic>
       <p:sp>
         <p:nvSpPr>
-          <p:cNvPr id="6" name="Text 2"/>
-          <p:cNvSpPr/>
-          <p:nvPr/>
-        </p:nvSpPr>
-        <p:spPr>
-          <a:xfrm>
-            <a:off x="1828800" y="960120"/>
-            <a:ext cx="8229600" cy="548640"/>
-          </a:xfrm>
-          <a:prstGeom prst="rect">
-            <a:avLst/>
-          </a:prstGeom>
-          <a:noFill/>
-          <a:ln/>
-        </p:spPr>
-        <p:txBody>
-          <a:bodyPr wrap="square" rtlCol="0" anchor="ctr"/>
-          <a:lstStyle/>
-          <a:p>
-            <a:pPr algn="l" indent="0" marL="0">
-              <a:buNone/>
-            </a:pPr>
-            <a:r>
-              <a:rPr lang="en-US" sz="1700" b="1" spc="250" kern="0" dirty="0">
-                <a:solidFill>
-                  <a:srgbClr val="FF4D6D"/>
-                </a:solidFill>
-                <a:latin typeface="Calibri" pitchFamily="34" charset="0"/>
-                <a:ea typeface="Calibri" pitchFamily="34" charset="-122"/>
-                <a:cs typeface="Calibri" pitchFamily="34" charset="-120"/>
-              </a:rPr>
-              <a:t>HOSPITAL COURSE &amp; OUTCOME</a:t>
-            </a:r>
-            <a:endParaRPr lang="en-US" sz="1700" dirty="0"/>
-          </a:p>
-        </p:txBody>
-      </p:sp>
-      <p:sp>
-        <p:nvSpPr>
-          <p:cNvPr id="7" name="Text 3"/>
-          <p:cNvSpPr/>
-          <p:nvPr/>
-        </p:nvSpPr>
-        <p:spPr>
-          <a:xfrm>
-            <a:off x="640080" y="1965960"/>
-            <a:ext cx="10058400" cy="914400"/>
-          </a:xfrm>
-          <a:prstGeom prst="rect">
-            <a:avLst/>
-          </a:prstGeom>
-          <a:noFill/>
-          <a:ln/>
-        </p:spPr>
-        <p:txBody>
-          <a:bodyPr wrap="square" rtlCol="0" anchor="t"/>
-          <a:lstStyle/>
-          <a:p>
-            <a:pPr algn="l" indent="0" marL="0">
-              <a:buNone/>
-            </a:pPr>
-            <a:r>
-              <a:rPr lang="en-US" sz="5600" b="1" dirty="0">
-                <a:solidFill>
-                  <a:srgbClr val="FFFFFF"/>
-                </a:solidFill>
-                <a:latin typeface="Cambria" pitchFamily="34" charset="0"/>
-                <a:ea typeface="Cambria" pitchFamily="34" charset="-122"/>
-                <a:cs typeface="Cambria" pitchFamily="34" charset="-120"/>
-              </a:rPr>
-              <a:t>Clinically Improved</a:t>
-            </a:r>
-            <a:endParaRPr lang="en-US" sz="5600" dirty="0"/>
-          </a:p>
-        </p:txBody>
-      </p:sp>
-      <p:sp>
-        <p:nvSpPr>
-          <p:cNvPr id="8" name="Shape 4"/>
-          <p:cNvSpPr/>
-          <p:nvPr/>
-        </p:nvSpPr>
-        <p:spPr>
-          <a:xfrm>
-            <a:off x="685800" y="3200400"/>
-            <a:ext cx="3749040" cy="1554480"/>
-          </a:xfrm>
-          <a:prstGeom prst="roundRect">
-            <a:avLst>
-              <a:gd name="adj" fmla="val 7059"/>
-            </a:avLst>
+          <p:cNvPr id="5" name="Shape 1"/>
+          <p:cNvSpPr/>
+          <p:nvPr/>
+        </p:nvSpPr>
+        <p:spPr>
+          <a:xfrm>
+            <a:off x="685800" y="731520"/>
+            <a:ext cx="960120" cy="960120"/>
+          </a:xfrm>
+          <a:prstGeom prst="ellipse">
+            <a:avLst/>
           </a:prstGeom>
           <a:solidFill>
-            <a:srgbClr val="FFFFFF">
-              <a:alpha val="8000"/>
-            </a:srgbClr>
-          </a:solidFill>
-          <a:ln w="12700">
-            <a:solidFill>
-              <a:srgbClr val="FF4D6D"/>
-            </a:solidFill>
-            <a:prstDash val="solid"/>
-          </a:ln>
-          <a:effectLst>
-            <a:outerShdw sx="100000" sy="100000" kx="0" ky="0" algn="bl" rotWithShape="0" blurRad="101600" dist="38100" dir="5400000">
-              <a:srgbClr val="8A8A8A">
-                <a:alpha val="35000"/>
-              </a:srgbClr>
-            </a:outerShdw>
-          </a:effectLst>
-        </p:spPr>
-      </p:sp>
-      <p:sp>
-        <p:nvSpPr>
-          <p:cNvPr id="9" name="Shape 5"/>
-          <p:cNvSpPr/>
-          <p:nvPr/>
-        </p:nvSpPr>
-        <p:spPr>
-          <a:xfrm>
-            <a:off x="960120" y="3657600"/>
-            <a:ext cx="640080" cy="640080"/>
-          </a:xfrm>
-          <a:prstGeom prst="ellipse">
-            <a:avLst/>
-          </a:prstGeom>
-          <a:solidFill>
-            <a:srgbClr val="FFFFFF"/>
+            <a:srgbClr val="A4133C"/>
           </a:solidFill>
           <a:ln/>
         </p:spPr>
       </p:sp>
       <p:pic>
         <p:nvPicPr>
-          <p:cNvPr id="10" name="Image 2" descr="preencoded.png">    </p:cNvPr>
+          <p:cNvPr id="6" name="Image 2" descr="preencoded.png">    </p:cNvPr>
           <p:cNvPicPr>
             <a:picLocks noChangeAspect="1"/>
           </p:cNvPicPr>
@@ -23484,8 +23499,8 @@
         </p:blipFill>
         <p:spPr>
           <a:xfrm>
-            <a:off x="1088136" y="3785616"/>
-            <a:ext cx="384048" cy="384048"/>
+            <a:off x="896112" y="941832"/>
+            <a:ext cx="548640" cy="548640"/>
           </a:xfrm>
           <a:prstGeom prst="rect">
             <a:avLst/>
@@ -23494,30 +23509,69 @@
       </p:pic>
       <p:sp>
         <p:nvSpPr>
-          <p:cNvPr id="11" name="Text 6"/>
-          <p:cNvSpPr/>
-          <p:nvPr/>
-        </p:nvSpPr>
-        <p:spPr>
-          <a:xfrm>
-            <a:off x="1737360" y="3493008"/>
-            <a:ext cx="2560320" cy="457200"/>
-          </a:xfrm>
-          <a:prstGeom prst="rect">
-            <a:avLst/>
-          </a:prstGeom>
-          <a:noFill/>
-          <a:ln/>
-        </p:spPr>
-        <p:txBody>
-          <a:bodyPr wrap="square" lIns="0" tIns="0" rIns="0" bIns="0" rtlCol="0" anchor="ctr"/>
-          <a:lstStyle/>
-          <a:p>
-            <a:pPr algn="l" indent="0" marL="0">
-              <a:buNone/>
-            </a:pPr>
-            <a:r>
-              <a:rPr lang="en-US" sz="1900" b="1" dirty="0">
+          <p:cNvPr id="7" name="Text 2"/>
+          <p:cNvSpPr/>
+          <p:nvPr/>
+        </p:nvSpPr>
+        <p:spPr>
+          <a:xfrm>
+            <a:off x="1828800" y="914400"/>
+            <a:ext cx="8229600" cy="548640"/>
+          </a:xfrm>
+          <a:prstGeom prst="rect">
+            <a:avLst/>
+          </a:prstGeom>
+          <a:noFill/>
+          <a:ln/>
+        </p:spPr>
+        <p:txBody>
+          <a:bodyPr wrap="square" rtlCol="0" anchor="ctr"/>
+          <a:lstStyle/>
+          <a:p>
+            <a:pPr algn="l" indent="0" marL="0">
+              <a:buNone/>
+            </a:pPr>
+            <a:r>
+              <a:rPr lang="en-US" sz="1700" b="1" spc="250" kern="0" dirty="0">
+                <a:solidFill>
+                  <a:srgbClr val="FF4D6D"/>
+                </a:solidFill>
+                <a:latin typeface="Calibri" pitchFamily="34" charset="0"/>
+                <a:ea typeface="Calibri" pitchFamily="34" charset="-122"/>
+                <a:cs typeface="Calibri" pitchFamily="34" charset="-120"/>
+              </a:rPr>
+              <a:t>HOSPITAL COURSE &amp; OUTCOME</a:t>
+            </a:r>
+            <a:endParaRPr lang="en-US" sz="1700" dirty="0"/>
+          </a:p>
+        </p:txBody>
+      </p:sp>
+      <p:sp>
+        <p:nvSpPr>
+          <p:cNvPr id="8" name="Text 3"/>
+          <p:cNvSpPr/>
+          <p:nvPr/>
+        </p:nvSpPr>
+        <p:spPr>
+          <a:xfrm>
+            <a:off x="640080" y="1783080"/>
+            <a:ext cx="10515600" cy="868680"/>
+          </a:xfrm>
+          <a:prstGeom prst="rect">
+            <a:avLst/>
+          </a:prstGeom>
+          <a:noFill/>
+          <a:ln/>
+        </p:spPr>
+        <p:txBody>
+          <a:bodyPr wrap="square" rtlCol="0" anchor="t"/>
+          <a:lstStyle/>
+          <a:p>
+            <a:pPr algn="l" indent="0" marL="0">
+              <a:buNone/>
+            </a:pPr>
+            <a:r>
+              <a:rPr lang="en-US" sz="5200" b="1" dirty="0">
                 <a:solidFill>
                   <a:srgbClr val="FFFFFF"/>
                 </a:solidFill>
@@ -23525,38 +23579,38 @@
                 <a:ea typeface="Cambria" pitchFamily="34" charset="-122"/>
                 <a:cs typeface="Cambria" pitchFamily="34" charset="-120"/>
               </a:rPr>
-              <a:t>Symptoms settled</a:t>
-            </a:r>
-            <a:endParaRPr lang="en-US" sz="1900" dirty="0"/>
-          </a:p>
-        </p:txBody>
-      </p:sp>
-      <p:sp>
-        <p:nvSpPr>
-          <p:cNvPr id="12" name="Text 7"/>
-          <p:cNvSpPr/>
-          <p:nvPr/>
-        </p:nvSpPr>
-        <p:spPr>
-          <a:xfrm>
-            <a:off x="1737360" y="3950208"/>
-            <a:ext cx="2606040" cy="640080"/>
-          </a:xfrm>
-          <a:prstGeom prst="rect">
-            <a:avLst/>
-          </a:prstGeom>
-          <a:noFill/>
-          <a:ln/>
-        </p:spPr>
-        <p:txBody>
-          <a:bodyPr wrap="square" lIns="0" tIns="0" rIns="0" bIns="0" rtlCol="0" anchor="t"/>
-          <a:lstStyle/>
-          <a:p>
-            <a:pPr algn="l" indent="0" marL="0">
-              <a:buNone/>
-            </a:pPr>
-            <a:r>
-              <a:rPr lang="en-US" sz="1250" i="1" dirty="0">
+              <a:t>Clinically Improved</a:t>
+            </a:r>
+            <a:endParaRPr lang="en-US" sz="5200" dirty="0"/>
+          </a:p>
+        </p:txBody>
+      </p:sp>
+      <p:sp>
+        <p:nvSpPr>
+          <p:cNvPr id="9" name="Text 4"/>
+          <p:cNvSpPr/>
+          <p:nvPr/>
+        </p:nvSpPr>
+        <p:spPr>
+          <a:xfrm>
+            <a:off x="685800" y="2697480"/>
+            <a:ext cx="10515600" cy="365760"/>
+          </a:xfrm>
+          <a:prstGeom prst="rect">
+            <a:avLst/>
+          </a:prstGeom>
+          <a:noFill/>
+          <a:ln/>
+        </p:spPr>
+        <p:txBody>
+          <a:bodyPr wrap="square" rtlCol="0" anchor="t"/>
+          <a:lstStyle/>
+          <a:p>
+            <a:pPr algn="l" indent="0" marL="0">
+              <a:buNone/>
+            </a:pPr>
+            <a:r>
+              <a:rPr lang="en-US" sz="1600" i="1" dirty="0">
                 <a:solidFill>
                   <a:srgbClr val="FBD8DF"/>
                 </a:solidFill>
@@ -23564,71 +23618,64 @@
                 <a:ea typeface="Calibri" pitchFamily="34" charset="-122"/>
                 <a:cs typeface="Calibri" pitchFamily="34" charset="-120"/>
               </a:rPr>
-              <a:t>Rhythm &amp; symptoms controlled</a:t>
-            </a:r>
-            <a:endParaRPr lang="en-US" sz="1250" dirty="0"/>
-          </a:p>
-        </p:txBody>
-      </p:sp>
-      <p:sp>
-        <p:nvSpPr>
-          <p:cNvPr id="13" name="Shape 8"/>
-          <p:cNvSpPr/>
-          <p:nvPr/>
-        </p:nvSpPr>
-        <p:spPr>
-          <a:xfrm>
-            <a:off x="4709160" y="3200400"/>
-            <a:ext cx="3749040" cy="1554480"/>
+              <a:t>From cardiac emergency to safe discharge</a:t>
+            </a:r>
+            <a:endParaRPr lang="en-US" sz="1600" dirty="0"/>
+          </a:p>
+        </p:txBody>
+      </p:sp>
+      <p:sp>
+        <p:nvSpPr>
+          <p:cNvPr id="10" name="Shape 5"/>
+          <p:cNvSpPr/>
+          <p:nvPr/>
+        </p:nvSpPr>
+        <p:spPr>
+          <a:xfrm>
+            <a:off x="1874520" y="4133088"/>
+            <a:ext cx="8503920" cy="54864"/>
           </a:xfrm>
           <a:prstGeom prst="roundRect">
             <a:avLst>
-              <a:gd name="adj" fmla="val 7059"/>
+              <a:gd name="adj" fmla="val 50000"/>
             </a:avLst>
           </a:prstGeom>
           <a:solidFill>
-            <a:srgbClr val="FFFFFF">
-              <a:alpha val="8000"/>
+            <a:srgbClr val="FF4D6D">
+              <a:alpha val="55000"/>
             </a:srgbClr>
           </a:solidFill>
-          <a:ln w="12700">
+          <a:ln/>
+        </p:spPr>
+      </p:sp>
+      <p:sp>
+        <p:nvSpPr>
+          <p:cNvPr id="11" name="Shape 6"/>
+          <p:cNvSpPr/>
+          <p:nvPr/>
+        </p:nvSpPr>
+        <p:spPr>
+          <a:xfrm>
+            <a:off x="1371600" y="3657600"/>
+            <a:ext cx="1005840" cy="1005840"/>
+          </a:xfrm>
+          <a:prstGeom prst="ellipse">
+            <a:avLst/>
+          </a:prstGeom>
+          <a:solidFill>
+            <a:srgbClr val="A4133C"/>
+          </a:solidFill>
+          <a:ln w="19050">
             <a:solidFill>
               <a:srgbClr val="FF4D6D"/>
             </a:solidFill>
             <a:prstDash val="solid"/>
           </a:ln>
-          <a:effectLst>
-            <a:outerShdw sx="100000" sy="100000" kx="0" ky="0" algn="bl" rotWithShape="0" blurRad="101600" dist="38100" dir="5400000">
-              <a:srgbClr val="8A8A8A">
-                <a:alpha val="35000"/>
-              </a:srgbClr>
-            </a:outerShdw>
-          </a:effectLst>
-        </p:spPr>
-      </p:sp>
-      <p:sp>
-        <p:nvSpPr>
-          <p:cNvPr id="14" name="Shape 9"/>
-          <p:cNvSpPr/>
-          <p:nvPr/>
-        </p:nvSpPr>
-        <p:spPr>
-          <a:xfrm>
-            <a:off x="4983480" y="3657600"/>
-            <a:ext cx="640080" cy="640080"/>
-          </a:xfrm>
-          <a:prstGeom prst="ellipse">
-            <a:avLst/>
-          </a:prstGeom>
-          <a:solidFill>
-            <a:srgbClr val="FFFFFF"/>
-          </a:solidFill>
-          <a:ln/>
         </p:spPr>
       </p:sp>
       <p:pic>
         <p:nvPicPr>
-          <p:cNvPr id="15" name="Image 3" descr="preencoded.png">    </p:cNvPr>
+          <p:cNvPr id="12" name="Image 3" descr="preencoded.png">    </p:cNvPr>
           <p:cNvPicPr>
             <a:picLocks noChangeAspect="1"/>
           </p:cNvPicPr>
@@ -23642,8 +23689,8 @@
         </p:blipFill>
         <p:spPr>
           <a:xfrm>
-            <a:off x="5111496" y="3785616"/>
-            <a:ext cx="384048" cy="384048"/>
+            <a:off x="1609344" y="3895344"/>
+            <a:ext cx="530352" cy="530352"/>
           </a:xfrm>
           <a:prstGeom prst="rect">
             <a:avLst/>
@@ -23652,26 +23699,26 @@
       </p:pic>
       <p:sp>
         <p:nvSpPr>
-          <p:cNvPr id="16" name="Text 10"/>
-          <p:cNvSpPr/>
-          <p:nvPr/>
-        </p:nvSpPr>
-        <p:spPr>
-          <a:xfrm>
-            <a:off x="5760720" y="3493008"/>
-            <a:ext cx="2560320" cy="457200"/>
-          </a:xfrm>
-          <a:prstGeom prst="rect">
-            <a:avLst/>
-          </a:prstGeom>
-          <a:noFill/>
-          <a:ln/>
-        </p:spPr>
-        <p:txBody>
-          <a:bodyPr wrap="square" lIns="0" tIns="0" rIns="0" bIns="0" rtlCol="0" anchor="ctr"/>
-          <a:lstStyle/>
-          <a:p>
-            <a:pPr algn="l" indent="0" marL="0">
+          <p:cNvPr id="13" name="Text 7"/>
+          <p:cNvSpPr/>
+          <p:nvPr/>
+        </p:nvSpPr>
+        <p:spPr>
+          <a:xfrm>
+            <a:off x="548640" y="4818888"/>
+            <a:ext cx="2651760" cy="320040"/>
+          </a:xfrm>
+          <a:prstGeom prst="rect">
+            <a:avLst/>
+          </a:prstGeom>
+          <a:noFill/>
+          <a:ln/>
+        </p:spPr>
+        <p:txBody>
+          <a:bodyPr wrap="square" rtlCol="0" anchor="t"/>
+          <a:lstStyle/>
+          <a:p>
+            <a:pPr algn="ctr" indent="0" marL="0">
               <a:buNone/>
             </a:pPr>
             <a:r>
@@ -23683,7 +23730,7 @@
                 <a:ea typeface="Cambria" pitchFamily="34" charset="-122"/>
                 <a:cs typeface="Cambria" pitchFamily="34" charset="-120"/>
               </a:rPr>
-              <a:t>Discharged home</a:t>
+              <a:t>Admitted</a:t>
             </a:r>
             <a:endParaRPr lang="en-US" sz="1900" dirty="0"/>
           </a:p>
@@ -23691,30 +23738,33 @@
       </p:sp>
       <p:sp>
         <p:nvSpPr>
-          <p:cNvPr id="17" name="Text 11"/>
-          <p:cNvSpPr/>
-          <p:nvPr/>
-        </p:nvSpPr>
-        <p:spPr>
-          <a:xfrm>
-            <a:off x="5760720" y="3950208"/>
-            <a:ext cx="2606040" cy="640080"/>
-          </a:xfrm>
-          <a:prstGeom prst="rect">
-            <a:avLst/>
-          </a:prstGeom>
-          <a:noFill/>
-          <a:ln/>
-        </p:spPr>
-        <p:txBody>
-          <a:bodyPr wrap="square" lIns="0" tIns="0" rIns="0" bIns="0" rtlCol="0" anchor="t"/>
-          <a:lstStyle/>
-          <a:p>
-            <a:pPr algn="l" indent="0" marL="0">
-              <a:buNone/>
-            </a:pPr>
-            <a:r>
-              <a:rPr lang="en-US" sz="1250" i="1" dirty="0">
+          <p:cNvPr id="14" name="Text 8"/>
+          <p:cNvSpPr/>
+          <p:nvPr/>
+        </p:nvSpPr>
+        <p:spPr>
+          <a:xfrm>
+            <a:off x="548640" y="5148072"/>
+            <a:ext cx="2651760" cy="548640"/>
+          </a:xfrm>
+          <a:prstGeom prst="rect">
+            <a:avLst/>
+          </a:prstGeom>
+          <a:noFill/>
+          <a:ln/>
+        </p:spPr>
+        <p:txBody>
+          <a:bodyPr wrap="square" rtlCol="0" anchor="t"/>
+          <a:lstStyle/>
+          <a:p>
+            <a:pPr algn="ctr" indent="0" marL="0">
+              <a:lnSpc>
+                <a:spcPct val="102000"/>
+              </a:lnSpc>
+              <a:buNone/>
+            </a:pPr>
+            <a:r>
+              <a:rPr lang="en-US" sz="1250" dirty="0">
                 <a:solidFill>
                   <a:srgbClr val="FBD8DF"/>
                 </a:solidFill>
@@ -23722,7 +23772,7 @@
                 <a:ea typeface="Calibri" pitchFamily="34" charset="-122"/>
                 <a:cs typeface="Calibri" pitchFamily="34" charset="-120"/>
               </a:rPr>
-              <a:t>Stable for outpatient follow-up</a:t>
+              <a:t>Cardiac emergency</a:t>
             </a:r>
             <a:endParaRPr lang="en-US" sz="1250" dirty="0"/>
           </a:p>
@@ -23730,189 +23780,323 @@
       </p:sp>
       <p:sp>
         <p:nvSpPr>
-          <p:cNvPr id="18" name="Shape 12"/>
-          <p:cNvSpPr/>
-          <p:nvPr/>
-        </p:nvSpPr>
-        <p:spPr>
-          <a:xfrm>
-            <a:off x="731520" y="5486400"/>
-            <a:ext cx="2020824" cy="0"/>
-          </a:xfrm>
-          <a:prstGeom prst="line">
-            <a:avLst/>
-          </a:prstGeom>
-          <a:noFill/>
-          <a:ln w="28575">
+          <p:cNvPr id="15" name="Shape 9"/>
+          <p:cNvSpPr/>
+          <p:nvPr/>
+        </p:nvSpPr>
+        <p:spPr>
+          <a:xfrm>
+            <a:off x="4206240" y="3657600"/>
+            <a:ext cx="1005840" cy="1005840"/>
+          </a:xfrm>
+          <a:prstGeom prst="ellipse">
+            <a:avLst/>
+          </a:prstGeom>
+          <a:solidFill>
+            <a:srgbClr val="A4133C"/>
+          </a:solidFill>
+          <a:ln w="19050">
             <a:solidFill>
-              <a:srgbClr val="FF4D6D">
-                <a:alpha val="95000"/>
-              </a:srgbClr>
+              <a:srgbClr val="FF4D6D"/>
             </a:solidFill>
             <a:prstDash val="solid"/>
           </a:ln>
         </p:spPr>
       </p:sp>
-      <p:sp>
-        <p:nvSpPr>
-          <p:cNvPr id="19" name="Shape 13"/>
-          <p:cNvSpPr/>
-          <p:nvPr/>
-        </p:nvSpPr>
-        <p:spPr>
-          <a:xfrm flipV="1">
-            <a:off x="2752344" y="5340096"/>
-            <a:ext cx="356616" cy="146304"/>
-          </a:xfrm>
-          <a:prstGeom prst="line">
-            <a:avLst/>
-          </a:prstGeom>
-          <a:noFill/>
-          <a:ln w="28575">
+      <p:pic>
+        <p:nvPicPr>
+          <p:cNvPr id="16" name="Image 4" descr="preencoded.png">    </p:cNvPr>
+          <p:cNvPicPr>
+            <a:picLocks noChangeAspect="1"/>
+          </p:cNvPicPr>
+          <p:nvPr/>
+        </p:nvPicPr>
+        <p:blipFill>
+          <a:blip r:embed="rId5"/>
+          <a:stretch>
+            <a:fillRect/>
+          </a:stretch>
+        </p:blipFill>
+        <p:spPr>
+          <a:xfrm>
+            <a:off x="4443984" y="3895344"/>
+            <a:ext cx="530352" cy="530352"/>
+          </a:xfrm>
+          <a:prstGeom prst="rect">
+            <a:avLst/>
+          </a:prstGeom>
+        </p:spPr>
+      </p:pic>
+      <p:sp>
+        <p:nvSpPr>
+          <p:cNvPr id="17" name="Text 10"/>
+          <p:cNvSpPr/>
+          <p:nvPr/>
+        </p:nvSpPr>
+        <p:spPr>
+          <a:xfrm>
+            <a:off x="3383280" y="4818888"/>
+            <a:ext cx="2651760" cy="320040"/>
+          </a:xfrm>
+          <a:prstGeom prst="rect">
+            <a:avLst/>
+          </a:prstGeom>
+          <a:noFill/>
+          <a:ln/>
+        </p:spPr>
+        <p:txBody>
+          <a:bodyPr wrap="square" rtlCol="0" anchor="t"/>
+          <a:lstStyle/>
+          <a:p>
+            <a:pPr algn="ctr" indent="0" marL="0">
+              <a:buNone/>
+            </a:pPr>
+            <a:r>
+              <a:rPr lang="en-US" sz="1900" b="1" dirty="0">
+                <a:solidFill>
+                  <a:srgbClr val="FFFFFF"/>
+                </a:solidFill>
+                <a:latin typeface="Cambria" pitchFamily="34" charset="0"/>
+                <a:ea typeface="Cambria" pitchFamily="34" charset="-122"/>
+                <a:cs typeface="Cambria" pitchFamily="34" charset="-120"/>
+              </a:rPr>
+              <a:t>Treated</a:t>
+            </a:r>
+            <a:endParaRPr lang="en-US" sz="1900" dirty="0"/>
+          </a:p>
+        </p:txBody>
+      </p:sp>
+      <p:sp>
+        <p:nvSpPr>
+          <p:cNvPr id="18" name="Text 11"/>
+          <p:cNvSpPr/>
+          <p:nvPr/>
+        </p:nvSpPr>
+        <p:spPr>
+          <a:xfrm>
+            <a:off x="3383280" y="5148072"/>
+            <a:ext cx="2651760" cy="548640"/>
+          </a:xfrm>
+          <a:prstGeom prst="rect">
+            <a:avLst/>
+          </a:prstGeom>
+          <a:noFill/>
+          <a:ln/>
+        </p:spPr>
+        <p:txBody>
+          <a:bodyPr wrap="square" rtlCol="0" anchor="t"/>
+          <a:lstStyle/>
+          <a:p>
+            <a:pPr algn="ctr" indent="0" marL="0">
+              <a:lnSpc>
+                <a:spcPct val="102000"/>
+              </a:lnSpc>
+              <a:buNone/>
+            </a:pPr>
+            <a:r>
+              <a:rPr lang="en-US" sz="1250" dirty="0">
+                <a:solidFill>
+                  <a:srgbClr val="FBD8DF"/>
+                </a:solidFill>
+                <a:latin typeface="Calibri" pitchFamily="34" charset="0"/>
+                <a:ea typeface="Calibri" pitchFamily="34" charset="-122"/>
+                <a:cs typeface="Calibri" pitchFamily="34" charset="-120"/>
+              </a:rPr>
+              <a:t>IV medication</a:t>
+            </a:r>
+            <a:endParaRPr lang="en-US" sz="1250" dirty="0"/>
+          </a:p>
+        </p:txBody>
+      </p:sp>
+      <p:sp>
+        <p:nvSpPr>
+          <p:cNvPr id="19" name="Shape 12"/>
+          <p:cNvSpPr/>
+          <p:nvPr/>
+        </p:nvSpPr>
+        <p:spPr>
+          <a:xfrm>
+            <a:off x="7040880" y="3657600"/>
+            <a:ext cx="1005840" cy="1005840"/>
+          </a:xfrm>
+          <a:prstGeom prst="ellipse">
+            <a:avLst/>
+          </a:prstGeom>
+          <a:solidFill>
+            <a:srgbClr val="A4133C"/>
+          </a:solidFill>
+          <a:ln w="19050">
             <a:solidFill>
-              <a:srgbClr val="FF4D6D">
-                <a:alpha val="95000"/>
-              </a:srgbClr>
+              <a:srgbClr val="FF4D6D"/>
             </a:solidFill>
             <a:prstDash val="solid"/>
           </a:ln>
         </p:spPr>
       </p:sp>
-      <p:sp>
-        <p:nvSpPr>
-          <p:cNvPr id="20" name="Shape 14"/>
-          <p:cNvSpPr/>
-          <p:nvPr/>
-        </p:nvSpPr>
-        <p:spPr>
-          <a:xfrm>
-            <a:off x="3108960" y="5340096"/>
-            <a:ext cx="356616" cy="457200"/>
-          </a:xfrm>
-          <a:prstGeom prst="line">
-            <a:avLst/>
-          </a:prstGeom>
-          <a:noFill/>
-          <a:ln w="28575">
+      <p:pic>
+        <p:nvPicPr>
+          <p:cNvPr id="20" name="Image 5" descr="preencoded.png">    </p:cNvPr>
+          <p:cNvPicPr>
+            <a:picLocks noChangeAspect="1"/>
+          </p:cNvPicPr>
+          <p:nvPr/>
+        </p:nvPicPr>
+        <p:blipFill>
+          <a:blip r:embed="rId6"/>
+          <a:stretch>
+            <a:fillRect/>
+          </a:stretch>
+        </p:blipFill>
+        <p:spPr>
+          <a:xfrm>
+            <a:off x="7278624" y="3895344"/>
+            <a:ext cx="530352" cy="530352"/>
+          </a:xfrm>
+          <a:prstGeom prst="rect">
+            <a:avLst/>
+          </a:prstGeom>
+        </p:spPr>
+      </p:pic>
+      <p:sp>
+        <p:nvSpPr>
+          <p:cNvPr id="21" name="Text 13"/>
+          <p:cNvSpPr/>
+          <p:nvPr/>
+        </p:nvSpPr>
+        <p:spPr>
+          <a:xfrm>
+            <a:off x="6217920" y="4818888"/>
+            <a:ext cx="2651760" cy="320040"/>
+          </a:xfrm>
+          <a:prstGeom prst="rect">
+            <a:avLst/>
+          </a:prstGeom>
+          <a:noFill/>
+          <a:ln/>
+        </p:spPr>
+        <p:txBody>
+          <a:bodyPr wrap="square" rtlCol="0" anchor="t"/>
+          <a:lstStyle/>
+          <a:p>
+            <a:pPr algn="ctr" indent="0" marL="0">
+              <a:buNone/>
+            </a:pPr>
+            <a:r>
+              <a:rPr lang="en-US" sz="1900" b="1" dirty="0">
+                <a:solidFill>
+                  <a:srgbClr val="FFFFFF"/>
+                </a:solidFill>
+                <a:latin typeface="Cambria" pitchFamily="34" charset="0"/>
+                <a:ea typeface="Cambria" pitchFamily="34" charset="-122"/>
+                <a:cs typeface="Cambria" pitchFamily="34" charset="-120"/>
+              </a:rPr>
+              <a:t>Improved</a:t>
+            </a:r>
+            <a:endParaRPr lang="en-US" sz="1900" dirty="0"/>
+          </a:p>
+        </p:txBody>
+      </p:sp>
+      <p:sp>
+        <p:nvSpPr>
+          <p:cNvPr id="22" name="Text 14"/>
+          <p:cNvSpPr/>
+          <p:nvPr/>
+        </p:nvSpPr>
+        <p:spPr>
+          <a:xfrm>
+            <a:off x="6217920" y="5148072"/>
+            <a:ext cx="2651760" cy="548640"/>
+          </a:xfrm>
+          <a:prstGeom prst="rect">
+            <a:avLst/>
+          </a:prstGeom>
+          <a:noFill/>
+          <a:ln/>
+        </p:spPr>
+        <p:txBody>
+          <a:bodyPr wrap="square" rtlCol="0" anchor="t"/>
+          <a:lstStyle/>
+          <a:p>
+            <a:pPr algn="ctr" indent="0" marL="0">
+              <a:lnSpc>
+                <a:spcPct val="102000"/>
+              </a:lnSpc>
+              <a:buNone/>
+            </a:pPr>
+            <a:r>
+              <a:rPr lang="en-US" sz="1250" dirty="0">
+                <a:solidFill>
+                  <a:srgbClr val="FBD8DF"/>
+                </a:solidFill>
+                <a:latin typeface="Calibri" pitchFamily="34" charset="0"/>
+                <a:ea typeface="Calibri" pitchFamily="34" charset="-122"/>
+                <a:cs typeface="Calibri" pitchFamily="34" charset="-120"/>
+              </a:rPr>
+              <a:t>Rhythm &amp; symptoms settled</a:t>
+            </a:r>
+            <a:endParaRPr lang="en-US" sz="1250" dirty="0"/>
+          </a:p>
+        </p:txBody>
+      </p:sp>
+      <p:sp>
+        <p:nvSpPr>
+          <p:cNvPr id="23" name="Shape 15"/>
+          <p:cNvSpPr/>
+          <p:nvPr/>
+        </p:nvSpPr>
+        <p:spPr>
+          <a:xfrm>
+            <a:off x="9875520" y="3657600"/>
+            <a:ext cx="1005840" cy="1005840"/>
+          </a:xfrm>
+          <a:prstGeom prst="ellipse">
+            <a:avLst/>
+          </a:prstGeom>
+          <a:solidFill>
+            <a:srgbClr val="A4133C"/>
+          </a:solidFill>
+          <a:ln w="19050">
             <a:solidFill>
-              <a:srgbClr val="FF4D6D">
-                <a:alpha val="95000"/>
-              </a:srgbClr>
+              <a:srgbClr val="FF4D6D"/>
             </a:solidFill>
             <a:prstDash val="solid"/>
           </a:ln>
         </p:spPr>
       </p:sp>
-      <p:sp>
-        <p:nvSpPr>
-          <p:cNvPr id="21" name="Shape 15"/>
-          <p:cNvSpPr/>
-          <p:nvPr/>
-        </p:nvSpPr>
-        <p:spPr>
-          <a:xfrm flipV="1">
-            <a:off x="3465576" y="4983480"/>
-            <a:ext cx="356616" cy="813816"/>
-          </a:xfrm>
-          <a:prstGeom prst="line">
-            <a:avLst/>
-          </a:prstGeom>
-          <a:noFill/>
-          <a:ln w="28575">
-            <a:solidFill>
-              <a:srgbClr val="FF4D6D">
-                <a:alpha val="95000"/>
-              </a:srgbClr>
-            </a:solidFill>
-            <a:prstDash val="solid"/>
-          </a:ln>
-        </p:spPr>
-      </p:sp>
-      <p:sp>
-        <p:nvSpPr>
-          <p:cNvPr id="22" name="Shape 16"/>
-          <p:cNvSpPr/>
-          <p:nvPr/>
-        </p:nvSpPr>
-        <p:spPr>
-          <a:xfrm>
-            <a:off x="3822192" y="4983480"/>
-            <a:ext cx="356616" cy="685800"/>
-          </a:xfrm>
-          <a:prstGeom prst="line">
-            <a:avLst/>
-          </a:prstGeom>
-          <a:noFill/>
-          <a:ln w="28575">
-            <a:solidFill>
-              <a:srgbClr val="FF4D6D">
-                <a:alpha val="95000"/>
-              </a:srgbClr>
-            </a:solidFill>
-            <a:prstDash val="solid"/>
-          </a:ln>
-        </p:spPr>
-      </p:sp>
-      <p:sp>
-        <p:nvSpPr>
-          <p:cNvPr id="23" name="Shape 17"/>
-          <p:cNvSpPr/>
-          <p:nvPr/>
-        </p:nvSpPr>
-        <p:spPr>
-          <a:xfrm flipV="1">
-            <a:off x="4178808" y="5486400"/>
-            <a:ext cx="356616" cy="182880"/>
-          </a:xfrm>
-          <a:prstGeom prst="line">
-            <a:avLst/>
-          </a:prstGeom>
-          <a:noFill/>
-          <a:ln w="28575">
-            <a:solidFill>
-              <a:srgbClr val="FF4D6D">
-                <a:alpha val="95000"/>
-              </a:srgbClr>
-            </a:solidFill>
-            <a:prstDash val="solid"/>
-          </a:ln>
-        </p:spPr>
-      </p:sp>
-      <p:sp>
-        <p:nvSpPr>
-          <p:cNvPr id="24" name="Shape 18"/>
-          <p:cNvSpPr/>
-          <p:nvPr/>
-        </p:nvSpPr>
-        <p:spPr>
-          <a:xfrm>
-            <a:off x="4535424" y="5486400"/>
-            <a:ext cx="2139696" cy="0"/>
-          </a:xfrm>
-          <a:prstGeom prst="line">
-            <a:avLst/>
-          </a:prstGeom>
-          <a:noFill/>
-          <a:ln w="28575">
-            <a:solidFill>
-              <a:srgbClr val="FF4D6D">
-                <a:alpha val="95000"/>
-              </a:srgbClr>
-            </a:solidFill>
-            <a:prstDash val="solid"/>
-          </a:ln>
-        </p:spPr>
-      </p:sp>
-      <p:sp>
-        <p:nvSpPr>
-          <p:cNvPr id="25" name="Text 19"/>
-          <p:cNvSpPr/>
-          <p:nvPr/>
-        </p:nvSpPr>
-        <p:spPr>
-          <a:xfrm>
-            <a:off x="685800" y="5715000"/>
-            <a:ext cx="8229600" cy="548640"/>
+      <p:pic>
+        <p:nvPicPr>
+          <p:cNvPr id="24" name="Image 6" descr="preencoded.png">    </p:cNvPr>
+          <p:cNvPicPr>
+            <a:picLocks noChangeAspect="1"/>
+          </p:cNvPicPr>
+          <p:nvPr/>
+        </p:nvPicPr>
+        <p:blipFill>
+          <a:blip r:embed="rId7"/>
+          <a:stretch>
+            <a:fillRect/>
+          </a:stretch>
+        </p:blipFill>
+        <p:spPr>
+          <a:xfrm>
+            <a:off x="10113264" y="3895344"/>
+            <a:ext cx="530352" cy="530352"/>
+          </a:xfrm>
+          <a:prstGeom prst="rect">
+            <a:avLst/>
+          </a:prstGeom>
+        </p:spPr>
+      </p:pic>
+      <p:sp>
+        <p:nvSpPr>
+          <p:cNvPr id="25" name="Text 16"/>
+          <p:cNvSpPr/>
+          <p:nvPr/>
+        </p:nvSpPr>
+        <p:spPr>
+          <a:xfrm>
+            <a:off x="9052560" y="4818888"/>
+            <a:ext cx="2651760" cy="320040"/>
           </a:xfrm>
           <a:prstGeom prst="rect">
             <a:avLst/>
@@ -23924,27 +24108,108 @@
           <a:bodyPr wrap="square" rtlCol="0" anchor="t"/>
           <a:lstStyle/>
           <a:p>
-            <a:pPr algn="l" indent="0" marL="0">
-              <a:buNone/>
-            </a:pPr>
-            <a:r>
-              <a:rPr lang="en-US" sz="2200" b="1" i="1" dirty="0">
-                <a:solidFill>
-                  <a:srgbClr val="FBD8DF"/>
+            <a:pPr algn="ctr" indent="0" marL="0">
+              <a:buNone/>
+            </a:pPr>
+            <a:r>
+              <a:rPr lang="en-US" sz="1900" b="1" dirty="0">
+                <a:solidFill>
+                  <a:srgbClr val="FFFFFF"/>
                 </a:solidFill>
                 <a:latin typeface="Cambria" pitchFamily="34" charset="0"/>
                 <a:ea typeface="Cambria" pitchFamily="34" charset="-122"/>
                 <a:cs typeface="Cambria" pitchFamily="34" charset="-120"/>
               </a:rPr>
+              <a:t>Discharged</a:t>
+            </a:r>
+            <a:endParaRPr lang="en-US" sz="1900" dirty="0"/>
+          </a:p>
+        </p:txBody>
+      </p:sp>
+      <p:sp>
+        <p:nvSpPr>
+          <p:cNvPr id="26" name="Text 17"/>
+          <p:cNvSpPr/>
+          <p:nvPr/>
+        </p:nvSpPr>
+        <p:spPr>
+          <a:xfrm>
+            <a:off x="9052560" y="5148072"/>
+            <a:ext cx="2651760" cy="548640"/>
+          </a:xfrm>
+          <a:prstGeom prst="rect">
+            <a:avLst/>
+          </a:prstGeom>
+          <a:noFill/>
+          <a:ln/>
+        </p:spPr>
+        <p:txBody>
+          <a:bodyPr wrap="square" rtlCol="0" anchor="t"/>
+          <a:lstStyle/>
+          <a:p>
+            <a:pPr algn="ctr" indent="0" marL="0">
+              <a:lnSpc>
+                <a:spcPct val="102000"/>
+              </a:lnSpc>
+              <a:buNone/>
+            </a:pPr>
+            <a:r>
+              <a:rPr lang="en-US" sz="1250" dirty="0">
+                <a:solidFill>
+                  <a:srgbClr val="FBD8DF"/>
+                </a:solidFill>
+                <a:latin typeface="Calibri" pitchFamily="34" charset="0"/>
+                <a:ea typeface="Calibri" pitchFamily="34" charset="-122"/>
+                <a:cs typeface="Calibri" pitchFamily="34" charset="-120"/>
+              </a:rPr>
+              <a:t>Home for follow-up</a:t>
+            </a:r>
+            <a:endParaRPr lang="en-US" sz="1250" dirty="0"/>
+          </a:p>
+        </p:txBody>
+      </p:sp>
+      <p:sp>
+        <p:nvSpPr>
+          <p:cNvPr id="27" name="Text 18"/>
+          <p:cNvSpPr/>
+          <p:nvPr/>
+        </p:nvSpPr>
+        <p:spPr>
+          <a:xfrm>
+            <a:off x="685800" y="5943600"/>
+            <a:ext cx="8229600" cy="411480"/>
+          </a:xfrm>
+          <a:prstGeom prst="rect">
+            <a:avLst/>
+          </a:prstGeom>
+          <a:noFill/>
+          <a:ln/>
+        </p:spPr>
+        <p:txBody>
+          <a:bodyPr wrap="square" rtlCol="0" anchor="t"/>
+          <a:lstStyle/>
+          <a:p>
+            <a:pPr algn="l" indent="0" marL="0">
+              <a:buNone/>
+            </a:pPr>
+            <a:r>
+              <a:rPr lang="en-US" sz="2000" b="1" i="1" dirty="0">
+                <a:solidFill>
+                  <a:srgbClr val="FBD8DF"/>
+                </a:solidFill>
+                <a:latin typeface="Cambria" pitchFamily="34" charset="0"/>
+                <a:ea typeface="Cambria" pitchFamily="34" charset="-122"/>
+                <a:cs typeface="Cambria" pitchFamily="34" charset="-120"/>
+              </a:rPr>
               <a:t>The case in context — Atrial Fibrillation</a:t>
             </a:r>
-            <a:endParaRPr lang="en-US" sz="2200" dirty="0"/>
-          </a:p>
-        </p:txBody>
-      </p:sp>
-      <p:sp>
-        <p:nvSpPr>
-          <p:cNvPr id="26" name="Text 20"/>
+            <a:endParaRPr lang="en-US" sz="2000" dirty="0"/>
+          </a:p>
+        </p:txBody>
+      </p:sp>
+      <p:sp>
+        <p:nvSpPr>
+          <p:cNvPr id="28" name="Text 19"/>
           <p:cNvSpPr/>
           <p:nvPr/>
         </p:nvSpPr>
@@ -23983,7 +24248,7 @@
       </p:sp>
       <p:sp>
         <p:nvSpPr>
-          <p:cNvPr id="27" name="Text 21"/>
+          <p:cNvPr id="29" name="Text 20"/>
           <p:cNvSpPr/>
           <p:nvPr/>
         </p:nvSpPr>

</xml_diff>

<commit_message>
Add detailed CVS inspection & palpation findings
CVS slide: Inspection now 'Shape normal, no scar, no pulsations visible
over the precordium'; Palpation lists apex beat (5th ICS, medial to
midclavicular line, normal character), no thrill / other palpable sounds,
and no left parasternal heave.

Co-Authored-By: Claude Opus 4.8 <noreply@anthropic.com>
Claude-Session: https://claude.ai/code/session_01S7QW8AwqyMReKwuqyBkBBv
</commit_message>
<xml_diff>
--- a/presentations/Clinicopathological-Conference-COMPLETE.pptx
+++ b/presentations/Clinicopathological-Conference-COMPLETE.pptx
@@ -6488,11 +6488,11 @@
         <p:spPr>
           <a:xfrm>
             <a:off x="4937760" y="1783080"/>
-            <a:ext cx="6766560" cy="822960"/>
+            <a:ext cx="6766560" cy="777240"/>
           </a:xfrm>
           <a:prstGeom prst="roundRect">
             <a:avLst>
-              <a:gd name="adj" fmla="val 11111"/>
+              <a:gd name="adj" fmla="val 11765"/>
             </a:avLst>
           </a:prstGeom>
           <a:solidFill>
@@ -6521,7 +6521,7 @@
         </p:nvSpPr>
         <p:spPr>
           <a:xfrm>
-            <a:off x="5212080" y="1920240"/>
+            <a:off x="5212080" y="1901952"/>
             <a:ext cx="548640" cy="548640"/>
           </a:xfrm>
           <a:prstGeom prst="ellipse">
@@ -6554,7 +6554,7 @@
         </p:blipFill>
         <p:spPr>
           <a:xfrm>
-            <a:off x="5349240" y="2057400"/>
+            <a:off x="5349240" y="2039112"/>
             <a:ext cx="274320" cy="274320"/>
           </a:xfrm>
           <a:prstGeom prst="rect">
@@ -6570,8 +6570,8 @@
         </p:nvSpPr>
         <p:spPr>
           <a:xfrm>
-            <a:off x="5925312" y="1929384"/>
-            <a:ext cx="5486400" cy="256032"/>
+            <a:off x="5925312" y="1901952"/>
+            <a:ext cx="5577840" cy="237744"/>
           </a:xfrm>
           <a:prstGeom prst="rect">
             <a:avLst/>
@@ -6587,7 +6587,7 @@
               <a:buNone/>
             </a:pPr>
             <a:r>
-              <a:rPr lang="en-US" sz="1200" b="1" spc="120" kern="0" dirty="0">
+              <a:rPr lang="en-US" sz="1150" b="1" spc="120" kern="0" dirty="0">
                 <a:solidFill>
                   <a:srgbClr val="A4133C"/>
                 </a:solidFill>
@@ -6597,7 +6597,7 @@
               </a:rPr>
               <a:t>INSPECTION</a:t>
             </a:r>
-            <a:endParaRPr lang="en-US" sz="1200" dirty="0"/>
+            <a:endParaRPr lang="en-US" sz="1150" dirty="0"/>
           </a:p>
         </p:txBody>
       </p:sp>
@@ -6609,24 +6609,27 @@
         </p:nvSpPr>
         <p:spPr>
           <a:xfrm>
-            <a:off x="5925312" y="2185416"/>
-            <a:ext cx="5486400" cy="310896"/>
-          </a:xfrm>
-          <a:prstGeom prst="rect">
-            <a:avLst/>
-          </a:prstGeom>
-          <a:noFill/>
-          <a:ln/>
-        </p:spPr>
-        <p:txBody>
-          <a:bodyPr wrap="square" lIns="0" tIns="0" rIns="0" bIns="0" rtlCol="0" anchor="ctr"/>
-          <a:lstStyle/>
-          <a:p>
-            <a:pPr algn="l" indent="0" marL="0">
-              <a:buNone/>
-            </a:pPr>
-            <a:r>
-              <a:rPr lang="en-US" sz="1700" b="1" dirty="0">
+            <a:off x="5925312" y="2148840"/>
+            <a:ext cx="5532120" cy="365760"/>
+          </a:xfrm>
+          <a:prstGeom prst="rect">
+            <a:avLst/>
+          </a:prstGeom>
+          <a:noFill/>
+          <a:ln/>
+        </p:spPr>
+        <p:txBody>
+          <a:bodyPr wrap="square" lIns="0" tIns="0" rIns="0" bIns="0" rtlCol="0" anchor="t"/>
+          <a:lstStyle/>
+          <a:p>
+            <a:pPr algn="l" indent="0" marL="0">
+              <a:lnSpc>
+                <a:spcPct val="100000"/>
+              </a:lnSpc>
+              <a:buNone/>
+            </a:pPr>
+            <a:r>
+              <a:rPr lang="en-US" sz="1350" b="1" dirty="0">
                 <a:solidFill>
                   <a:srgbClr val="2B2B33"/>
                 </a:solidFill>
@@ -6634,9 +6637,9 @@
                 <a:ea typeface="Cambria" pitchFamily="34" charset="-122"/>
                 <a:cs typeface="Cambria" pitchFamily="34" charset="-120"/>
               </a:rPr>
-              <a:t>No visible pulsations or striae marks</a:t>
-            </a:r>
-            <a:endParaRPr lang="en-US" sz="1700" dirty="0"/>
+              <a:t>Shape normal, no scar, no pulsations visible over the precordium</a:t>
+            </a:r>
+            <a:endParaRPr lang="en-US" sz="1350" dirty="0"/>
           </a:p>
         </p:txBody>
       </p:sp>
@@ -6648,12 +6651,12 @@
         </p:nvSpPr>
         <p:spPr>
           <a:xfrm>
-            <a:off x="4937760" y="2715768"/>
-            <a:ext cx="6766560" cy="822960"/>
+            <a:off x="4937760" y="2651760"/>
+            <a:ext cx="6766560" cy="1554480"/>
           </a:xfrm>
           <a:prstGeom prst="roundRect">
             <a:avLst>
-              <a:gd name="adj" fmla="val 11111"/>
+              <a:gd name="adj" fmla="val 5882"/>
             </a:avLst>
           </a:prstGeom>
           <a:solidFill>
@@ -6682,7 +6685,7 @@
         </p:nvSpPr>
         <p:spPr>
           <a:xfrm>
-            <a:off x="5212080" y="2852928"/>
+            <a:off x="5212080" y="2816352"/>
             <a:ext cx="548640" cy="548640"/>
           </a:xfrm>
           <a:prstGeom prst="ellipse">
@@ -6715,7 +6718,7 @@
         </p:blipFill>
         <p:spPr>
           <a:xfrm>
-            <a:off x="5349240" y="2990088"/>
+            <a:off x="5349240" y="2953512"/>
             <a:ext cx="274320" cy="274320"/>
           </a:xfrm>
           <a:prstGeom prst="rect">
@@ -6731,8 +6734,8 @@
         </p:nvSpPr>
         <p:spPr>
           <a:xfrm>
-            <a:off x="5925312" y="2862072"/>
-            <a:ext cx="5486400" cy="256032"/>
+            <a:off x="5925312" y="2852928"/>
+            <a:ext cx="5577840" cy="274320"/>
           </a:xfrm>
           <a:prstGeom prst="rect">
             <a:avLst/>
@@ -6764,57 +6767,204 @@
       </p:sp>
       <p:sp>
         <p:nvSpPr>
-          <p:cNvPr id="26" name="Text 20"/>
-          <p:cNvSpPr/>
-          <p:nvPr/>
-        </p:nvSpPr>
-        <p:spPr>
-          <a:xfrm>
-            <a:off x="5925312" y="3118104"/>
-            <a:ext cx="5486400" cy="310896"/>
-          </a:xfrm>
-          <a:prstGeom prst="rect">
-            <a:avLst/>
-          </a:prstGeom>
-          <a:noFill/>
-          <a:ln/>
-        </p:spPr>
-        <p:txBody>
-          <a:bodyPr wrap="square" lIns="0" tIns="0" rIns="0" bIns="0" rtlCol="0" anchor="ctr"/>
-          <a:lstStyle/>
-          <a:p>
-            <a:pPr algn="l" indent="0" marL="0">
-              <a:buNone/>
-            </a:pPr>
-            <a:r>
-              <a:rPr lang="en-US" sz="1700" b="1" dirty="0">
+          <p:cNvPr id="26" name="Shape 20"/>
+          <p:cNvSpPr/>
+          <p:nvPr/>
+        </p:nvSpPr>
+        <p:spPr>
+          <a:xfrm>
+            <a:off x="5394960" y="3255264"/>
+            <a:ext cx="118872" cy="118872"/>
+          </a:xfrm>
+          <a:prstGeom prst="ellipse">
+            <a:avLst/>
+          </a:prstGeom>
+          <a:solidFill>
+            <a:srgbClr val="FF4D6D"/>
+          </a:solidFill>
+          <a:ln/>
+        </p:spPr>
+      </p:sp>
+      <p:sp>
+        <p:nvSpPr>
+          <p:cNvPr id="27" name="Text 21"/>
+          <p:cNvSpPr/>
+          <p:nvPr/>
+        </p:nvSpPr>
+        <p:spPr>
+          <a:xfrm>
+            <a:off x="5669280" y="3182112"/>
+            <a:ext cx="5623560" cy="420624"/>
+          </a:xfrm>
+          <a:prstGeom prst="rect">
+            <a:avLst/>
+          </a:prstGeom>
+          <a:noFill/>
+          <a:ln/>
+        </p:spPr>
+        <p:txBody>
+          <a:bodyPr wrap="square" lIns="0" tIns="0" rIns="0" bIns="0" rtlCol="0" anchor="t"/>
+          <a:lstStyle/>
+          <a:p>
+            <a:pPr algn="l" indent="0" marL="0">
+              <a:lnSpc>
+                <a:spcPct val="100000"/>
+              </a:lnSpc>
+              <a:buNone/>
+            </a:pPr>
+            <a:r>
+              <a:rPr lang="en-US" sz="1250" dirty="0">
                 <a:solidFill>
                   <a:srgbClr val="2B2B33"/>
                 </a:solidFill>
-                <a:latin typeface="Cambria" pitchFamily="34" charset="0"/>
-                <a:ea typeface="Cambria" pitchFamily="34" charset="-122"/>
-                <a:cs typeface="Cambria" pitchFamily="34" charset="-120"/>
-              </a:rPr>
-              <a:t>Normal</a:t>
-            </a:r>
-            <a:endParaRPr lang="en-US" sz="1700" dirty="0"/>
-          </a:p>
-        </p:txBody>
-      </p:sp>
-      <p:sp>
-        <p:nvSpPr>
-          <p:cNvPr id="27" name="Shape 21"/>
-          <p:cNvSpPr/>
-          <p:nvPr/>
-        </p:nvSpPr>
-        <p:spPr>
-          <a:xfrm>
-            <a:off x="4937760" y="3703320"/>
-            <a:ext cx="6766560" cy="2286000"/>
+                <a:latin typeface="Calibri" pitchFamily="34" charset="0"/>
+                <a:ea typeface="Calibri" pitchFamily="34" charset="-122"/>
+                <a:cs typeface="Calibri" pitchFamily="34" charset="-120"/>
+              </a:rPr>
+              <a:t>Apex beat in 5th intercostal space, medial to midclavicular line — normal character</a:t>
+            </a:r>
+            <a:endParaRPr lang="en-US" sz="1250" dirty="0"/>
+          </a:p>
+        </p:txBody>
+      </p:sp>
+      <p:sp>
+        <p:nvSpPr>
+          <p:cNvPr id="28" name="Shape 22"/>
+          <p:cNvSpPr/>
+          <p:nvPr/>
+        </p:nvSpPr>
+        <p:spPr>
+          <a:xfrm>
+            <a:off x="5394960" y="3712464"/>
+            <a:ext cx="118872" cy="118872"/>
+          </a:xfrm>
+          <a:prstGeom prst="ellipse">
+            <a:avLst/>
+          </a:prstGeom>
+          <a:solidFill>
+            <a:srgbClr val="FF4D6D"/>
+          </a:solidFill>
+          <a:ln/>
+        </p:spPr>
+      </p:sp>
+      <p:sp>
+        <p:nvSpPr>
+          <p:cNvPr id="29" name="Text 23"/>
+          <p:cNvSpPr/>
+          <p:nvPr/>
+        </p:nvSpPr>
+        <p:spPr>
+          <a:xfrm>
+            <a:off x="5669280" y="3639312"/>
+            <a:ext cx="5623560" cy="420624"/>
+          </a:xfrm>
+          <a:prstGeom prst="rect">
+            <a:avLst/>
+          </a:prstGeom>
+          <a:noFill/>
+          <a:ln/>
+        </p:spPr>
+        <p:txBody>
+          <a:bodyPr wrap="square" lIns="0" tIns="0" rIns="0" bIns="0" rtlCol="0" anchor="t"/>
+          <a:lstStyle/>
+          <a:p>
+            <a:pPr algn="l" indent="0" marL="0">
+              <a:lnSpc>
+                <a:spcPct val="100000"/>
+              </a:lnSpc>
+              <a:buNone/>
+            </a:pPr>
+            <a:r>
+              <a:rPr lang="en-US" sz="1250" dirty="0">
+                <a:solidFill>
+                  <a:srgbClr val="2B2B33"/>
+                </a:solidFill>
+                <a:latin typeface="Calibri" pitchFamily="34" charset="0"/>
+                <a:ea typeface="Calibri" pitchFamily="34" charset="-122"/>
+                <a:cs typeface="Calibri" pitchFamily="34" charset="-120"/>
+              </a:rPr>
+              <a:t>No thrill; no other palpable sounds</a:t>
+            </a:r>
+            <a:endParaRPr lang="en-US" sz="1250" dirty="0"/>
+          </a:p>
+        </p:txBody>
+      </p:sp>
+      <p:sp>
+        <p:nvSpPr>
+          <p:cNvPr id="30" name="Shape 24"/>
+          <p:cNvSpPr/>
+          <p:nvPr/>
+        </p:nvSpPr>
+        <p:spPr>
+          <a:xfrm>
+            <a:off x="5394960" y="4023360"/>
+            <a:ext cx="118872" cy="118872"/>
+          </a:xfrm>
+          <a:prstGeom prst="ellipse">
+            <a:avLst/>
+          </a:prstGeom>
+          <a:solidFill>
+            <a:srgbClr val="FF4D6D"/>
+          </a:solidFill>
+          <a:ln/>
+        </p:spPr>
+      </p:sp>
+      <p:sp>
+        <p:nvSpPr>
+          <p:cNvPr id="31" name="Text 25"/>
+          <p:cNvSpPr/>
+          <p:nvPr/>
+        </p:nvSpPr>
+        <p:spPr>
+          <a:xfrm>
+            <a:off x="5669280" y="3950208"/>
+            <a:ext cx="5623560" cy="420624"/>
+          </a:xfrm>
+          <a:prstGeom prst="rect">
+            <a:avLst/>
+          </a:prstGeom>
+          <a:noFill/>
+          <a:ln/>
+        </p:spPr>
+        <p:txBody>
+          <a:bodyPr wrap="square" lIns="0" tIns="0" rIns="0" bIns="0" rtlCol="0" anchor="t"/>
+          <a:lstStyle/>
+          <a:p>
+            <a:pPr algn="l" indent="0" marL="0">
+              <a:lnSpc>
+                <a:spcPct val="100000"/>
+              </a:lnSpc>
+              <a:buNone/>
+            </a:pPr>
+            <a:r>
+              <a:rPr lang="en-US" sz="1250" dirty="0">
+                <a:solidFill>
+                  <a:srgbClr val="2B2B33"/>
+                </a:solidFill>
+                <a:latin typeface="Calibri" pitchFamily="34" charset="0"/>
+                <a:ea typeface="Calibri" pitchFamily="34" charset="-122"/>
+                <a:cs typeface="Calibri" pitchFamily="34" charset="-120"/>
+              </a:rPr>
+              <a:t>No left parasternal heave</a:t>
+            </a:r>
+            <a:endParaRPr lang="en-US" sz="1250" dirty="0"/>
+          </a:p>
+        </p:txBody>
+      </p:sp>
+      <p:sp>
+        <p:nvSpPr>
+          <p:cNvPr id="32" name="Shape 26"/>
+          <p:cNvSpPr/>
+          <p:nvPr/>
+        </p:nvSpPr>
+        <p:spPr>
+          <a:xfrm>
+            <a:off x="4937760" y="4297680"/>
+            <a:ext cx="6766560" cy="1691640"/>
           </a:xfrm>
           <a:prstGeom prst="roundRect">
             <a:avLst>
-              <a:gd name="adj" fmla="val 4000"/>
+              <a:gd name="adj" fmla="val 5405"/>
             </a:avLst>
           </a:prstGeom>
           <a:solidFill>
@@ -6837,14 +6987,14 @@
       </p:sp>
       <p:sp>
         <p:nvSpPr>
-          <p:cNvPr id="28" name="Shape 22"/>
-          <p:cNvSpPr/>
-          <p:nvPr/>
-        </p:nvSpPr>
-        <p:spPr>
-          <a:xfrm>
-            <a:off x="5212080" y="3941064"/>
-            <a:ext cx="603504" cy="603504"/>
+          <p:cNvPr id="33" name="Shape 27"/>
+          <p:cNvSpPr/>
+          <p:nvPr/>
+        </p:nvSpPr>
+        <p:spPr>
+          <a:xfrm>
+            <a:off x="5212080" y="4462272"/>
+            <a:ext cx="548640" cy="548640"/>
           </a:xfrm>
           <a:prstGeom prst="ellipse">
             <a:avLst/>
@@ -6862,7 +7012,7 @@
       </p:sp>
       <p:pic>
         <p:nvPicPr>
-          <p:cNvPr id="29" name="Image 4" descr="preencoded.png">    </p:cNvPr>
+          <p:cNvPr id="34" name="Image 4" descr="preencoded.png">    </p:cNvPr>
           <p:cNvPicPr>
             <a:picLocks noChangeAspect="1"/>
           </p:cNvPicPr>
@@ -6876,8 +7026,8 @@
         </p:blipFill>
         <p:spPr>
           <a:xfrm>
-            <a:off x="5367528" y="4096512"/>
-            <a:ext cx="292608" cy="292608"/>
+            <a:off x="5349240" y="4599432"/>
+            <a:ext cx="274320" cy="274320"/>
           </a:xfrm>
           <a:prstGeom prst="rect">
             <a:avLst/>
@@ -6886,14 +7036,14 @@
       </p:pic>
       <p:sp>
         <p:nvSpPr>
-          <p:cNvPr id="30" name="Text 23"/>
-          <p:cNvSpPr/>
-          <p:nvPr/>
-        </p:nvSpPr>
-        <p:spPr>
-          <a:xfrm>
-            <a:off x="5961888" y="4041648"/>
-            <a:ext cx="5486400" cy="292608"/>
+          <p:cNvPr id="35" name="Text 28"/>
+          <p:cNvSpPr/>
+          <p:nvPr/>
+        </p:nvSpPr>
+        <p:spPr>
+          <a:xfrm>
+            <a:off x="5925312" y="4498848"/>
+            <a:ext cx="5577840" cy="274320"/>
           </a:xfrm>
           <a:prstGeom prst="rect">
             <a:avLst/>
@@ -6909,7 +7059,7 @@
               <a:buNone/>
             </a:pPr>
             <a:r>
-              <a:rPr lang="en-US" sz="1250" b="1" spc="120" kern="0" dirty="0">
+              <a:rPr lang="en-US" sz="1200" b="1" spc="120" kern="0" dirty="0">
                 <a:solidFill>
                   <a:srgbClr val="A4133C"/>
                 </a:solidFill>
@@ -6919,20 +7069,20 @@
               </a:rPr>
               <a:t>AUSCULTATION</a:t>
             </a:r>
-            <a:endParaRPr lang="en-US" sz="1250" dirty="0"/>
-          </a:p>
-        </p:txBody>
-      </p:sp>
-      <p:sp>
-        <p:nvSpPr>
-          <p:cNvPr id="31" name="Shape 24"/>
-          <p:cNvSpPr/>
-          <p:nvPr/>
-        </p:nvSpPr>
-        <p:spPr>
-          <a:xfrm>
-            <a:off x="5394960" y="4718304"/>
-            <a:ext cx="128016" cy="128016"/>
+            <a:endParaRPr lang="en-US" sz="1200" dirty="0"/>
+          </a:p>
+        </p:txBody>
+      </p:sp>
+      <p:sp>
+        <p:nvSpPr>
+          <p:cNvPr id="36" name="Shape 29"/>
+          <p:cNvSpPr/>
+          <p:nvPr/>
+        </p:nvSpPr>
+        <p:spPr>
+          <a:xfrm>
+            <a:off x="5394960" y="4901184"/>
+            <a:ext cx="118872" cy="118872"/>
           </a:xfrm>
           <a:prstGeom prst="ellipse">
             <a:avLst/>
@@ -6945,14 +7095,14 @@
       </p:sp>
       <p:sp>
         <p:nvSpPr>
-          <p:cNvPr id="32" name="Text 25"/>
-          <p:cNvSpPr/>
-          <p:nvPr/>
-        </p:nvSpPr>
-        <p:spPr>
-          <a:xfrm>
-            <a:off x="5687568" y="4636008"/>
-            <a:ext cx="5596128" cy="457200"/>
+          <p:cNvPr id="37" name="Text 30"/>
+          <p:cNvSpPr/>
+          <p:nvPr/>
+        </p:nvSpPr>
+        <p:spPr>
+          <a:xfrm>
+            <a:off x="5669280" y="4828032"/>
+            <a:ext cx="5623560" cy="420624"/>
           </a:xfrm>
           <a:prstGeom prst="rect">
             <a:avLst/>
@@ -6987,14 +7137,14 @@
       </p:sp>
       <p:sp>
         <p:nvSpPr>
-          <p:cNvPr id="33" name="Shape 26"/>
-          <p:cNvSpPr/>
-          <p:nvPr/>
-        </p:nvSpPr>
-        <p:spPr>
-          <a:xfrm>
-            <a:off x="5394960" y="5175504"/>
-            <a:ext cx="128016" cy="128016"/>
+          <p:cNvPr id="38" name="Shape 31"/>
+          <p:cNvSpPr/>
+          <p:nvPr/>
+        </p:nvSpPr>
+        <p:spPr>
+          <a:xfrm>
+            <a:off x="5394960" y="5340096"/>
+            <a:ext cx="118872" cy="118872"/>
           </a:xfrm>
           <a:prstGeom prst="ellipse">
             <a:avLst/>
@@ -7007,14 +7157,14 @@
       </p:sp>
       <p:sp>
         <p:nvSpPr>
-          <p:cNvPr id="34" name="Text 27"/>
-          <p:cNvSpPr/>
-          <p:nvPr/>
-        </p:nvSpPr>
-        <p:spPr>
-          <a:xfrm>
-            <a:off x="5687568" y="5093208"/>
-            <a:ext cx="5596128" cy="457200"/>
+          <p:cNvPr id="39" name="Text 32"/>
+          <p:cNvSpPr/>
+          <p:nvPr/>
+        </p:nvSpPr>
+        <p:spPr>
+          <a:xfrm>
+            <a:off x="5669280" y="5266944"/>
+            <a:ext cx="5623560" cy="420624"/>
           </a:xfrm>
           <a:prstGeom prst="rect">
             <a:avLst/>
@@ -7049,14 +7199,14 @@
       </p:sp>
       <p:sp>
         <p:nvSpPr>
-          <p:cNvPr id="35" name="Shape 28"/>
-          <p:cNvSpPr/>
-          <p:nvPr/>
-        </p:nvSpPr>
-        <p:spPr>
-          <a:xfrm>
-            <a:off x="5394960" y="5632704"/>
-            <a:ext cx="128016" cy="128016"/>
+          <p:cNvPr id="40" name="Shape 33"/>
+          <p:cNvSpPr/>
+          <p:nvPr/>
+        </p:nvSpPr>
+        <p:spPr>
+          <a:xfrm>
+            <a:off x="5394960" y="5779008"/>
+            <a:ext cx="118872" cy="118872"/>
           </a:xfrm>
           <a:prstGeom prst="ellipse">
             <a:avLst/>
@@ -7069,14 +7219,14 @@
       </p:sp>
       <p:sp>
         <p:nvSpPr>
-          <p:cNvPr id="36" name="Text 29"/>
-          <p:cNvSpPr/>
-          <p:nvPr/>
-        </p:nvSpPr>
-        <p:spPr>
-          <a:xfrm>
-            <a:off x="5687568" y="5550408"/>
-            <a:ext cx="5596128" cy="457200"/>
+          <p:cNvPr id="41" name="Text 34"/>
+          <p:cNvSpPr/>
+          <p:nvPr/>
+        </p:nvSpPr>
+        <p:spPr>
+          <a:xfrm>
+            <a:off x="5669280" y="5705856"/>
+            <a:ext cx="5623560" cy="420624"/>
           </a:xfrm>
           <a:prstGeom prst="rect">
             <a:avLst/>
@@ -7111,7 +7261,7 @@
       </p:sp>
       <p:sp>
         <p:nvSpPr>
-          <p:cNvPr id="37" name="Text 30"/>
+          <p:cNvPr id="42" name="Text 35"/>
           <p:cNvSpPr/>
           <p:nvPr/>
         </p:nvSpPr>
@@ -7150,7 +7300,7 @@
       </p:sp>
       <p:sp>
         <p:nvSpPr>
-          <p:cNvPr id="38" name="Text 31"/>
+          <p:cNvPr id="43" name="Text 36"/>
           <p:cNvSpPr/>
           <p:nvPr/>
         </p:nvSpPr>

</xml_diff>

<commit_message>
Add vital signs to GPE slide
Redesign the general physical examination slide around vital signs: five
stat tiles (HR 136, radial pulse 96, BP 110/70, temp 98F, RR 14), a
pulse-deficit highlight (~40 bpm apex-radial — an AF hallmark), and
detail cards for pulse character, blood pressure and general findings.

Co-Authored-By: Claude Opus 4.8 <noreply@anthropic.com>
Claude-Session: https://claude.ai/code/session_01S7QW8AwqyMReKwuqyBkBBv
</commit_message>
<xml_diff>
--- a/presentations/Clinicopathological-Conference-COMPLETE.pptx
+++ b/presentations/Clinicopathological-Conference-COMPLETE.pptx
@@ -5436,12 +5436,12 @@
         </p:nvSpPr>
         <p:spPr>
           <a:xfrm>
-            <a:off x="502920" y="1920240"/>
-            <a:ext cx="3611880" cy="4023360"/>
+            <a:off x="502920" y="1463040"/>
+            <a:ext cx="2084832" cy="1261872"/>
           </a:xfrm>
           <a:prstGeom prst="roundRect">
             <a:avLst>
-              <a:gd name="adj" fmla="val 3038"/>
+              <a:gd name="adj" fmla="val 7246"/>
             </a:avLst>
           </a:prstGeom>
           <a:solidFill>
@@ -5464,63 +5464,14 @@
       </p:sp>
       <p:sp>
         <p:nvSpPr>
-          <p:cNvPr id="7" name="Shape 4"/>
-          <p:cNvSpPr/>
-          <p:nvPr/>
-        </p:nvSpPr>
-        <p:spPr>
-          <a:xfrm>
-            <a:off x="868680" y="2331720"/>
-            <a:ext cx="1051560" cy="1051560"/>
-          </a:xfrm>
-          <a:prstGeom prst="ellipse">
-            <a:avLst/>
-          </a:prstGeom>
-          <a:solidFill>
-            <a:srgbClr val="FFFFFF"/>
-          </a:solidFill>
-          <a:ln w="12700">
-            <a:solidFill>
-              <a:srgbClr val="FBD8DF"/>
-            </a:solidFill>
-            <a:prstDash val="solid"/>
-          </a:ln>
-        </p:spPr>
-      </p:sp>
-      <p:pic>
-        <p:nvPicPr>
-          <p:cNvPr id="8" name="Image 1" descr="preencoded.png">    </p:cNvPr>
-          <p:cNvPicPr>
-            <a:picLocks noChangeAspect="1"/>
-          </p:cNvPicPr>
-          <p:nvPr/>
-        </p:nvPicPr>
-        <p:blipFill>
-          <a:blip r:embed="rId2"/>
-          <a:stretch>
-            <a:fillRect/>
-          </a:stretch>
-        </p:blipFill>
-        <p:spPr>
-          <a:xfrm>
-            <a:off x="1161288" y="2624328"/>
-            <a:ext cx="466344" cy="466344"/>
-          </a:xfrm>
-          <a:prstGeom prst="rect">
-            <a:avLst/>
-          </a:prstGeom>
-        </p:spPr>
-      </p:pic>
-      <p:sp>
-        <p:nvSpPr>
-          <p:cNvPr id="9" name="Text 5"/>
-          <p:cNvSpPr/>
-          <p:nvPr/>
-        </p:nvSpPr>
-        <p:spPr>
-          <a:xfrm>
-            <a:off x="3063240" y="2286000"/>
-            <a:ext cx="822960" cy="640080"/>
+          <p:cNvPr id="7" name="Text 4"/>
+          <p:cNvSpPr/>
+          <p:nvPr/>
+        </p:nvSpPr>
+        <p:spPr>
+          <a:xfrm>
+            <a:off x="612648" y="1609344"/>
+            <a:ext cx="1865376" cy="237744"/>
           </a:xfrm>
           <a:prstGeom prst="rect">
             <a:avLst/>
@@ -5532,322 +5483,116 @@
           <a:bodyPr wrap="square" lIns="0" tIns="0" rIns="0" bIns="0" rtlCol="0" anchor="t"/>
           <a:lstStyle/>
           <a:p>
-            <a:pPr algn="r" indent="0" marL="0">
-              <a:buNone/>
-            </a:pPr>
-            <a:r>
-              <a:rPr lang="en-US" sz="4000" b="1" dirty="0">
-                <a:solidFill>
-                  <a:srgbClr val="FBD8DF"/>
+            <a:pPr algn="ctr" indent="0" marL="0">
+              <a:buNone/>
+            </a:pPr>
+            <a:r>
+              <a:rPr lang="en-US" sz="1000" b="1" spc="80" kern="0" dirty="0">
+                <a:solidFill>
+                  <a:srgbClr val="A4133C"/>
+                </a:solidFill>
+                <a:latin typeface="Calibri" pitchFamily="34" charset="0"/>
+                <a:ea typeface="Calibri" pitchFamily="34" charset="-122"/>
+                <a:cs typeface="Calibri" pitchFamily="34" charset="-120"/>
+              </a:rPr>
+              <a:t>HEART RATE</a:t>
+            </a:r>
+            <a:endParaRPr lang="en-US" sz="1000" dirty="0"/>
+          </a:p>
+        </p:txBody>
+      </p:sp>
+      <p:sp>
+        <p:nvSpPr>
+          <p:cNvPr id="8" name="Text 5"/>
+          <p:cNvSpPr/>
+          <p:nvPr/>
+        </p:nvSpPr>
+        <p:spPr>
+          <a:xfrm>
+            <a:off x="576072" y="1847088"/>
+            <a:ext cx="1938528" cy="548640"/>
+          </a:xfrm>
+          <a:prstGeom prst="rect">
+            <a:avLst/>
+          </a:prstGeom>
+          <a:noFill/>
+          <a:ln/>
+        </p:spPr>
+        <p:txBody>
+          <a:bodyPr wrap="square" lIns="0" tIns="0" rIns="0" bIns="0" rtlCol="0" anchor="ctr"/>
+          <a:lstStyle/>
+          <a:p>
+            <a:pPr algn="ctr" indent="0" marL="0">
+              <a:buNone/>
+            </a:pPr>
+            <a:r>
+              <a:rPr lang="en-US" sz="3200" b="1" dirty="0">
+                <a:solidFill>
+                  <a:srgbClr val="FF4D6D"/>
                 </a:solidFill>
                 <a:latin typeface="Cambria" pitchFamily="34" charset="0"/>
                 <a:ea typeface="Cambria" pitchFamily="34" charset="-122"/>
                 <a:cs typeface="Cambria" pitchFamily="34" charset="-120"/>
               </a:rPr>
-              <a:t>01</a:t>
-            </a:r>
-            <a:endParaRPr lang="en-US" sz="4000" dirty="0"/>
-          </a:p>
-        </p:txBody>
-      </p:sp>
-      <p:sp>
-        <p:nvSpPr>
-          <p:cNvPr id="10" name="Text 6"/>
-          <p:cNvSpPr/>
-          <p:nvPr/>
-        </p:nvSpPr>
-        <p:spPr>
-          <a:xfrm>
-            <a:off x="886968" y="3703320"/>
-            <a:ext cx="2971800" cy="292608"/>
-          </a:xfrm>
-          <a:prstGeom prst="rect">
-            <a:avLst/>
-          </a:prstGeom>
-          <a:noFill/>
-          <a:ln/>
-        </p:spPr>
-        <p:txBody>
-          <a:bodyPr wrap="square" rtlCol="0" anchor="t"/>
-          <a:lstStyle/>
-          <a:p>
-            <a:pPr algn="l" indent="0" marL="0">
-              <a:buNone/>
-            </a:pPr>
-            <a:r>
-              <a:rPr lang="en-US" sz="1300" b="1" spc="120" kern="0" dirty="0">
-                <a:solidFill>
-                  <a:srgbClr val="A4133C"/>
-                </a:solidFill>
-                <a:latin typeface="Calibri" pitchFamily="34" charset="0"/>
-                <a:ea typeface="Calibri" pitchFamily="34" charset="-122"/>
-                <a:cs typeface="Calibri" pitchFamily="34" charset="-120"/>
-              </a:rPr>
-              <a:t>BUILD</a:t>
-            </a:r>
-            <a:endParaRPr lang="en-US" sz="1300" dirty="0"/>
-          </a:p>
-        </p:txBody>
-      </p:sp>
-      <p:sp>
-        <p:nvSpPr>
-          <p:cNvPr id="11" name="Text 7"/>
-          <p:cNvSpPr/>
-          <p:nvPr/>
-        </p:nvSpPr>
-        <p:spPr>
-          <a:xfrm>
-            <a:off x="886968" y="4069080"/>
-            <a:ext cx="2880360" cy="1554480"/>
-          </a:xfrm>
-          <a:prstGeom prst="rect">
-            <a:avLst/>
-          </a:prstGeom>
-          <a:noFill/>
-          <a:ln/>
-        </p:spPr>
-        <p:txBody>
-          <a:bodyPr wrap="square" rtlCol="0" anchor="t"/>
-          <a:lstStyle/>
-          <a:p>
-            <a:pPr algn="l" indent="0" marL="0">
-              <a:lnSpc>
-                <a:spcPct val="115000"/>
-              </a:lnSpc>
-              <a:buNone/>
-            </a:pPr>
-            <a:r>
-              <a:rPr lang="en-US" sz="1650" dirty="0">
-                <a:solidFill>
-                  <a:srgbClr val="2B2B33"/>
-                </a:solidFill>
-                <a:latin typeface="Calibri" pitchFamily="34" charset="0"/>
-                <a:ea typeface="Calibri" pitchFamily="34" charset="-122"/>
-                <a:cs typeface="Calibri" pitchFamily="34" charset="-120"/>
-              </a:rPr>
-              <a:t>Thin, lean, middle-aged female lying comfortably in bed</a:t>
-            </a:r>
-            <a:endParaRPr lang="en-US" sz="1650" dirty="0"/>
-          </a:p>
-        </p:txBody>
-      </p:sp>
-      <p:sp>
-        <p:nvSpPr>
-          <p:cNvPr id="12" name="Shape 8"/>
-          <p:cNvSpPr/>
-          <p:nvPr/>
-        </p:nvSpPr>
-        <p:spPr>
-          <a:xfrm>
-            <a:off x="4407408" y="1920240"/>
-            <a:ext cx="3611880" cy="4023360"/>
+              <a:t>136</a:t>
+            </a:r>
+            <a:endParaRPr lang="en-US" sz="3200" dirty="0"/>
+          </a:p>
+        </p:txBody>
+      </p:sp>
+      <p:sp>
+        <p:nvSpPr>
+          <p:cNvPr id="9" name="Text 6"/>
+          <p:cNvSpPr/>
+          <p:nvPr/>
+        </p:nvSpPr>
+        <p:spPr>
+          <a:xfrm>
+            <a:off x="612648" y="2414016"/>
+            <a:ext cx="1865376" cy="219456"/>
+          </a:xfrm>
+          <a:prstGeom prst="rect">
+            <a:avLst/>
+          </a:prstGeom>
+          <a:noFill/>
+          <a:ln/>
+        </p:spPr>
+        <p:txBody>
+          <a:bodyPr wrap="square" lIns="0" tIns="0" rIns="0" bIns="0" rtlCol="0" anchor="t"/>
+          <a:lstStyle/>
+          <a:p>
+            <a:pPr algn="ctr" indent="0" marL="0">
+              <a:buNone/>
+            </a:pPr>
+            <a:r>
+              <a:rPr lang="en-US" sz="1150" dirty="0">
+                <a:solidFill>
+                  <a:srgbClr val="6B6B76"/>
+                </a:solidFill>
+                <a:latin typeface="Calibri" pitchFamily="34" charset="0"/>
+                <a:ea typeface="Calibri" pitchFamily="34" charset="-122"/>
+                <a:cs typeface="Calibri" pitchFamily="34" charset="-120"/>
+              </a:rPr>
+              <a:t>bpm</a:t>
+            </a:r>
+            <a:endParaRPr lang="en-US" sz="1150" dirty="0"/>
+          </a:p>
+        </p:txBody>
+      </p:sp>
+      <p:sp>
+        <p:nvSpPr>
+          <p:cNvPr id="10" name="Shape 7"/>
+          <p:cNvSpPr/>
+          <p:nvPr/>
+        </p:nvSpPr>
+        <p:spPr>
+          <a:xfrm>
+            <a:off x="2761488" y="1463040"/>
+            <a:ext cx="2084832" cy="1261872"/>
           </a:xfrm>
           <a:prstGeom prst="roundRect">
             <a:avLst>
-              <a:gd name="adj" fmla="val 3038"/>
-            </a:avLst>
-          </a:prstGeom>
-          <a:solidFill>
-            <a:srgbClr val="590D22"/>
-          </a:solidFill>
-          <a:ln w="12700">
-            <a:solidFill>
-              <a:srgbClr val="FBD8DF"/>
-            </a:solidFill>
-            <a:prstDash val="solid"/>
-          </a:ln>
-          <a:effectLst>
-            <a:outerShdw sx="100000" sy="100000" kx="0" ky="0" algn="bl" rotWithShape="0" blurRad="127000" dist="50800" dir="5400000">
-              <a:srgbClr val="C9A3AC">
-                <a:alpha val="45000"/>
-              </a:srgbClr>
-            </a:outerShdw>
-          </a:effectLst>
-        </p:spPr>
-      </p:sp>
-      <p:sp>
-        <p:nvSpPr>
-          <p:cNvPr id="13" name="Shape 9"/>
-          <p:cNvSpPr/>
-          <p:nvPr/>
-        </p:nvSpPr>
-        <p:spPr>
-          <a:xfrm>
-            <a:off x="4773168" y="2331720"/>
-            <a:ext cx="1051560" cy="1051560"/>
-          </a:xfrm>
-          <a:prstGeom prst="ellipse">
-            <a:avLst/>
-          </a:prstGeom>
-          <a:solidFill>
-            <a:srgbClr val="A4133C"/>
-          </a:solidFill>
-          <a:ln w="12700">
-            <a:solidFill>
-              <a:srgbClr val="FBD8DF"/>
-            </a:solidFill>
-            <a:prstDash val="solid"/>
-          </a:ln>
-        </p:spPr>
-      </p:sp>
-      <p:pic>
-        <p:nvPicPr>
-          <p:cNvPr id="14" name="Image 2" descr="preencoded.png">    </p:cNvPr>
-          <p:cNvPicPr>
-            <a:picLocks noChangeAspect="1"/>
-          </p:cNvPicPr>
-          <p:nvPr/>
-        </p:nvPicPr>
-        <p:blipFill>
-          <a:blip r:embed="rId3"/>
-          <a:stretch>
-            <a:fillRect/>
-          </a:stretch>
-        </p:blipFill>
-        <p:spPr>
-          <a:xfrm>
-            <a:off x="5065776" y="2624328"/>
-            <a:ext cx="466344" cy="466344"/>
-          </a:xfrm>
-          <a:prstGeom prst="rect">
-            <a:avLst/>
-          </a:prstGeom>
-        </p:spPr>
-      </p:pic>
-      <p:sp>
-        <p:nvSpPr>
-          <p:cNvPr id="15" name="Text 10"/>
-          <p:cNvSpPr/>
-          <p:nvPr/>
-        </p:nvSpPr>
-        <p:spPr>
-          <a:xfrm>
-            <a:off x="6967728" y="2286000"/>
-            <a:ext cx="822960" cy="640080"/>
-          </a:xfrm>
-          <a:prstGeom prst="rect">
-            <a:avLst/>
-          </a:prstGeom>
-          <a:noFill/>
-          <a:ln/>
-        </p:spPr>
-        <p:txBody>
-          <a:bodyPr wrap="square" lIns="0" tIns="0" rIns="0" bIns="0" rtlCol="0" anchor="t"/>
-          <a:lstStyle/>
-          <a:p>
-            <a:pPr algn="r" indent="0" marL="0">
-              <a:buNone/>
-            </a:pPr>
-            <a:r>
-              <a:rPr lang="en-US" sz="4000" b="1" dirty="0">
-                <a:solidFill>
-                  <a:srgbClr val="7A2233"/>
-                </a:solidFill>
-                <a:latin typeface="Cambria" pitchFamily="34" charset="0"/>
-                <a:ea typeface="Cambria" pitchFamily="34" charset="-122"/>
-                <a:cs typeface="Cambria" pitchFamily="34" charset="-120"/>
-              </a:rPr>
-              <a:t>02</a:t>
-            </a:r>
-            <a:endParaRPr lang="en-US" sz="4000" dirty="0"/>
-          </a:p>
-        </p:txBody>
-      </p:sp>
-      <p:sp>
-        <p:nvSpPr>
-          <p:cNvPr id="16" name="Text 11"/>
-          <p:cNvSpPr/>
-          <p:nvPr/>
-        </p:nvSpPr>
-        <p:spPr>
-          <a:xfrm>
-            <a:off x="4791456" y="3703320"/>
-            <a:ext cx="2971800" cy="292608"/>
-          </a:xfrm>
-          <a:prstGeom prst="rect">
-            <a:avLst/>
-          </a:prstGeom>
-          <a:noFill/>
-          <a:ln/>
-        </p:spPr>
-        <p:txBody>
-          <a:bodyPr wrap="square" rtlCol="0" anchor="t"/>
-          <a:lstStyle/>
-          <a:p>
-            <a:pPr algn="l" indent="0" marL="0">
-              <a:buNone/>
-            </a:pPr>
-            <a:r>
-              <a:rPr lang="en-US" sz="1300" b="1" spc="120" kern="0" dirty="0">
-                <a:solidFill>
-                  <a:srgbClr val="FF4D6D"/>
-                </a:solidFill>
-                <a:latin typeface="Calibri" pitchFamily="34" charset="0"/>
-                <a:ea typeface="Calibri" pitchFamily="34" charset="-122"/>
-                <a:cs typeface="Calibri" pitchFamily="34" charset="-120"/>
-              </a:rPr>
-              <a:t>ACCESS</a:t>
-            </a:r>
-            <a:endParaRPr lang="en-US" sz="1300" dirty="0"/>
-          </a:p>
-        </p:txBody>
-      </p:sp>
-      <p:sp>
-        <p:nvSpPr>
-          <p:cNvPr id="17" name="Text 12"/>
-          <p:cNvSpPr/>
-          <p:nvPr/>
-        </p:nvSpPr>
-        <p:spPr>
-          <a:xfrm>
-            <a:off x="4791456" y="4069080"/>
-            <a:ext cx="2880360" cy="1554480"/>
-          </a:xfrm>
-          <a:prstGeom prst="rect">
-            <a:avLst/>
-          </a:prstGeom>
-          <a:noFill/>
-          <a:ln/>
-        </p:spPr>
-        <p:txBody>
-          <a:bodyPr wrap="square" rtlCol="0" anchor="t"/>
-          <a:lstStyle/>
-          <a:p>
-            <a:pPr algn="l" indent="0" marL="0">
-              <a:lnSpc>
-                <a:spcPct val="115000"/>
-              </a:lnSpc>
-              <a:buNone/>
-            </a:pPr>
-            <a:r>
-              <a:rPr lang="en-US" sz="1650" dirty="0">
-                <a:solidFill>
-                  <a:srgbClr val="FFFFFF"/>
-                </a:solidFill>
-                <a:latin typeface="Calibri" pitchFamily="34" charset="0"/>
-                <a:ea typeface="Calibri" pitchFamily="34" charset="-122"/>
-                <a:cs typeface="Calibri" pitchFamily="34" charset="-120"/>
-              </a:rPr>
-              <a:t>IV cannula in situ — right hand</a:t>
-            </a:r>
-            <a:endParaRPr lang="en-US" sz="1650" dirty="0"/>
-          </a:p>
-        </p:txBody>
-      </p:sp>
-      <p:sp>
-        <p:nvSpPr>
-          <p:cNvPr id="18" name="Shape 13"/>
-          <p:cNvSpPr/>
-          <p:nvPr/>
-        </p:nvSpPr>
-        <p:spPr>
-          <a:xfrm>
-            <a:off x="8311896" y="1920240"/>
-            <a:ext cx="3611880" cy="4023360"/>
-          </a:xfrm>
-          <a:prstGeom prst="roundRect">
-            <a:avLst>
-              <a:gd name="adj" fmla="val 3038"/>
+              <a:gd name="adj" fmla="val 7246"/>
             </a:avLst>
           </a:prstGeom>
           <a:solidFill>
@@ -5870,14 +5615,724 @@
       </p:sp>
       <p:sp>
         <p:nvSpPr>
-          <p:cNvPr id="19" name="Shape 14"/>
-          <p:cNvSpPr/>
-          <p:nvPr/>
-        </p:nvSpPr>
-        <p:spPr>
-          <a:xfrm>
-            <a:off x="8677656" y="2331720"/>
-            <a:ext cx="1051560" cy="1051560"/>
+          <p:cNvPr id="11" name="Text 8"/>
+          <p:cNvSpPr/>
+          <p:nvPr/>
+        </p:nvSpPr>
+        <p:spPr>
+          <a:xfrm>
+            <a:off x="2871216" y="1609344"/>
+            <a:ext cx="1865376" cy="237744"/>
+          </a:xfrm>
+          <a:prstGeom prst="rect">
+            <a:avLst/>
+          </a:prstGeom>
+          <a:noFill/>
+          <a:ln/>
+        </p:spPr>
+        <p:txBody>
+          <a:bodyPr wrap="square" lIns="0" tIns="0" rIns="0" bIns="0" rtlCol="0" anchor="t"/>
+          <a:lstStyle/>
+          <a:p>
+            <a:pPr algn="ctr" indent="0" marL="0">
+              <a:buNone/>
+            </a:pPr>
+            <a:r>
+              <a:rPr lang="en-US" sz="1000" b="1" spc="80" kern="0" dirty="0">
+                <a:solidFill>
+                  <a:srgbClr val="A4133C"/>
+                </a:solidFill>
+                <a:latin typeface="Calibri" pitchFamily="34" charset="0"/>
+                <a:ea typeface="Calibri" pitchFamily="34" charset="-122"/>
+                <a:cs typeface="Calibri" pitchFamily="34" charset="-120"/>
+              </a:rPr>
+              <a:t>RADIAL PULSE</a:t>
+            </a:r>
+            <a:endParaRPr lang="en-US" sz="1000" dirty="0"/>
+          </a:p>
+        </p:txBody>
+      </p:sp>
+      <p:sp>
+        <p:nvSpPr>
+          <p:cNvPr id="12" name="Text 9"/>
+          <p:cNvSpPr/>
+          <p:nvPr/>
+        </p:nvSpPr>
+        <p:spPr>
+          <a:xfrm>
+            <a:off x="2834640" y="1847088"/>
+            <a:ext cx="1938528" cy="548640"/>
+          </a:xfrm>
+          <a:prstGeom prst="rect">
+            <a:avLst/>
+          </a:prstGeom>
+          <a:noFill/>
+          <a:ln/>
+        </p:spPr>
+        <p:txBody>
+          <a:bodyPr wrap="square" lIns="0" tIns="0" rIns="0" bIns="0" rtlCol="0" anchor="ctr"/>
+          <a:lstStyle/>
+          <a:p>
+            <a:pPr algn="ctr" indent="0" marL="0">
+              <a:buNone/>
+            </a:pPr>
+            <a:r>
+              <a:rPr lang="en-US" sz="3200" b="1" dirty="0">
+                <a:solidFill>
+                  <a:srgbClr val="2B2B33"/>
+                </a:solidFill>
+                <a:latin typeface="Cambria" pitchFamily="34" charset="0"/>
+                <a:ea typeface="Cambria" pitchFamily="34" charset="-122"/>
+                <a:cs typeface="Cambria" pitchFamily="34" charset="-120"/>
+              </a:rPr>
+              <a:t>96</a:t>
+            </a:r>
+            <a:endParaRPr lang="en-US" sz="3200" dirty="0"/>
+          </a:p>
+        </p:txBody>
+      </p:sp>
+      <p:sp>
+        <p:nvSpPr>
+          <p:cNvPr id="13" name="Text 10"/>
+          <p:cNvSpPr/>
+          <p:nvPr/>
+        </p:nvSpPr>
+        <p:spPr>
+          <a:xfrm>
+            <a:off x="2871216" y="2414016"/>
+            <a:ext cx="1865376" cy="219456"/>
+          </a:xfrm>
+          <a:prstGeom prst="rect">
+            <a:avLst/>
+          </a:prstGeom>
+          <a:noFill/>
+          <a:ln/>
+        </p:spPr>
+        <p:txBody>
+          <a:bodyPr wrap="square" lIns="0" tIns="0" rIns="0" bIns="0" rtlCol="0" anchor="t"/>
+          <a:lstStyle/>
+          <a:p>
+            <a:pPr algn="ctr" indent="0" marL="0">
+              <a:buNone/>
+            </a:pPr>
+            <a:r>
+              <a:rPr lang="en-US" sz="1150" dirty="0">
+                <a:solidFill>
+                  <a:srgbClr val="6B6B76"/>
+                </a:solidFill>
+                <a:latin typeface="Calibri" pitchFamily="34" charset="0"/>
+                <a:ea typeface="Calibri" pitchFamily="34" charset="-122"/>
+                <a:cs typeface="Calibri" pitchFamily="34" charset="-120"/>
+              </a:rPr>
+              <a:t>bpm</a:t>
+            </a:r>
+            <a:endParaRPr lang="en-US" sz="1150" dirty="0"/>
+          </a:p>
+        </p:txBody>
+      </p:sp>
+      <p:sp>
+        <p:nvSpPr>
+          <p:cNvPr id="14" name="Shape 11"/>
+          <p:cNvSpPr/>
+          <p:nvPr/>
+        </p:nvSpPr>
+        <p:spPr>
+          <a:xfrm>
+            <a:off x="5020056" y="1463040"/>
+            <a:ext cx="2084832" cy="1261872"/>
+          </a:xfrm>
+          <a:prstGeom prst="roundRect">
+            <a:avLst>
+              <a:gd name="adj" fmla="val 7246"/>
+            </a:avLst>
+          </a:prstGeom>
+          <a:solidFill>
+            <a:srgbClr val="FFF0F3"/>
+          </a:solidFill>
+          <a:ln w="12700">
+            <a:solidFill>
+              <a:srgbClr val="FBD8DF"/>
+            </a:solidFill>
+            <a:prstDash val="solid"/>
+          </a:ln>
+          <a:effectLst>
+            <a:outerShdw sx="100000" sy="100000" kx="0" ky="0" algn="bl" rotWithShape="0" blurRad="127000" dist="50800" dir="5400000">
+              <a:srgbClr val="C9A3AC">
+                <a:alpha val="45000"/>
+              </a:srgbClr>
+            </a:outerShdw>
+          </a:effectLst>
+        </p:spPr>
+      </p:sp>
+      <p:sp>
+        <p:nvSpPr>
+          <p:cNvPr id="15" name="Text 12"/>
+          <p:cNvSpPr/>
+          <p:nvPr/>
+        </p:nvSpPr>
+        <p:spPr>
+          <a:xfrm>
+            <a:off x="5129784" y="1609344"/>
+            <a:ext cx="1865376" cy="237744"/>
+          </a:xfrm>
+          <a:prstGeom prst="rect">
+            <a:avLst/>
+          </a:prstGeom>
+          <a:noFill/>
+          <a:ln/>
+        </p:spPr>
+        <p:txBody>
+          <a:bodyPr wrap="square" lIns="0" tIns="0" rIns="0" bIns="0" rtlCol="0" anchor="t"/>
+          <a:lstStyle/>
+          <a:p>
+            <a:pPr algn="ctr" indent="0" marL="0">
+              <a:buNone/>
+            </a:pPr>
+            <a:r>
+              <a:rPr lang="en-US" sz="1000" b="1" spc="80" kern="0" dirty="0">
+                <a:solidFill>
+                  <a:srgbClr val="A4133C"/>
+                </a:solidFill>
+                <a:latin typeface="Calibri" pitchFamily="34" charset="0"/>
+                <a:ea typeface="Calibri" pitchFamily="34" charset="-122"/>
+                <a:cs typeface="Calibri" pitchFamily="34" charset="-120"/>
+              </a:rPr>
+              <a:t>BLOOD PRESSURE</a:t>
+            </a:r>
+            <a:endParaRPr lang="en-US" sz="1000" dirty="0"/>
+          </a:p>
+        </p:txBody>
+      </p:sp>
+      <p:sp>
+        <p:nvSpPr>
+          <p:cNvPr id="16" name="Text 13"/>
+          <p:cNvSpPr/>
+          <p:nvPr/>
+        </p:nvSpPr>
+        <p:spPr>
+          <a:xfrm>
+            <a:off x="5093208" y="1847088"/>
+            <a:ext cx="1938528" cy="548640"/>
+          </a:xfrm>
+          <a:prstGeom prst="rect">
+            <a:avLst/>
+          </a:prstGeom>
+          <a:noFill/>
+          <a:ln/>
+        </p:spPr>
+        <p:txBody>
+          <a:bodyPr wrap="square" lIns="0" tIns="0" rIns="0" bIns="0" rtlCol="0" anchor="ctr"/>
+          <a:lstStyle/>
+          <a:p>
+            <a:pPr algn="ctr" indent="0" marL="0">
+              <a:buNone/>
+            </a:pPr>
+            <a:r>
+              <a:rPr lang="en-US" sz="2600" b="1" dirty="0">
+                <a:solidFill>
+                  <a:srgbClr val="2B2B33"/>
+                </a:solidFill>
+                <a:latin typeface="Cambria" pitchFamily="34" charset="0"/>
+                <a:ea typeface="Cambria" pitchFamily="34" charset="-122"/>
+                <a:cs typeface="Cambria" pitchFamily="34" charset="-120"/>
+              </a:rPr>
+              <a:t>110/70</a:t>
+            </a:r>
+            <a:endParaRPr lang="en-US" sz="2600" dirty="0"/>
+          </a:p>
+        </p:txBody>
+      </p:sp>
+      <p:sp>
+        <p:nvSpPr>
+          <p:cNvPr id="17" name="Text 14"/>
+          <p:cNvSpPr/>
+          <p:nvPr/>
+        </p:nvSpPr>
+        <p:spPr>
+          <a:xfrm>
+            <a:off x="5129784" y="2414016"/>
+            <a:ext cx="1865376" cy="219456"/>
+          </a:xfrm>
+          <a:prstGeom prst="rect">
+            <a:avLst/>
+          </a:prstGeom>
+          <a:noFill/>
+          <a:ln/>
+        </p:spPr>
+        <p:txBody>
+          <a:bodyPr wrap="square" lIns="0" tIns="0" rIns="0" bIns="0" rtlCol="0" anchor="t"/>
+          <a:lstStyle/>
+          <a:p>
+            <a:pPr algn="ctr" indent="0" marL="0">
+              <a:buNone/>
+            </a:pPr>
+            <a:r>
+              <a:rPr lang="en-US" sz="1150" dirty="0">
+                <a:solidFill>
+                  <a:srgbClr val="6B6B76"/>
+                </a:solidFill>
+                <a:latin typeface="Calibri" pitchFamily="34" charset="0"/>
+                <a:ea typeface="Calibri" pitchFamily="34" charset="-122"/>
+                <a:cs typeface="Calibri" pitchFamily="34" charset="-120"/>
+              </a:rPr>
+              <a:t>mmHg</a:t>
+            </a:r>
+            <a:endParaRPr lang="en-US" sz="1150" dirty="0"/>
+          </a:p>
+        </p:txBody>
+      </p:sp>
+      <p:sp>
+        <p:nvSpPr>
+          <p:cNvPr id="18" name="Shape 15"/>
+          <p:cNvSpPr/>
+          <p:nvPr/>
+        </p:nvSpPr>
+        <p:spPr>
+          <a:xfrm>
+            <a:off x="7278624" y="1463040"/>
+            <a:ext cx="2084832" cy="1261872"/>
+          </a:xfrm>
+          <a:prstGeom prst="roundRect">
+            <a:avLst>
+              <a:gd name="adj" fmla="val 7246"/>
+            </a:avLst>
+          </a:prstGeom>
+          <a:solidFill>
+            <a:srgbClr val="FFF0F3"/>
+          </a:solidFill>
+          <a:ln w="12700">
+            <a:solidFill>
+              <a:srgbClr val="FBD8DF"/>
+            </a:solidFill>
+            <a:prstDash val="solid"/>
+          </a:ln>
+          <a:effectLst>
+            <a:outerShdw sx="100000" sy="100000" kx="0" ky="0" algn="bl" rotWithShape="0" blurRad="127000" dist="50800" dir="5400000">
+              <a:srgbClr val="C9A3AC">
+                <a:alpha val="45000"/>
+              </a:srgbClr>
+            </a:outerShdw>
+          </a:effectLst>
+        </p:spPr>
+      </p:sp>
+      <p:sp>
+        <p:nvSpPr>
+          <p:cNvPr id="19" name="Text 16"/>
+          <p:cNvSpPr/>
+          <p:nvPr/>
+        </p:nvSpPr>
+        <p:spPr>
+          <a:xfrm>
+            <a:off x="7388352" y="1609344"/>
+            <a:ext cx="1865376" cy="237744"/>
+          </a:xfrm>
+          <a:prstGeom prst="rect">
+            <a:avLst/>
+          </a:prstGeom>
+          <a:noFill/>
+          <a:ln/>
+        </p:spPr>
+        <p:txBody>
+          <a:bodyPr wrap="square" lIns="0" tIns="0" rIns="0" bIns="0" rtlCol="0" anchor="t"/>
+          <a:lstStyle/>
+          <a:p>
+            <a:pPr algn="ctr" indent="0" marL="0">
+              <a:buNone/>
+            </a:pPr>
+            <a:r>
+              <a:rPr lang="en-US" sz="1000" b="1" spc="80" kern="0" dirty="0">
+                <a:solidFill>
+                  <a:srgbClr val="A4133C"/>
+                </a:solidFill>
+                <a:latin typeface="Calibri" pitchFamily="34" charset="0"/>
+                <a:ea typeface="Calibri" pitchFamily="34" charset="-122"/>
+                <a:cs typeface="Calibri" pitchFamily="34" charset="-120"/>
+              </a:rPr>
+              <a:t>TEMPERATURE</a:t>
+            </a:r>
+            <a:endParaRPr lang="en-US" sz="1000" dirty="0"/>
+          </a:p>
+        </p:txBody>
+      </p:sp>
+      <p:sp>
+        <p:nvSpPr>
+          <p:cNvPr id="20" name="Text 17"/>
+          <p:cNvSpPr/>
+          <p:nvPr/>
+        </p:nvSpPr>
+        <p:spPr>
+          <a:xfrm>
+            <a:off x="7351776" y="1847088"/>
+            <a:ext cx="1938528" cy="548640"/>
+          </a:xfrm>
+          <a:prstGeom prst="rect">
+            <a:avLst/>
+          </a:prstGeom>
+          <a:noFill/>
+          <a:ln/>
+        </p:spPr>
+        <p:txBody>
+          <a:bodyPr wrap="square" lIns="0" tIns="0" rIns="0" bIns="0" rtlCol="0" anchor="ctr"/>
+          <a:lstStyle/>
+          <a:p>
+            <a:pPr algn="ctr" indent="0" marL="0">
+              <a:buNone/>
+            </a:pPr>
+            <a:r>
+              <a:rPr lang="en-US" sz="3200" b="1" dirty="0">
+                <a:solidFill>
+                  <a:srgbClr val="2B2B33"/>
+                </a:solidFill>
+                <a:latin typeface="Cambria" pitchFamily="34" charset="0"/>
+                <a:ea typeface="Cambria" pitchFamily="34" charset="-122"/>
+                <a:cs typeface="Cambria" pitchFamily="34" charset="-120"/>
+              </a:rPr>
+              <a:t>98</a:t>
+            </a:r>
+            <a:endParaRPr lang="en-US" sz="3200" dirty="0"/>
+          </a:p>
+        </p:txBody>
+      </p:sp>
+      <p:sp>
+        <p:nvSpPr>
+          <p:cNvPr id="21" name="Text 18"/>
+          <p:cNvSpPr/>
+          <p:nvPr/>
+        </p:nvSpPr>
+        <p:spPr>
+          <a:xfrm>
+            <a:off x="7388352" y="2414016"/>
+            <a:ext cx="1865376" cy="219456"/>
+          </a:xfrm>
+          <a:prstGeom prst="rect">
+            <a:avLst/>
+          </a:prstGeom>
+          <a:noFill/>
+          <a:ln/>
+        </p:spPr>
+        <p:txBody>
+          <a:bodyPr wrap="square" lIns="0" tIns="0" rIns="0" bIns="0" rtlCol="0" anchor="t"/>
+          <a:lstStyle/>
+          <a:p>
+            <a:pPr algn="ctr" indent="0" marL="0">
+              <a:buNone/>
+            </a:pPr>
+            <a:r>
+              <a:rPr lang="en-US" sz="1150" dirty="0">
+                <a:solidFill>
+                  <a:srgbClr val="6B6B76"/>
+                </a:solidFill>
+                <a:latin typeface="Calibri" pitchFamily="34" charset="0"/>
+                <a:ea typeface="Calibri" pitchFamily="34" charset="-122"/>
+                <a:cs typeface="Calibri" pitchFamily="34" charset="-120"/>
+              </a:rPr>
+              <a:t>°F</a:t>
+            </a:r>
+            <a:endParaRPr lang="en-US" sz="1150" dirty="0"/>
+          </a:p>
+        </p:txBody>
+      </p:sp>
+      <p:sp>
+        <p:nvSpPr>
+          <p:cNvPr id="22" name="Shape 19"/>
+          <p:cNvSpPr/>
+          <p:nvPr/>
+        </p:nvSpPr>
+        <p:spPr>
+          <a:xfrm>
+            <a:off x="9537192" y="1463040"/>
+            <a:ext cx="2084832" cy="1261872"/>
+          </a:xfrm>
+          <a:prstGeom prst="roundRect">
+            <a:avLst>
+              <a:gd name="adj" fmla="val 7246"/>
+            </a:avLst>
+          </a:prstGeom>
+          <a:solidFill>
+            <a:srgbClr val="FFF0F3"/>
+          </a:solidFill>
+          <a:ln w="12700">
+            <a:solidFill>
+              <a:srgbClr val="FBD8DF"/>
+            </a:solidFill>
+            <a:prstDash val="solid"/>
+          </a:ln>
+          <a:effectLst>
+            <a:outerShdw sx="100000" sy="100000" kx="0" ky="0" algn="bl" rotWithShape="0" blurRad="127000" dist="50800" dir="5400000">
+              <a:srgbClr val="C9A3AC">
+                <a:alpha val="45000"/>
+              </a:srgbClr>
+            </a:outerShdw>
+          </a:effectLst>
+        </p:spPr>
+      </p:sp>
+      <p:sp>
+        <p:nvSpPr>
+          <p:cNvPr id="23" name="Text 20"/>
+          <p:cNvSpPr/>
+          <p:nvPr/>
+        </p:nvSpPr>
+        <p:spPr>
+          <a:xfrm>
+            <a:off x="9646920" y="1609344"/>
+            <a:ext cx="1865376" cy="237744"/>
+          </a:xfrm>
+          <a:prstGeom prst="rect">
+            <a:avLst/>
+          </a:prstGeom>
+          <a:noFill/>
+          <a:ln/>
+        </p:spPr>
+        <p:txBody>
+          <a:bodyPr wrap="square" lIns="0" tIns="0" rIns="0" bIns="0" rtlCol="0" anchor="t"/>
+          <a:lstStyle/>
+          <a:p>
+            <a:pPr algn="ctr" indent="0" marL="0">
+              <a:buNone/>
+            </a:pPr>
+            <a:r>
+              <a:rPr lang="en-US" sz="1000" b="1" spc="80" kern="0" dirty="0">
+                <a:solidFill>
+                  <a:srgbClr val="A4133C"/>
+                </a:solidFill>
+                <a:latin typeface="Calibri" pitchFamily="34" charset="0"/>
+                <a:ea typeface="Calibri" pitchFamily="34" charset="-122"/>
+                <a:cs typeface="Calibri" pitchFamily="34" charset="-120"/>
+              </a:rPr>
+              <a:t>RESP. RATE</a:t>
+            </a:r>
+            <a:endParaRPr lang="en-US" sz="1000" dirty="0"/>
+          </a:p>
+        </p:txBody>
+      </p:sp>
+      <p:sp>
+        <p:nvSpPr>
+          <p:cNvPr id="24" name="Text 21"/>
+          <p:cNvSpPr/>
+          <p:nvPr/>
+        </p:nvSpPr>
+        <p:spPr>
+          <a:xfrm>
+            <a:off x="9610344" y="1847088"/>
+            <a:ext cx="1938528" cy="548640"/>
+          </a:xfrm>
+          <a:prstGeom prst="rect">
+            <a:avLst/>
+          </a:prstGeom>
+          <a:noFill/>
+          <a:ln/>
+        </p:spPr>
+        <p:txBody>
+          <a:bodyPr wrap="square" lIns="0" tIns="0" rIns="0" bIns="0" rtlCol="0" anchor="ctr"/>
+          <a:lstStyle/>
+          <a:p>
+            <a:pPr algn="ctr" indent="0" marL="0">
+              <a:buNone/>
+            </a:pPr>
+            <a:r>
+              <a:rPr lang="en-US" sz="3200" b="1" dirty="0">
+                <a:solidFill>
+                  <a:srgbClr val="2B2B33"/>
+                </a:solidFill>
+                <a:latin typeface="Cambria" pitchFamily="34" charset="0"/>
+                <a:ea typeface="Cambria" pitchFamily="34" charset="-122"/>
+                <a:cs typeface="Cambria" pitchFamily="34" charset="-120"/>
+              </a:rPr>
+              <a:t>14</a:t>
+            </a:r>
+            <a:endParaRPr lang="en-US" sz="3200" dirty="0"/>
+          </a:p>
+        </p:txBody>
+      </p:sp>
+      <p:sp>
+        <p:nvSpPr>
+          <p:cNvPr id="25" name="Text 22"/>
+          <p:cNvSpPr/>
+          <p:nvPr/>
+        </p:nvSpPr>
+        <p:spPr>
+          <a:xfrm>
+            <a:off x="9646920" y="2414016"/>
+            <a:ext cx="1865376" cy="219456"/>
+          </a:xfrm>
+          <a:prstGeom prst="rect">
+            <a:avLst/>
+          </a:prstGeom>
+          <a:noFill/>
+          <a:ln/>
+        </p:spPr>
+        <p:txBody>
+          <a:bodyPr wrap="square" lIns="0" tIns="0" rIns="0" bIns="0" rtlCol="0" anchor="t"/>
+          <a:lstStyle/>
+          <a:p>
+            <a:pPr algn="ctr" indent="0" marL="0">
+              <a:buNone/>
+            </a:pPr>
+            <a:r>
+              <a:rPr lang="en-US" sz="1150" dirty="0">
+                <a:solidFill>
+                  <a:srgbClr val="6B6B76"/>
+                </a:solidFill>
+                <a:latin typeface="Calibri" pitchFamily="34" charset="0"/>
+                <a:ea typeface="Calibri" pitchFamily="34" charset="-122"/>
+                <a:cs typeface="Calibri" pitchFamily="34" charset="-120"/>
+              </a:rPr>
+              <a:t>/min</a:t>
+            </a:r>
+            <a:endParaRPr lang="en-US" sz="1150" dirty="0"/>
+          </a:p>
+        </p:txBody>
+      </p:sp>
+      <p:sp>
+        <p:nvSpPr>
+          <p:cNvPr id="26" name="Shape 23"/>
+          <p:cNvSpPr/>
+          <p:nvPr/>
+        </p:nvSpPr>
+        <p:spPr>
+          <a:xfrm>
+            <a:off x="502920" y="2816352"/>
+            <a:ext cx="11183112" cy="548640"/>
+          </a:xfrm>
+          <a:prstGeom prst="roundRect">
+            <a:avLst>
+              <a:gd name="adj" fmla="val 16667"/>
+            </a:avLst>
+          </a:prstGeom>
+          <a:solidFill>
+            <a:srgbClr val="590D22"/>
+          </a:solidFill>
+          <a:ln/>
+          <a:effectLst>
+            <a:outerShdw sx="100000" sy="100000" kx="0" ky="0" algn="bl" rotWithShape="0" blurRad="127000" dist="50800" dir="5400000">
+              <a:srgbClr val="C9A3AC">
+                <a:alpha val="45000"/>
+              </a:srgbClr>
+            </a:outerShdw>
+          </a:effectLst>
+        </p:spPr>
+      </p:sp>
+      <p:pic>
+        <p:nvPicPr>
+          <p:cNvPr id="27" name="Image 1" descr="preencoded.png">    </p:cNvPr>
+          <p:cNvPicPr>
+            <a:picLocks noChangeAspect="1"/>
+          </p:cNvPicPr>
+          <p:nvPr/>
+        </p:nvPicPr>
+        <p:blipFill>
+          <a:blip r:embed="rId2"/>
+          <a:stretch>
+            <a:fillRect/>
+          </a:stretch>
+        </p:blipFill>
+        <p:spPr>
+          <a:xfrm>
+            <a:off x="777240" y="2926080"/>
+            <a:ext cx="329184" cy="329184"/>
+          </a:xfrm>
+          <a:prstGeom prst="rect">
+            <a:avLst/>
+          </a:prstGeom>
+        </p:spPr>
+      </p:pic>
+      <p:sp>
+        <p:nvSpPr>
+          <p:cNvPr id="28" name="Text 24"/>
+          <p:cNvSpPr/>
+          <p:nvPr/>
+        </p:nvSpPr>
+        <p:spPr>
+          <a:xfrm>
+            <a:off x="1280160" y="2816352"/>
+            <a:ext cx="10241280" cy="548640"/>
+          </a:xfrm>
+          <a:prstGeom prst="rect">
+            <a:avLst/>
+          </a:prstGeom>
+          <a:noFill/>
+          <a:ln/>
+        </p:spPr>
+        <p:txBody>
+          <a:bodyPr wrap="square" lIns="0" tIns="0" rIns="0" bIns="0" rtlCol="0" anchor="ctr"/>
+          <a:lstStyle/>
+          <a:p>
+            <a:pPr algn="l" indent="0" marL="0">
+              <a:buNone/>
+            </a:pPr>
+            <a:r>
+              <a:rPr lang="en-US" sz="1400" b="1" dirty="0">
+                <a:solidFill>
+                  <a:srgbClr val="FF4D6D"/>
+                </a:solidFill>
+                <a:latin typeface="Calibri" pitchFamily="34" charset="0"/>
+                <a:ea typeface="Calibri" pitchFamily="34" charset="-122"/>
+                <a:cs typeface="Calibri" pitchFamily="34" charset="-120"/>
+              </a:rPr>
+              <a:t>Apex–radial pulse deficit ≈ 40 bpm</a:t>
+            </a:r>
+            <a:pPr algn="l" indent="0" marL="0">
+              <a:buNone/>
+            </a:pPr>
+            <a:r>
+              <a:rPr lang="en-US" sz="1400" dirty="0">
+                <a:solidFill>
+                  <a:srgbClr val="FBD8DF"/>
+                </a:solidFill>
+                <a:latin typeface="Calibri" pitchFamily="34" charset="0"/>
+                <a:ea typeface="Calibri" pitchFamily="34" charset="-122"/>
+                <a:cs typeface="Calibri" pitchFamily="34" charset="-120"/>
+              </a:rPr>
+              <a:t>   (heart rate 136 vs radial pulse 96) — a hallmark of atrial fibrillation.</a:t>
+            </a:r>
+            <a:endParaRPr lang="en-US" sz="1400" dirty="0"/>
+          </a:p>
+        </p:txBody>
+      </p:sp>
+      <p:sp>
+        <p:nvSpPr>
+          <p:cNvPr id="29" name="Shape 25"/>
+          <p:cNvSpPr/>
+          <p:nvPr/>
+        </p:nvSpPr>
+        <p:spPr>
+          <a:xfrm>
+            <a:off x="502920" y="3474720"/>
+            <a:ext cx="3611880" cy="2514600"/>
+          </a:xfrm>
+          <a:prstGeom prst="roundRect">
+            <a:avLst>
+              <a:gd name="adj" fmla="val 4364"/>
+            </a:avLst>
+          </a:prstGeom>
+          <a:solidFill>
+            <a:srgbClr val="FFF0F3"/>
+          </a:solidFill>
+          <a:ln w="12700">
+            <a:solidFill>
+              <a:srgbClr val="FBD8DF"/>
+            </a:solidFill>
+            <a:prstDash val="solid"/>
+          </a:ln>
+          <a:effectLst>
+            <a:outerShdw sx="100000" sy="100000" kx="0" ky="0" algn="bl" rotWithShape="0" blurRad="127000" dist="50800" dir="5400000">
+              <a:srgbClr val="C9A3AC">
+                <a:alpha val="45000"/>
+              </a:srgbClr>
+            </a:outerShdw>
+          </a:effectLst>
+        </p:spPr>
+      </p:sp>
+      <p:sp>
+        <p:nvSpPr>
+          <p:cNvPr id="30" name="Shape 26"/>
+          <p:cNvSpPr/>
+          <p:nvPr/>
+        </p:nvSpPr>
+        <p:spPr>
+          <a:xfrm>
+            <a:off x="777240" y="3694176"/>
+            <a:ext cx="566928" cy="566928"/>
           </a:xfrm>
           <a:prstGeom prst="ellipse">
             <a:avLst/>
@@ -5895,7 +6350,439 @@
       </p:sp>
       <p:pic>
         <p:nvPicPr>
-          <p:cNvPr id="20" name="Image 3" descr="preencoded.png">    </p:cNvPr>
+          <p:cNvPr id="31" name="Image 2" descr="preencoded.png">    </p:cNvPr>
+          <p:cNvPicPr>
+            <a:picLocks noChangeAspect="1"/>
+          </p:cNvPicPr>
+          <p:nvPr/>
+        </p:nvPicPr>
+        <p:blipFill>
+          <a:blip r:embed="rId3"/>
+          <a:stretch>
+            <a:fillRect/>
+          </a:stretch>
+        </p:blipFill>
+        <p:spPr>
+          <a:xfrm>
+            <a:off x="923544" y="3840480"/>
+            <a:ext cx="274320" cy="274320"/>
+          </a:xfrm>
+          <a:prstGeom prst="rect">
+            <a:avLst/>
+          </a:prstGeom>
+        </p:spPr>
+      </p:pic>
+      <p:sp>
+        <p:nvSpPr>
+          <p:cNvPr id="32" name="Text 27"/>
+          <p:cNvSpPr/>
+          <p:nvPr/>
+        </p:nvSpPr>
+        <p:spPr>
+          <a:xfrm>
+            <a:off x="1463040" y="3694176"/>
+            <a:ext cx="2514600" cy="566928"/>
+          </a:xfrm>
+          <a:prstGeom prst="rect">
+            <a:avLst/>
+          </a:prstGeom>
+          <a:noFill/>
+          <a:ln/>
+        </p:spPr>
+        <p:txBody>
+          <a:bodyPr wrap="square" lIns="0" tIns="0" rIns="0" bIns="0" rtlCol="0" anchor="ctr"/>
+          <a:lstStyle/>
+          <a:p>
+            <a:pPr algn="l" indent="0" marL="0">
+              <a:buNone/>
+            </a:pPr>
+            <a:r>
+              <a:rPr lang="en-US" sz="1600" b="1" dirty="0">
+                <a:solidFill>
+                  <a:srgbClr val="2B2B33"/>
+                </a:solidFill>
+                <a:latin typeface="Cambria" pitchFamily="34" charset="0"/>
+                <a:ea typeface="Cambria" pitchFamily="34" charset="-122"/>
+                <a:cs typeface="Cambria" pitchFamily="34" charset="-120"/>
+              </a:rPr>
+              <a:t>Pulse Character</a:t>
+            </a:r>
+            <a:endParaRPr lang="en-US" sz="1600" dirty="0"/>
+          </a:p>
+        </p:txBody>
+      </p:sp>
+      <p:sp>
+        <p:nvSpPr>
+          <p:cNvPr id="33" name="Shape 28"/>
+          <p:cNvSpPr/>
+          <p:nvPr/>
+        </p:nvSpPr>
+        <p:spPr>
+          <a:xfrm>
+            <a:off x="795528" y="4443984"/>
+            <a:ext cx="109728" cy="109728"/>
+          </a:xfrm>
+          <a:prstGeom prst="ellipse">
+            <a:avLst/>
+          </a:prstGeom>
+          <a:solidFill>
+            <a:srgbClr val="FF4D6D"/>
+          </a:solidFill>
+          <a:ln/>
+        </p:spPr>
+      </p:sp>
+      <p:sp>
+        <p:nvSpPr>
+          <p:cNvPr id="34" name="Text 29"/>
+          <p:cNvSpPr/>
+          <p:nvPr/>
+        </p:nvSpPr>
+        <p:spPr>
+          <a:xfrm>
+            <a:off x="1014984" y="4389120"/>
+            <a:ext cx="2880360" cy="301752"/>
+          </a:xfrm>
+          <a:prstGeom prst="rect">
+            <a:avLst/>
+          </a:prstGeom>
+          <a:noFill/>
+          <a:ln/>
+        </p:spPr>
+        <p:txBody>
+          <a:bodyPr wrap="square" lIns="0" tIns="0" rIns="0" bIns="0" rtlCol="0" anchor="t"/>
+          <a:lstStyle/>
+          <a:p>
+            <a:pPr algn="l" indent="0" marL="0">
+              <a:lnSpc>
+                <a:spcPct val="100000"/>
+              </a:lnSpc>
+              <a:buNone/>
+            </a:pPr>
+            <a:r>
+              <a:rPr lang="en-US" sz="1200" dirty="0">
+                <a:solidFill>
+                  <a:srgbClr val="2B2B33"/>
+                </a:solidFill>
+                <a:latin typeface="Calibri" pitchFamily="34" charset="0"/>
+                <a:ea typeface="Calibri" pitchFamily="34" charset="-122"/>
+                <a:cs typeface="Calibri" pitchFamily="34" charset="-120"/>
+              </a:rPr>
+              <a:t>Irregularly irregular</a:t>
+            </a:r>
+            <a:endParaRPr lang="en-US" sz="1200" dirty="0"/>
+          </a:p>
+        </p:txBody>
+      </p:sp>
+      <p:sp>
+        <p:nvSpPr>
+          <p:cNvPr id="35" name="Shape 30"/>
+          <p:cNvSpPr/>
+          <p:nvPr/>
+        </p:nvSpPr>
+        <p:spPr>
+          <a:xfrm>
+            <a:off x="795528" y="4745736"/>
+            <a:ext cx="109728" cy="109728"/>
+          </a:xfrm>
+          <a:prstGeom prst="ellipse">
+            <a:avLst/>
+          </a:prstGeom>
+          <a:solidFill>
+            <a:srgbClr val="FF4D6D"/>
+          </a:solidFill>
+          <a:ln/>
+        </p:spPr>
+      </p:sp>
+      <p:sp>
+        <p:nvSpPr>
+          <p:cNvPr id="36" name="Text 31"/>
+          <p:cNvSpPr/>
+          <p:nvPr/>
+        </p:nvSpPr>
+        <p:spPr>
+          <a:xfrm>
+            <a:off x="1014984" y="4690872"/>
+            <a:ext cx="2880360" cy="301752"/>
+          </a:xfrm>
+          <a:prstGeom prst="rect">
+            <a:avLst/>
+          </a:prstGeom>
+          <a:noFill/>
+          <a:ln/>
+        </p:spPr>
+        <p:txBody>
+          <a:bodyPr wrap="square" lIns="0" tIns="0" rIns="0" bIns="0" rtlCol="0" anchor="t"/>
+          <a:lstStyle/>
+          <a:p>
+            <a:pPr algn="l" indent="0" marL="0">
+              <a:lnSpc>
+                <a:spcPct val="100000"/>
+              </a:lnSpc>
+              <a:buNone/>
+            </a:pPr>
+            <a:r>
+              <a:rPr lang="en-US" sz="1200" dirty="0">
+                <a:solidFill>
+                  <a:srgbClr val="2B2B33"/>
+                </a:solidFill>
+                <a:latin typeface="Calibri" pitchFamily="34" charset="0"/>
+                <a:ea typeface="Calibri" pitchFamily="34" charset="-122"/>
+                <a:cs typeface="Calibri" pitchFamily="34" charset="-120"/>
+              </a:rPr>
+              <a:t>Normal volume &amp; character</a:t>
+            </a:r>
+            <a:endParaRPr lang="en-US" sz="1200" dirty="0"/>
+          </a:p>
+        </p:txBody>
+      </p:sp>
+      <p:sp>
+        <p:nvSpPr>
+          <p:cNvPr id="37" name="Shape 32"/>
+          <p:cNvSpPr/>
+          <p:nvPr/>
+        </p:nvSpPr>
+        <p:spPr>
+          <a:xfrm>
+            <a:off x="795528" y="5047488"/>
+            <a:ext cx="109728" cy="109728"/>
+          </a:xfrm>
+          <a:prstGeom prst="ellipse">
+            <a:avLst/>
+          </a:prstGeom>
+          <a:solidFill>
+            <a:srgbClr val="FF4D6D"/>
+          </a:solidFill>
+          <a:ln/>
+        </p:spPr>
+      </p:sp>
+      <p:sp>
+        <p:nvSpPr>
+          <p:cNvPr id="38" name="Text 33"/>
+          <p:cNvSpPr/>
+          <p:nvPr/>
+        </p:nvSpPr>
+        <p:spPr>
+          <a:xfrm>
+            <a:off x="1014984" y="4992624"/>
+            <a:ext cx="2880360" cy="301752"/>
+          </a:xfrm>
+          <a:prstGeom prst="rect">
+            <a:avLst/>
+          </a:prstGeom>
+          <a:noFill/>
+          <a:ln/>
+        </p:spPr>
+        <p:txBody>
+          <a:bodyPr wrap="square" lIns="0" tIns="0" rIns="0" bIns="0" rtlCol="0" anchor="t"/>
+          <a:lstStyle/>
+          <a:p>
+            <a:pPr algn="l" indent="0" marL="0">
+              <a:lnSpc>
+                <a:spcPct val="100000"/>
+              </a:lnSpc>
+              <a:buNone/>
+            </a:pPr>
+            <a:r>
+              <a:rPr lang="en-US" sz="1200" dirty="0">
+                <a:solidFill>
+                  <a:srgbClr val="2B2B33"/>
+                </a:solidFill>
+                <a:latin typeface="Calibri" pitchFamily="34" charset="0"/>
+                <a:ea typeface="Calibri" pitchFamily="34" charset="-122"/>
+                <a:cs typeface="Calibri" pitchFamily="34" charset="-120"/>
+              </a:rPr>
+              <a:t>Vessel wall not palpable</a:t>
+            </a:r>
+            <a:endParaRPr lang="en-US" sz="1200" dirty="0"/>
+          </a:p>
+        </p:txBody>
+      </p:sp>
+      <p:sp>
+        <p:nvSpPr>
+          <p:cNvPr id="39" name="Shape 34"/>
+          <p:cNvSpPr/>
+          <p:nvPr/>
+        </p:nvSpPr>
+        <p:spPr>
+          <a:xfrm>
+            <a:off x="795528" y="5349240"/>
+            <a:ext cx="109728" cy="109728"/>
+          </a:xfrm>
+          <a:prstGeom prst="ellipse">
+            <a:avLst/>
+          </a:prstGeom>
+          <a:solidFill>
+            <a:srgbClr val="FF4D6D"/>
+          </a:solidFill>
+          <a:ln/>
+        </p:spPr>
+      </p:sp>
+      <p:sp>
+        <p:nvSpPr>
+          <p:cNvPr id="40" name="Text 35"/>
+          <p:cNvSpPr/>
+          <p:nvPr/>
+        </p:nvSpPr>
+        <p:spPr>
+          <a:xfrm>
+            <a:off x="1014984" y="5294376"/>
+            <a:ext cx="2880360" cy="301752"/>
+          </a:xfrm>
+          <a:prstGeom prst="rect">
+            <a:avLst/>
+          </a:prstGeom>
+          <a:noFill/>
+          <a:ln/>
+        </p:spPr>
+        <p:txBody>
+          <a:bodyPr wrap="square" lIns="0" tIns="0" rIns="0" bIns="0" rtlCol="0" anchor="t"/>
+          <a:lstStyle/>
+          <a:p>
+            <a:pPr algn="l" indent="0" marL="0">
+              <a:lnSpc>
+                <a:spcPct val="100000"/>
+              </a:lnSpc>
+              <a:buNone/>
+            </a:pPr>
+            <a:r>
+              <a:rPr lang="en-US" sz="1200" dirty="0">
+                <a:solidFill>
+                  <a:srgbClr val="2B2B33"/>
+                </a:solidFill>
+                <a:latin typeface="Calibri" pitchFamily="34" charset="0"/>
+                <a:ea typeface="Calibri" pitchFamily="34" charset="-122"/>
+                <a:cs typeface="Calibri" pitchFamily="34" charset="-120"/>
+              </a:rPr>
+              <a:t>No radio-radial / femoral delay</a:t>
+            </a:r>
+            <a:endParaRPr lang="en-US" sz="1200" dirty="0"/>
+          </a:p>
+        </p:txBody>
+      </p:sp>
+      <p:sp>
+        <p:nvSpPr>
+          <p:cNvPr id="41" name="Shape 36"/>
+          <p:cNvSpPr/>
+          <p:nvPr/>
+        </p:nvSpPr>
+        <p:spPr>
+          <a:xfrm>
+            <a:off x="795528" y="5650992"/>
+            <a:ext cx="109728" cy="109728"/>
+          </a:xfrm>
+          <a:prstGeom prst="ellipse">
+            <a:avLst/>
+          </a:prstGeom>
+          <a:solidFill>
+            <a:srgbClr val="FF4D6D"/>
+          </a:solidFill>
+          <a:ln/>
+        </p:spPr>
+      </p:sp>
+      <p:sp>
+        <p:nvSpPr>
+          <p:cNvPr id="42" name="Text 37"/>
+          <p:cNvSpPr/>
+          <p:nvPr/>
+        </p:nvSpPr>
+        <p:spPr>
+          <a:xfrm>
+            <a:off x="1014984" y="5596128"/>
+            <a:ext cx="2880360" cy="301752"/>
+          </a:xfrm>
+          <a:prstGeom prst="rect">
+            <a:avLst/>
+          </a:prstGeom>
+          <a:noFill/>
+          <a:ln/>
+        </p:spPr>
+        <p:txBody>
+          <a:bodyPr wrap="square" lIns="0" tIns="0" rIns="0" bIns="0" rtlCol="0" anchor="t"/>
+          <a:lstStyle/>
+          <a:p>
+            <a:pPr algn="l" indent="0" marL="0">
+              <a:lnSpc>
+                <a:spcPct val="100000"/>
+              </a:lnSpc>
+              <a:buNone/>
+            </a:pPr>
+            <a:r>
+              <a:rPr lang="en-US" sz="1200" dirty="0">
+                <a:solidFill>
+                  <a:srgbClr val="2B2B33"/>
+                </a:solidFill>
+                <a:latin typeface="Calibri" pitchFamily="34" charset="0"/>
+                <a:ea typeface="Calibri" pitchFamily="34" charset="-122"/>
+                <a:cs typeface="Calibri" pitchFamily="34" charset="-120"/>
+              </a:rPr>
+              <a:t>Pulse deficit present</a:t>
+            </a:r>
+            <a:endParaRPr lang="en-US" sz="1200" dirty="0"/>
+          </a:p>
+        </p:txBody>
+      </p:sp>
+      <p:sp>
+        <p:nvSpPr>
+          <p:cNvPr id="43" name="Shape 38"/>
+          <p:cNvSpPr/>
+          <p:nvPr/>
+        </p:nvSpPr>
+        <p:spPr>
+          <a:xfrm>
+            <a:off x="4288536" y="3474720"/>
+            <a:ext cx="3611880" cy="2514600"/>
+          </a:xfrm>
+          <a:prstGeom prst="roundRect">
+            <a:avLst>
+              <a:gd name="adj" fmla="val 4364"/>
+            </a:avLst>
+          </a:prstGeom>
+          <a:solidFill>
+            <a:srgbClr val="FFF0F3"/>
+          </a:solidFill>
+          <a:ln w="12700">
+            <a:solidFill>
+              <a:srgbClr val="FBD8DF"/>
+            </a:solidFill>
+            <a:prstDash val="solid"/>
+          </a:ln>
+          <a:effectLst>
+            <a:outerShdw sx="100000" sy="100000" kx="0" ky="0" algn="bl" rotWithShape="0" blurRad="127000" dist="50800" dir="5400000">
+              <a:srgbClr val="C9A3AC">
+                <a:alpha val="45000"/>
+              </a:srgbClr>
+            </a:outerShdw>
+          </a:effectLst>
+        </p:spPr>
+      </p:sp>
+      <p:sp>
+        <p:nvSpPr>
+          <p:cNvPr id="44" name="Shape 39"/>
+          <p:cNvSpPr/>
+          <p:nvPr/>
+        </p:nvSpPr>
+        <p:spPr>
+          <a:xfrm>
+            <a:off x="4562856" y="3694176"/>
+            <a:ext cx="566928" cy="566928"/>
+          </a:xfrm>
+          <a:prstGeom prst="ellipse">
+            <a:avLst/>
+          </a:prstGeom>
+          <a:solidFill>
+            <a:srgbClr val="FFFFFF"/>
+          </a:solidFill>
+          <a:ln w="12700">
+            <a:solidFill>
+              <a:srgbClr val="FBD8DF"/>
+            </a:solidFill>
+            <a:prstDash val="solid"/>
+          </a:ln>
+        </p:spPr>
+      </p:sp>
+      <p:pic>
+        <p:nvPicPr>
+          <p:cNvPr id="45" name="Image 3" descr="preencoded.png">    </p:cNvPr>
           <p:cNvPicPr>
             <a:picLocks noChangeAspect="1"/>
           </p:cNvPicPr>
@@ -5909,8 +6796,8 @@
         </p:blipFill>
         <p:spPr>
           <a:xfrm>
-            <a:off x="8970264" y="2624328"/>
-            <a:ext cx="466344" cy="466344"/>
+            <a:off x="4709160" y="3840480"/>
+            <a:ext cx="274320" cy="274320"/>
           </a:xfrm>
           <a:prstGeom prst="rect">
             <a:avLst/>
@@ -5919,111 +6806,92 @@
       </p:pic>
       <p:sp>
         <p:nvSpPr>
-          <p:cNvPr id="21" name="Text 15"/>
-          <p:cNvSpPr/>
-          <p:nvPr/>
-        </p:nvSpPr>
-        <p:spPr>
-          <a:xfrm>
-            <a:off x="10872216" y="2286000"/>
-            <a:ext cx="822960" cy="640080"/>
-          </a:xfrm>
-          <a:prstGeom prst="rect">
-            <a:avLst/>
-          </a:prstGeom>
-          <a:noFill/>
-          <a:ln/>
-        </p:spPr>
-        <p:txBody>
-          <a:bodyPr wrap="square" lIns="0" tIns="0" rIns="0" bIns="0" rtlCol="0" anchor="t"/>
-          <a:lstStyle/>
-          <a:p>
-            <a:pPr algn="r" indent="0" marL="0">
-              <a:buNone/>
-            </a:pPr>
-            <a:r>
-              <a:rPr lang="en-US" sz="4000" b="1" dirty="0">
-                <a:solidFill>
-                  <a:srgbClr val="FBD8DF"/>
+          <p:cNvPr id="46" name="Text 40"/>
+          <p:cNvSpPr/>
+          <p:nvPr/>
+        </p:nvSpPr>
+        <p:spPr>
+          <a:xfrm>
+            <a:off x="5248656" y="3694176"/>
+            <a:ext cx="2514600" cy="566928"/>
+          </a:xfrm>
+          <a:prstGeom prst="rect">
+            <a:avLst/>
+          </a:prstGeom>
+          <a:noFill/>
+          <a:ln/>
+        </p:spPr>
+        <p:txBody>
+          <a:bodyPr wrap="square" lIns="0" tIns="0" rIns="0" bIns="0" rtlCol="0" anchor="ctr"/>
+          <a:lstStyle/>
+          <a:p>
+            <a:pPr algn="l" indent="0" marL="0">
+              <a:buNone/>
+            </a:pPr>
+            <a:r>
+              <a:rPr lang="en-US" sz="1600" b="1" dirty="0">
+                <a:solidFill>
+                  <a:srgbClr val="2B2B33"/>
                 </a:solidFill>
                 <a:latin typeface="Cambria" pitchFamily="34" charset="0"/>
                 <a:ea typeface="Cambria" pitchFamily="34" charset="-122"/>
                 <a:cs typeface="Cambria" pitchFamily="34" charset="-120"/>
               </a:rPr>
-              <a:t>03</a:t>
-            </a:r>
-            <a:endParaRPr lang="en-US" sz="4000" dirty="0"/>
-          </a:p>
-        </p:txBody>
-      </p:sp>
-      <p:sp>
-        <p:nvSpPr>
-          <p:cNvPr id="22" name="Text 16"/>
-          <p:cNvSpPr/>
-          <p:nvPr/>
-        </p:nvSpPr>
-        <p:spPr>
-          <a:xfrm>
-            <a:off x="8695944" y="3703320"/>
-            <a:ext cx="2971800" cy="292608"/>
-          </a:xfrm>
-          <a:prstGeom prst="rect">
-            <a:avLst/>
-          </a:prstGeom>
-          <a:noFill/>
-          <a:ln/>
-        </p:spPr>
-        <p:txBody>
-          <a:bodyPr wrap="square" rtlCol="0" anchor="t"/>
-          <a:lstStyle/>
-          <a:p>
-            <a:pPr algn="l" indent="0" marL="0">
-              <a:buNone/>
-            </a:pPr>
-            <a:r>
-              <a:rPr lang="en-US" sz="1300" b="1" spc="120" kern="0" dirty="0">
-                <a:solidFill>
-                  <a:srgbClr val="A4133C"/>
-                </a:solidFill>
-                <a:latin typeface="Calibri" pitchFamily="34" charset="0"/>
-                <a:ea typeface="Calibri" pitchFamily="34" charset="-122"/>
-                <a:cs typeface="Calibri" pitchFamily="34" charset="-120"/>
-              </a:rPr>
-              <a:t>CONSCIOUSNESS</a:t>
-            </a:r>
-            <a:endParaRPr lang="en-US" sz="1300" dirty="0"/>
-          </a:p>
-        </p:txBody>
-      </p:sp>
-      <p:sp>
-        <p:nvSpPr>
-          <p:cNvPr id="23" name="Text 17"/>
-          <p:cNvSpPr/>
-          <p:nvPr/>
-        </p:nvSpPr>
-        <p:spPr>
-          <a:xfrm>
-            <a:off x="8695944" y="4069080"/>
-            <a:ext cx="2880360" cy="1554480"/>
-          </a:xfrm>
-          <a:prstGeom prst="rect">
-            <a:avLst/>
-          </a:prstGeom>
-          <a:noFill/>
-          <a:ln/>
-        </p:spPr>
-        <p:txBody>
-          <a:bodyPr wrap="square" rtlCol="0" anchor="t"/>
+              <a:t>Blood Pressure</a:t>
+            </a:r>
+            <a:endParaRPr lang="en-US" sz="1600" dirty="0"/>
+          </a:p>
+        </p:txBody>
+      </p:sp>
+      <p:sp>
+        <p:nvSpPr>
+          <p:cNvPr id="47" name="Shape 41"/>
+          <p:cNvSpPr/>
+          <p:nvPr/>
+        </p:nvSpPr>
+        <p:spPr>
+          <a:xfrm>
+            <a:off x="4581144" y="4443984"/>
+            <a:ext cx="109728" cy="109728"/>
+          </a:xfrm>
+          <a:prstGeom prst="ellipse">
+            <a:avLst/>
+          </a:prstGeom>
+          <a:solidFill>
+            <a:srgbClr val="FF4D6D"/>
+          </a:solidFill>
+          <a:ln/>
+        </p:spPr>
+      </p:sp>
+      <p:sp>
+        <p:nvSpPr>
+          <p:cNvPr id="48" name="Text 42"/>
+          <p:cNvSpPr/>
+          <p:nvPr/>
+        </p:nvSpPr>
+        <p:spPr>
+          <a:xfrm>
+            <a:off x="4800600" y="4389120"/>
+            <a:ext cx="2880360" cy="502920"/>
+          </a:xfrm>
+          <a:prstGeom prst="rect">
+            <a:avLst/>
+          </a:prstGeom>
+          <a:noFill/>
+          <a:ln/>
+        </p:spPr>
+        <p:txBody>
+          <a:bodyPr wrap="square" lIns="0" tIns="0" rIns="0" bIns="0" rtlCol="0" anchor="t"/>
           <a:lstStyle/>
           <a:p>
             <a:pPr algn="l" indent="0" marL="0">
               <a:lnSpc>
-                <a:spcPct val="115000"/>
+                <a:spcPct val="100000"/>
               </a:lnSpc>
               <a:buNone/>
             </a:pPr>
             <a:r>
-              <a:rPr lang="en-US" sz="1650" dirty="0">
+              <a:rPr lang="en-US" sz="1200" dirty="0">
                 <a:solidFill>
                   <a:srgbClr val="2B2B33"/>
                 </a:solidFill>
@@ -6031,15 +6899,447 @@
                 <a:ea typeface="Calibri" pitchFamily="34" charset="-122"/>
                 <a:cs typeface="Calibri" pitchFamily="34" charset="-120"/>
               </a:rPr>
-              <a:t>Alert &amp; oriented to time, place and person</a:t>
-            </a:r>
-            <a:endParaRPr lang="en-US" sz="1650" dirty="0"/>
-          </a:p>
-        </p:txBody>
-      </p:sp>
-      <p:sp>
-        <p:nvSpPr>
-          <p:cNvPr id="24" name="Text 18"/>
+              <a:t>110/70 mmHg — right arm, lying</a:t>
+            </a:r>
+            <a:endParaRPr lang="en-US" sz="1200" dirty="0"/>
+          </a:p>
+        </p:txBody>
+      </p:sp>
+      <p:sp>
+        <p:nvSpPr>
+          <p:cNvPr id="49" name="Shape 43"/>
+          <p:cNvSpPr/>
+          <p:nvPr/>
+        </p:nvSpPr>
+        <p:spPr>
+          <a:xfrm>
+            <a:off x="4581144" y="4946904"/>
+            <a:ext cx="109728" cy="109728"/>
+          </a:xfrm>
+          <a:prstGeom prst="ellipse">
+            <a:avLst/>
+          </a:prstGeom>
+          <a:solidFill>
+            <a:srgbClr val="FF4D6D"/>
+          </a:solidFill>
+          <a:ln/>
+        </p:spPr>
+      </p:sp>
+      <p:sp>
+        <p:nvSpPr>
+          <p:cNvPr id="50" name="Text 44"/>
+          <p:cNvSpPr/>
+          <p:nvPr/>
+        </p:nvSpPr>
+        <p:spPr>
+          <a:xfrm>
+            <a:off x="4800600" y="4892040"/>
+            <a:ext cx="2880360" cy="502920"/>
+          </a:xfrm>
+          <a:prstGeom prst="rect">
+            <a:avLst/>
+          </a:prstGeom>
+          <a:noFill/>
+          <a:ln/>
+        </p:spPr>
+        <p:txBody>
+          <a:bodyPr wrap="square" lIns="0" tIns="0" rIns="0" bIns="0" rtlCol="0" anchor="t"/>
+          <a:lstStyle/>
+          <a:p>
+            <a:pPr algn="l" indent="0" marL="0">
+              <a:lnSpc>
+                <a:spcPct val="100000"/>
+              </a:lnSpc>
+              <a:buNone/>
+            </a:pPr>
+            <a:r>
+              <a:rPr lang="en-US" sz="1200" dirty="0">
+                <a:solidFill>
+                  <a:srgbClr val="2B2B33"/>
+                </a:solidFill>
+                <a:latin typeface="Calibri" pitchFamily="34" charset="0"/>
+                <a:ea typeface="Calibri" pitchFamily="34" charset="-122"/>
+                <a:cs typeface="Calibri" pitchFamily="34" charset="-120"/>
+              </a:rPr>
+              <a:t>No significant inter-arm difference</a:t>
+            </a:r>
+            <a:endParaRPr lang="en-US" sz="1200" dirty="0"/>
+          </a:p>
+        </p:txBody>
+      </p:sp>
+      <p:sp>
+        <p:nvSpPr>
+          <p:cNvPr id="51" name="Shape 45"/>
+          <p:cNvSpPr/>
+          <p:nvPr/>
+        </p:nvSpPr>
+        <p:spPr>
+          <a:xfrm>
+            <a:off x="4581144" y="5449824"/>
+            <a:ext cx="109728" cy="109728"/>
+          </a:xfrm>
+          <a:prstGeom prst="ellipse">
+            <a:avLst/>
+          </a:prstGeom>
+          <a:solidFill>
+            <a:srgbClr val="FF4D6D"/>
+          </a:solidFill>
+          <a:ln/>
+        </p:spPr>
+      </p:sp>
+      <p:sp>
+        <p:nvSpPr>
+          <p:cNvPr id="52" name="Text 46"/>
+          <p:cNvSpPr/>
+          <p:nvPr/>
+        </p:nvSpPr>
+        <p:spPr>
+          <a:xfrm>
+            <a:off x="4800600" y="5394960"/>
+            <a:ext cx="2880360" cy="502920"/>
+          </a:xfrm>
+          <a:prstGeom prst="rect">
+            <a:avLst/>
+          </a:prstGeom>
+          <a:noFill/>
+          <a:ln/>
+        </p:spPr>
+        <p:txBody>
+          <a:bodyPr wrap="square" lIns="0" tIns="0" rIns="0" bIns="0" rtlCol="0" anchor="t"/>
+          <a:lstStyle/>
+          <a:p>
+            <a:pPr algn="l" indent="0" marL="0">
+              <a:lnSpc>
+                <a:spcPct val="100000"/>
+              </a:lnSpc>
+              <a:buNone/>
+            </a:pPr>
+            <a:r>
+              <a:rPr lang="en-US" sz="1200" dirty="0">
+                <a:solidFill>
+                  <a:srgbClr val="2B2B33"/>
+                </a:solidFill>
+                <a:latin typeface="Calibri" pitchFamily="34" charset="0"/>
+                <a:ea typeface="Calibri" pitchFamily="34" charset="-122"/>
+                <a:cs typeface="Calibri" pitchFamily="34" charset="-120"/>
+              </a:rPr>
+              <a:t>No postural drop</a:t>
+            </a:r>
+            <a:endParaRPr lang="en-US" sz="1200" dirty="0"/>
+          </a:p>
+        </p:txBody>
+      </p:sp>
+      <p:sp>
+        <p:nvSpPr>
+          <p:cNvPr id="53" name="Shape 47"/>
+          <p:cNvSpPr/>
+          <p:nvPr/>
+        </p:nvSpPr>
+        <p:spPr>
+          <a:xfrm>
+            <a:off x="8074152" y="3474720"/>
+            <a:ext cx="3611880" cy="2514600"/>
+          </a:xfrm>
+          <a:prstGeom prst="roundRect">
+            <a:avLst>
+              <a:gd name="adj" fmla="val 4364"/>
+            </a:avLst>
+          </a:prstGeom>
+          <a:solidFill>
+            <a:srgbClr val="FFF0F3"/>
+          </a:solidFill>
+          <a:ln w="12700">
+            <a:solidFill>
+              <a:srgbClr val="FBD8DF"/>
+            </a:solidFill>
+            <a:prstDash val="solid"/>
+          </a:ln>
+          <a:effectLst>
+            <a:outerShdw sx="100000" sy="100000" kx="0" ky="0" algn="bl" rotWithShape="0" blurRad="127000" dist="50800" dir="5400000">
+              <a:srgbClr val="C9A3AC">
+                <a:alpha val="45000"/>
+              </a:srgbClr>
+            </a:outerShdw>
+          </a:effectLst>
+        </p:spPr>
+      </p:sp>
+      <p:sp>
+        <p:nvSpPr>
+          <p:cNvPr id="54" name="Shape 48"/>
+          <p:cNvSpPr/>
+          <p:nvPr/>
+        </p:nvSpPr>
+        <p:spPr>
+          <a:xfrm>
+            <a:off x="8348472" y="3694176"/>
+            <a:ext cx="566928" cy="566928"/>
+          </a:xfrm>
+          <a:prstGeom prst="ellipse">
+            <a:avLst/>
+          </a:prstGeom>
+          <a:solidFill>
+            <a:srgbClr val="FFFFFF"/>
+          </a:solidFill>
+          <a:ln w="12700">
+            <a:solidFill>
+              <a:srgbClr val="FBD8DF"/>
+            </a:solidFill>
+            <a:prstDash val="solid"/>
+          </a:ln>
+        </p:spPr>
+      </p:sp>
+      <p:pic>
+        <p:nvPicPr>
+          <p:cNvPr id="55" name="Image 4" descr="preencoded.png">    </p:cNvPr>
+          <p:cNvPicPr>
+            <a:picLocks noChangeAspect="1"/>
+          </p:cNvPicPr>
+          <p:nvPr/>
+        </p:nvPicPr>
+        <p:blipFill>
+          <a:blip r:embed="rId5"/>
+          <a:stretch>
+            <a:fillRect/>
+          </a:stretch>
+        </p:blipFill>
+        <p:spPr>
+          <a:xfrm>
+            <a:off x="8494776" y="3840480"/>
+            <a:ext cx="274320" cy="274320"/>
+          </a:xfrm>
+          <a:prstGeom prst="rect">
+            <a:avLst/>
+          </a:prstGeom>
+        </p:spPr>
+      </p:pic>
+      <p:sp>
+        <p:nvSpPr>
+          <p:cNvPr id="56" name="Text 49"/>
+          <p:cNvSpPr/>
+          <p:nvPr/>
+        </p:nvSpPr>
+        <p:spPr>
+          <a:xfrm>
+            <a:off x="9034272" y="3694176"/>
+            <a:ext cx="2514600" cy="566928"/>
+          </a:xfrm>
+          <a:prstGeom prst="rect">
+            <a:avLst/>
+          </a:prstGeom>
+          <a:noFill/>
+          <a:ln/>
+        </p:spPr>
+        <p:txBody>
+          <a:bodyPr wrap="square" lIns="0" tIns="0" rIns="0" bIns="0" rtlCol="0" anchor="ctr"/>
+          <a:lstStyle/>
+          <a:p>
+            <a:pPr algn="l" indent="0" marL="0">
+              <a:buNone/>
+            </a:pPr>
+            <a:r>
+              <a:rPr lang="en-US" sz="1600" b="1" dirty="0">
+                <a:solidFill>
+                  <a:srgbClr val="2B2B33"/>
+                </a:solidFill>
+                <a:latin typeface="Cambria" pitchFamily="34" charset="0"/>
+                <a:ea typeface="Cambria" pitchFamily="34" charset="-122"/>
+                <a:cs typeface="Cambria" pitchFamily="34" charset="-120"/>
+              </a:rPr>
+              <a:t>General</a:t>
+            </a:r>
+            <a:endParaRPr lang="en-US" sz="1600" dirty="0"/>
+          </a:p>
+        </p:txBody>
+      </p:sp>
+      <p:sp>
+        <p:nvSpPr>
+          <p:cNvPr id="57" name="Shape 50"/>
+          <p:cNvSpPr/>
+          <p:nvPr/>
+        </p:nvSpPr>
+        <p:spPr>
+          <a:xfrm>
+            <a:off x="8366760" y="4443984"/>
+            <a:ext cx="109728" cy="109728"/>
+          </a:xfrm>
+          <a:prstGeom prst="ellipse">
+            <a:avLst/>
+          </a:prstGeom>
+          <a:solidFill>
+            <a:srgbClr val="FF4D6D"/>
+          </a:solidFill>
+          <a:ln/>
+        </p:spPr>
+      </p:sp>
+      <p:sp>
+        <p:nvSpPr>
+          <p:cNvPr id="58" name="Text 51"/>
+          <p:cNvSpPr/>
+          <p:nvPr/>
+        </p:nvSpPr>
+        <p:spPr>
+          <a:xfrm>
+            <a:off x="8586216" y="4389120"/>
+            <a:ext cx="2880360" cy="502920"/>
+          </a:xfrm>
+          <a:prstGeom prst="rect">
+            <a:avLst/>
+          </a:prstGeom>
+          <a:noFill/>
+          <a:ln/>
+        </p:spPr>
+        <p:txBody>
+          <a:bodyPr wrap="square" lIns="0" tIns="0" rIns="0" bIns="0" rtlCol="0" anchor="t"/>
+          <a:lstStyle/>
+          <a:p>
+            <a:pPr algn="l" indent="0" marL="0">
+              <a:lnSpc>
+                <a:spcPct val="100000"/>
+              </a:lnSpc>
+              <a:buNone/>
+            </a:pPr>
+            <a:r>
+              <a:rPr lang="en-US" sz="1200" dirty="0">
+                <a:solidFill>
+                  <a:srgbClr val="2B2B33"/>
+                </a:solidFill>
+                <a:latin typeface="Calibri" pitchFamily="34" charset="0"/>
+                <a:ea typeface="Calibri" pitchFamily="34" charset="-122"/>
+                <a:cs typeface="Calibri" pitchFamily="34" charset="-120"/>
+              </a:rPr>
+              <a:t>Thin, lean, middle-aged female; comfortable in bed</a:t>
+            </a:r>
+            <a:endParaRPr lang="en-US" sz="1200" dirty="0"/>
+          </a:p>
+        </p:txBody>
+      </p:sp>
+      <p:sp>
+        <p:nvSpPr>
+          <p:cNvPr id="59" name="Shape 52"/>
+          <p:cNvSpPr/>
+          <p:nvPr/>
+        </p:nvSpPr>
+        <p:spPr>
+          <a:xfrm>
+            <a:off x="8366760" y="4946904"/>
+            <a:ext cx="109728" cy="109728"/>
+          </a:xfrm>
+          <a:prstGeom prst="ellipse">
+            <a:avLst/>
+          </a:prstGeom>
+          <a:solidFill>
+            <a:srgbClr val="FF4D6D"/>
+          </a:solidFill>
+          <a:ln/>
+        </p:spPr>
+      </p:sp>
+      <p:sp>
+        <p:nvSpPr>
+          <p:cNvPr id="60" name="Text 53"/>
+          <p:cNvSpPr/>
+          <p:nvPr/>
+        </p:nvSpPr>
+        <p:spPr>
+          <a:xfrm>
+            <a:off x="8586216" y="4892040"/>
+            <a:ext cx="2880360" cy="502920"/>
+          </a:xfrm>
+          <a:prstGeom prst="rect">
+            <a:avLst/>
+          </a:prstGeom>
+          <a:noFill/>
+          <a:ln/>
+        </p:spPr>
+        <p:txBody>
+          <a:bodyPr wrap="square" lIns="0" tIns="0" rIns="0" bIns="0" rtlCol="0" anchor="t"/>
+          <a:lstStyle/>
+          <a:p>
+            <a:pPr algn="l" indent="0" marL="0">
+              <a:lnSpc>
+                <a:spcPct val="100000"/>
+              </a:lnSpc>
+              <a:buNone/>
+            </a:pPr>
+            <a:r>
+              <a:rPr lang="en-US" sz="1200" dirty="0">
+                <a:solidFill>
+                  <a:srgbClr val="2B2B33"/>
+                </a:solidFill>
+                <a:latin typeface="Calibri" pitchFamily="34" charset="0"/>
+                <a:ea typeface="Calibri" pitchFamily="34" charset="-122"/>
+                <a:cs typeface="Calibri" pitchFamily="34" charset="-120"/>
+              </a:rPr>
+              <a:t>IV cannula in situ (right hand)</a:t>
+            </a:r>
+            <a:endParaRPr lang="en-US" sz="1200" dirty="0"/>
+          </a:p>
+        </p:txBody>
+      </p:sp>
+      <p:sp>
+        <p:nvSpPr>
+          <p:cNvPr id="61" name="Shape 54"/>
+          <p:cNvSpPr/>
+          <p:nvPr/>
+        </p:nvSpPr>
+        <p:spPr>
+          <a:xfrm>
+            <a:off x="8366760" y="5449824"/>
+            <a:ext cx="109728" cy="109728"/>
+          </a:xfrm>
+          <a:prstGeom prst="ellipse">
+            <a:avLst/>
+          </a:prstGeom>
+          <a:solidFill>
+            <a:srgbClr val="FF4D6D"/>
+          </a:solidFill>
+          <a:ln/>
+        </p:spPr>
+      </p:sp>
+      <p:sp>
+        <p:nvSpPr>
+          <p:cNvPr id="62" name="Text 55"/>
+          <p:cNvSpPr/>
+          <p:nvPr/>
+        </p:nvSpPr>
+        <p:spPr>
+          <a:xfrm>
+            <a:off x="8586216" y="5394960"/>
+            <a:ext cx="2880360" cy="502920"/>
+          </a:xfrm>
+          <a:prstGeom prst="rect">
+            <a:avLst/>
+          </a:prstGeom>
+          <a:noFill/>
+          <a:ln/>
+        </p:spPr>
+        <p:txBody>
+          <a:bodyPr wrap="square" lIns="0" tIns="0" rIns="0" bIns="0" rtlCol="0" anchor="t"/>
+          <a:lstStyle/>
+          <a:p>
+            <a:pPr algn="l" indent="0" marL="0">
+              <a:lnSpc>
+                <a:spcPct val="100000"/>
+              </a:lnSpc>
+              <a:buNone/>
+            </a:pPr>
+            <a:r>
+              <a:rPr lang="en-US" sz="1200" dirty="0">
+                <a:solidFill>
+                  <a:srgbClr val="2B2B33"/>
+                </a:solidFill>
+                <a:latin typeface="Calibri" pitchFamily="34" charset="0"/>
+                <a:ea typeface="Calibri" pitchFamily="34" charset="-122"/>
+                <a:cs typeface="Calibri" pitchFamily="34" charset="-120"/>
+              </a:rPr>
+              <a:t>Alert &amp; oriented — time, place, person</a:t>
+            </a:r>
+            <a:endParaRPr lang="en-US" sz="1200" dirty="0"/>
+          </a:p>
+        </p:txBody>
+      </p:sp>
+      <p:sp>
+        <p:nvSpPr>
+          <p:cNvPr id="63" name="Text 56"/>
           <p:cNvSpPr/>
           <p:nvPr/>
         </p:nvSpPr>
@@ -6078,7 +7378,7 @@
       </p:sp>
       <p:sp>
         <p:nvSpPr>
-          <p:cNvPr id="25" name="Text 19"/>
+          <p:cNvPr id="64" name="Text 57"/>
           <p:cNvSpPr/>
           <p:nvPr/>
         </p:nvSpPr>

</xml_diff>

<commit_message>
Change PEIC to PIC on the title slide
Co-Authored-By: Claude Opus 4.8 <noreply@anthropic.com>
Claude-Session: https://claude.ai/code/session_01S7QW8AwqyMReKwuqyBkBBv
</commit_message>
<xml_diff>
--- a/presentations/Clinicopathological-Conference-COMPLETE.pptx
+++ b/presentations/Clinicopathological-Conference-COMPLETE.pptx
@@ -4944,7 +4944,7 @@
                 <a:ea typeface="Calibri" pitchFamily="34" charset="-122"/>
                 <a:cs typeface="Calibri" pitchFamily="34" charset="-120"/>
               </a:rPr>
-              <a:t>DEPARTMENT OF CARDIOLOGY  ·  PEIC, BAHAWALPUR</a:t>
+              <a:t>DEPARTMENT OF CARDIOLOGY  ·  PIC, BAHAWALPUR</a:t>
             </a:r>
             <a:endParaRPr lang="en-US" sz="1400" dirty="0"/>
           </a:p>
@@ -5185,7 +5185,7 @@
                 <a:ea typeface="Calibri" pitchFamily="34" charset="-122"/>
                 <a:cs typeface="Calibri" pitchFamily="34" charset="-120"/>
               </a:rPr>
-              <a:t>PGR Cardiology  ·  PEIC, BWP</a:t>
+              <a:t>PGR Cardiology  ·  PIC, BWP</a:t>
             </a:r>
             <a:endParaRPr lang="en-US" sz="1900" dirty="0"/>
           </a:p>

</xml_diff>

<commit_message>
Redesign CVS slide as full-width section bands
Replace the stacked-cards CVS layout with three full-width bands
(Inspection, Palpation, Auscultation) — bold crimson icon badge + label
on the left, a hairline divider, and findings as evenly-spaced single-
line bullets on the right. Clearer and more elegant.

Co-Authored-By: Claude Opus 4.8 <noreply@anthropic.com>
Claude-Session: https://claude.ai/code/session_01S7QW8AwqyMReKwuqyBkBBv
</commit_message>
<xml_diff>
--- a/presentations/Clinicopathological-Conference-COMPLETE.pptx
+++ b/presentations/Clinicopathological-Conference-COMPLETE.pptx
@@ -7582,306 +7582,12 @@
         </p:nvSpPr>
         <p:spPr>
           <a:xfrm>
-            <a:off x="502920" y="1783080"/>
-            <a:ext cx="4114800" cy="4206240"/>
+            <a:off x="502920" y="1691640"/>
+            <a:ext cx="11183112" cy="1097280"/>
           </a:xfrm>
           <a:prstGeom prst="roundRect">
             <a:avLst>
-              <a:gd name="adj" fmla="val 3111"/>
-            </a:avLst>
-          </a:prstGeom>
-          <a:solidFill>
-            <a:srgbClr val="590D22"/>
-          </a:solidFill>
-          <a:ln/>
-          <a:effectLst>
-            <a:outerShdw sx="100000" sy="100000" kx="0" ky="0" algn="bl" rotWithShape="0" blurRad="127000" dist="50800" dir="5400000">
-              <a:srgbClr val="C9A3AC">
-                <a:alpha val="45000"/>
-              </a:srgbClr>
-            </a:outerShdw>
-          </a:effectLst>
-        </p:spPr>
-      </p:sp>
-      <p:sp>
-        <p:nvSpPr>
-          <p:cNvPr id="7" name="Shape 4"/>
-          <p:cNvSpPr/>
-          <p:nvPr/>
-        </p:nvSpPr>
-        <p:spPr>
-          <a:xfrm>
-            <a:off x="1691640" y="2423160"/>
-            <a:ext cx="1737360" cy="1737360"/>
-          </a:xfrm>
-          <a:prstGeom prst="ellipse">
-            <a:avLst/>
-          </a:prstGeom>
-          <a:solidFill>
-            <a:srgbClr val="FFFFFF">
-              <a:alpha val="10000"/>
-            </a:srgbClr>
-          </a:solidFill>
-          <a:ln w="19050">
-            <a:solidFill>
-              <a:srgbClr val="FF4D6D"/>
-            </a:solidFill>
-            <a:prstDash val="solid"/>
-          </a:ln>
-        </p:spPr>
-      </p:sp>
-      <p:pic>
-        <p:nvPicPr>
-          <p:cNvPr id="8" name="Image 1" descr="preencoded.png">    </p:cNvPr>
-          <p:cNvPicPr>
-            <a:picLocks noChangeAspect="1"/>
-          </p:cNvPicPr>
-          <p:nvPr/>
-        </p:nvPicPr>
-        <p:blipFill>
-          <a:blip r:embed="rId2"/>
-          <a:stretch>
-            <a:fillRect/>
-          </a:stretch>
-        </p:blipFill>
-        <p:spPr>
-          <a:xfrm>
-            <a:off x="2057400" y="2788920"/>
-            <a:ext cx="1005840" cy="1005840"/>
-          </a:xfrm>
-          <a:prstGeom prst="rect">
-            <a:avLst/>
-          </a:prstGeom>
-        </p:spPr>
-      </p:pic>
-      <p:sp>
-        <p:nvSpPr>
-          <p:cNvPr id="9" name="Text 5"/>
-          <p:cNvSpPr/>
-          <p:nvPr/>
-        </p:nvSpPr>
-        <p:spPr>
-          <a:xfrm>
-            <a:off x="685800" y="4434840"/>
-            <a:ext cx="3749040" cy="548640"/>
-          </a:xfrm>
-          <a:prstGeom prst="rect">
-            <a:avLst/>
-          </a:prstGeom>
-          <a:noFill/>
-          <a:ln/>
-        </p:spPr>
-        <p:txBody>
-          <a:bodyPr wrap="square" rtlCol="0" anchor="t"/>
-          <a:lstStyle/>
-          <a:p>
-            <a:pPr algn="ctr" indent="0" marL="0">
-              <a:buNone/>
-            </a:pPr>
-            <a:r>
-              <a:rPr lang="en-US" sz="2500" b="1" dirty="0">
-                <a:solidFill>
-                  <a:srgbClr val="FFFFFF"/>
-                </a:solidFill>
-                <a:latin typeface="Cambria" pitchFamily="34" charset="0"/>
-                <a:ea typeface="Cambria" pitchFamily="34" charset="-122"/>
-                <a:cs typeface="Cambria" pitchFamily="34" charset="-120"/>
-              </a:rPr>
-              <a:t>CVS</a:t>
-            </a:r>
-            <a:endParaRPr lang="en-US" sz="2500" dirty="0"/>
-          </a:p>
-        </p:txBody>
-      </p:sp>
-      <p:sp>
-        <p:nvSpPr>
-          <p:cNvPr id="10" name="Shape 6"/>
-          <p:cNvSpPr/>
-          <p:nvPr/>
-        </p:nvSpPr>
-        <p:spPr>
-          <a:xfrm>
-            <a:off x="1280160" y="5349240"/>
-            <a:ext cx="839419" cy="0"/>
-          </a:xfrm>
-          <a:prstGeom prst="line">
-            <a:avLst/>
-          </a:prstGeom>
-          <a:noFill/>
-          <a:ln w="28575">
-            <a:solidFill>
-              <a:srgbClr val="FF4D6D">
-                <a:alpha val="88000"/>
-              </a:srgbClr>
-            </a:solidFill>
-            <a:prstDash val="solid"/>
-          </a:ln>
-        </p:spPr>
-      </p:sp>
-      <p:sp>
-        <p:nvSpPr>
-          <p:cNvPr id="11" name="Shape 7"/>
-          <p:cNvSpPr/>
-          <p:nvPr/>
-        </p:nvSpPr>
-        <p:spPr>
-          <a:xfrm flipV="1">
-            <a:off x="2119579" y="5202936"/>
-            <a:ext cx="148133" cy="146304"/>
-          </a:xfrm>
-          <a:prstGeom prst="line">
-            <a:avLst/>
-          </a:prstGeom>
-          <a:noFill/>
-          <a:ln w="28575">
-            <a:solidFill>
-              <a:srgbClr val="FF4D6D">
-                <a:alpha val="88000"/>
-              </a:srgbClr>
-            </a:solidFill>
-            <a:prstDash val="solid"/>
-          </a:ln>
-        </p:spPr>
-      </p:sp>
-      <p:sp>
-        <p:nvSpPr>
-          <p:cNvPr id="12" name="Shape 8"/>
-          <p:cNvSpPr/>
-          <p:nvPr/>
-        </p:nvSpPr>
-        <p:spPr>
-          <a:xfrm>
-            <a:off x="2267712" y="5202936"/>
-            <a:ext cx="148133" cy="457200"/>
-          </a:xfrm>
-          <a:prstGeom prst="line">
-            <a:avLst/>
-          </a:prstGeom>
-          <a:noFill/>
-          <a:ln w="28575">
-            <a:solidFill>
-              <a:srgbClr val="FF4D6D">
-                <a:alpha val="88000"/>
-              </a:srgbClr>
-            </a:solidFill>
-            <a:prstDash val="solid"/>
-          </a:ln>
-        </p:spPr>
-      </p:sp>
-      <p:sp>
-        <p:nvSpPr>
-          <p:cNvPr id="13" name="Shape 9"/>
-          <p:cNvSpPr/>
-          <p:nvPr/>
-        </p:nvSpPr>
-        <p:spPr>
-          <a:xfrm flipV="1">
-            <a:off x="2415845" y="4846320"/>
-            <a:ext cx="148133" cy="813816"/>
-          </a:xfrm>
-          <a:prstGeom prst="line">
-            <a:avLst/>
-          </a:prstGeom>
-          <a:noFill/>
-          <a:ln w="28575">
-            <a:solidFill>
-              <a:srgbClr val="FF4D6D">
-                <a:alpha val="88000"/>
-              </a:srgbClr>
-            </a:solidFill>
-            <a:prstDash val="solid"/>
-          </a:ln>
-        </p:spPr>
-      </p:sp>
-      <p:sp>
-        <p:nvSpPr>
-          <p:cNvPr id="14" name="Shape 10"/>
-          <p:cNvSpPr/>
-          <p:nvPr/>
-        </p:nvSpPr>
-        <p:spPr>
-          <a:xfrm>
-            <a:off x="2563978" y="4846320"/>
-            <a:ext cx="148133" cy="685800"/>
-          </a:xfrm>
-          <a:prstGeom prst="line">
-            <a:avLst/>
-          </a:prstGeom>
-          <a:noFill/>
-          <a:ln w="28575">
-            <a:solidFill>
-              <a:srgbClr val="FF4D6D">
-                <a:alpha val="88000"/>
-              </a:srgbClr>
-            </a:solidFill>
-            <a:prstDash val="solid"/>
-          </a:ln>
-        </p:spPr>
-      </p:sp>
-      <p:sp>
-        <p:nvSpPr>
-          <p:cNvPr id="15" name="Shape 11"/>
-          <p:cNvSpPr/>
-          <p:nvPr/>
-        </p:nvSpPr>
-        <p:spPr>
-          <a:xfrm flipV="1">
-            <a:off x="2712110" y="5349240"/>
-            <a:ext cx="148133" cy="182880"/>
-          </a:xfrm>
-          <a:prstGeom prst="line">
-            <a:avLst/>
-          </a:prstGeom>
-          <a:noFill/>
-          <a:ln w="28575">
-            <a:solidFill>
-              <a:srgbClr val="FF4D6D">
-                <a:alpha val="88000"/>
-              </a:srgbClr>
-            </a:solidFill>
-            <a:prstDash val="solid"/>
-          </a:ln>
-        </p:spPr>
-      </p:sp>
-      <p:sp>
-        <p:nvSpPr>
-          <p:cNvPr id="16" name="Shape 12"/>
-          <p:cNvSpPr/>
-          <p:nvPr/>
-        </p:nvSpPr>
-        <p:spPr>
-          <a:xfrm>
-            <a:off x="2860243" y="5349240"/>
-            <a:ext cx="888797" cy="0"/>
-          </a:xfrm>
-          <a:prstGeom prst="line">
-            <a:avLst/>
-          </a:prstGeom>
-          <a:noFill/>
-          <a:ln w="28575">
-            <a:solidFill>
-              <a:srgbClr val="FF4D6D">
-                <a:alpha val="88000"/>
-              </a:srgbClr>
-            </a:solidFill>
-            <a:prstDash val="solid"/>
-          </a:ln>
-        </p:spPr>
-      </p:sp>
-      <p:sp>
-        <p:nvSpPr>
-          <p:cNvPr id="17" name="Shape 13"/>
-          <p:cNvSpPr/>
-          <p:nvPr/>
-        </p:nvSpPr>
-        <p:spPr>
-          <a:xfrm>
-            <a:off x="4937760" y="1783080"/>
-            <a:ext cx="6766560" cy="822960"/>
-          </a:xfrm>
-          <a:prstGeom prst="roundRect">
-            <a:avLst>
-              <a:gd name="adj" fmla="val 12222"/>
+              <a:gd name="adj" fmla="val 10000"/>
             </a:avLst>
           </a:prstGeom>
           <a:solidFill>
@@ -7904,14 +7610,14 @@
       </p:sp>
       <p:sp>
         <p:nvSpPr>
-          <p:cNvPr id="18" name="Shape 14"/>
-          <p:cNvSpPr/>
-          <p:nvPr/>
-        </p:nvSpPr>
-        <p:spPr>
-          <a:xfrm>
-            <a:off x="5193792" y="1920240"/>
-            <a:ext cx="475488" cy="475488"/>
+          <p:cNvPr id="7" name="Shape 4"/>
+          <p:cNvSpPr/>
+          <p:nvPr/>
+        </p:nvSpPr>
+        <p:spPr>
+          <a:xfrm>
+            <a:off x="868680" y="1856232"/>
+            <a:ext cx="768096" cy="768096"/>
           </a:xfrm>
           <a:prstGeom prst="ellipse">
             <a:avLst/>
@@ -7919,7 +7625,7 @@
           <a:solidFill>
             <a:srgbClr val="A4133C"/>
           </a:solidFill>
-          <a:ln w="12700">
+          <a:ln w="19050">
             <a:solidFill>
               <a:srgbClr val="FF4D6D"/>
             </a:solidFill>
@@ -7929,22 +7635,22 @@
       </p:sp>
       <p:pic>
         <p:nvPicPr>
-          <p:cNvPr id="19" name="Image 2" descr="preencoded.png">    </p:cNvPr>
+          <p:cNvPr id="8" name="Image 1" descr="preencoded.png">    </p:cNvPr>
           <p:cNvPicPr>
             <a:picLocks noChangeAspect="1"/>
           </p:cNvPicPr>
           <p:nvPr/>
         </p:nvPicPr>
         <p:blipFill>
-          <a:blip r:embed="rId3"/>
+          <a:blip r:embed="rId2"/>
           <a:stretch>
             <a:fillRect/>
           </a:stretch>
         </p:blipFill>
         <p:spPr>
           <a:xfrm>
-            <a:off x="5312664" y="2039112"/>
-            <a:ext cx="237744" cy="237744"/>
+            <a:off x="1088136" y="2075688"/>
+            <a:ext cx="329184" cy="329184"/>
           </a:xfrm>
           <a:prstGeom prst="rect">
             <a:avLst/>
@@ -7953,68 +7659,111 @@
       </p:pic>
       <p:sp>
         <p:nvSpPr>
-          <p:cNvPr id="20" name="Text 15"/>
-          <p:cNvSpPr/>
-          <p:nvPr/>
-        </p:nvSpPr>
-        <p:spPr>
-          <a:xfrm>
-            <a:off x="5852160" y="1975104"/>
-            <a:ext cx="5623560" cy="256032"/>
-          </a:xfrm>
-          <a:prstGeom prst="rect">
-            <a:avLst/>
-          </a:prstGeom>
-          <a:noFill/>
-          <a:ln/>
-        </p:spPr>
-        <p:txBody>
-          <a:bodyPr wrap="square" lIns="0" tIns="0" rIns="0" bIns="0" rtlCol="0" anchor="t"/>
-          <a:lstStyle/>
-          <a:p>
-            <a:pPr algn="l" indent="0" marL="0">
-              <a:buNone/>
-            </a:pPr>
-            <a:r>
-              <a:rPr lang="en-US" sz="1150" b="1" spc="150" kern="0" dirty="0">
+          <p:cNvPr id="9" name="Text 5"/>
+          <p:cNvSpPr/>
+          <p:nvPr/>
+        </p:nvSpPr>
+        <p:spPr>
+          <a:xfrm>
+            <a:off x="1783080" y="1691640"/>
+            <a:ext cx="1417320" cy="1097280"/>
+          </a:xfrm>
+          <a:prstGeom prst="rect">
+            <a:avLst/>
+          </a:prstGeom>
+          <a:noFill/>
+          <a:ln/>
+        </p:spPr>
+        <p:txBody>
+          <a:bodyPr wrap="square" lIns="0" tIns="0" rIns="0" bIns="0" rtlCol="0" anchor="ctr"/>
+          <a:lstStyle/>
+          <a:p>
+            <a:pPr algn="l" indent="0" marL="0">
+              <a:lnSpc>
+                <a:spcPct val="95000"/>
+              </a:lnSpc>
+              <a:buNone/>
+            </a:pPr>
+            <a:r>
+              <a:rPr lang="en-US" sz="1400" b="1" dirty="0">
                 <a:solidFill>
                   <a:srgbClr val="A4133C"/>
                 </a:solidFill>
-                <a:latin typeface="Calibri" pitchFamily="34" charset="0"/>
-                <a:ea typeface="Calibri" pitchFamily="34" charset="-122"/>
-                <a:cs typeface="Calibri" pitchFamily="34" charset="-120"/>
+                <a:latin typeface="Cambria" pitchFamily="34" charset="0"/>
+                <a:ea typeface="Cambria" pitchFamily="34" charset="-122"/>
+                <a:cs typeface="Cambria" pitchFamily="34" charset="-120"/>
               </a:rPr>
               <a:t>INSPECTION</a:t>
             </a:r>
-            <a:endParaRPr lang="en-US" sz="1150" dirty="0"/>
-          </a:p>
-        </p:txBody>
-      </p:sp>
-      <p:sp>
-        <p:nvSpPr>
-          <p:cNvPr id="21" name="Text 16"/>
-          <p:cNvSpPr/>
-          <p:nvPr/>
-        </p:nvSpPr>
-        <p:spPr>
-          <a:xfrm>
-            <a:off x="5852160" y="2167128"/>
-            <a:ext cx="5623560" cy="384048"/>
-          </a:xfrm>
-          <a:prstGeom prst="rect">
-            <a:avLst/>
-          </a:prstGeom>
-          <a:noFill/>
-          <a:ln/>
-        </p:spPr>
-        <p:txBody>
-          <a:bodyPr wrap="square" lIns="0" tIns="0" rIns="0" bIns="0" rtlCol="0" anchor="t"/>
-          <a:lstStyle/>
-          <a:p>
-            <a:pPr algn="l" indent="0" marL="0">
-              <a:lnSpc>
-                <a:spcPct val="100000"/>
-              </a:lnSpc>
+            <a:endParaRPr lang="en-US" sz="1400" dirty="0"/>
+          </a:p>
+        </p:txBody>
+      </p:sp>
+      <p:sp>
+        <p:nvSpPr>
+          <p:cNvPr id="10" name="Shape 6"/>
+          <p:cNvSpPr/>
+          <p:nvPr/>
+        </p:nvSpPr>
+        <p:spPr>
+          <a:xfrm>
+            <a:off x="3246120" y="1929384"/>
+            <a:ext cx="0" cy="621792"/>
+          </a:xfrm>
+          <a:prstGeom prst="line">
+            <a:avLst/>
+          </a:prstGeom>
+          <a:noFill/>
+          <a:ln w="12700">
+            <a:solidFill>
+              <a:srgbClr val="FBD8DF"/>
+            </a:solidFill>
+            <a:prstDash val="solid"/>
+          </a:ln>
+        </p:spPr>
+      </p:sp>
+      <p:sp>
+        <p:nvSpPr>
+          <p:cNvPr id="11" name="Shape 7"/>
+          <p:cNvSpPr/>
+          <p:nvPr/>
+        </p:nvSpPr>
+        <p:spPr>
+          <a:xfrm>
+            <a:off x="3520440" y="2002536"/>
+            <a:ext cx="118872" cy="118872"/>
+          </a:xfrm>
+          <a:prstGeom prst="ellipse">
+            <a:avLst/>
+          </a:prstGeom>
+          <a:solidFill>
+            <a:srgbClr val="FF4D6D"/>
+          </a:solidFill>
+          <a:ln/>
+        </p:spPr>
+      </p:sp>
+      <p:sp>
+        <p:nvSpPr>
+          <p:cNvPr id="12" name="Text 8"/>
+          <p:cNvSpPr/>
+          <p:nvPr/>
+        </p:nvSpPr>
+        <p:spPr>
+          <a:xfrm>
+            <a:off x="3767328" y="1874520"/>
+            <a:ext cx="7680960" cy="384048"/>
+          </a:xfrm>
+          <a:prstGeom prst="rect">
+            <a:avLst/>
+          </a:prstGeom>
+          <a:noFill/>
+          <a:ln/>
+        </p:spPr>
+        <p:txBody>
+          <a:bodyPr wrap="square" lIns="0" tIns="0" rIns="0" bIns="0" rtlCol="0" anchor="ctr"/>
+          <a:lstStyle/>
+          <a:p>
+            <a:pPr algn="l" indent="0" marL="0">
               <a:buNone/>
             </a:pPr>
             <a:r>
@@ -8026,7 +7775,7 @@
                 <a:ea typeface="Calibri" pitchFamily="34" charset="-122"/>
                 <a:cs typeface="Calibri" pitchFamily="34" charset="-120"/>
               </a:rPr>
-              <a:t>Shape of the precordium was normal; the rest of the inspection could not be performed because of limited exposure</a:t>
+              <a:t>Shape of the precordium — normal</a:t>
             </a:r>
             <a:endParaRPr lang="en-US" sz="1250" dirty="0"/>
           </a:p>
@@ -8034,18 +7783,77 @@
       </p:sp>
       <p:sp>
         <p:nvSpPr>
-          <p:cNvPr id="22" name="Shape 17"/>
-          <p:cNvSpPr/>
-          <p:nvPr/>
-        </p:nvSpPr>
-        <p:spPr>
-          <a:xfrm>
-            <a:off x="4937760" y="2679192"/>
-            <a:ext cx="6766560" cy="1572768"/>
+          <p:cNvPr id="13" name="Shape 9"/>
+          <p:cNvSpPr/>
+          <p:nvPr/>
+        </p:nvSpPr>
+        <p:spPr>
+          <a:xfrm>
+            <a:off x="3520440" y="2386584"/>
+            <a:ext cx="118872" cy="118872"/>
+          </a:xfrm>
+          <a:prstGeom prst="ellipse">
+            <a:avLst/>
+          </a:prstGeom>
+          <a:solidFill>
+            <a:srgbClr val="FF4D6D"/>
+          </a:solidFill>
+          <a:ln/>
+        </p:spPr>
+      </p:sp>
+      <p:sp>
+        <p:nvSpPr>
+          <p:cNvPr id="14" name="Text 10"/>
+          <p:cNvSpPr/>
+          <p:nvPr/>
+        </p:nvSpPr>
+        <p:spPr>
+          <a:xfrm>
+            <a:off x="3767328" y="2258568"/>
+            <a:ext cx="7680960" cy="384048"/>
+          </a:xfrm>
+          <a:prstGeom prst="rect">
+            <a:avLst/>
+          </a:prstGeom>
+          <a:noFill/>
+          <a:ln/>
+        </p:spPr>
+        <p:txBody>
+          <a:bodyPr wrap="square" lIns="0" tIns="0" rIns="0" bIns="0" rtlCol="0" anchor="ctr"/>
+          <a:lstStyle/>
+          <a:p>
+            <a:pPr algn="l" indent="0" marL="0">
+              <a:buNone/>
+            </a:pPr>
+            <a:r>
+              <a:rPr lang="en-US" sz="1250" dirty="0">
+                <a:solidFill>
+                  <a:srgbClr val="2B2B33"/>
+                </a:solidFill>
+                <a:latin typeface="Calibri" pitchFamily="34" charset="0"/>
+                <a:ea typeface="Calibri" pitchFamily="34" charset="-122"/>
+                <a:cs typeface="Calibri" pitchFamily="34" charset="-120"/>
+              </a:rPr>
+              <a:t>Remainder of the inspection limited by exposure</a:t>
+            </a:r>
+            <a:endParaRPr lang="en-US" sz="1250" dirty="0"/>
+          </a:p>
+        </p:txBody>
+      </p:sp>
+      <p:sp>
+        <p:nvSpPr>
+          <p:cNvPr id="15" name="Shape 11"/>
+          <p:cNvSpPr/>
+          <p:nvPr/>
+        </p:nvSpPr>
+        <p:spPr>
+          <a:xfrm>
+            <a:off x="502920" y="2926080"/>
+            <a:ext cx="11183112" cy="1444752"/>
           </a:xfrm>
           <a:prstGeom prst="roundRect">
             <a:avLst>
-              <a:gd name="adj" fmla="val 6395"/>
+              <a:gd name="adj" fmla="val 7595"/>
             </a:avLst>
           </a:prstGeom>
           <a:solidFill>
@@ -8068,14 +7876,14 @@
       </p:sp>
       <p:sp>
         <p:nvSpPr>
-          <p:cNvPr id="23" name="Shape 18"/>
-          <p:cNvSpPr/>
-          <p:nvPr/>
-        </p:nvSpPr>
-        <p:spPr>
-          <a:xfrm>
-            <a:off x="5193792" y="2816352"/>
-            <a:ext cx="475488" cy="475488"/>
+          <p:cNvPr id="16" name="Shape 12"/>
+          <p:cNvSpPr/>
+          <p:nvPr/>
+        </p:nvSpPr>
+        <p:spPr>
+          <a:xfrm>
+            <a:off x="868680" y="3264408"/>
+            <a:ext cx="768096" cy="768096"/>
           </a:xfrm>
           <a:prstGeom prst="ellipse">
             <a:avLst/>
@@ -8083,7 +7891,7 @@
           <a:solidFill>
             <a:srgbClr val="A4133C"/>
           </a:solidFill>
-          <a:ln w="12700">
+          <a:ln w="19050">
             <a:solidFill>
               <a:srgbClr val="FF4D6D"/>
             </a:solidFill>
@@ -8093,22 +7901,22 @@
       </p:sp>
       <p:pic>
         <p:nvPicPr>
-          <p:cNvPr id="24" name="Image 3" descr="preencoded.png">    </p:cNvPr>
+          <p:cNvPr id="17" name="Image 2" descr="preencoded.png">    </p:cNvPr>
           <p:cNvPicPr>
             <a:picLocks noChangeAspect="1"/>
           </p:cNvPicPr>
           <p:nvPr/>
         </p:nvPicPr>
         <p:blipFill>
-          <a:blip r:embed="rId4"/>
+          <a:blip r:embed="rId3"/>
           <a:stretch>
             <a:fillRect/>
           </a:stretch>
         </p:blipFill>
         <p:spPr>
           <a:xfrm>
-            <a:off x="5312664" y="2935224"/>
-            <a:ext cx="237744" cy="237744"/>
+            <a:off x="1088136" y="3483864"/>
+            <a:ext cx="329184" cy="329184"/>
           </a:xfrm>
           <a:prstGeom prst="rect">
             <a:avLst/>
@@ -8117,53 +7925,79 @@
       </p:pic>
       <p:sp>
         <p:nvSpPr>
-          <p:cNvPr id="25" name="Text 19"/>
-          <p:cNvSpPr/>
-          <p:nvPr/>
-        </p:nvSpPr>
-        <p:spPr>
-          <a:xfrm>
-            <a:off x="5852160" y="2871216"/>
-            <a:ext cx="5623560" cy="256032"/>
-          </a:xfrm>
-          <a:prstGeom prst="rect">
-            <a:avLst/>
-          </a:prstGeom>
-          <a:noFill/>
-          <a:ln/>
-        </p:spPr>
-        <p:txBody>
-          <a:bodyPr wrap="square" lIns="0" tIns="0" rIns="0" bIns="0" rtlCol="0" anchor="t"/>
-          <a:lstStyle/>
-          <a:p>
-            <a:pPr algn="l" indent="0" marL="0">
-              <a:buNone/>
-            </a:pPr>
-            <a:r>
-              <a:rPr lang="en-US" sz="1150" b="1" spc="150" kern="0" dirty="0">
+          <p:cNvPr id="18" name="Text 13"/>
+          <p:cNvSpPr/>
+          <p:nvPr/>
+        </p:nvSpPr>
+        <p:spPr>
+          <a:xfrm>
+            <a:off x="1783080" y="2926080"/>
+            <a:ext cx="1417320" cy="1444752"/>
+          </a:xfrm>
+          <a:prstGeom prst="rect">
+            <a:avLst/>
+          </a:prstGeom>
+          <a:noFill/>
+          <a:ln/>
+        </p:spPr>
+        <p:txBody>
+          <a:bodyPr wrap="square" lIns="0" tIns="0" rIns="0" bIns="0" rtlCol="0" anchor="ctr"/>
+          <a:lstStyle/>
+          <a:p>
+            <a:pPr algn="l" indent="0" marL="0">
+              <a:lnSpc>
+                <a:spcPct val="95000"/>
+              </a:lnSpc>
+              <a:buNone/>
+            </a:pPr>
+            <a:r>
+              <a:rPr lang="en-US" sz="1400" b="1" dirty="0">
                 <a:solidFill>
                   <a:srgbClr val="A4133C"/>
                 </a:solidFill>
-                <a:latin typeface="Calibri" pitchFamily="34" charset="0"/>
-                <a:ea typeface="Calibri" pitchFamily="34" charset="-122"/>
-                <a:cs typeface="Calibri" pitchFamily="34" charset="-120"/>
+                <a:latin typeface="Cambria" pitchFamily="34" charset="0"/>
+                <a:ea typeface="Cambria" pitchFamily="34" charset="-122"/>
+                <a:cs typeface="Cambria" pitchFamily="34" charset="-120"/>
               </a:rPr>
               <a:t>PALPATION</a:t>
             </a:r>
-            <a:endParaRPr lang="en-US" sz="1150" dirty="0"/>
-          </a:p>
-        </p:txBody>
-      </p:sp>
-      <p:sp>
-        <p:nvSpPr>
-          <p:cNvPr id="26" name="Shape 20"/>
-          <p:cNvSpPr/>
-          <p:nvPr/>
-        </p:nvSpPr>
-        <p:spPr>
-          <a:xfrm>
-            <a:off x="5394960" y="3401568"/>
-            <a:ext cx="109728" cy="109728"/>
+            <a:endParaRPr lang="en-US" sz="1400" dirty="0"/>
+          </a:p>
+        </p:txBody>
+      </p:sp>
+      <p:sp>
+        <p:nvSpPr>
+          <p:cNvPr id="19" name="Shape 14"/>
+          <p:cNvSpPr/>
+          <p:nvPr/>
+        </p:nvSpPr>
+        <p:spPr>
+          <a:xfrm>
+            <a:off x="3246120" y="3163824"/>
+            <a:ext cx="0" cy="969264"/>
+          </a:xfrm>
+          <a:prstGeom prst="line">
+            <a:avLst/>
+          </a:prstGeom>
+          <a:noFill/>
+          <a:ln w="12700">
+            <a:solidFill>
+              <a:srgbClr val="FBD8DF"/>
+            </a:solidFill>
+            <a:prstDash val="solid"/>
+          </a:ln>
+        </p:spPr>
+      </p:sp>
+      <p:sp>
+        <p:nvSpPr>
+          <p:cNvPr id="20" name="Shape 15"/>
+          <p:cNvSpPr/>
+          <p:nvPr/>
+        </p:nvSpPr>
+        <p:spPr>
+          <a:xfrm>
+            <a:off x="3520440" y="3218688"/>
+            <a:ext cx="118872" cy="118872"/>
           </a:xfrm>
           <a:prstGeom prst="ellipse">
             <a:avLst/>
@@ -8176,33 +8010,30 @@
       </p:sp>
       <p:sp>
         <p:nvSpPr>
-          <p:cNvPr id="27" name="Text 21"/>
-          <p:cNvSpPr/>
-          <p:nvPr/>
-        </p:nvSpPr>
-        <p:spPr>
-          <a:xfrm>
-            <a:off x="5650992" y="3337560"/>
-            <a:ext cx="5669280" cy="384048"/>
-          </a:xfrm>
-          <a:prstGeom prst="rect">
-            <a:avLst/>
-          </a:prstGeom>
-          <a:noFill/>
-          <a:ln/>
-        </p:spPr>
-        <p:txBody>
-          <a:bodyPr wrap="square" lIns="0" tIns="0" rIns="0" bIns="0" rtlCol="0" anchor="t"/>
-          <a:lstStyle/>
-          <a:p>
-            <a:pPr algn="l" indent="0" marL="0">
-              <a:lnSpc>
-                <a:spcPct val="100000"/>
-              </a:lnSpc>
-              <a:buNone/>
-            </a:pPr>
-            <a:r>
-              <a:rPr lang="en-US" sz="1200" dirty="0">
+          <p:cNvPr id="21" name="Text 16"/>
+          <p:cNvSpPr/>
+          <p:nvPr/>
+        </p:nvSpPr>
+        <p:spPr>
+          <a:xfrm>
+            <a:off x="3767328" y="3090672"/>
+            <a:ext cx="7680960" cy="384048"/>
+          </a:xfrm>
+          <a:prstGeom prst="rect">
+            <a:avLst/>
+          </a:prstGeom>
+          <a:noFill/>
+          <a:ln/>
+        </p:spPr>
+        <p:txBody>
+          <a:bodyPr wrap="square" lIns="0" tIns="0" rIns="0" bIns="0" rtlCol="0" anchor="ctr"/>
+          <a:lstStyle/>
+          <a:p>
+            <a:pPr algn="l" indent="0" marL="0">
+              <a:buNone/>
+            </a:pPr>
+            <a:r>
+              <a:rPr lang="en-US" sz="1250" dirty="0">
                 <a:solidFill>
                   <a:srgbClr val="2B2B33"/>
                 </a:solidFill>
@@ -8210,22 +8041,22 @@
                 <a:ea typeface="Calibri" pitchFamily="34" charset="-122"/>
                 <a:cs typeface="Calibri" pitchFamily="34" charset="-120"/>
               </a:rPr>
-              <a:t>Apex beat in 5th intercostal space, medial to midclavicular line — normal character</a:t>
-            </a:r>
-            <a:endParaRPr lang="en-US" sz="1200" dirty="0"/>
-          </a:p>
-        </p:txBody>
-      </p:sp>
-      <p:sp>
-        <p:nvSpPr>
-          <p:cNvPr id="28" name="Shape 22"/>
-          <p:cNvSpPr/>
-          <p:nvPr/>
-        </p:nvSpPr>
-        <p:spPr>
-          <a:xfrm>
-            <a:off x="5394960" y="3785616"/>
-            <a:ext cx="109728" cy="109728"/>
+              <a:t>Apex beat: 5th intercostal space, medial to the midclavicular line — normal character</a:t>
+            </a:r>
+            <a:endParaRPr lang="en-US" sz="1250" dirty="0"/>
+          </a:p>
+        </p:txBody>
+      </p:sp>
+      <p:sp>
+        <p:nvSpPr>
+          <p:cNvPr id="22" name="Shape 17"/>
+          <p:cNvSpPr/>
+          <p:nvPr/>
+        </p:nvSpPr>
+        <p:spPr>
+          <a:xfrm>
+            <a:off x="3520440" y="3602736"/>
+            <a:ext cx="118872" cy="118872"/>
           </a:xfrm>
           <a:prstGeom prst="ellipse">
             <a:avLst/>
@@ -8238,33 +8069,30 @@
       </p:sp>
       <p:sp>
         <p:nvSpPr>
-          <p:cNvPr id="29" name="Text 23"/>
-          <p:cNvSpPr/>
-          <p:nvPr/>
-        </p:nvSpPr>
-        <p:spPr>
-          <a:xfrm>
-            <a:off x="5650992" y="3721608"/>
-            <a:ext cx="5669280" cy="384048"/>
-          </a:xfrm>
-          <a:prstGeom prst="rect">
-            <a:avLst/>
-          </a:prstGeom>
-          <a:noFill/>
-          <a:ln/>
-        </p:spPr>
-        <p:txBody>
-          <a:bodyPr wrap="square" lIns="0" tIns="0" rIns="0" bIns="0" rtlCol="0" anchor="t"/>
-          <a:lstStyle/>
-          <a:p>
-            <a:pPr algn="l" indent="0" marL="0">
-              <a:lnSpc>
-                <a:spcPct val="100000"/>
-              </a:lnSpc>
-              <a:buNone/>
-            </a:pPr>
-            <a:r>
-              <a:rPr lang="en-US" sz="1200" dirty="0">
+          <p:cNvPr id="23" name="Text 18"/>
+          <p:cNvSpPr/>
+          <p:nvPr/>
+        </p:nvSpPr>
+        <p:spPr>
+          <a:xfrm>
+            <a:off x="3767328" y="3474720"/>
+            <a:ext cx="7680960" cy="384048"/>
+          </a:xfrm>
+          <a:prstGeom prst="rect">
+            <a:avLst/>
+          </a:prstGeom>
+          <a:noFill/>
+          <a:ln/>
+        </p:spPr>
+        <p:txBody>
+          <a:bodyPr wrap="square" lIns="0" tIns="0" rIns="0" bIns="0" rtlCol="0" anchor="ctr"/>
+          <a:lstStyle/>
+          <a:p>
+            <a:pPr algn="l" indent="0" marL="0">
+              <a:buNone/>
+            </a:pPr>
+            <a:r>
+              <a:rPr lang="en-US" sz="1250" dirty="0">
                 <a:solidFill>
                   <a:srgbClr val="2B2B33"/>
                 </a:solidFill>
@@ -8274,20 +8102,20 @@
               </a:rPr>
               <a:t>No thrill; no other palpable sounds</a:t>
             </a:r>
-            <a:endParaRPr lang="en-US" sz="1200" dirty="0"/>
-          </a:p>
-        </p:txBody>
-      </p:sp>
-      <p:sp>
-        <p:nvSpPr>
-          <p:cNvPr id="30" name="Shape 24"/>
-          <p:cNvSpPr/>
-          <p:nvPr/>
-        </p:nvSpPr>
-        <p:spPr>
-          <a:xfrm>
-            <a:off x="5394960" y="4041648"/>
-            <a:ext cx="109728" cy="109728"/>
+            <a:endParaRPr lang="en-US" sz="1250" dirty="0"/>
+          </a:p>
+        </p:txBody>
+      </p:sp>
+      <p:sp>
+        <p:nvSpPr>
+          <p:cNvPr id="24" name="Shape 19"/>
+          <p:cNvSpPr/>
+          <p:nvPr/>
+        </p:nvSpPr>
+        <p:spPr>
+          <a:xfrm>
+            <a:off x="3520440" y="3986784"/>
+            <a:ext cx="118872" cy="118872"/>
           </a:xfrm>
           <a:prstGeom prst="ellipse">
             <a:avLst/>
@@ -8300,33 +8128,30 @@
       </p:sp>
       <p:sp>
         <p:nvSpPr>
-          <p:cNvPr id="31" name="Text 25"/>
-          <p:cNvSpPr/>
-          <p:nvPr/>
-        </p:nvSpPr>
-        <p:spPr>
-          <a:xfrm>
-            <a:off x="5650992" y="3977640"/>
-            <a:ext cx="5669280" cy="384048"/>
-          </a:xfrm>
-          <a:prstGeom prst="rect">
-            <a:avLst/>
-          </a:prstGeom>
-          <a:noFill/>
-          <a:ln/>
-        </p:spPr>
-        <p:txBody>
-          <a:bodyPr wrap="square" lIns="0" tIns="0" rIns="0" bIns="0" rtlCol="0" anchor="t"/>
-          <a:lstStyle/>
-          <a:p>
-            <a:pPr algn="l" indent="0" marL="0">
-              <a:lnSpc>
-                <a:spcPct val="100000"/>
-              </a:lnSpc>
-              <a:buNone/>
-            </a:pPr>
-            <a:r>
-              <a:rPr lang="en-US" sz="1200" dirty="0">
+          <p:cNvPr id="25" name="Text 20"/>
+          <p:cNvSpPr/>
+          <p:nvPr/>
+        </p:nvSpPr>
+        <p:spPr>
+          <a:xfrm>
+            <a:off x="3767328" y="3858768"/>
+            <a:ext cx="7680960" cy="384048"/>
+          </a:xfrm>
+          <a:prstGeom prst="rect">
+            <a:avLst/>
+          </a:prstGeom>
+          <a:noFill/>
+          <a:ln/>
+        </p:spPr>
+        <p:txBody>
+          <a:bodyPr wrap="square" lIns="0" tIns="0" rIns="0" bIns="0" rtlCol="0" anchor="ctr"/>
+          <a:lstStyle/>
+          <a:p>
+            <a:pPr algn="l" indent="0" marL="0">
+              <a:buNone/>
+            </a:pPr>
+            <a:r>
+              <a:rPr lang="en-US" sz="1250" dirty="0">
                 <a:solidFill>
                   <a:srgbClr val="2B2B33"/>
                 </a:solidFill>
@@ -8336,24 +8161,24 @@
               </a:rPr>
               <a:t>No left parasternal heave</a:t>
             </a:r>
-            <a:endParaRPr lang="en-US" sz="1200" dirty="0"/>
-          </a:p>
-        </p:txBody>
-      </p:sp>
-      <p:sp>
-        <p:nvSpPr>
-          <p:cNvPr id="32" name="Shape 26"/>
-          <p:cNvSpPr/>
-          <p:nvPr/>
-        </p:nvSpPr>
-        <p:spPr>
-          <a:xfrm>
-            <a:off x="4937760" y="4325112"/>
-            <a:ext cx="6766560" cy="1664208"/>
+            <a:endParaRPr lang="en-US" sz="1250" dirty="0"/>
+          </a:p>
+        </p:txBody>
+      </p:sp>
+      <p:sp>
+        <p:nvSpPr>
+          <p:cNvPr id="26" name="Shape 21"/>
+          <p:cNvSpPr/>
+          <p:nvPr/>
+        </p:nvSpPr>
+        <p:spPr>
+          <a:xfrm>
+            <a:off x="502920" y="4507992"/>
+            <a:ext cx="11183112" cy="1444752"/>
           </a:xfrm>
           <a:prstGeom prst="roundRect">
             <a:avLst>
-              <a:gd name="adj" fmla="val 6044"/>
+              <a:gd name="adj" fmla="val 7595"/>
             </a:avLst>
           </a:prstGeom>
           <a:solidFill>
@@ -8376,14 +8201,14 @@
       </p:sp>
       <p:sp>
         <p:nvSpPr>
-          <p:cNvPr id="33" name="Shape 27"/>
-          <p:cNvSpPr/>
-          <p:nvPr/>
-        </p:nvSpPr>
-        <p:spPr>
-          <a:xfrm>
-            <a:off x="5193792" y="4462272"/>
-            <a:ext cx="475488" cy="475488"/>
+          <p:cNvPr id="27" name="Shape 22"/>
+          <p:cNvSpPr/>
+          <p:nvPr/>
+        </p:nvSpPr>
+        <p:spPr>
+          <a:xfrm>
+            <a:off x="868680" y="4846320"/>
+            <a:ext cx="768096" cy="768096"/>
           </a:xfrm>
           <a:prstGeom prst="ellipse">
             <a:avLst/>
@@ -8391,7 +8216,7 @@
           <a:solidFill>
             <a:srgbClr val="A4133C"/>
           </a:solidFill>
-          <a:ln w="12700">
+          <a:ln w="19050">
             <a:solidFill>
               <a:srgbClr val="FF4D6D"/>
             </a:solidFill>
@@ -8401,22 +8226,22 @@
       </p:sp>
       <p:pic>
         <p:nvPicPr>
-          <p:cNvPr id="34" name="Image 4" descr="preencoded.png">    </p:cNvPr>
+          <p:cNvPr id="28" name="Image 3" descr="preencoded.png">    </p:cNvPr>
           <p:cNvPicPr>
             <a:picLocks noChangeAspect="1"/>
           </p:cNvPicPr>
           <p:nvPr/>
         </p:nvPicPr>
         <p:blipFill>
-          <a:blip r:embed="rId5"/>
+          <a:blip r:embed="rId4"/>
           <a:stretch>
             <a:fillRect/>
           </a:stretch>
         </p:blipFill>
         <p:spPr>
           <a:xfrm>
-            <a:off x="5312664" y="4581144"/>
-            <a:ext cx="237744" cy="237744"/>
+            <a:off x="1088136" y="5065776"/>
+            <a:ext cx="329184" cy="329184"/>
           </a:xfrm>
           <a:prstGeom prst="rect">
             <a:avLst/>
@@ -8425,53 +8250,79 @@
       </p:pic>
       <p:sp>
         <p:nvSpPr>
-          <p:cNvPr id="35" name="Text 28"/>
-          <p:cNvSpPr/>
-          <p:nvPr/>
-        </p:nvSpPr>
-        <p:spPr>
-          <a:xfrm>
-            <a:off x="5852160" y="4517136"/>
-            <a:ext cx="5623560" cy="256032"/>
-          </a:xfrm>
-          <a:prstGeom prst="rect">
-            <a:avLst/>
-          </a:prstGeom>
-          <a:noFill/>
-          <a:ln/>
-        </p:spPr>
-        <p:txBody>
-          <a:bodyPr wrap="square" lIns="0" tIns="0" rIns="0" bIns="0" rtlCol="0" anchor="t"/>
-          <a:lstStyle/>
-          <a:p>
-            <a:pPr algn="l" indent="0" marL="0">
-              <a:buNone/>
-            </a:pPr>
-            <a:r>
-              <a:rPr lang="en-US" sz="1150" b="1" spc="150" kern="0" dirty="0">
+          <p:cNvPr id="29" name="Text 23"/>
+          <p:cNvSpPr/>
+          <p:nvPr/>
+        </p:nvSpPr>
+        <p:spPr>
+          <a:xfrm>
+            <a:off x="1783080" y="4507992"/>
+            <a:ext cx="1417320" cy="1444752"/>
+          </a:xfrm>
+          <a:prstGeom prst="rect">
+            <a:avLst/>
+          </a:prstGeom>
+          <a:noFill/>
+          <a:ln/>
+        </p:spPr>
+        <p:txBody>
+          <a:bodyPr wrap="square" lIns="0" tIns="0" rIns="0" bIns="0" rtlCol="0" anchor="ctr"/>
+          <a:lstStyle/>
+          <a:p>
+            <a:pPr algn="l" indent="0" marL="0">
+              <a:lnSpc>
+                <a:spcPct val="95000"/>
+              </a:lnSpc>
+              <a:buNone/>
+            </a:pPr>
+            <a:r>
+              <a:rPr lang="en-US" sz="1400" b="1" dirty="0">
                 <a:solidFill>
                   <a:srgbClr val="A4133C"/>
                 </a:solidFill>
-                <a:latin typeface="Calibri" pitchFamily="34" charset="0"/>
-                <a:ea typeface="Calibri" pitchFamily="34" charset="-122"/>
-                <a:cs typeface="Calibri" pitchFamily="34" charset="-120"/>
+                <a:latin typeface="Cambria" pitchFamily="34" charset="0"/>
+                <a:ea typeface="Cambria" pitchFamily="34" charset="-122"/>
+                <a:cs typeface="Cambria" pitchFamily="34" charset="-120"/>
               </a:rPr>
               <a:t>AUSCULTATION</a:t>
             </a:r>
-            <a:endParaRPr lang="en-US" sz="1150" dirty="0"/>
-          </a:p>
-        </p:txBody>
-      </p:sp>
-      <p:sp>
-        <p:nvSpPr>
-          <p:cNvPr id="36" name="Shape 29"/>
-          <p:cNvSpPr/>
-          <p:nvPr/>
-        </p:nvSpPr>
-        <p:spPr>
-          <a:xfrm>
-            <a:off x="5394960" y="5029200"/>
-            <a:ext cx="109728" cy="109728"/>
+            <a:endParaRPr lang="en-US" sz="1400" dirty="0"/>
+          </a:p>
+        </p:txBody>
+      </p:sp>
+      <p:sp>
+        <p:nvSpPr>
+          <p:cNvPr id="30" name="Shape 24"/>
+          <p:cNvSpPr/>
+          <p:nvPr/>
+        </p:nvSpPr>
+        <p:spPr>
+          <a:xfrm>
+            <a:off x="3246120" y="4745736"/>
+            <a:ext cx="0" cy="969264"/>
+          </a:xfrm>
+          <a:prstGeom prst="line">
+            <a:avLst/>
+          </a:prstGeom>
+          <a:noFill/>
+          <a:ln w="12700">
+            <a:solidFill>
+              <a:srgbClr val="FBD8DF"/>
+            </a:solidFill>
+            <a:prstDash val="solid"/>
+          </a:ln>
+        </p:spPr>
+      </p:sp>
+      <p:sp>
+        <p:nvSpPr>
+          <p:cNvPr id="31" name="Shape 25"/>
+          <p:cNvSpPr/>
+          <p:nvPr/>
+        </p:nvSpPr>
+        <p:spPr>
+          <a:xfrm>
+            <a:off x="3520440" y="4800600"/>
+            <a:ext cx="118872" cy="118872"/>
           </a:xfrm>
           <a:prstGeom prst="ellipse">
             <a:avLst/>
@@ -8484,33 +8335,30 @@
       </p:sp>
       <p:sp>
         <p:nvSpPr>
-          <p:cNvPr id="37" name="Text 30"/>
-          <p:cNvSpPr/>
-          <p:nvPr/>
-        </p:nvSpPr>
-        <p:spPr>
-          <a:xfrm>
-            <a:off x="5650992" y="4965192"/>
-            <a:ext cx="5669280" cy="384048"/>
-          </a:xfrm>
-          <a:prstGeom prst="rect">
-            <a:avLst/>
-          </a:prstGeom>
-          <a:noFill/>
-          <a:ln/>
-        </p:spPr>
-        <p:txBody>
-          <a:bodyPr wrap="square" lIns="0" tIns="0" rIns="0" bIns="0" rtlCol="0" anchor="t"/>
-          <a:lstStyle/>
-          <a:p>
-            <a:pPr algn="l" indent="0" marL="0">
-              <a:lnSpc>
-                <a:spcPct val="100000"/>
-              </a:lnSpc>
-              <a:buNone/>
-            </a:pPr>
-            <a:r>
-              <a:rPr lang="en-US" sz="1200" dirty="0">
+          <p:cNvPr id="32" name="Text 26"/>
+          <p:cNvSpPr/>
+          <p:nvPr/>
+        </p:nvSpPr>
+        <p:spPr>
+          <a:xfrm>
+            <a:off x="3767328" y="4672584"/>
+            <a:ext cx="7680960" cy="384048"/>
+          </a:xfrm>
+          <a:prstGeom prst="rect">
+            <a:avLst/>
+          </a:prstGeom>
+          <a:noFill/>
+          <a:ln/>
+        </p:spPr>
+        <p:txBody>
+          <a:bodyPr wrap="square" lIns="0" tIns="0" rIns="0" bIns="0" rtlCol="0" anchor="ctr"/>
+          <a:lstStyle/>
+          <a:p>
+            <a:pPr algn="l" indent="0" marL="0">
+              <a:buNone/>
+            </a:pPr>
+            <a:r>
+              <a:rPr lang="en-US" sz="1250" dirty="0">
                 <a:solidFill>
                   <a:srgbClr val="2B2B33"/>
                 </a:solidFill>
@@ -8520,20 +8368,20 @@
               </a:rPr>
               <a:t>1st heart sound &amp; both components of 2nd heart sound audible at their respective areas</a:t>
             </a:r>
-            <a:endParaRPr lang="en-US" sz="1200" dirty="0"/>
-          </a:p>
-        </p:txBody>
-      </p:sp>
-      <p:sp>
-        <p:nvSpPr>
-          <p:cNvPr id="38" name="Shape 31"/>
-          <p:cNvSpPr/>
-          <p:nvPr/>
-        </p:nvSpPr>
-        <p:spPr>
-          <a:xfrm>
-            <a:off x="5394960" y="5394960"/>
-            <a:ext cx="109728" cy="109728"/>
+            <a:endParaRPr lang="en-US" sz="1250" dirty="0"/>
+          </a:p>
+        </p:txBody>
+      </p:sp>
+      <p:sp>
+        <p:nvSpPr>
+          <p:cNvPr id="33" name="Shape 27"/>
+          <p:cNvSpPr/>
+          <p:nvPr/>
+        </p:nvSpPr>
+        <p:spPr>
+          <a:xfrm>
+            <a:off x="3520440" y="5184648"/>
+            <a:ext cx="118872" cy="118872"/>
           </a:xfrm>
           <a:prstGeom prst="ellipse">
             <a:avLst/>
@@ -8546,33 +8394,30 @@
       </p:sp>
       <p:sp>
         <p:nvSpPr>
-          <p:cNvPr id="39" name="Text 32"/>
-          <p:cNvSpPr/>
-          <p:nvPr/>
-        </p:nvSpPr>
-        <p:spPr>
-          <a:xfrm>
-            <a:off x="5650992" y="5330952"/>
-            <a:ext cx="5669280" cy="384048"/>
-          </a:xfrm>
-          <a:prstGeom prst="rect">
-            <a:avLst/>
-          </a:prstGeom>
-          <a:noFill/>
-          <a:ln/>
-        </p:spPr>
-        <p:txBody>
-          <a:bodyPr wrap="square" lIns="0" tIns="0" rIns="0" bIns="0" rtlCol="0" anchor="t"/>
-          <a:lstStyle/>
-          <a:p>
-            <a:pPr algn="l" indent="0" marL="0">
-              <a:lnSpc>
-                <a:spcPct val="100000"/>
-              </a:lnSpc>
-              <a:buNone/>
-            </a:pPr>
-            <a:r>
-              <a:rPr lang="en-US" sz="1200" dirty="0">
+          <p:cNvPr id="34" name="Text 28"/>
+          <p:cNvSpPr/>
+          <p:nvPr/>
+        </p:nvSpPr>
+        <p:spPr>
+          <a:xfrm>
+            <a:off x="3767328" y="5056632"/>
+            <a:ext cx="7680960" cy="384048"/>
+          </a:xfrm>
+          <a:prstGeom prst="rect">
+            <a:avLst/>
+          </a:prstGeom>
+          <a:noFill/>
+          <a:ln/>
+        </p:spPr>
+        <p:txBody>
+          <a:bodyPr wrap="square" lIns="0" tIns="0" rIns="0" bIns="0" rtlCol="0" anchor="ctr"/>
+          <a:lstStyle/>
+          <a:p>
+            <a:pPr algn="l" indent="0" marL="0">
+              <a:buNone/>
+            </a:pPr>
+            <a:r>
+              <a:rPr lang="en-US" sz="1250" dirty="0">
                 <a:solidFill>
                   <a:srgbClr val="2B2B33"/>
                 </a:solidFill>
@@ -8580,22 +8425,22 @@
                 <a:ea typeface="Calibri" pitchFamily="34" charset="-122"/>
                 <a:cs typeface="Calibri" pitchFamily="34" charset="-120"/>
               </a:rPr>
-              <a:t>1st heart sound of variable intensity; both components of 2nd heart sound of normal intensity</a:t>
-            </a:r>
-            <a:endParaRPr lang="en-US" sz="1200" dirty="0"/>
-          </a:p>
-        </p:txBody>
-      </p:sp>
-      <p:sp>
-        <p:nvSpPr>
-          <p:cNvPr id="40" name="Shape 33"/>
-          <p:cNvSpPr/>
-          <p:nvPr/>
-        </p:nvSpPr>
-        <p:spPr>
-          <a:xfrm>
-            <a:off x="5394960" y="5760720"/>
-            <a:ext cx="109728" cy="109728"/>
+              <a:t>1st heart sound: variable intensity;  2nd heart sound: both components normal intensity</a:t>
+            </a:r>
+            <a:endParaRPr lang="en-US" sz="1250" dirty="0"/>
+          </a:p>
+        </p:txBody>
+      </p:sp>
+      <p:sp>
+        <p:nvSpPr>
+          <p:cNvPr id="35" name="Shape 29"/>
+          <p:cNvSpPr/>
+          <p:nvPr/>
+        </p:nvSpPr>
+        <p:spPr>
+          <a:xfrm>
+            <a:off x="3520440" y="5568696"/>
+            <a:ext cx="118872" cy="118872"/>
           </a:xfrm>
           <a:prstGeom prst="ellipse">
             <a:avLst/>
@@ -8608,33 +8453,30 @@
       </p:sp>
       <p:sp>
         <p:nvSpPr>
-          <p:cNvPr id="41" name="Text 34"/>
-          <p:cNvSpPr/>
-          <p:nvPr/>
-        </p:nvSpPr>
-        <p:spPr>
-          <a:xfrm>
-            <a:off x="5650992" y="5696712"/>
-            <a:ext cx="5669280" cy="384048"/>
-          </a:xfrm>
-          <a:prstGeom prst="rect">
-            <a:avLst/>
-          </a:prstGeom>
-          <a:noFill/>
-          <a:ln/>
-        </p:spPr>
-        <p:txBody>
-          <a:bodyPr wrap="square" lIns="0" tIns="0" rIns="0" bIns="0" rtlCol="0" anchor="t"/>
-          <a:lstStyle/>
-          <a:p>
-            <a:pPr algn="l" indent="0" marL="0">
-              <a:lnSpc>
-                <a:spcPct val="100000"/>
-              </a:lnSpc>
-              <a:buNone/>
-            </a:pPr>
-            <a:r>
-              <a:rPr lang="en-US" sz="1200" dirty="0">
+          <p:cNvPr id="36" name="Text 30"/>
+          <p:cNvSpPr/>
+          <p:nvPr/>
+        </p:nvSpPr>
+        <p:spPr>
+          <a:xfrm>
+            <a:off x="3767328" y="5440680"/>
+            <a:ext cx="7680960" cy="384048"/>
+          </a:xfrm>
+          <a:prstGeom prst="rect">
+            <a:avLst/>
+          </a:prstGeom>
+          <a:noFill/>
+          <a:ln/>
+        </p:spPr>
+        <p:txBody>
+          <a:bodyPr wrap="square" lIns="0" tIns="0" rIns="0" bIns="0" rtlCol="0" anchor="ctr"/>
+          <a:lstStyle/>
+          <a:p>
+            <a:pPr algn="l" indent="0" marL="0">
+              <a:buNone/>
+            </a:pPr>
+            <a:r>
+              <a:rPr lang="en-US" sz="1250" dirty="0">
                 <a:solidFill>
                   <a:srgbClr val="2B2B33"/>
                 </a:solidFill>
@@ -8644,13 +8486,13 @@
               </a:rPr>
               <a:t>No added sounds audible</a:t>
             </a:r>
-            <a:endParaRPr lang="en-US" sz="1200" dirty="0"/>
-          </a:p>
-        </p:txBody>
-      </p:sp>
-      <p:sp>
-        <p:nvSpPr>
-          <p:cNvPr id="42" name="Text 35"/>
+            <a:endParaRPr lang="en-US" sz="1250" dirty="0"/>
+          </a:p>
+        </p:txBody>
+      </p:sp>
+      <p:sp>
+        <p:nvSpPr>
+          <p:cNvPr id="37" name="Text 31"/>
           <p:cNvSpPr/>
           <p:nvPr/>
         </p:nvSpPr>
@@ -8689,7 +8531,7 @@
       </p:sp>
       <p:sp>
         <p:nvSpPr>
-          <p:cNvPr id="43" name="Text 36"/>
+          <p:cNvPr id="38" name="Text 32"/>
           <p:cNvSpPr/>
           <p:nvPr/>
         </p:nvSpPr>

</xml_diff>

<commit_message>
Add 'Choice of Anticoagulant' slide (nonvalvular vs valvular AF)
New slide after the Anticoagulation slide with two headings: Nonvalvular
AF (IV/LMW heparin, warfarin, DOACs — any may be considered) and Valvular
AF (mitral stenosis -> warfarin only; other valve disease -> DOACs
supported per ACC/AHA). Combined deck now 45 slides; topic 22.

Co-Authored-By: Claude Opus 4.8 <noreply@anthropic.com>
Claude-Session: https://claude.ai/code/session_01S7QW8AwqyMReKwuqyBkBBv
</commit_message>
<xml_diff>
--- a/presentations/Clinicopathological-Conference-COMPLETE.pptx
+++ b/presentations/Clinicopathological-Conference-COMPLETE.pptx
@@ -49,9 +49,10 @@
     <p:sldId id="297" r:id="rId43"/>
     <p:sldId id="298" r:id="rId44"/>
     <p:sldId id="299" r:id="rId45"/>
+    <p:sldId id="300" r:id="rId46"/>
   </p:sldIdLst>
   <p:notesMasterIdLst>
-    <p:notesMasterId r:id="rId46"/>
+    <p:notesMasterId r:id="rId47"/>
   </p:notesMasterIdLst>
   <p:sldSz cx="12191695" cy="6858000"/>
   <p:notesSz cx="6858000" cy="12191695"/>
@@ -3913,6 +3914,94 @@
             <a:fld id="{F7021451-1387-4CA6-816F-3879F97B5CBC}" type="slidenum">
               <a:rPr lang="en-US"/>
               <a:t>44</a:t>
+            </a:fld>
+            <a:endParaRPr lang="en-US"/>
+          </a:p>
+        </p:txBody>
+      </p:sp>
+    </p:spTree>
+    <p:extLst>
+      <p:ext uri="{BB962C8B-B14F-4D97-AF65-F5344CB8AC3E}">
+        <p14:creationId xmlns:p14="http://schemas.microsoft.com/office/powerpoint/2010/main" val="1024086991"/>
+      </p:ext>
+    </p:extLst>
+  </p:cSld>
+  <p:clrMapOvr>
+    <a:masterClrMapping/>
+  </p:clrMapOvr>
+</p:notes>
+</file>
+
+<file path=ppt/notesSlides/notesSlide45.xml><?xml version="1.0" encoding="utf-8"?>
+<p:notes xmlns:a="http://schemas.openxmlformats.org/drawingml/2006/main" xmlns:r="http://schemas.openxmlformats.org/officeDocument/2006/relationships" xmlns:p="http://schemas.openxmlformats.org/presentationml/2006/main">
+  <p:cSld>
+    <p:spTree>
+      <p:nvGrpSpPr>
+        <p:cNvPr id="1" name=""/>
+        <p:cNvGrpSpPr/>
+        <p:nvPr/>
+      </p:nvGrpSpPr>
+      <p:grpSpPr>
+        <a:xfrm>
+          <a:off x="0" y="0"/>
+          <a:ext cx="0" cy="0"/>
+          <a:chOff x="0" y="0"/>
+          <a:chExt cx="0" cy="0"/>
+        </a:xfrm>
+      </p:grpSpPr>
+      <p:sp>
+        <p:nvSpPr>
+          <p:cNvPr id="2" name="Slide Image Placeholder 1"/>
+          <p:cNvSpPr>
+            <a:spLocks noGrp="1" noRot="1" noChangeAspect="1"/>
+          </p:cNvSpPr>
+          <p:nvPr>
+            <p:ph type="sldImg"/>
+          </p:nvPr>
+        </p:nvSpPr>
+        <p:spPr/>
+      </p:sp>
+      <p:sp>
+        <p:nvSpPr>
+          <p:cNvPr id="3" name="Notes Placeholder 2"/>
+          <p:cNvSpPr>
+            <a:spLocks noGrp="1"/>
+          </p:cNvSpPr>
+          <p:nvPr>
+            <p:ph type="body" idx="1"/>
+          </p:nvPr>
+        </p:nvSpPr>
+        <p:spPr/>
+        <p:txBody>
+          <a:bodyPr/>
+          <a:lstStyle/>
+          <a:p>
+            <a:r>
+              <a:rPr lang="en-US" dirty="0"/>
+              <a:t/>
+            </a:r>
+            <a:endParaRPr lang="en-US" dirty="0"/>
+          </a:p>
+        </p:txBody>
+      </p:sp>
+      <p:sp>
+        <p:nvSpPr>
+          <p:cNvPr id="4" name="Slide Number Placeholder 3"/>
+          <p:cNvSpPr>
+            <a:spLocks noGrp="1"/>
+          </p:cNvSpPr>
+          <p:nvPr>
+            <p:ph type="sldNum" sz="quarter" idx="10"/>
+          </p:nvPr>
+        </p:nvSpPr>
+        <p:spPr/>
+        <p:txBody>
+          <a:bodyPr/>
+          <a:lstStyle/>
+          <a:p>
+            <a:fld id="{F7021451-1387-4CA6-816F-3879F97B5CBC}" type="slidenum">
+              <a:rPr lang="en-US"/>
+              <a:t>45</a:t>
             </a:fld>
             <a:endParaRPr lang="en-US"/>
           </a:p>
@@ -48348,7 +48437,7 @@
                 <a:ea typeface="Calibri" pitchFamily="34" charset="-122"/>
                 <a:cs typeface="Calibri" pitchFamily="34" charset="-120"/>
               </a:rPr>
-              <a:t>SPECIAL POPULATIONS · PREGNANCY</a:t>
+              <a:t>STROKE PREVENTION · VALVULAR VS NONVALVULAR</a:t>
             </a:r>
             <a:endParaRPr lang="en-US" sz="1250" dirty="0"/>
           </a:p>
@@ -48387,7 +48476,7 @@
                 <a:ea typeface="Cambria" pitchFamily="34" charset="-122"/>
                 <a:cs typeface="Cambria" pitchFamily="34" charset="-120"/>
               </a:rPr>
-              <a:t>Anticoagulation in Pregnancy</a:t>
+              <a:t>Choice of Anticoagulant</a:t>
             </a:r>
             <a:endParaRPr lang="en-US" sz="3000" dirty="0"/>
           </a:p>
@@ -48402,11 +48491,11 @@
         <p:spPr>
           <a:xfrm>
             <a:off x="502920" y="1783080"/>
-            <a:ext cx="5532120" cy="2971800"/>
+            <a:ext cx="5532120" cy="4206240"/>
           </a:xfrm>
           <a:prstGeom prst="roundRect">
             <a:avLst>
-              <a:gd name="adj" fmla="val 3692"/>
+              <a:gd name="adj" fmla="val 2609"/>
             </a:avLst>
           </a:prstGeom>
           <a:solidFill>
@@ -48429,80 +48518,27 @@
       </p:sp>
       <p:sp>
         <p:nvSpPr>
-          <p:cNvPr id="7" name="Text 4"/>
-          <p:cNvSpPr/>
-          <p:nvPr/>
-        </p:nvSpPr>
-        <p:spPr>
-          <a:xfrm>
-            <a:off x="822960" y="2011680"/>
-            <a:ext cx="4846320" cy="274320"/>
-          </a:xfrm>
-          <a:prstGeom prst="rect">
-            <a:avLst/>
-          </a:prstGeom>
-          <a:noFill/>
-          <a:ln/>
-        </p:spPr>
-        <p:txBody>
-          <a:bodyPr wrap="square" rtlCol="0" anchor="t"/>
-          <a:lstStyle/>
-          <a:p>
-            <a:pPr algn="l" indent="0" marL="0">
-              <a:buNone/>
-            </a:pPr>
-            <a:r>
-              <a:rPr lang="en-US" sz="1300" b="1" spc="150" kern="0" dirty="0">
-                <a:solidFill>
-                  <a:srgbClr val="2E7D32"/>
-                </a:solidFill>
-                <a:latin typeface="Calibri" pitchFamily="34" charset="0"/>
-                <a:ea typeface="Calibri" pitchFamily="34" charset="-122"/>
-                <a:cs typeface="Calibri" pitchFamily="34" charset="-120"/>
-              </a:rPr>
-              <a:t>✓  </a:t>
-            </a:r>
-            <a:pPr algn="l" indent="0" marL="0">
-              <a:buNone/>
-            </a:pPr>
-            <a:r>
-              <a:rPr lang="en-US" sz="1300" b="1" spc="150" kern="0" dirty="0">
-                <a:solidFill>
-                  <a:srgbClr val="2E7D32"/>
-                </a:solidFill>
-                <a:latin typeface="Calibri" pitchFamily="34" charset="0"/>
-                <a:ea typeface="Calibri" pitchFamily="34" charset="-122"/>
-                <a:cs typeface="Calibri" pitchFamily="34" charset="-120"/>
-              </a:rPr>
-              <a:t>PREFERRED</a:t>
-            </a:r>
-            <a:endParaRPr lang="en-US" sz="1300" dirty="0"/>
-          </a:p>
-        </p:txBody>
-      </p:sp>
-      <p:sp>
-        <p:nvSpPr>
-          <p:cNvPr id="8" name="Shape 5"/>
-          <p:cNvSpPr/>
-          <p:nvPr/>
-        </p:nvSpPr>
-        <p:spPr>
-          <a:xfrm>
-            <a:off x="822960" y="2395728"/>
-            <a:ext cx="548640" cy="548640"/>
+          <p:cNvPr id="7" name="Shape 4"/>
+          <p:cNvSpPr/>
+          <p:nvPr/>
+        </p:nvSpPr>
+        <p:spPr>
+          <a:xfrm>
+            <a:off x="822960" y="2084832"/>
+            <a:ext cx="749808" cy="749808"/>
           </a:xfrm>
           <a:prstGeom prst="ellipse">
             <a:avLst/>
           </a:prstGeom>
           <a:solidFill>
-            <a:srgbClr val="2E7D32"/>
+            <a:srgbClr val="A4133C"/>
           </a:solidFill>
           <a:ln/>
         </p:spPr>
       </p:sp>
       <p:pic>
         <p:nvPicPr>
-          <p:cNvPr id="9" name="Image 1" descr="preencoded.png">    </p:cNvPr>
+          <p:cNvPr id="8" name="Image 1" descr="preencoded.png">    </p:cNvPr>
           <p:cNvPicPr>
             <a:picLocks noChangeAspect="1"/>
           </p:cNvPicPr>
@@ -48516,8 +48552,8 @@
         </p:blipFill>
         <p:spPr>
           <a:xfrm>
-            <a:off x="960120" y="2551176"/>
-            <a:ext cx="283464" cy="246888"/>
+            <a:off x="1042416" y="2304288"/>
+            <a:ext cx="310896" cy="310896"/>
           </a:xfrm>
           <a:prstGeom prst="rect">
             <a:avLst/>
@@ -48526,30 +48562,30 @@
       </p:pic>
       <p:sp>
         <p:nvSpPr>
-          <p:cNvPr id="10" name="Text 6"/>
-          <p:cNvSpPr/>
-          <p:nvPr/>
-        </p:nvSpPr>
-        <p:spPr>
-          <a:xfrm>
-            <a:off x="1508760" y="2350008"/>
-            <a:ext cx="4343400" cy="365760"/>
-          </a:xfrm>
-          <a:prstGeom prst="rect">
-            <a:avLst/>
-          </a:prstGeom>
-          <a:noFill/>
-          <a:ln/>
-        </p:spPr>
-        <p:txBody>
-          <a:bodyPr wrap="square" lIns="0" tIns="0" rIns="0" bIns="0" rtlCol="0" anchor="t"/>
-          <a:lstStyle/>
-          <a:p>
-            <a:pPr algn="l" indent="0" marL="0">
-              <a:buNone/>
-            </a:pPr>
-            <a:r>
-              <a:rPr lang="en-US" sz="1650" b="1" dirty="0">
+          <p:cNvPr id="9" name="Text 5"/>
+          <p:cNvSpPr/>
+          <p:nvPr/>
+        </p:nvSpPr>
+        <p:spPr>
+          <a:xfrm>
+            <a:off x="1783080" y="2084832"/>
+            <a:ext cx="4114800" cy="749808"/>
+          </a:xfrm>
+          <a:prstGeom prst="rect">
+            <a:avLst/>
+          </a:prstGeom>
+          <a:noFill/>
+          <a:ln/>
+        </p:spPr>
+        <p:txBody>
+          <a:bodyPr wrap="square" lIns="0" tIns="0" rIns="0" bIns="0" rtlCol="0" anchor="ctr"/>
+          <a:lstStyle/>
+          <a:p>
+            <a:pPr algn="l" indent="0" marL="0">
+              <a:buNone/>
+            </a:pPr>
+            <a:r>
+              <a:rPr lang="en-US" sz="2200" b="1" dirty="0">
                 <a:solidFill>
                   <a:srgbClr val="2B2B33"/>
                 </a:solidFill>
@@ -48557,22 +48593,22 @@
                 <a:ea typeface="Cambria" pitchFamily="34" charset="-122"/>
                 <a:cs typeface="Cambria" pitchFamily="34" charset="-120"/>
               </a:rPr>
-              <a:t>LMWH (enoxaparin)</a:t>
-            </a:r>
-            <a:endParaRPr lang="en-US" sz="1650" dirty="0"/>
-          </a:p>
-        </p:txBody>
-      </p:sp>
-      <p:sp>
-        <p:nvSpPr>
-          <p:cNvPr id="11" name="Text 7"/>
-          <p:cNvSpPr/>
-          <p:nvPr/>
-        </p:nvSpPr>
-        <p:spPr>
-          <a:xfrm>
-            <a:off x="1508760" y="2706624"/>
-            <a:ext cx="4389120" cy="685800"/>
+              <a:t>Nonvalvular AF</a:t>
+            </a:r>
+            <a:endParaRPr lang="en-US" sz="2200" dirty="0"/>
+          </a:p>
+        </p:txBody>
+      </p:sp>
+      <p:sp>
+        <p:nvSpPr>
+          <p:cNvPr id="10" name="Text 6"/>
+          <p:cNvSpPr/>
+          <p:nvPr/>
+        </p:nvSpPr>
+        <p:spPr>
+          <a:xfrm>
+            <a:off x="868680" y="2944368"/>
+            <a:ext cx="4846320" cy="274320"/>
           </a:xfrm>
           <a:prstGeom prst="rect">
             <a:avLst/>
@@ -48585,13 +48621,10 @@
           <a:lstStyle/>
           <a:p>
             <a:pPr algn="l" indent="0" marL="0">
-              <a:lnSpc>
-                <a:spcPct val="108000"/>
-              </a:lnSpc>
-              <a:buNone/>
-            </a:pPr>
-            <a:r>
-              <a:rPr lang="en-US" sz="1250" dirty="0">
+              <a:buNone/>
+            </a:pPr>
+            <a:r>
+              <a:rPr lang="en-US" sz="1350" i="1" dirty="0">
                 <a:solidFill>
                   <a:srgbClr val="6B6B76"/>
                 </a:solidFill>
@@ -48599,35 +48632,349 @@
                 <a:ea typeface="Calibri" pitchFamily="34" charset="-122"/>
                 <a:cs typeface="Calibri" pitchFamily="34" charset="-120"/>
               </a:rPr>
-              <a:t>Does not cross the placenta — the agent of choice; weight-adjusted, monitor anti-Xa</a:t>
-            </a:r>
-            <a:endParaRPr lang="en-US" sz="1250" dirty="0"/>
-          </a:p>
-        </p:txBody>
-      </p:sp>
-      <p:sp>
-        <p:nvSpPr>
-          <p:cNvPr id="12" name="Shape 8"/>
-          <p:cNvSpPr/>
-          <p:nvPr/>
-        </p:nvSpPr>
-        <p:spPr>
-          <a:xfrm>
-            <a:off x="822960" y="3511296"/>
-            <a:ext cx="548640" cy="548640"/>
+              <a:t>Broadest choice of agents</a:t>
+            </a:r>
+            <a:endParaRPr lang="en-US" sz="1350" dirty="0"/>
+          </a:p>
+        </p:txBody>
+      </p:sp>
+      <p:sp>
+        <p:nvSpPr>
+          <p:cNvPr id="11" name="Shape 7"/>
+          <p:cNvSpPr/>
+          <p:nvPr/>
+        </p:nvSpPr>
+        <p:spPr>
+          <a:xfrm>
+            <a:off x="914400" y="3419856"/>
+            <a:ext cx="128016" cy="128016"/>
           </a:xfrm>
           <a:prstGeom prst="ellipse">
             <a:avLst/>
           </a:prstGeom>
           <a:solidFill>
-            <a:srgbClr val="2E7D32"/>
+            <a:srgbClr val="FF4D6D"/>
+          </a:solidFill>
+          <a:ln/>
+        </p:spPr>
+      </p:sp>
+      <p:sp>
+        <p:nvSpPr>
+          <p:cNvPr id="12" name="Text 8"/>
+          <p:cNvSpPr/>
+          <p:nvPr/>
+        </p:nvSpPr>
+        <p:spPr>
+          <a:xfrm>
+            <a:off x="1170432" y="3346704"/>
+            <a:ext cx="4663440" cy="365760"/>
+          </a:xfrm>
+          <a:prstGeom prst="rect">
+            <a:avLst/>
+          </a:prstGeom>
+          <a:noFill/>
+          <a:ln/>
+        </p:spPr>
+        <p:txBody>
+          <a:bodyPr wrap="square" lIns="0" tIns="0" rIns="0" bIns="0" rtlCol="0" anchor="ctr"/>
+          <a:lstStyle/>
+          <a:p>
+            <a:pPr algn="l" indent="0" marL="0">
+              <a:buNone/>
+            </a:pPr>
+            <a:r>
+              <a:rPr lang="en-US" sz="1350" b="1" dirty="0">
+                <a:solidFill>
+                  <a:srgbClr val="A4133C"/>
+                </a:solidFill>
+                <a:latin typeface="Calibri" pitchFamily="34" charset="0"/>
+                <a:ea typeface="Calibri" pitchFamily="34" charset="-122"/>
+                <a:cs typeface="Calibri" pitchFamily="34" charset="-120"/>
+              </a:rPr>
+              <a:t>IV heparin / LMWH  </a:t>
+            </a:r>
+            <a:pPr algn="l" indent="0" marL="0">
+              <a:buNone/>
+            </a:pPr>
+            <a:r>
+              <a:rPr lang="en-US" sz="1350" dirty="0">
+                <a:solidFill>
+                  <a:srgbClr val="6B6B76"/>
+                </a:solidFill>
+                <a:latin typeface="Calibri" pitchFamily="34" charset="0"/>
+                <a:ea typeface="Calibri" pitchFamily="34" charset="-122"/>
+                <a:cs typeface="Calibri" pitchFamily="34" charset="-120"/>
+              </a:rPr>
+              <a:t>— Parenteral anticoagulation</a:t>
+            </a:r>
+            <a:endParaRPr lang="en-US" sz="1350" dirty="0"/>
+          </a:p>
+        </p:txBody>
+      </p:sp>
+      <p:sp>
+        <p:nvSpPr>
+          <p:cNvPr id="13" name="Shape 9"/>
+          <p:cNvSpPr/>
+          <p:nvPr/>
+        </p:nvSpPr>
+        <p:spPr>
+          <a:xfrm>
+            <a:off x="914400" y="3968496"/>
+            <a:ext cx="128016" cy="128016"/>
+          </a:xfrm>
+          <a:prstGeom prst="ellipse">
+            <a:avLst/>
+          </a:prstGeom>
+          <a:solidFill>
+            <a:srgbClr val="FF4D6D"/>
+          </a:solidFill>
+          <a:ln/>
+        </p:spPr>
+      </p:sp>
+      <p:sp>
+        <p:nvSpPr>
+          <p:cNvPr id="14" name="Text 10"/>
+          <p:cNvSpPr/>
+          <p:nvPr/>
+        </p:nvSpPr>
+        <p:spPr>
+          <a:xfrm>
+            <a:off x="1170432" y="3895344"/>
+            <a:ext cx="4663440" cy="365760"/>
+          </a:xfrm>
+          <a:prstGeom prst="rect">
+            <a:avLst/>
+          </a:prstGeom>
+          <a:noFill/>
+          <a:ln/>
+        </p:spPr>
+        <p:txBody>
+          <a:bodyPr wrap="square" lIns="0" tIns="0" rIns="0" bIns="0" rtlCol="0" anchor="ctr"/>
+          <a:lstStyle/>
+          <a:p>
+            <a:pPr algn="l" indent="0" marL="0">
+              <a:buNone/>
+            </a:pPr>
+            <a:r>
+              <a:rPr lang="en-US" sz="1350" b="1" dirty="0">
+                <a:solidFill>
+                  <a:srgbClr val="A4133C"/>
+                </a:solidFill>
+                <a:latin typeface="Calibri" pitchFamily="34" charset="0"/>
+                <a:ea typeface="Calibri" pitchFamily="34" charset="-122"/>
+                <a:cs typeface="Calibri" pitchFamily="34" charset="-120"/>
+              </a:rPr>
+              <a:t>Warfarin  </a:t>
+            </a:r>
+            <a:pPr algn="l" indent="0" marL="0">
+              <a:buNone/>
+            </a:pPr>
+            <a:r>
+              <a:rPr lang="en-US" sz="1350" dirty="0">
+                <a:solidFill>
+                  <a:srgbClr val="6B6B76"/>
+                </a:solidFill>
+                <a:latin typeface="Calibri" pitchFamily="34" charset="0"/>
+                <a:ea typeface="Calibri" pitchFamily="34" charset="-122"/>
+                <a:cs typeface="Calibri" pitchFamily="34" charset="-120"/>
+              </a:rPr>
+              <a:t>— Vitamin-K antagonist</a:t>
+            </a:r>
+            <a:endParaRPr lang="en-US" sz="1350" dirty="0"/>
+          </a:p>
+        </p:txBody>
+      </p:sp>
+      <p:sp>
+        <p:nvSpPr>
+          <p:cNvPr id="15" name="Shape 11"/>
+          <p:cNvSpPr/>
+          <p:nvPr/>
+        </p:nvSpPr>
+        <p:spPr>
+          <a:xfrm>
+            <a:off x="914400" y="4517136"/>
+            <a:ext cx="128016" cy="128016"/>
+          </a:xfrm>
+          <a:prstGeom prst="ellipse">
+            <a:avLst/>
+          </a:prstGeom>
+          <a:solidFill>
+            <a:srgbClr val="FF4D6D"/>
+          </a:solidFill>
+          <a:ln/>
+        </p:spPr>
+      </p:sp>
+      <p:sp>
+        <p:nvSpPr>
+          <p:cNvPr id="16" name="Text 12"/>
+          <p:cNvSpPr/>
+          <p:nvPr/>
+        </p:nvSpPr>
+        <p:spPr>
+          <a:xfrm>
+            <a:off x="1170432" y="4443984"/>
+            <a:ext cx="4663440" cy="365760"/>
+          </a:xfrm>
+          <a:prstGeom prst="rect">
+            <a:avLst/>
+          </a:prstGeom>
+          <a:noFill/>
+          <a:ln/>
+        </p:spPr>
+        <p:txBody>
+          <a:bodyPr wrap="square" lIns="0" tIns="0" rIns="0" bIns="0" rtlCol="0" anchor="ctr"/>
+          <a:lstStyle/>
+          <a:p>
+            <a:pPr algn="l" indent="0" marL="0">
+              <a:buNone/>
+            </a:pPr>
+            <a:r>
+              <a:rPr lang="en-US" sz="1350" b="1" dirty="0">
+                <a:solidFill>
+                  <a:srgbClr val="A4133C"/>
+                </a:solidFill>
+                <a:latin typeface="Calibri" pitchFamily="34" charset="0"/>
+                <a:ea typeface="Calibri" pitchFamily="34" charset="-122"/>
+                <a:cs typeface="Calibri" pitchFamily="34" charset="-120"/>
+              </a:rPr>
+              <a:t>DOACs  </a:t>
+            </a:r>
+            <a:pPr algn="l" indent="0" marL="0">
+              <a:buNone/>
+            </a:pPr>
+            <a:r>
+              <a:rPr lang="en-US" sz="1350" dirty="0">
+                <a:solidFill>
+                  <a:srgbClr val="6B6B76"/>
+                </a:solidFill>
+                <a:latin typeface="Calibri" pitchFamily="34" charset="0"/>
+                <a:ea typeface="Calibri" pitchFamily="34" charset="-122"/>
+                <a:cs typeface="Calibri" pitchFamily="34" charset="-120"/>
+              </a:rPr>
+              <a:t>— New oral anticoagulants</a:t>
+            </a:r>
+            <a:endParaRPr lang="en-US" sz="1350" dirty="0"/>
+          </a:p>
+        </p:txBody>
+      </p:sp>
+      <p:sp>
+        <p:nvSpPr>
+          <p:cNvPr id="17" name="Shape 13"/>
+          <p:cNvSpPr/>
+          <p:nvPr/>
+        </p:nvSpPr>
+        <p:spPr>
+          <a:xfrm>
+            <a:off x="822960" y="5175504"/>
+            <a:ext cx="4892040" cy="566928"/>
+          </a:xfrm>
+          <a:prstGeom prst="roundRect">
+            <a:avLst>
+              <a:gd name="adj" fmla="val 50000"/>
+            </a:avLst>
+          </a:prstGeom>
+          <a:solidFill>
+            <a:srgbClr val="590D22"/>
+          </a:solidFill>
+          <a:ln/>
+        </p:spPr>
+      </p:sp>
+      <p:sp>
+        <p:nvSpPr>
+          <p:cNvPr id="18" name="Text 14"/>
+          <p:cNvSpPr/>
+          <p:nvPr/>
+        </p:nvSpPr>
+        <p:spPr>
+          <a:xfrm>
+            <a:off x="822960" y="5175504"/>
+            <a:ext cx="4892040" cy="566928"/>
+          </a:xfrm>
+          <a:prstGeom prst="rect">
+            <a:avLst/>
+          </a:prstGeom>
+          <a:noFill/>
+          <a:ln/>
+        </p:spPr>
+        <p:txBody>
+          <a:bodyPr wrap="square" lIns="0" tIns="0" rIns="0" bIns="0" rtlCol="0" anchor="ctr"/>
+          <a:lstStyle/>
+          <a:p>
+            <a:pPr algn="ctr" indent="0" marL="0">
+              <a:buNone/>
+            </a:pPr>
+            <a:r>
+              <a:rPr lang="en-US" sz="1300" b="1" dirty="0">
+                <a:solidFill>
+                  <a:srgbClr val="FBD8DF"/>
+                </a:solidFill>
+                <a:latin typeface="Calibri" pitchFamily="34" charset="0"/>
+                <a:ea typeface="Calibri" pitchFamily="34" charset="-122"/>
+                <a:cs typeface="Calibri" pitchFamily="34" charset="-120"/>
+              </a:rPr>
+              <a:t>Any of these may be considered</a:t>
+            </a:r>
+            <a:endParaRPr lang="en-US" sz="1300" dirty="0"/>
+          </a:p>
+        </p:txBody>
+      </p:sp>
+      <p:sp>
+        <p:nvSpPr>
+          <p:cNvPr id="19" name="Shape 15"/>
+          <p:cNvSpPr/>
+          <p:nvPr/>
+        </p:nvSpPr>
+        <p:spPr>
+          <a:xfrm>
+            <a:off x="6153912" y="1783080"/>
+            <a:ext cx="5532120" cy="4206240"/>
+          </a:xfrm>
+          <a:prstGeom prst="roundRect">
+            <a:avLst>
+              <a:gd name="adj" fmla="val 2609"/>
+            </a:avLst>
+          </a:prstGeom>
+          <a:solidFill>
+            <a:srgbClr val="FFF0F3"/>
+          </a:solidFill>
+          <a:ln w="12700">
+            <a:solidFill>
+              <a:srgbClr val="FBD8DF"/>
+            </a:solidFill>
+            <a:prstDash val="solid"/>
+          </a:ln>
+          <a:effectLst>
+            <a:outerShdw sx="100000" sy="100000" kx="0" ky="0" algn="bl" rotWithShape="0" blurRad="127000" dist="50800" dir="5400000">
+              <a:srgbClr val="C9A3AC">
+                <a:alpha val="45000"/>
+              </a:srgbClr>
+            </a:outerShdw>
+          </a:effectLst>
+        </p:spPr>
+      </p:sp>
+      <p:sp>
+        <p:nvSpPr>
+          <p:cNvPr id="20" name="Shape 16"/>
+          <p:cNvSpPr/>
+          <p:nvPr/>
+        </p:nvSpPr>
+        <p:spPr>
+          <a:xfrm>
+            <a:off x="6473952" y="2084832"/>
+            <a:ext cx="749808" cy="749808"/>
+          </a:xfrm>
+          <a:prstGeom prst="ellipse">
+            <a:avLst/>
+          </a:prstGeom>
+          <a:solidFill>
+            <a:srgbClr val="A4133C"/>
           </a:solidFill>
           <a:ln/>
         </p:spPr>
       </p:sp>
       <p:pic>
         <p:nvPicPr>
-          <p:cNvPr id="13" name="Image 2" descr="preencoded.png">    </p:cNvPr>
+          <p:cNvPr id="21" name="Image 2" descr="preencoded.png">    </p:cNvPr>
           <p:cNvPicPr>
             <a:picLocks noChangeAspect="1"/>
           </p:cNvPicPr>
@@ -48641,8 +48988,8 @@
         </p:blipFill>
         <p:spPr>
           <a:xfrm>
-            <a:off x="960120" y="3666744"/>
-            <a:ext cx="283464" cy="246888"/>
+            <a:off x="6693408" y="2304288"/>
+            <a:ext cx="310896" cy="310896"/>
           </a:xfrm>
           <a:prstGeom prst="rect">
             <a:avLst/>
@@ -48651,30 +48998,30 @@
       </p:pic>
       <p:sp>
         <p:nvSpPr>
-          <p:cNvPr id="14" name="Text 9"/>
-          <p:cNvSpPr/>
-          <p:nvPr/>
-        </p:nvSpPr>
-        <p:spPr>
-          <a:xfrm>
-            <a:off x="1508760" y="3465576"/>
-            <a:ext cx="4343400" cy="365760"/>
-          </a:xfrm>
-          <a:prstGeom prst="rect">
-            <a:avLst/>
-          </a:prstGeom>
-          <a:noFill/>
-          <a:ln/>
-        </p:spPr>
-        <p:txBody>
-          <a:bodyPr wrap="square" lIns="0" tIns="0" rIns="0" bIns="0" rtlCol="0" anchor="t"/>
-          <a:lstStyle/>
-          <a:p>
-            <a:pPr algn="l" indent="0" marL="0">
-              <a:buNone/>
-            </a:pPr>
-            <a:r>
-              <a:rPr lang="en-US" sz="1650" b="1" dirty="0">
+          <p:cNvPr id="22" name="Text 17"/>
+          <p:cNvSpPr/>
+          <p:nvPr/>
+        </p:nvSpPr>
+        <p:spPr>
+          <a:xfrm>
+            <a:off x="7434072" y="2084832"/>
+            <a:ext cx="4114800" cy="749808"/>
+          </a:xfrm>
+          <a:prstGeom prst="rect">
+            <a:avLst/>
+          </a:prstGeom>
+          <a:noFill/>
+          <a:ln/>
+        </p:spPr>
+        <p:txBody>
+          <a:bodyPr wrap="square" lIns="0" tIns="0" rIns="0" bIns="0" rtlCol="0" anchor="ctr"/>
+          <a:lstStyle/>
+          <a:p>
+            <a:pPr algn="l" indent="0" marL="0">
+              <a:buNone/>
+            </a:pPr>
+            <a:r>
+              <a:rPr lang="en-US" sz="2200" b="1" dirty="0">
                 <a:solidFill>
                   <a:srgbClr val="2B2B33"/>
                 </a:solidFill>
@@ -48682,22 +49029,22 @@
                 <a:ea typeface="Cambria" pitchFamily="34" charset="-122"/>
                 <a:cs typeface="Cambria" pitchFamily="34" charset="-120"/>
               </a:rPr>
-              <a:t>Unfractionated heparin</a:t>
-            </a:r>
-            <a:endParaRPr lang="en-US" sz="1650" dirty="0"/>
-          </a:p>
-        </p:txBody>
-      </p:sp>
-      <p:sp>
-        <p:nvSpPr>
-          <p:cNvPr id="15" name="Text 10"/>
-          <p:cNvSpPr/>
-          <p:nvPr/>
-        </p:nvSpPr>
-        <p:spPr>
-          <a:xfrm>
-            <a:off x="1508760" y="3822192"/>
-            <a:ext cx="4389120" cy="685800"/>
+              <a:t>Valvular AF</a:t>
+            </a:r>
+            <a:endParaRPr lang="en-US" sz="2200" dirty="0"/>
+          </a:p>
+        </p:txBody>
+      </p:sp>
+      <p:sp>
+        <p:nvSpPr>
+          <p:cNvPr id="23" name="Text 18"/>
+          <p:cNvSpPr/>
+          <p:nvPr/>
+        </p:nvSpPr>
+        <p:spPr>
+          <a:xfrm>
+            <a:off x="6519672" y="2944368"/>
+            <a:ext cx="5029200" cy="274320"/>
           </a:xfrm>
           <a:prstGeom prst="rect">
             <a:avLst/>
@@ -48710,13 +49057,10 @@
           <a:lstStyle/>
           <a:p>
             <a:pPr algn="l" indent="0" marL="0">
-              <a:lnSpc>
-                <a:spcPct val="108000"/>
-              </a:lnSpc>
-              <a:buNone/>
-            </a:pPr>
-            <a:r>
-              <a:rPr lang="en-US" sz="1250" dirty="0">
+              <a:buNone/>
+            </a:pPr>
+            <a:r>
+              <a:rPr lang="en-US" sz="1350" i="1" dirty="0">
                 <a:solidFill>
                   <a:srgbClr val="6B6B76"/>
                 </a:solidFill>
@@ -48724,187 +49068,88 @@
                 <a:ea typeface="Calibri" pitchFamily="34" charset="-122"/>
                 <a:cs typeface="Calibri" pitchFamily="34" charset="-120"/>
               </a:rPr>
-              <a:t>Also placenta-safe; useful peri-delivery — short-acting &amp; reversible</a:t>
-            </a:r>
-            <a:endParaRPr lang="en-US" sz="1250" dirty="0"/>
-          </a:p>
-        </p:txBody>
-      </p:sp>
-      <p:sp>
-        <p:nvSpPr>
-          <p:cNvPr id="16" name="Shape 11"/>
-          <p:cNvSpPr/>
-          <p:nvPr/>
-        </p:nvSpPr>
-        <p:spPr>
-          <a:xfrm>
-            <a:off x="6172200" y="1783080"/>
-            <a:ext cx="5532120" cy="2971800"/>
+              <a:t>Agent depends on the valve lesion</a:t>
+            </a:r>
+            <a:endParaRPr lang="en-US" sz="1350" dirty="0"/>
+          </a:p>
+        </p:txBody>
+      </p:sp>
+      <p:sp>
+        <p:nvSpPr>
+          <p:cNvPr id="24" name="Shape 19"/>
+          <p:cNvSpPr/>
+          <p:nvPr/>
+        </p:nvSpPr>
+        <p:spPr>
+          <a:xfrm>
+            <a:off x="6473952" y="3246120"/>
+            <a:ext cx="4892040" cy="1170432"/>
           </a:xfrm>
           <a:prstGeom prst="roundRect">
             <a:avLst>
-              <a:gd name="adj" fmla="val 3692"/>
+              <a:gd name="adj" fmla="val 7813"/>
             </a:avLst>
           </a:prstGeom>
           <a:solidFill>
             <a:srgbClr val="590D22"/>
           </a:solidFill>
-          <a:ln/>
-          <a:effectLst>
-            <a:outerShdw sx="100000" sy="100000" kx="0" ky="0" algn="bl" rotWithShape="0" blurRad="127000" dist="50800" dir="5400000">
-              <a:srgbClr val="C9A3AC">
-                <a:alpha val="45000"/>
-              </a:srgbClr>
-            </a:outerShdw>
-          </a:effectLst>
-        </p:spPr>
-      </p:sp>
-      <p:sp>
-        <p:nvSpPr>
-          <p:cNvPr id="17" name="Text 12"/>
-          <p:cNvSpPr/>
-          <p:nvPr/>
-        </p:nvSpPr>
-        <p:spPr>
-          <a:xfrm>
-            <a:off x="6492240" y="2011680"/>
-            <a:ext cx="4846320" cy="274320"/>
-          </a:xfrm>
-          <a:prstGeom prst="rect">
-            <a:avLst/>
-          </a:prstGeom>
-          <a:noFill/>
-          <a:ln/>
-        </p:spPr>
-        <p:txBody>
-          <a:bodyPr wrap="square" rtlCol="0" anchor="t"/>
-          <a:lstStyle/>
-          <a:p>
-            <a:pPr algn="l" indent="0" marL="0">
-              <a:buNone/>
-            </a:pPr>
-            <a:r>
-              <a:rPr lang="en-US" sz="1300" b="1" spc="150" kern="0" dirty="0">
+          <a:ln w="12700">
+            <a:solidFill>
+              <a:srgbClr val="FBD8DF"/>
+            </a:solidFill>
+            <a:prstDash val="solid"/>
+          </a:ln>
+        </p:spPr>
+      </p:sp>
+      <p:sp>
+        <p:nvSpPr>
+          <p:cNvPr id="25" name="Text 20"/>
+          <p:cNvSpPr/>
+          <p:nvPr/>
+        </p:nvSpPr>
+        <p:spPr>
+          <a:xfrm>
+            <a:off x="6720840" y="3410712"/>
+            <a:ext cx="4480560" cy="274320"/>
+          </a:xfrm>
+          <a:prstGeom prst="rect">
+            <a:avLst/>
+          </a:prstGeom>
+          <a:noFill/>
+          <a:ln/>
+        </p:spPr>
+        <p:txBody>
+          <a:bodyPr wrap="square" lIns="0" tIns="0" rIns="0" bIns="0" rtlCol="0" anchor="t"/>
+          <a:lstStyle/>
+          <a:p>
+            <a:pPr algn="l" indent="0" marL="0">
+              <a:buNone/>
+            </a:pPr>
+            <a:r>
+              <a:rPr lang="en-US" sz="1500" b="1" dirty="0">
                 <a:solidFill>
                   <a:srgbClr val="FF4D6D"/>
-                </a:solidFill>
-                <a:latin typeface="Calibri" pitchFamily="34" charset="0"/>
-                <a:ea typeface="Calibri" pitchFamily="34" charset="-122"/>
-                <a:cs typeface="Calibri" pitchFamily="34" charset="-120"/>
-              </a:rPr>
-              <a:t>✕  </a:t>
-            </a:r>
-            <a:pPr algn="l" indent="0" marL="0">
-              <a:buNone/>
-            </a:pPr>
-            <a:r>
-              <a:rPr lang="en-US" sz="1300" b="1" spc="150" kern="0" dirty="0">
-                <a:solidFill>
-                  <a:srgbClr val="FFFFFF"/>
-                </a:solidFill>
-                <a:latin typeface="Calibri" pitchFamily="34" charset="0"/>
-                <a:ea typeface="Calibri" pitchFamily="34" charset="-122"/>
-                <a:cs typeface="Calibri" pitchFamily="34" charset="-120"/>
-              </a:rPr>
-              <a:t>AVOID</a:t>
-            </a:r>
-            <a:endParaRPr lang="en-US" sz="1300" dirty="0"/>
-          </a:p>
-        </p:txBody>
-      </p:sp>
-      <p:sp>
-        <p:nvSpPr>
-          <p:cNvPr id="18" name="Shape 13"/>
-          <p:cNvSpPr/>
-          <p:nvPr/>
-        </p:nvSpPr>
-        <p:spPr>
-          <a:xfrm>
-            <a:off x="6492240" y="2395728"/>
-            <a:ext cx="548640" cy="548640"/>
-          </a:xfrm>
-          <a:prstGeom prst="ellipse">
-            <a:avLst/>
-          </a:prstGeom>
-          <a:solidFill>
-            <a:srgbClr val="A4133C"/>
-          </a:solidFill>
-          <a:ln/>
-        </p:spPr>
-      </p:sp>
-      <p:pic>
-        <p:nvPicPr>
-          <p:cNvPr id="19" name="Image 3" descr="preencoded.png">    </p:cNvPr>
-          <p:cNvPicPr>
-            <a:picLocks noChangeAspect="1"/>
-          </p:cNvPicPr>
-          <p:nvPr/>
-        </p:nvPicPr>
-        <p:blipFill>
-          <a:blip r:embed="rId4"/>
-          <a:stretch>
-            <a:fillRect/>
-          </a:stretch>
-        </p:blipFill>
-        <p:spPr>
-          <a:xfrm>
-            <a:off x="6638544" y="2551176"/>
-            <a:ext cx="256032" cy="256032"/>
-          </a:xfrm>
-          <a:prstGeom prst="rect">
-            <a:avLst/>
-          </a:prstGeom>
-        </p:spPr>
-      </p:pic>
-      <p:sp>
-        <p:nvSpPr>
-          <p:cNvPr id="20" name="Text 14"/>
-          <p:cNvSpPr/>
-          <p:nvPr/>
-        </p:nvSpPr>
-        <p:spPr>
-          <a:xfrm>
-            <a:off x="7178040" y="2350008"/>
-            <a:ext cx="4297680" cy="365760"/>
-          </a:xfrm>
-          <a:prstGeom prst="rect">
-            <a:avLst/>
-          </a:prstGeom>
-          <a:noFill/>
-          <a:ln/>
-        </p:spPr>
-        <p:txBody>
-          <a:bodyPr wrap="square" lIns="0" tIns="0" rIns="0" bIns="0" rtlCol="0" anchor="t"/>
-          <a:lstStyle/>
-          <a:p>
-            <a:pPr algn="l" indent="0" marL="0">
-              <a:buNone/>
-            </a:pPr>
-            <a:r>
-              <a:rPr lang="en-US" sz="1650" b="1" dirty="0">
-                <a:solidFill>
-                  <a:srgbClr val="FFFFFF"/>
                 </a:solidFill>
                 <a:latin typeface="Cambria" pitchFamily="34" charset="0"/>
                 <a:ea typeface="Cambria" pitchFamily="34" charset="-122"/>
                 <a:cs typeface="Cambria" pitchFamily="34" charset="-120"/>
               </a:rPr>
-              <a:t>Warfarin (VKA)</a:t>
-            </a:r>
-            <a:endParaRPr lang="en-US" sz="1650" dirty="0"/>
-          </a:p>
-        </p:txBody>
-      </p:sp>
-      <p:sp>
-        <p:nvSpPr>
-          <p:cNvPr id="21" name="Text 15"/>
-          <p:cNvSpPr/>
-          <p:nvPr/>
-        </p:nvSpPr>
-        <p:spPr>
-          <a:xfrm>
-            <a:off x="7178040" y="2706624"/>
-            <a:ext cx="4343400" cy="685800"/>
+              <a:t>Mitral stenosis + AF</a:t>
+            </a:r>
+            <a:endParaRPr lang="en-US" sz="1500" dirty="0"/>
+          </a:p>
+        </p:txBody>
+      </p:sp>
+      <p:sp>
+        <p:nvSpPr>
+          <p:cNvPr id="26" name="Text 21"/>
+          <p:cNvSpPr/>
+          <p:nvPr/>
+        </p:nvSpPr>
+        <p:spPr>
+          <a:xfrm>
+            <a:off x="6720840" y="3758184"/>
+            <a:ext cx="4434840" cy="594360"/>
           </a:xfrm>
           <a:prstGeom prst="rect">
             <a:avLst/>
@@ -48918,12 +49163,12 @@
           <a:p>
             <a:pPr algn="l" indent="0" marL="0">
               <a:lnSpc>
-                <a:spcPct val="108000"/>
+                <a:spcPct val="105000"/>
               </a:lnSpc>
               <a:buNone/>
             </a:pPr>
             <a:r>
-              <a:rPr lang="en-US" sz="1250" dirty="0">
+              <a:rPr lang="en-US" sz="1300" dirty="0">
                 <a:solidFill>
                   <a:srgbClr val="FBD8DF"/>
                 </a:solidFill>
@@ -48931,66 +49176,49 @@
                 <a:ea typeface="Calibri" pitchFamily="34" charset="-122"/>
                 <a:cs typeface="Calibri" pitchFamily="34" charset="-120"/>
               </a:rPr>
-              <a:t>Teratogenic — embryopathy at weeks 6–12 and fetal bleeding near term</a:t>
-            </a:r>
-            <a:endParaRPr lang="en-US" sz="1250" dirty="0"/>
-          </a:p>
-        </p:txBody>
-      </p:sp>
-      <p:sp>
-        <p:nvSpPr>
-          <p:cNvPr id="22" name="Shape 16"/>
-          <p:cNvSpPr/>
-          <p:nvPr/>
-        </p:nvSpPr>
-        <p:spPr>
-          <a:xfrm>
-            <a:off x="6492240" y="3511296"/>
-            <a:ext cx="548640" cy="548640"/>
-          </a:xfrm>
-          <a:prstGeom prst="ellipse">
-            <a:avLst/>
+              <a:t>Warfarin — the only proven oral anticoagulant to date</a:t>
+            </a:r>
+            <a:endParaRPr lang="en-US" sz="1300" dirty="0"/>
+          </a:p>
+        </p:txBody>
+      </p:sp>
+      <p:sp>
+        <p:nvSpPr>
+          <p:cNvPr id="27" name="Shape 22"/>
+          <p:cNvSpPr/>
+          <p:nvPr/>
+        </p:nvSpPr>
+        <p:spPr>
+          <a:xfrm>
+            <a:off x="6473952" y="4544568"/>
+            <a:ext cx="4892040" cy="1170432"/>
+          </a:xfrm>
+          <a:prstGeom prst="roundRect">
+            <a:avLst>
+              <a:gd name="adj" fmla="val 7813"/>
+            </a:avLst>
           </a:prstGeom>
           <a:solidFill>
-            <a:srgbClr val="A4133C"/>
+            <a:srgbClr val="FFFFFF"/>
           </a:solidFill>
-          <a:ln/>
-        </p:spPr>
-      </p:sp>
-      <p:pic>
-        <p:nvPicPr>
-          <p:cNvPr id="23" name="Image 4" descr="preencoded.png">    </p:cNvPr>
-          <p:cNvPicPr>
-            <a:picLocks noChangeAspect="1"/>
-          </p:cNvPicPr>
-          <p:nvPr/>
-        </p:nvPicPr>
-        <p:blipFill>
-          <a:blip r:embed="rId5"/>
-          <a:stretch>
-            <a:fillRect/>
-          </a:stretch>
-        </p:blipFill>
-        <p:spPr>
-          <a:xfrm>
-            <a:off x="6638544" y="3666744"/>
-            <a:ext cx="256032" cy="256032"/>
-          </a:xfrm>
-          <a:prstGeom prst="rect">
-            <a:avLst/>
-          </a:prstGeom>
-        </p:spPr>
-      </p:pic>
-      <p:sp>
-        <p:nvSpPr>
-          <p:cNvPr id="24" name="Text 17"/>
-          <p:cNvSpPr/>
-          <p:nvPr/>
-        </p:nvSpPr>
-        <p:spPr>
-          <a:xfrm>
-            <a:off x="7178040" y="3465576"/>
-            <a:ext cx="4297680" cy="365760"/>
+          <a:ln w="12700">
+            <a:solidFill>
+              <a:srgbClr val="FBD8DF"/>
+            </a:solidFill>
+            <a:prstDash val="solid"/>
+          </a:ln>
+        </p:spPr>
+      </p:sp>
+      <p:sp>
+        <p:nvSpPr>
+          <p:cNvPr id="28" name="Text 23"/>
+          <p:cNvSpPr/>
+          <p:nvPr/>
+        </p:nvSpPr>
+        <p:spPr>
+          <a:xfrm>
+            <a:off x="6720840" y="4709160"/>
+            <a:ext cx="4480560" cy="274320"/>
           </a:xfrm>
           <a:prstGeom prst="rect">
             <a:avLst/>
@@ -49006,30 +49234,30 @@
               <a:buNone/>
             </a:pPr>
             <a:r>
-              <a:rPr lang="en-US" sz="1650" b="1" dirty="0">
-                <a:solidFill>
-                  <a:srgbClr val="FFFFFF"/>
+              <a:rPr lang="en-US" sz="1500" b="1" dirty="0">
+                <a:solidFill>
+                  <a:srgbClr val="A4133C"/>
                 </a:solidFill>
                 <a:latin typeface="Cambria" pitchFamily="34" charset="0"/>
                 <a:ea typeface="Cambria" pitchFamily="34" charset="-122"/>
                 <a:cs typeface="Cambria" pitchFamily="34" charset="-120"/>
               </a:rPr>
-              <a:t>DOACs</a:t>
-            </a:r>
-            <a:endParaRPr lang="en-US" sz="1650" dirty="0"/>
-          </a:p>
-        </p:txBody>
-      </p:sp>
-      <p:sp>
-        <p:nvSpPr>
-          <p:cNvPr id="25" name="Text 18"/>
-          <p:cNvSpPr/>
-          <p:nvPr/>
-        </p:nvSpPr>
-        <p:spPr>
-          <a:xfrm>
-            <a:off x="7178040" y="3822192"/>
-            <a:ext cx="4343400" cy="685800"/>
+              <a:t>Other valve disease + AF</a:t>
+            </a:r>
+            <a:endParaRPr lang="en-US" sz="1500" dirty="0"/>
+          </a:p>
+        </p:txBody>
+      </p:sp>
+      <p:sp>
+        <p:nvSpPr>
+          <p:cNvPr id="29" name="Text 24"/>
+          <p:cNvSpPr/>
+          <p:nvPr/>
+        </p:nvSpPr>
+        <p:spPr>
+          <a:xfrm>
+            <a:off x="6720840" y="5056632"/>
+            <a:ext cx="4434840" cy="594360"/>
           </a:xfrm>
           <a:prstGeom prst="rect">
             <a:avLst/>
@@ -49043,87 +49271,12 @@
           <a:p>
             <a:pPr algn="l" indent="0" marL="0">
               <a:lnSpc>
-                <a:spcPct val="108000"/>
+                <a:spcPct val="105000"/>
               </a:lnSpc>
               <a:buNone/>
             </a:pPr>
             <a:r>
-              <a:rPr lang="en-US" sz="1250" dirty="0">
-                <a:solidFill>
-                  <a:srgbClr val="FBD8DF"/>
-                </a:solidFill>
-                <a:latin typeface="Calibri" pitchFamily="34" charset="0"/>
-                <a:ea typeface="Calibri" pitchFamily="34" charset="-122"/>
-                <a:cs typeface="Calibri" pitchFamily="34" charset="-120"/>
-              </a:rPr>
-              <a:t>Not recommended — cross the placenta with limited safety data</a:t>
-            </a:r>
-            <a:endParaRPr lang="en-US" sz="1250" dirty="0"/>
-          </a:p>
-        </p:txBody>
-      </p:sp>
-      <p:sp>
-        <p:nvSpPr>
-          <p:cNvPr id="26" name="Shape 19"/>
-          <p:cNvSpPr/>
-          <p:nvPr/>
-        </p:nvSpPr>
-        <p:spPr>
-          <a:xfrm>
-            <a:off x="502920" y="4937760"/>
-            <a:ext cx="11183112" cy="1051560"/>
-          </a:xfrm>
-          <a:prstGeom prst="roundRect">
-            <a:avLst>
-              <a:gd name="adj" fmla="val 10435"/>
-            </a:avLst>
-          </a:prstGeom>
-          <a:solidFill>
-            <a:srgbClr val="FBD8DF"/>
-          </a:solidFill>
-          <a:ln/>
-        </p:spPr>
-      </p:sp>
-      <p:sp>
-        <p:nvSpPr>
-          <p:cNvPr id="27" name="Text 20"/>
-          <p:cNvSpPr/>
-          <p:nvPr/>
-        </p:nvSpPr>
-        <p:spPr>
-          <a:xfrm>
-            <a:off x="914400" y="5084064"/>
-            <a:ext cx="10424160" cy="365760"/>
-          </a:xfrm>
-          <a:prstGeom prst="rect">
-            <a:avLst/>
-          </a:prstGeom>
-          <a:noFill/>
-          <a:ln/>
-        </p:spPr>
-        <p:txBody>
-          <a:bodyPr wrap="square" lIns="0" tIns="0" rIns="0" bIns="0" rtlCol="0" anchor="ctr"/>
-          <a:lstStyle/>
-          <a:p>
-            <a:pPr algn="l" indent="0" marL="0">
-              <a:buNone/>
-            </a:pPr>
-            <a:r>
-              <a:rPr lang="en-US" sz="1350" b="1" dirty="0">
-                <a:solidFill>
-                  <a:srgbClr val="A4133C"/>
-                </a:solidFill>
-                <a:latin typeface="Calibri" pitchFamily="34" charset="0"/>
-                <a:ea typeface="Calibri" pitchFamily="34" charset="-122"/>
-                <a:cs typeface="Calibri" pitchFamily="34" charset="-120"/>
-              </a:rPr>
-              <a:t>Peri-delivery   </a:t>
-            </a:r>
-            <a:pPr algn="l" indent="0" marL="0">
-              <a:buNone/>
-            </a:pPr>
-            <a:r>
-              <a:rPr lang="en-US" sz="1350" dirty="0">
+              <a:rPr lang="en-US" sz="1300" dirty="0">
                 <a:solidFill>
                   <a:srgbClr val="2B2B33"/>
                 </a:solidFill>
@@ -49131,68 +49284,15 @@
                 <a:ea typeface="Calibri" pitchFamily="34" charset="-122"/>
                 <a:cs typeface="Calibri" pitchFamily="34" charset="-120"/>
               </a:rPr>
-              <a:t>switch LMWH → UFH (or briefly hold) to allow neuraxial anaesthesia and limit bleeding.</a:t>
-            </a:r>
-            <a:endParaRPr lang="en-US" sz="1350" dirty="0"/>
-          </a:p>
-        </p:txBody>
-      </p:sp>
-      <p:sp>
-        <p:nvSpPr>
-          <p:cNvPr id="28" name="Text 21"/>
-          <p:cNvSpPr/>
-          <p:nvPr/>
-        </p:nvSpPr>
-        <p:spPr>
-          <a:xfrm>
-            <a:off x="914400" y="5468112"/>
-            <a:ext cx="10607040" cy="365760"/>
-          </a:xfrm>
-          <a:prstGeom prst="rect">
-            <a:avLst/>
-          </a:prstGeom>
-          <a:noFill/>
-          <a:ln/>
-        </p:spPr>
-        <p:txBody>
-          <a:bodyPr wrap="square" lIns="0" tIns="0" rIns="0" bIns="0" rtlCol="0" anchor="ctr"/>
-          <a:lstStyle/>
-          <a:p>
-            <a:pPr algn="l" indent="0" marL="0">
-              <a:buNone/>
-            </a:pPr>
-            <a:r>
-              <a:rPr lang="en-US" sz="1350" b="1" dirty="0">
-                <a:solidFill>
-                  <a:srgbClr val="A4133C"/>
-                </a:solidFill>
-                <a:latin typeface="Calibri" pitchFamily="34" charset="0"/>
-                <a:ea typeface="Calibri" pitchFamily="34" charset="-122"/>
-                <a:cs typeface="Calibri" pitchFamily="34" charset="-120"/>
-              </a:rPr>
-              <a:t>Breastfeeding   </a:t>
-            </a:r>
-            <a:pPr algn="l" indent="0" marL="0">
-              <a:buNone/>
-            </a:pPr>
-            <a:r>
-              <a:rPr lang="en-US" sz="1350" dirty="0">
-                <a:solidFill>
-                  <a:srgbClr val="2B2B33"/>
-                </a:solidFill>
-                <a:latin typeface="Calibri" pitchFamily="34" charset="0"/>
-                <a:ea typeface="Calibri" pitchFamily="34" charset="-122"/>
-                <a:cs typeface="Calibri" pitchFamily="34" charset="-120"/>
-              </a:rPr>
-              <a:t>warfarin, LMWH and UFH are compatible; DOACs are avoided. Plan with a specialist team.</a:t>
-            </a:r>
-            <a:endParaRPr lang="en-US" sz="1350" dirty="0"/>
-          </a:p>
-        </p:txBody>
-      </p:sp>
-      <p:sp>
-        <p:nvSpPr>
-          <p:cNvPr id="29" name="Text 22"/>
+              <a:t>Non-coumadin agents (DOACs) supported — ACC/AHA guidelines (registry data)</a:t>
+            </a:r>
+            <a:endParaRPr lang="en-US" sz="1300" dirty="0"/>
+          </a:p>
+        </p:txBody>
+      </p:sp>
+      <p:sp>
+        <p:nvSpPr>
+          <p:cNvPr id="30" name="Text 25"/>
           <p:cNvSpPr/>
           <p:nvPr/>
         </p:nvSpPr>
@@ -49231,7 +49331,7 @@
       </p:sp>
       <p:sp>
         <p:nvSpPr>
-          <p:cNvPr id="30" name="Text 23"/>
+          <p:cNvPr id="31" name="Text 26"/>
           <p:cNvSpPr/>
           <p:nvPr/>
         </p:nvSpPr>
@@ -49421,7 +49521,7 @@
                 <a:ea typeface="Cambria" pitchFamily="34" charset="-122"/>
                 <a:cs typeface="Cambria" pitchFamily="34" charset="-120"/>
               </a:rPr>
-              <a:t>Rhythm &amp; Rate Control in Pregnancy</a:t>
+              <a:t>Anticoagulation in Pregnancy</a:t>
             </a:r>
             <a:endParaRPr lang="en-US" sz="3000" dirty="0"/>
           </a:p>
@@ -49436,11 +49536,11 @@
         <p:spPr>
           <a:xfrm>
             <a:off x="502920" y="1783080"/>
-            <a:ext cx="5532120" cy="4206240"/>
+            <a:ext cx="5532120" cy="2971800"/>
           </a:xfrm>
           <a:prstGeom prst="roundRect">
             <a:avLst>
-              <a:gd name="adj" fmla="val 2609"/>
+              <a:gd name="adj" fmla="val 3692"/>
             </a:avLst>
           </a:prstGeom>
           <a:solidFill>
@@ -49469,7 +49569,7 @@
         </p:nvSpPr>
         <p:spPr>
           <a:xfrm>
-            <a:off x="868680" y="2057400"/>
+            <a:off x="822960" y="2011680"/>
             <a:ext cx="4846320" cy="274320"/>
           </a:xfrm>
           <a:prstGeom prst="rect">
@@ -49508,7 +49608,7 @@
                 <a:ea typeface="Calibri" pitchFamily="34" charset="-122"/>
                 <a:cs typeface="Calibri" pitchFamily="34" charset="-120"/>
               </a:rPr>
-              <a:t>GENERALLY SAFE</a:t>
+              <a:t>PREFERRED</a:t>
             </a:r>
             <a:endParaRPr lang="en-US" sz="1300" dirty="0"/>
           </a:p>
@@ -49522,21 +49622,16 @@
         </p:nvSpPr>
         <p:spPr>
           <a:xfrm>
-            <a:off x="868680" y="2542032"/>
-            <a:ext cx="566928" cy="566928"/>
+            <a:off x="822960" y="2395728"/>
+            <a:ext cx="548640" cy="548640"/>
           </a:xfrm>
           <a:prstGeom prst="ellipse">
             <a:avLst/>
           </a:prstGeom>
           <a:solidFill>
-            <a:srgbClr val="FFFFFF"/>
+            <a:srgbClr val="2E7D32"/>
           </a:solidFill>
-          <a:ln w="12700">
-            <a:solidFill>
-              <a:srgbClr val="FBD8DF"/>
-            </a:solidFill>
-            <a:prstDash val="solid"/>
-          </a:ln>
+          <a:ln/>
         </p:spPr>
       </p:sp>
       <p:pic>
@@ -49555,8 +49650,8 @@
         </p:blipFill>
         <p:spPr>
           <a:xfrm>
-            <a:off x="1014984" y="2688336"/>
-            <a:ext cx="274320" cy="274320"/>
+            <a:off x="960120" y="2551176"/>
+            <a:ext cx="283464" cy="246888"/>
           </a:xfrm>
           <a:prstGeom prst="rect">
             <a:avLst/>
@@ -49571,8 +49666,8 @@
         </p:nvSpPr>
         <p:spPr>
           <a:xfrm>
-            <a:off x="1618488" y="2505456"/>
-            <a:ext cx="4233672" cy="292608"/>
+            <a:off x="1508760" y="2350008"/>
+            <a:ext cx="4343400" cy="365760"/>
           </a:xfrm>
           <a:prstGeom prst="rect">
             <a:avLst/>
@@ -49588,7 +49683,7 @@
               <a:buNone/>
             </a:pPr>
             <a:r>
-              <a:rPr lang="en-US" sz="1600" b="1" dirty="0">
+              <a:rPr lang="en-US" sz="1650" b="1" dirty="0">
                 <a:solidFill>
                   <a:srgbClr val="2B2B33"/>
                 </a:solidFill>
@@ -49596,9 +49691,9 @@
                 <a:ea typeface="Cambria" pitchFamily="34" charset="-122"/>
                 <a:cs typeface="Cambria" pitchFamily="34" charset="-120"/>
               </a:rPr>
-              <a:t>Beta-blockers</a:t>
-            </a:r>
-            <a:endParaRPr lang="en-US" sz="1600" dirty="0"/>
+              <a:t>LMWH (enoxaparin)</a:t>
+            </a:r>
+            <a:endParaRPr lang="en-US" sz="1650" dirty="0"/>
           </a:p>
         </p:txBody>
       </p:sp>
@@ -49610,8 +49705,8 @@
         </p:nvSpPr>
         <p:spPr>
           <a:xfrm>
-            <a:off x="1618488" y="2816352"/>
-            <a:ext cx="4233672" cy="365760"/>
+            <a:off x="1508760" y="2706624"/>
+            <a:ext cx="4389120" cy="685800"/>
           </a:xfrm>
           <a:prstGeom prst="rect">
             <a:avLst/>
@@ -49624,6 +49719,9 @@
           <a:lstStyle/>
           <a:p>
             <a:pPr algn="l" indent="0" marL="0">
+              <a:lnSpc>
+                <a:spcPct val="108000"/>
+              </a:lnSpc>
               <a:buNone/>
             </a:pPr>
             <a:r>
@@ -49635,7 +49733,7 @@
                 <a:ea typeface="Calibri" pitchFamily="34" charset="-122"/>
                 <a:cs typeface="Calibri" pitchFamily="34" charset="-120"/>
               </a:rPr>
-              <a:t>First-line rate control (metoprolol, bisoprolol) — avoid atenolol</a:t>
+              <a:t>Does not cross the placenta — the agent of choice; weight-adjusted, monitor anti-Xa</a:t>
             </a:r>
             <a:endParaRPr lang="en-US" sz="1250" dirty="0"/>
           </a:p>
@@ -49649,21 +49747,16 @@
         </p:nvSpPr>
         <p:spPr>
           <a:xfrm>
-            <a:off x="868680" y="3621024"/>
-            <a:ext cx="566928" cy="566928"/>
+            <a:off x="822960" y="3511296"/>
+            <a:ext cx="548640" cy="548640"/>
           </a:xfrm>
           <a:prstGeom prst="ellipse">
             <a:avLst/>
           </a:prstGeom>
           <a:solidFill>
-            <a:srgbClr val="FFFFFF"/>
+            <a:srgbClr val="2E7D32"/>
           </a:solidFill>
-          <a:ln w="12700">
-            <a:solidFill>
-              <a:srgbClr val="FBD8DF"/>
-            </a:solidFill>
-            <a:prstDash val="solid"/>
-          </a:ln>
+          <a:ln/>
         </p:spPr>
       </p:sp>
       <p:pic>
@@ -49682,8 +49775,8 @@
         </p:blipFill>
         <p:spPr>
           <a:xfrm>
-            <a:off x="1014984" y="3767328"/>
-            <a:ext cx="274320" cy="274320"/>
+            <a:off x="960120" y="3666744"/>
+            <a:ext cx="283464" cy="246888"/>
           </a:xfrm>
           <a:prstGeom prst="rect">
             <a:avLst/>
@@ -49698,8 +49791,8 @@
         </p:nvSpPr>
         <p:spPr>
           <a:xfrm>
-            <a:off x="1618488" y="3584448"/>
-            <a:ext cx="4233672" cy="292608"/>
+            <a:off x="1508760" y="3465576"/>
+            <a:ext cx="4343400" cy="365760"/>
           </a:xfrm>
           <a:prstGeom prst="rect">
             <a:avLst/>
@@ -49715,7 +49808,7 @@
               <a:buNone/>
             </a:pPr>
             <a:r>
-              <a:rPr lang="en-US" sz="1600" b="1" dirty="0">
+              <a:rPr lang="en-US" sz="1650" b="1" dirty="0">
                 <a:solidFill>
                   <a:srgbClr val="2B2B33"/>
                 </a:solidFill>
@@ -49723,9 +49816,9 @@
                 <a:ea typeface="Cambria" pitchFamily="34" charset="-122"/>
                 <a:cs typeface="Cambria" pitchFamily="34" charset="-120"/>
               </a:rPr>
-              <a:t>Digoxin</a:t>
-            </a:r>
-            <a:endParaRPr lang="en-US" sz="1600" dirty="0"/>
+              <a:t>Unfractionated heparin</a:t>
+            </a:r>
+            <a:endParaRPr lang="en-US" sz="1650" dirty="0"/>
           </a:p>
         </p:txBody>
       </p:sp>
@@ -49737,8 +49830,8 @@
         </p:nvSpPr>
         <p:spPr>
           <a:xfrm>
-            <a:off x="1618488" y="3895344"/>
-            <a:ext cx="4233672" cy="365760"/>
+            <a:off x="1508760" y="3822192"/>
+            <a:ext cx="4389120" cy="685800"/>
           </a:xfrm>
           <a:prstGeom prst="rect">
             <a:avLst/>
@@ -49751,6 +49844,9 @@
           <a:lstStyle/>
           <a:p>
             <a:pPr algn="l" indent="0" marL="0">
+              <a:lnSpc>
+                <a:spcPct val="108000"/>
+              </a:lnSpc>
               <a:buNone/>
             </a:pPr>
             <a:r>
@@ -49762,7 +49858,7 @@
                 <a:ea typeface="Calibri" pitchFamily="34" charset="-122"/>
                 <a:cs typeface="Calibri" pitchFamily="34" charset="-120"/>
               </a:rPr>
-              <a:t>Safe option for rate control</a:t>
+              <a:t>Also placenta-safe; useful peri-delivery — short-acting &amp; reversible</a:t>
             </a:r>
             <a:endParaRPr lang="en-US" sz="1250" dirty="0"/>
           </a:p>
@@ -49776,26 +49872,103 @@
         </p:nvSpPr>
         <p:spPr>
           <a:xfrm>
-            <a:off x="868680" y="4700016"/>
-            <a:ext cx="566928" cy="566928"/>
+            <a:off x="6172200" y="1783080"/>
+            <a:ext cx="5532120" cy="2971800"/>
+          </a:xfrm>
+          <a:prstGeom prst="roundRect">
+            <a:avLst>
+              <a:gd name="adj" fmla="val 3692"/>
+            </a:avLst>
+          </a:prstGeom>
+          <a:solidFill>
+            <a:srgbClr val="590D22"/>
+          </a:solidFill>
+          <a:ln/>
+          <a:effectLst>
+            <a:outerShdw sx="100000" sy="100000" kx="0" ky="0" algn="bl" rotWithShape="0" blurRad="127000" dist="50800" dir="5400000">
+              <a:srgbClr val="C9A3AC">
+                <a:alpha val="45000"/>
+              </a:srgbClr>
+            </a:outerShdw>
+          </a:effectLst>
+        </p:spPr>
+      </p:sp>
+      <p:sp>
+        <p:nvSpPr>
+          <p:cNvPr id="17" name="Text 12"/>
+          <p:cNvSpPr/>
+          <p:nvPr/>
+        </p:nvSpPr>
+        <p:spPr>
+          <a:xfrm>
+            <a:off x="6492240" y="2011680"/>
+            <a:ext cx="4846320" cy="274320"/>
+          </a:xfrm>
+          <a:prstGeom prst="rect">
+            <a:avLst/>
+          </a:prstGeom>
+          <a:noFill/>
+          <a:ln/>
+        </p:spPr>
+        <p:txBody>
+          <a:bodyPr wrap="square" rtlCol="0" anchor="t"/>
+          <a:lstStyle/>
+          <a:p>
+            <a:pPr algn="l" indent="0" marL="0">
+              <a:buNone/>
+            </a:pPr>
+            <a:r>
+              <a:rPr lang="en-US" sz="1300" b="1" spc="150" kern="0" dirty="0">
+                <a:solidFill>
+                  <a:srgbClr val="FF4D6D"/>
+                </a:solidFill>
+                <a:latin typeface="Calibri" pitchFamily="34" charset="0"/>
+                <a:ea typeface="Calibri" pitchFamily="34" charset="-122"/>
+                <a:cs typeface="Calibri" pitchFamily="34" charset="-120"/>
+              </a:rPr>
+              <a:t>✕  </a:t>
+            </a:r>
+            <a:pPr algn="l" indent="0" marL="0">
+              <a:buNone/>
+            </a:pPr>
+            <a:r>
+              <a:rPr lang="en-US" sz="1300" b="1" spc="150" kern="0" dirty="0">
+                <a:solidFill>
+                  <a:srgbClr val="FFFFFF"/>
+                </a:solidFill>
+                <a:latin typeface="Calibri" pitchFamily="34" charset="0"/>
+                <a:ea typeface="Calibri" pitchFamily="34" charset="-122"/>
+                <a:cs typeface="Calibri" pitchFamily="34" charset="-120"/>
+              </a:rPr>
+              <a:t>AVOID</a:t>
+            </a:r>
+            <a:endParaRPr lang="en-US" sz="1300" dirty="0"/>
+          </a:p>
+        </p:txBody>
+      </p:sp>
+      <p:sp>
+        <p:nvSpPr>
+          <p:cNvPr id="18" name="Shape 13"/>
+          <p:cNvSpPr/>
+          <p:nvPr/>
+        </p:nvSpPr>
+        <p:spPr>
+          <a:xfrm>
+            <a:off x="6492240" y="2395728"/>
+            <a:ext cx="548640" cy="548640"/>
           </a:xfrm>
           <a:prstGeom prst="ellipse">
             <a:avLst/>
           </a:prstGeom>
           <a:solidFill>
-            <a:srgbClr val="FFFFFF"/>
+            <a:srgbClr val="A4133C"/>
           </a:solidFill>
-          <a:ln w="12700">
-            <a:solidFill>
-              <a:srgbClr val="FBD8DF"/>
-            </a:solidFill>
-            <a:prstDash val="solid"/>
-          </a:ln>
+          <a:ln/>
         </p:spPr>
       </p:sp>
       <p:pic>
         <p:nvPicPr>
-          <p:cNvPr id="17" name="Image 3" descr="preencoded.png">    </p:cNvPr>
+          <p:cNvPr id="19" name="Image 3" descr="preencoded.png">    </p:cNvPr>
           <p:cNvPicPr>
             <a:picLocks noChangeAspect="1"/>
           </p:cNvPicPr>
@@ -49809,8 +49982,8 @@
         </p:blipFill>
         <p:spPr>
           <a:xfrm>
-            <a:off x="1014984" y="4846320"/>
-            <a:ext cx="274320" cy="274320"/>
+            <a:off x="6638544" y="2551176"/>
+            <a:ext cx="256032" cy="256032"/>
           </a:xfrm>
           <a:prstGeom prst="rect">
             <a:avLst/>
@@ -49819,14 +49992,14 @@
       </p:pic>
       <p:sp>
         <p:nvSpPr>
-          <p:cNvPr id="18" name="Text 12"/>
-          <p:cNvSpPr/>
-          <p:nvPr/>
-        </p:nvSpPr>
-        <p:spPr>
-          <a:xfrm>
-            <a:off x="1618488" y="4663440"/>
-            <a:ext cx="4233672" cy="292608"/>
+          <p:cNvPr id="20" name="Text 14"/>
+          <p:cNvSpPr/>
+          <p:nvPr/>
+        </p:nvSpPr>
+        <p:spPr>
+          <a:xfrm>
+            <a:off x="7178040" y="2350008"/>
+            <a:ext cx="4297680" cy="365760"/>
           </a:xfrm>
           <a:prstGeom prst="rect">
             <a:avLst/>
@@ -49842,30 +50015,30 @@
               <a:buNone/>
             </a:pPr>
             <a:r>
-              <a:rPr lang="en-US" sz="1600" b="1" dirty="0">
-                <a:solidFill>
-                  <a:srgbClr val="2B2B33"/>
+              <a:rPr lang="en-US" sz="1650" b="1" dirty="0">
+                <a:solidFill>
+                  <a:srgbClr val="FFFFFF"/>
                 </a:solidFill>
                 <a:latin typeface="Cambria" pitchFamily="34" charset="0"/>
                 <a:ea typeface="Cambria" pitchFamily="34" charset="-122"/>
                 <a:cs typeface="Cambria" pitchFamily="34" charset="-120"/>
               </a:rPr>
-              <a:t>Flecainide / sotalol</a:t>
-            </a:r>
-            <a:endParaRPr lang="en-US" sz="1600" dirty="0"/>
-          </a:p>
-        </p:txBody>
-      </p:sp>
-      <p:sp>
-        <p:nvSpPr>
-          <p:cNvPr id="19" name="Text 13"/>
-          <p:cNvSpPr/>
-          <p:nvPr/>
-        </p:nvSpPr>
-        <p:spPr>
-          <a:xfrm>
-            <a:off x="1618488" y="4974336"/>
-            <a:ext cx="4233672" cy="365760"/>
+              <a:t>Warfarin (VKA)</a:t>
+            </a:r>
+            <a:endParaRPr lang="en-US" sz="1650" dirty="0"/>
+          </a:p>
+        </p:txBody>
+      </p:sp>
+      <p:sp>
+        <p:nvSpPr>
+          <p:cNvPr id="21" name="Text 15"/>
+          <p:cNvSpPr/>
+          <p:nvPr/>
+        </p:nvSpPr>
+        <p:spPr>
+          <a:xfrm>
+            <a:off x="7178040" y="2706624"/>
+            <a:ext cx="4343400" cy="685800"/>
           </a:xfrm>
           <a:prstGeom prst="rect">
             <a:avLst/>
@@ -49878,18 +50051,21 @@
           <a:lstStyle/>
           <a:p>
             <a:pPr algn="l" indent="0" marL="0">
+              <a:lnSpc>
+                <a:spcPct val="108000"/>
+              </a:lnSpc>
               <a:buNone/>
             </a:pPr>
             <a:r>
               <a:rPr lang="en-US" sz="1250" dirty="0">
                 <a:solidFill>
-                  <a:srgbClr val="6B6B76"/>
-                </a:solidFill>
-                <a:latin typeface="Calibri" pitchFamily="34" charset="0"/>
-                <a:ea typeface="Calibri" pitchFamily="34" charset="-122"/>
-                <a:cs typeface="Calibri" pitchFamily="34" charset="-120"/>
-              </a:rPr>
-              <a:t>For rhythm control when needed</a:t>
+                  <a:srgbClr val="FBD8DF"/>
+                </a:solidFill>
+                <a:latin typeface="Calibri" pitchFamily="34" charset="0"/>
+                <a:ea typeface="Calibri" pitchFamily="34" charset="-122"/>
+                <a:cs typeface="Calibri" pitchFamily="34" charset="-120"/>
+              </a:rPr>
+              <a:t>Teratogenic — embryopathy at weeks 6–12 and fetal bleeding near term</a:t>
             </a:r>
             <a:endParaRPr lang="en-US" sz="1250" dirty="0"/>
           </a:p>
@@ -49897,43 +50073,14 @@
       </p:sp>
       <p:sp>
         <p:nvSpPr>
-          <p:cNvPr id="20" name="Shape 14"/>
-          <p:cNvSpPr/>
-          <p:nvPr/>
-        </p:nvSpPr>
-        <p:spPr>
-          <a:xfrm>
-            <a:off x="6172200" y="1783080"/>
-            <a:ext cx="5532120" cy="2011680"/>
-          </a:xfrm>
-          <a:prstGeom prst="roundRect">
-            <a:avLst>
-              <a:gd name="adj" fmla="val 5455"/>
-            </a:avLst>
-          </a:prstGeom>
-          <a:solidFill>
-            <a:srgbClr val="590D22"/>
-          </a:solidFill>
-          <a:ln/>
-          <a:effectLst>
-            <a:outerShdw sx="100000" sy="100000" kx="0" ky="0" algn="bl" rotWithShape="0" blurRad="127000" dist="50800" dir="5400000">
-              <a:srgbClr val="C9A3AC">
-                <a:alpha val="45000"/>
-              </a:srgbClr>
-            </a:outerShdw>
-          </a:effectLst>
-        </p:spPr>
-      </p:sp>
-      <p:sp>
-        <p:nvSpPr>
-          <p:cNvPr id="21" name="Shape 15"/>
-          <p:cNvSpPr/>
-          <p:nvPr/>
-        </p:nvSpPr>
-        <p:spPr>
-          <a:xfrm>
-            <a:off x="6492240" y="2148840"/>
-            <a:ext cx="868680" cy="868680"/>
+          <p:cNvPr id="22" name="Shape 16"/>
+          <p:cNvSpPr/>
+          <p:nvPr/>
+        </p:nvSpPr>
+        <p:spPr>
+          <a:xfrm>
+            <a:off x="6492240" y="3511296"/>
+            <a:ext cx="548640" cy="548640"/>
           </a:xfrm>
           <a:prstGeom prst="ellipse">
             <a:avLst/>
@@ -49946,7 +50093,7 @@
       </p:sp>
       <p:pic>
         <p:nvPicPr>
-          <p:cNvPr id="22" name="Image 4" descr="preencoded.png">    </p:cNvPr>
+          <p:cNvPr id="23" name="Image 4" descr="preencoded.png">    </p:cNvPr>
           <p:cNvPicPr>
             <a:picLocks noChangeAspect="1"/>
           </p:cNvPicPr>
@@ -49960,8 +50107,8 @@
         </p:blipFill>
         <p:spPr>
           <a:xfrm>
-            <a:off x="6729984" y="2377440"/>
-            <a:ext cx="402336" cy="402336"/>
+            <a:off x="6638544" y="3666744"/>
+            <a:ext cx="256032" cy="256032"/>
           </a:xfrm>
           <a:prstGeom prst="rect">
             <a:avLst/>
@@ -49970,30 +50117,30 @@
       </p:pic>
       <p:sp>
         <p:nvSpPr>
-          <p:cNvPr id="23" name="Text 16"/>
-          <p:cNvSpPr/>
-          <p:nvPr/>
-        </p:nvSpPr>
-        <p:spPr>
-          <a:xfrm>
-            <a:off x="7498080" y="2194560"/>
-            <a:ext cx="4023360" cy="457200"/>
-          </a:xfrm>
-          <a:prstGeom prst="rect">
-            <a:avLst/>
-          </a:prstGeom>
-          <a:noFill/>
-          <a:ln/>
-        </p:spPr>
-        <p:txBody>
-          <a:bodyPr wrap="square" rtlCol="0" anchor="ctr"/>
-          <a:lstStyle/>
-          <a:p>
-            <a:pPr algn="l" indent="0" marL="0">
-              <a:buNone/>
-            </a:pPr>
-            <a:r>
-              <a:rPr lang="en-US" sz="2100" b="1" dirty="0">
+          <p:cNvPr id="24" name="Text 17"/>
+          <p:cNvSpPr/>
+          <p:nvPr/>
+        </p:nvSpPr>
+        <p:spPr>
+          <a:xfrm>
+            <a:off x="7178040" y="3465576"/>
+            <a:ext cx="4297680" cy="365760"/>
+          </a:xfrm>
+          <a:prstGeom prst="rect">
+            <a:avLst/>
+          </a:prstGeom>
+          <a:noFill/>
+          <a:ln/>
+        </p:spPr>
+        <p:txBody>
+          <a:bodyPr wrap="square" lIns="0" tIns="0" rIns="0" bIns="0" rtlCol="0" anchor="t"/>
+          <a:lstStyle/>
+          <a:p>
+            <a:pPr algn="l" indent="0" marL="0">
+              <a:buNone/>
+            </a:pPr>
+            <a:r>
+              <a:rPr lang="en-US" sz="1650" b="1" dirty="0">
                 <a:solidFill>
                   <a:srgbClr val="FFFFFF"/>
                 </a:solidFill>
@@ -50001,41 +50148,41 @@
                 <a:ea typeface="Cambria" pitchFamily="34" charset="-122"/>
                 <a:cs typeface="Cambria" pitchFamily="34" charset="-120"/>
               </a:rPr>
-              <a:t>Cardioversion</a:t>
-            </a:r>
-            <a:endParaRPr lang="en-US" sz="2100" dirty="0"/>
-          </a:p>
-        </p:txBody>
-      </p:sp>
-      <p:sp>
-        <p:nvSpPr>
-          <p:cNvPr id="24" name="Text 17"/>
-          <p:cNvSpPr/>
-          <p:nvPr/>
-        </p:nvSpPr>
-        <p:spPr>
-          <a:xfrm>
-            <a:off x="6537960" y="2852928"/>
-            <a:ext cx="5029200" cy="822960"/>
-          </a:xfrm>
-          <a:prstGeom prst="rect">
-            <a:avLst/>
-          </a:prstGeom>
-          <a:noFill/>
-          <a:ln/>
-        </p:spPr>
-        <p:txBody>
-          <a:bodyPr wrap="square" rtlCol="0" anchor="t"/>
+              <a:t>DOACs</a:t>
+            </a:r>
+            <a:endParaRPr lang="en-US" sz="1650" dirty="0"/>
+          </a:p>
+        </p:txBody>
+      </p:sp>
+      <p:sp>
+        <p:nvSpPr>
+          <p:cNvPr id="25" name="Text 18"/>
+          <p:cNvSpPr/>
+          <p:nvPr/>
+        </p:nvSpPr>
+        <p:spPr>
+          <a:xfrm>
+            <a:off x="7178040" y="3822192"/>
+            <a:ext cx="4343400" cy="685800"/>
+          </a:xfrm>
+          <a:prstGeom prst="rect">
+            <a:avLst/>
+          </a:prstGeom>
+          <a:noFill/>
+          <a:ln/>
+        </p:spPr>
+        <p:txBody>
+          <a:bodyPr wrap="square" lIns="0" tIns="0" rIns="0" bIns="0" rtlCol="0" anchor="t"/>
           <a:lstStyle/>
           <a:p>
             <a:pPr algn="l" indent="0" marL="0">
               <a:lnSpc>
-                <a:spcPct val="112000"/>
+                <a:spcPct val="108000"/>
               </a:lnSpc>
               <a:buNone/>
             </a:pPr>
             <a:r>
-              <a:rPr lang="en-US" sz="1400" dirty="0">
+              <a:rPr lang="en-US" sz="1250" dirty="0">
                 <a:solidFill>
                   <a:srgbClr val="FBD8DF"/>
                 </a:solidFill>
@@ -50043,72 +50190,60 @@
                 <a:ea typeface="Calibri" pitchFamily="34" charset="-122"/>
                 <a:cs typeface="Calibri" pitchFamily="34" charset="-120"/>
               </a:rPr>
-              <a:t>DC cardioversion is safe in all trimesters — perform with fetal monitoring.</a:t>
-            </a:r>
-            <a:endParaRPr lang="en-US" sz="1400" dirty="0"/>
-          </a:p>
-        </p:txBody>
-      </p:sp>
-      <p:sp>
-        <p:nvSpPr>
-          <p:cNvPr id="25" name="Shape 18"/>
-          <p:cNvSpPr/>
-          <p:nvPr/>
-        </p:nvSpPr>
-        <p:spPr>
-          <a:xfrm>
-            <a:off x="6172200" y="3977640"/>
-            <a:ext cx="5532120" cy="2011680"/>
+              <a:t>Not recommended — cross the placenta with limited safety data</a:t>
+            </a:r>
+            <a:endParaRPr lang="en-US" sz="1250" dirty="0"/>
+          </a:p>
+        </p:txBody>
+      </p:sp>
+      <p:sp>
+        <p:nvSpPr>
+          <p:cNvPr id="26" name="Shape 19"/>
+          <p:cNvSpPr/>
+          <p:nvPr/>
+        </p:nvSpPr>
+        <p:spPr>
+          <a:xfrm>
+            <a:off x="502920" y="4937760"/>
+            <a:ext cx="11183112" cy="1051560"/>
           </a:xfrm>
           <a:prstGeom prst="roundRect">
             <a:avLst>
-              <a:gd name="adj" fmla="val 5455"/>
+              <a:gd name="adj" fmla="val 10435"/>
             </a:avLst>
           </a:prstGeom>
           <a:solidFill>
-            <a:srgbClr val="FFF0F3"/>
+            <a:srgbClr val="FBD8DF"/>
           </a:solidFill>
-          <a:ln w="12700">
-            <a:solidFill>
-              <a:srgbClr val="FBD8DF"/>
-            </a:solidFill>
-            <a:prstDash val="solid"/>
-          </a:ln>
-          <a:effectLst>
-            <a:outerShdw sx="100000" sy="100000" kx="0" ky="0" algn="bl" rotWithShape="0" blurRad="127000" dist="50800" dir="5400000">
-              <a:srgbClr val="C9A3AC">
-                <a:alpha val="45000"/>
-              </a:srgbClr>
-            </a:outerShdw>
-          </a:effectLst>
-        </p:spPr>
-      </p:sp>
-      <p:sp>
-        <p:nvSpPr>
-          <p:cNvPr id="26" name="Text 19"/>
-          <p:cNvSpPr/>
-          <p:nvPr/>
-        </p:nvSpPr>
-        <p:spPr>
-          <a:xfrm>
-            <a:off x="6537960" y="4206240"/>
-            <a:ext cx="4937760" cy="274320"/>
-          </a:xfrm>
-          <a:prstGeom prst="rect">
-            <a:avLst/>
-          </a:prstGeom>
-          <a:noFill/>
-          <a:ln/>
-        </p:spPr>
-        <p:txBody>
-          <a:bodyPr wrap="square" rtlCol="0" anchor="t"/>
-          <a:lstStyle/>
-          <a:p>
-            <a:pPr algn="l" indent="0" marL="0">
-              <a:buNone/>
-            </a:pPr>
-            <a:r>
-              <a:rPr lang="en-US" sz="1300" b="1" spc="120" kern="0" dirty="0">
+          <a:ln/>
+        </p:spPr>
+      </p:sp>
+      <p:sp>
+        <p:nvSpPr>
+          <p:cNvPr id="27" name="Text 20"/>
+          <p:cNvSpPr/>
+          <p:nvPr/>
+        </p:nvSpPr>
+        <p:spPr>
+          <a:xfrm>
+            <a:off x="914400" y="5084064"/>
+            <a:ext cx="10424160" cy="365760"/>
+          </a:xfrm>
+          <a:prstGeom prst="rect">
+            <a:avLst/>
+          </a:prstGeom>
+          <a:noFill/>
+          <a:ln/>
+        </p:spPr>
+        <p:txBody>
+          <a:bodyPr wrap="square" lIns="0" tIns="0" rIns="0" bIns="0" rtlCol="0" anchor="ctr"/>
+          <a:lstStyle/>
+          <a:p>
+            <a:pPr algn="l" indent="0" marL="0">
+              <a:buNone/>
+            </a:pPr>
+            <a:r>
+              <a:rPr lang="en-US" sz="1350" b="1" dirty="0">
                 <a:solidFill>
                   <a:srgbClr val="A4133C"/>
                 </a:solidFill>
@@ -50116,13 +50251,52 @@
                 <a:ea typeface="Calibri" pitchFamily="34" charset="-122"/>
                 <a:cs typeface="Calibri" pitchFamily="34" charset="-120"/>
               </a:rPr>
-              <a:t>✕  </a:t>
-            </a:r>
-            <a:pPr algn="l" indent="0" marL="0">
-              <a:buNone/>
-            </a:pPr>
-            <a:r>
-              <a:rPr lang="en-US" sz="1300" b="1" spc="120" kern="0" dirty="0">
+              <a:t>Peri-delivery   </a:t>
+            </a:r>
+            <a:pPr algn="l" indent="0" marL="0">
+              <a:buNone/>
+            </a:pPr>
+            <a:r>
+              <a:rPr lang="en-US" sz="1350" dirty="0">
+                <a:solidFill>
+                  <a:srgbClr val="2B2B33"/>
+                </a:solidFill>
+                <a:latin typeface="Calibri" pitchFamily="34" charset="0"/>
+                <a:ea typeface="Calibri" pitchFamily="34" charset="-122"/>
+                <a:cs typeface="Calibri" pitchFamily="34" charset="-120"/>
+              </a:rPr>
+              <a:t>switch LMWH → UFH (or briefly hold) to allow neuraxial anaesthesia and limit bleeding.</a:t>
+            </a:r>
+            <a:endParaRPr lang="en-US" sz="1350" dirty="0"/>
+          </a:p>
+        </p:txBody>
+      </p:sp>
+      <p:sp>
+        <p:nvSpPr>
+          <p:cNvPr id="28" name="Text 21"/>
+          <p:cNvSpPr/>
+          <p:nvPr/>
+        </p:nvSpPr>
+        <p:spPr>
+          <a:xfrm>
+            <a:off x="914400" y="5468112"/>
+            <a:ext cx="10607040" cy="365760"/>
+          </a:xfrm>
+          <a:prstGeom prst="rect">
+            <a:avLst/>
+          </a:prstGeom>
+          <a:noFill/>
+          <a:ln/>
+        </p:spPr>
+        <p:txBody>
+          <a:bodyPr wrap="square" lIns="0" tIns="0" rIns="0" bIns="0" rtlCol="0" anchor="ctr"/>
+          <a:lstStyle/>
+          <a:p>
+            <a:pPr algn="l" indent="0" marL="0">
+              <a:buNone/>
+            </a:pPr>
+            <a:r>
+              <a:rPr lang="en-US" sz="1350" b="1" dirty="0">
                 <a:solidFill>
                   <a:srgbClr val="A4133C"/>
                 </a:solidFill>
@@ -50130,41 +50304,13 @@
                 <a:ea typeface="Calibri" pitchFamily="34" charset="-122"/>
                 <a:cs typeface="Calibri" pitchFamily="34" charset="-120"/>
               </a:rPr>
-              <a:t>USE WITH CAUTION / AVOID</a:t>
-            </a:r>
-            <a:endParaRPr lang="en-US" sz="1300" dirty="0"/>
-          </a:p>
-        </p:txBody>
-      </p:sp>
-      <p:sp>
-        <p:nvSpPr>
-          <p:cNvPr id="27" name="Text 20"/>
-          <p:cNvSpPr/>
-          <p:nvPr/>
-        </p:nvSpPr>
-        <p:spPr>
-          <a:xfrm>
-            <a:off x="6537960" y="4645152"/>
-            <a:ext cx="5029200" cy="594360"/>
-          </a:xfrm>
-          <a:prstGeom prst="rect">
-            <a:avLst/>
-          </a:prstGeom>
-          <a:noFill/>
-          <a:ln/>
-        </p:spPr>
-        <p:txBody>
-          <a:bodyPr wrap="square" lIns="0" tIns="0" rIns="0" bIns="0" rtlCol="0" anchor="t"/>
-          <a:lstStyle/>
-          <a:p>
-            <a:pPr algn="l" indent="0" marL="0">
-              <a:lnSpc>
-                <a:spcPct val="105000"/>
-              </a:lnSpc>
-              <a:buNone/>
-            </a:pPr>
-            <a:r>
-              <a:rPr lang="en-US" sz="1350" b="1" dirty="0">
+              <a:t>Breastfeeding   </a:t>
+            </a:r>
+            <a:pPr algn="l" indent="0" marL="0">
+              <a:buNone/>
+            </a:pPr>
+            <a:r>
+              <a:rPr lang="en-US" sz="1350" dirty="0">
                 <a:solidFill>
                   <a:srgbClr val="2B2B33"/>
                 </a:solidFill>
@@ -50172,77 +50318,7 @@
                 <a:ea typeface="Calibri" pitchFamily="34" charset="-122"/>
                 <a:cs typeface="Calibri" pitchFamily="34" charset="-120"/>
               </a:rPr>
-              <a:t>Amiodarone  </a:t>
-            </a:r>
-            <a:pPr algn="l" indent="0" marL="0">
-              <a:lnSpc>
-                <a:spcPct val="105000"/>
-              </a:lnSpc>
-              <a:buNone/>
-            </a:pPr>
-            <a:r>
-              <a:rPr lang="en-US" sz="1350" dirty="0">
-                <a:solidFill>
-                  <a:srgbClr val="6B6B76"/>
-                </a:solidFill>
-                <a:latin typeface="Calibri" pitchFamily="34" charset="0"/>
-                <a:ea typeface="Calibri" pitchFamily="34" charset="-122"/>
-                <a:cs typeface="Calibri" pitchFamily="34" charset="-120"/>
-              </a:rPr>
-              <a:t>— fetal thyroid dysfunction &amp; IUGR; only if life-threatening</a:t>
-            </a:r>
-            <a:endParaRPr lang="en-US" sz="1350" dirty="0"/>
-          </a:p>
-        </p:txBody>
-      </p:sp>
-      <p:sp>
-        <p:nvSpPr>
-          <p:cNvPr id="28" name="Text 21"/>
-          <p:cNvSpPr/>
-          <p:nvPr/>
-        </p:nvSpPr>
-        <p:spPr>
-          <a:xfrm>
-            <a:off x="6537960" y="5285232"/>
-            <a:ext cx="5029200" cy="457200"/>
-          </a:xfrm>
-          <a:prstGeom prst="rect">
-            <a:avLst/>
-          </a:prstGeom>
-          <a:noFill/>
-          <a:ln/>
-        </p:spPr>
-        <p:txBody>
-          <a:bodyPr wrap="square" lIns="0" tIns="0" rIns="0" bIns="0" rtlCol="0" anchor="t"/>
-          <a:lstStyle/>
-          <a:p>
-            <a:pPr algn="l" indent="0" marL="0">
-              <a:buNone/>
-            </a:pPr>
-            <a:r>
-              <a:rPr lang="en-US" sz="1350" b="1" dirty="0">
-                <a:solidFill>
-                  <a:srgbClr val="2B2B33"/>
-                </a:solidFill>
-                <a:latin typeface="Calibri" pitchFamily="34" charset="0"/>
-                <a:ea typeface="Calibri" pitchFamily="34" charset="-122"/>
-                <a:cs typeface="Calibri" pitchFamily="34" charset="-120"/>
-              </a:rPr>
-              <a:t>Atenolol  </a:t>
-            </a:r>
-            <a:pPr algn="l" indent="0" marL="0">
-              <a:buNone/>
-            </a:pPr>
-            <a:r>
-              <a:rPr lang="en-US" sz="1350" dirty="0">
-                <a:solidFill>
-                  <a:srgbClr val="6B6B76"/>
-                </a:solidFill>
-                <a:latin typeface="Calibri" pitchFamily="34" charset="0"/>
-                <a:ea typeface="Calibri" pitchFamily="34" charset="-122"/>
-                <a:cs typeface="Calibri" pitchFamily="34" charset="-120"/>
-              </a:rPr>
-              <a:t>— linked to fetal growth restriction</a:t>
+              <a:t>warfarin, LMWH and UFH are compatible; DOACs are avoided. Plan with a specialist team.</a:t>
             </a:r>
             <a:endParaRPr lang="en-US" sz="1350" dirty="0"/>
           </a:p>
@@ -50479,7 +50555,7 @@
                 <a:ea typeface="Cambria" pitchFamily="34" charset="-122"/>
                 <a:cs typeface="Cambria" pitchFamily="34" charset="-120"/>
               </a:rPr>
-              <a:t>AF in Pregnancy — Overview</a:t>
+              <a:t>Rhythm &amp; Rate Control in Pregnancy</a:t>
             </a:r>
             <a:endParaRPr lang="en-US" sz="3000" dirty="0"/>
           </a:p>
@@ -50493,100 +50569,12 @@
         </p:nvSpPr>
         <p:spPr>
           <a:xfrm>
-            <a:off x="502920" y="1572768"/>
-            <a:ext cx="11183112" cy="914400"/>
+            <a:off x="502920" y="1783080"/>
+            <a:ext cx="5532120" cy="4206240"/>
           </a:xfrm>
           <a:prstGeom prst="roundRect">
             <a:avLst>
-              <a:gd name="adj" fmla="val 12000"/>
-            </a:avLst>
-          </a:prstGeom>
-          <a:solidFill>
-            <a:srgbClr val="590D22"/>
-          </a:solidFill>
-          <a:ln/>
-          <a:effectLst>
-            <a:outerShdw sx="100000" sy="100000" kx="0" ky="0" algn="bl" rotWithShape="0" blurRad="127000" dist="50800" dir="5400000">
-              <a:srgbClr val="C9A3AC">
-                <a:alpha val="45000"/>
-              </a:srgbClr>
-            </a:outerShdw>
-          </a:effectLst>
-        </p:spPr>
-      </p:sp>
-      <p:sp>
-        <p:nvSpPr>
-          <p:cNvPr id="7" name="Text 4"/>
-          <p:cNvSpPr/>
-          <p:nvPr/>
-        </p:nvSpPr>
-        <p:spPr>
-          <a:xfrm>
-            <a:off x="914400" y="1572768"/>
-            <a:ext cx="10424160" cy="914400"/>
-          </a:xfrm>
-          <a:prstGeom prst="rect">
-            <a:avLst/>
-          </a:prstGeom>
-          <a:noFill/>
-          <a:ln/>
-        </p:spPr>
-        <p:txBody>
-          <a:bodyPr wrap="square" rtlCol="0" anchor="ctr"/>
-          <a:lstStyle/>
-          <a:p>
-            <a:pPr algn="l" indent="0" marL="0">
-              <a:lnSpc>
-                <a:spcPct val="110000"/>
-              </a:lnSpc>
-              <a:buNone/>
-            </a:pPr>
-            <a:r>
-              <a:rPr lang="en-US" sz="1400" b="1" dirty="0">
-                <a:solidFill>
-                  <a:srgbClr val="FFFFFF"/>
-                </a:solidFill>
-                <a:latin typeface="Calibri" pitchFamily="34" charset="0"/>
-                <a:ea typeface="Calibri" pitchFamily="34" charset="-122"/>
-                <a:cs typeface="Calibri" pitchFamily="34" charset="-120"/>
-              </a:rPr>
-              <a:t>Rare — ~60 / 100,000 pregnancies</a:t>
-            </a:r>
-            <a:pPr algn="l" indent="0" marL="0">
-              <a:lnSpc>
-                <a:spcPct val="110000"/>
-              </a:lnSpc>
-              <a:buNone/>
-            </a:pPr>
-            <a:r>
-              <a:rPr lang="en-US" sz="1400" dirty="0">
-                <a:solidFill>
-                  <a:srgbClr val="FBD8DF"/>
-                </a:solidFill>
-                <a:latin typeface="Calibri" pitchFamily="34" charset="0"/>
-                <a:ea typeface="Calibri" pitchFamily="34" charset="-122"/>
-                <a:cs typeface="Calibri" pitchFamily="34" charset="-120"/>
-              </a:rPr>
-              <a:t>   ·   often congenital / valvular disease, thyrotoxicosis or electrolyte disturbance   ·   hypercoagulable, but no proven rise in AF-related thromboembolism</a:t>
-            </a:r>
-            <a:endParaRPr lang="en-US" sz="1400" dirty="0"/>
-          </a:p>
-        </p:txBody>
-      </p:sp>
-      <p:sp>
-        <p:nvSpPr>
-          <p:cNvPr id="8" name="Shape 5"/>
-          <p:cNvSpPr/>
-          <p:nvPr/>
-        </p:nvSpPr>
-        <p:spPr>
-          <a:xfrm>
-            <a:off x="502920" y="2670048"/>
-            <a:ext cx="3611880" cy="3319272"/>
-          </a:xfrm>
-          <a:prstGeom prst="roundRect">
-            <a:avLst>
-              <a:gd name="adj" fmla="val 3306"/>
+              <a:gd name="adj" fmla="val 2609"/>
             </a:avLst>
           </a:prstGeom>
           <a:solidFill>
@@ -50609,27 +50597,85 @@
       </p:sp>
       <p:sp>
         <p:nvSpPr>
-          <p:cNvPr id="9" name="Shape 6"/>
-          <p:cNvSpPr/>
-          <p:nvPr/>
-        </p:nvSpPr>
-        <p:spPr>
-          <a:xfrm>
-            <a:off x="777240" y="2926080"/>
-            <a:ext cx="658368" cy="658368"/>
+          <p:cNvPr id="7" name="Text 4"/>
+          <p:cNvSpPr/>
+          <p:nvPr/>
+        </p:nvSpPr>
+        <p:spPr>
+          <a:xfrm>
+            <a:off x="868680" y="2057400"/>
+            <a:ext cx="4846320" cy="274320"/>
+          </a:xfrm>
+          <a:prstGeom prst="rect">
+            <a:avLst/>
+          </a:prstGeom>
+          <a:noFill/>
+          <a:ln/>
+        </p:spPr>
+        <p:txBody>
+          <a:bodyPr wrap="square" rtlCol="0" anchor="t"/>
+          <a:lstStyle/>
+          <a:p>
+            <a:pPr algn="l" indent="0" marL="0">
+              <a:buNone/>
+            </a:pPr>
+            <a:r>
+              <a:rPr lang="en-US" sz="1300" b="1" spc="150" kern="0" dirty="0">
+                <a:solidFill>
+                  <a:srgbClr val="2E7D32"/>
+                </a:solidFill>
+                <a:latin typeface="Calibri" pitchFamily="34" charset="0"/>
+                <a:ea typeface="Calibri" pitchFamily="34" charset="-122"/>
+                <a:cs typeface="Calibri" pitchFamily="34" charset="-120"/>
+              </a:rPr>
+              <a:t>✓  </a:t>
+            </a:r>
+            <a:pPr algn="l" indent="0" marL="0">
+              <a:buNone/>
+            </a:pPr>
+            <a:r>
+              <a:rPr lang="en-US" sz="1300" b="1" spc="150" kern="0" dirty="0">
+                <a:solidFill>
+                  <a:srgbClr val="2E7D32"/>
+                </a:solidFill>
+                <a:latin typeface="Calibri" pitchFamily="34" charset="0"/>
+                <a:ea typeface="Calibri" pitchFamily="34" charset="-122"/>
+                <a:cs typeface="Calibri" pitchFamily="34" charset="-120"/>
+              </a:rPr>
+              <a:t>GENERALLY SAFE</a:t>
+            </a:r>
+            <a:endParaRPr lang="en-US" sz="1300" dirty="0"/>
+          </a:p>
+        </p:txBody>
+      </p:sp>
+      <p:sp>
+        <p:nvSpPr>
+          <p:cNvPr id="8" name="Shape 5"/>
+          <p:cNvSpPr/>
+          <p:nvPr/>
+        </p:nvSpPr>
+        <p:spPr>
+          <a:xfrm>
+            <a:off x="868680" y="2542032"/>
+            <a:ext cx="566928" cy="566928"/>
           </a:xfrm>
           <a:prstGeom prst="ellipse">
             <a:avLst/>
           </a:prstGeom>
           <a:solidFill>
-            <a:srgbClr val="A4133C"/>
+            <a:srgbClr val="FFFFFF"/>
           </a:solidFill>
-          <a:ln/>
+          <a:ln w="12700">
+            <a:solidFill>
+              <a:srgbClr val="FBD8DF"/>
+            </a:solidFill>
+            <a:prstDash val="solid"/>
+          </a:ln>
         </p:spPr>
       </p:sp>
       <p:pic>
         <p:nvPicPr>
-          <p:cNvPr id="10" name="Image 1" descr="preencoded.png">    </p:cNvPr>
+          <p:cNvPr id="9" name="Image 1" descr="preencoded.png">    </p:cNvPr>
           <p:cNvPicPr>
             <a:picLocks noChangeAspect="1"/>
           </p:cNvPicPr>
@@ -50643,8 +50689,8 @@
         </p:blipFill>
         <p:spPr>
           <a:xfrm>
-            <a:off x="932688" y="3081528"/>
-            <a:ext cx="347472" cy="347472"/>
+            <a:off x="1014984" y="2688336"/>
+            <a:ext cx="274320" cy="274320"/>
           </a:xfrm>
           <a:prstGeom prst="rect">
             <a:avLst/>
@@ -50653,30 +50699,30 @@
       </p:pic>
       <p:sp>
         <p:nvSpPr>
-          <p:cNvPr id="11" name="Text 7"/>
-          <p:cNvSpPr/>
-          <p:nvPr/>
-        </p:nvSpPr>
-        <p:spPr>
-          <a:xfrm>
-            <a:off x="1554480" y="2926080"/>
-            <a:ext cx="2423160" cy="658368"/>
-          </a:xfrm>
-          <a:prstGeom prst="rect">
-            <a:avLst/>
-          </a:prstGeom>
-          <a:noFill/>
-          <a:ln/>
-        </p:spPr>
-        <p:txBody>
-          <a:bodyPr wrap="square" lIns="0" tIns="0" rIns="0" bIns="0" rtlCol="0" anchor="ctr"/>
-          <a:lstStyle/>
-          <a:p>
-            <a:pPr algn="l" indent="0" marL="0">
-              <a:buNone/>
-            </a:pPr>
-            <a:r>
-              <a:rPr lang="en-US" sz="1700" b="1" dirty="0">
+          <p:cNvPr id="10" name="Text 6"/>
+          <p:cNvSpPr/>
+          <p:nvPr/>
+        </p:nvSpPr>
+        <p:spPr>
+          <a:xfrm>
+            <a:off x="1618488" y="2505456"/>
+            <a:ext cx="4233672" cy="292608"/>
+          </a:xfrm>
+          <a:prstGeom prst="rect">
+            <a:avLst/>
+          </a:prstGeom>
+          <a:noFill/>
+          <a:ln/>
+        </p:spPr>
+        <p:txBody>
+          <a:bodyPr wrap="square" lIns="0" tIns="0" rIns="0" bIns="0" rtlCol="0" anchor="t"/>
+          <a:lstStyle/>
+          <a:p>
+            <a:pPr algn="l" indent="0" marL="0">
+              <a:buNone/>
+            </a:pPr>
+            <a:r>
+              <a:rPr lang="en-US" sz="1600" b="1" dirty="0">
                 <a:solidFill>
                   <a:srgbClr val="2B2B33"/>
                 </a:solidFill>
@@ -50684,9 +50730,48 @@
                 <a:ea typeface="Cambria" pitchFamily="34" charset="-122"/>
                 <a:cs typeface="Cambria" pitchFamily="34" charset="-120"/>
               </a:rPr>
-              <a:t>Anticoagulation</a:t>
-            </a:r>
-            <a:endParaRPr lang="en-US" sz="1700" dirty="0"/>
+              <a:t>Beta-blockers</a:t>
+            </a:r>
+            <a:endParaRPr lang="en-US" sz="1600" dirty="0"/>
+          </a:p>
+        </p:txBody>
+      </p:sp>
+      <p:sp>
+        <p:nvSpPr>
+          <p:cNvPr id="11" name="Text 7"/>
+          <p:cNvSpPr/>
+          <p:nvPr/>
+        </p:nvSpPr>
+        <p:spPr>
+          <a:xfrm>
+            <a:off x="1618488" y="2816352"/>
+            <a:ext cx="4233672" cy="365760"/>
+          </a:xfrm>
+          <a:prstGeom prst="rect">
+            <a:avLst/>
+          </a:prstGeom>
+          <a:noFill/>
+          <a:ln/>
+        </p:spPr>
+        <p:txBody>
+          <a:bodyPr wrap="square" lIns="0" tIns="0" rIns="0" bIns="0" rtlCol="0" anchor="t"/>
+          <a:lstStyle/>
+          <a:p>
+            <a:pPr algn="l" indent="0" marL="0">
+              <a:buNone/>
+            </a:pPr>
+            <a:r>
+              <a:rPr lang="en-US" sz="1250" dirty="0">
+                <a:solidFill>
+                  <a:srgbClr val="6B6B76"/>
+                </a:solidFill>
+                <a:latin typeface="Calibri" pitchFamily="34" charset="0"/>
+                <a:ea typeface="Calibri" pitchFamily="34" charset="-122"/>
+                <a:cs typeface="Calibri" pitchFamily="34" charset="-120"/>
+              </a:rPr>
+              <a:t>First-line rate control (metoprolol, bisoprolol) — avoid atenolol</a:t>
+            </a:r>
+            <a:endParaRPr lang="en-US" sz="1250" dirty="0"/>
           </a:p>
         </p:txBody>
       </p:sp>
@@ -50698,28 +50783,57 @@
         </p:nvSpPr>
         <p:spPr>
           <a:xfrm>
-            <a:off x="795528" y="3822192"/>
-            <a:ext cx="118872" cy="118872"/>
+            <a:off x="868680" y="3621024"/>
+            <a:ext cx="566928" cy="566928"/>
           </a:xfrm>
           <a:prstGeom prst="ellipse">
             <a:avLst/>
           </a:prstGeom>
           <a:solidFill>
-            <a:srgbClr val="FF4D6D"/>
+            <a:srgbClr val="FFFFFF"/>
           </a:solidFill>
-          <a:ln/>
-        </p:spPr>
-      </p:sp>
-      <p:sp>
-        <p:nvSpPr>
-          <p:cNvPr id="13" name="Text 9"/>
-          <p:cNvSpPr/>
-          <p:nvPr/>
-        </p:nvSpPr>
-        <p:spPr>
-          <a:xfrm>
-            <a:off x="1033272" y="3767328"/>
-            <a:ext cx="2834640" cy="676656"/>
+          <a:ln w="12700">
+            <a:solidFill>
+              <a:srgbClr val="FBD8DF"/>
+            </a:solidFill>
+            <a:prstDash val="solid"/>
+          </a:ln>
+        </p:spPr>
+      </p:sp>
+      <p:pic>
+        <p:nvPicPr>
+          <p:cNvPr id="13" name="Image 2" descr="preencoded.png">    </p:cNvPr>
+          <p:cNvPicPr>
+            <a:picLocks noChangeAspect="1"/>
+          </p:cNvPicPr>
+          <p:nvPr/>
+        </p:nvPicPr>
+        <p:blipFill>
+          <a:blip r:embed="rId3"/>
+          <a:stretch>
+            <a:fillRect/>
+          </a:stretch>
+        </p:blipFill>
+        <p:spPr>
+          <a:xfrm>
+            <a:off x="1014984" y="3767328"/>
+            <a:ext cx="274320" cy="274320"/>
+          </a:xfrm>
+          <a:prstGeom prst="rect">
+            <a:avLst/>
+          </a:prstGeom>
+        </p:spPr>
+      </p:pic>
+      <p:sp>
+        <p:nvSpPr>
+          <p:cNvPr id="14" name="Text 9"/>
+          <p:cNvSpPr/>
+          <p:nvPr/>
+        </p:nvSpPr>
+        <p:spPr>
+          <a:xfrm>
+            <a:off x="1618488" y="3584448"/>
+            <a:ext cx="4233672" cy="292608"/>
           </a:xfrm>
           <a:prstGeom prst="rect">
             <a:avLst/>
@@ -50732,21 +50846,184 @@
           <a:lstStyle/>
           <a:p>
             <a:pPr algn="l" indent="0" marL="0">
-              <a:lnSpc>
-                <a:spcPct val="102000"/>
-              </a:lnSpc>
+              <a:buNone/>
+            </a:pPr>
+            <a:r>
+              <a:rPr lang="en-US" sz="1600" b="1" dirty="0">
+                <a:solidFill>
+                  <a:srgbClr val="2B2B33"/>
+                </a:solidFill>
+                <a:latin typeface="Cambria" pitchFamily="34" charset="0"/>
+                <a:ea typeface="Cambria" pitchFamily="34" charset="-122"/>
+                <a:cs typeface="Cambria" pitchFamily="34" charset="-120"/>
+              </a:rPr>
+              <a:t>Digoxin</a:t>
+            </a:r>
+            <a:endParaRPr lang="en-US" sz="1600" dirty="0"/>
+          </a:p>
+        </p:txBody>
+      </p:sp>
+      <p:sp>
+        <p:nvSpPr>
+          <p:cNvPr id="15" name="Text 10"/>
+          <p:cNvSpPr/>
+          <p:nvPr/>
+        </p:nvSpPr>
+        <p:spPr>
+          <a:xfrm>
+            <a:off x="1618488" y="3895344"/>
+            <a:ext cx="4233672" cy="365760"/>
+          </a:xfrm>
+          <a:prstGeom prst="rect">
+            <a:avLst/>
+          </a:prstGeom>
+          <a:noFill/>
+          <a:ln/>
+        </p:spPr>
+        <p:txBody>
+          <a:bodyPr wrap="square" lIns="0" tIns="0" rIns="0" bIns="0" rtlCol="0" anchor="t"/>
+          <a:lstStyle/>
+          <a:p>
+            <a:pPr algn="l" indent="0" marL="0">
               <a:buNone/>
             </a:pPr>
             <a:r>
               <a:rPr lang="en-US" sz="1250" dirty="0">
                 <a:solidFill>
+                  <a:srgbClr val="6B6B76"/>
+                </a:solidFill>
+                <a:latin typeface="Calibri" pitchFamily="34" charset="0"/>
+                <a:ea typeface="Calibri" pitchFamily="34" charset="-122"/>
+                <a:cs typeface="Calibri" pitchFamily="34" charset="-120"/>
+              </a:rPr>
+              <a:t>Safe option for rate control</a:t>
+            </a:r>
+            <a:endParaRPr lang="en-US" sz="1250" dirty="0"/>
+          </a:p>
+        </p:txBody>
+      </p:sp>
+      <p:sp>
+        <p:nvSpPr>
+          <p:cNvPr id="16" name="Shape 11"/>
+          <p:cNvSpPr/>
+          <p:nvPr/>
+        </p:nvSpPr>
+        <p:spPr>
+          <a:xfrm>
+            <a:off x="868680" y="4700016"/>
+            <a:ext cx="566928" cy="566928"/>
+          </a:xfrm>
+          <a:prstGeom prst="ellipse">
+            <a:avLst/>
+          </a:prstGeom>
+          <a:solidFill>
+            <a:srgbClr val="FFFFFF"/>
+          </a:solidFill>
+          <a:ln w="12700">
+            <a:solidFill>
+              <a:srgbClr val="FBD8DF"/>
+            </a:solidFill>
+            <a:prstDash val="solid"/>
+          </a:ln>
+        </p:spPr>
+      </p:sp>
+      <p:pic>
+        <p:nvPicPr>
+          <p:cNvPr id="17" name="Image 3" descr="preencoded.png">    </p:cNvPr>
+          <p:cNvPicPr>
+            <a:picLocks noChangeAspect="1"/>
+          </p:cNvPicPr>
+          <p:nvPr/>
+        </p:nvPicPr>
+        <p:blipFill>
+          <a:blip r:embed="rId4"/>
+          <a:stretch>
+            <a:fillRect/>
+          </a:stretch>
+        </p:blipFill>
+        <p:spPr>
+          <a:xfrm>
+            <a:off x="1014984" y="4846320"/>
+            <a:ext cx="274320" cy="274320"/>
+          </a:xfrm>
+          <a:prstGeom prst="rect">
+            <a:avLst/>
+          </a:prstGeom>
+        </p:spPr>
+      </p:pic>
+      <p:sp>
+        <p:nvSpPr>
+          <p:cNvPr id="18" name="Text 12"/>
+          <p:cNvSpPr/>
+          <p:nvPr/>
+        </p:nvSpPr>
+        <p:spPr>
+          <a:xfrm>
+            <a:off x="1618488" y="4663440"/>
+            <a:ext cx="4233672" cy="292608"/>
+          </a:xfrm>
+          <a:prstGeom prst="rect">
+            <a:avLst/>
+          </a:prstGeom>
+          <a:noFill/>
+          <a:ln/>
+        </p:spPr>
+        <p:txBody>
+          <a:bodyPr wrap="square" lIns="0" tIns="0" rIns="0" bIns="0" rtlCol="0" anchor="t"/>
+          <a:lstStyle/>
+          <a:p>
+            <a:pPr algn="l" indent="0" marL="0">
+              <a:buNone/>
+            </a:pPr>
+            <a:r>
+              <a:rPr lang="en-US" sz="1600" b="1" dirty="0">
+                <a:solidFill>
                   <a:srgbClr val="2B2B33"/>
                 </a:solidFill>
-                <a:latin typeface="Calibri" pitchFamily="34" charset="0"/>
-                <a:ea typeface="Calibri" pitchFamily="34" charset="-122"/>
-                <a:cs typeface="Calibri" pitchFamily="34" charset="-120"/>
-              </a:rPr>
-              <a:t>Same criteria as non-pregnant women</a:t>
+                <a:latin typeface="Cambria" pitchFamily="34" charset="0"/>
+                <a:ea typeface="Cambria" pitchFamily="34" charset="-122"/>
+                <a:cs typeface="Cambria" pitchFamily="34" charset="-120"/>
+              </a:rPr>
+              <a:t>Flecainide / sotalol</a:t>
+            </a:r>
+            <a:endParaRPr lang="en-US" sz="1600" dirty="0"/>
+          </a:p>
+        </p:txBody>
+      </p:sp>
+      <p:sp>
+        <p:nvSpPr>
+          <p:cNvPr id="19" name="Text 13"/>
+          <p:cNvSpPr/>
+          <p:nvPr/>
+        </p:nvSpPr>
+        <p:spPr>
+          <a:xfrm>
+            <a:off x="1618488" y="4974336"/>
+            <a:ext cx="4233672" cy="365760"/>
+          </a:xfrm>
+          <a:prstGeom prst="rect">
+            <a:avLst/>
+          </a:prstGeom>
+          <a:noFill/>
+          <a:ln/>
+        </p:spPr>
+        <p:txBody>
+          <a:bodyPr wrap="square" lIns="0" tIns="0" rIns="0" bIns="0" rtlCol="0" anchor="t"/>
+          <a:lstStyle/>
+          <a:p>
+            <a:pPr algn="l" indent="0" marL="0">
+              <a:buNone/>
+            </a:pPr>
+            <a:r>
+              <a:rPr lang="en-US" sz="1250" dirty="0">
+                <a:solidFill>
+                  <a:srgbClr val="6B6B76"/>
+                </a:solidFill>
+                <a:latin typeface="Calibri" pitchFamily="34" charset="0"/>
+                <a:ea typeface="Calibri" pitchFamily="34" charset="-122"/>
+                <a:cs typeface="Calibri" pitchFamily="34" charset="-120"/>
+              </a:rPr>
+              <a:t>For rhythm control when needed</a:t>
             </a:r>
             <a:endParaRPr lang="en-US" sz="1250" dirty="0"/>
           </a:p>
@@ -50754,142 +51031,172 @@
       </p:sp>
       <p:sp>
         <p:nvSpPr>
-          <p:cNvPr id="14" name="Shape 10"/>
-          <p:cNvSpPr/>
-          <p:nvPr/>
-        </p:nvSpPr>
-        <p:spPr>
-          <a:xfrm>
-            <a:off x="795528" y="4553712"/>
-            <a:ext cx="118872" cy="118872"/>
-          </a:xfrm>
-          <a:prstGeom prst="ellipse">
-            <a:avLst/>
-          </a:prstGeom>
-          <a:solidFill>
-            <a:srgbClr val="FF4D6D"/>
-          </a:solidFill>
-          <a:ln/>
-        </p:spPr>
-      </p:sp>
-      <p:sp>
-        <p:nvSpPr>
-          <p:cNvPr id="15" name="Text 11"/>
-          <p:cNvSpPr/>
-          <p:nvPr/>
-        </p:nvSpPr>
-        <p:spPr>
-          <a:xfrm>
-            <a:off x="1033272" y="4498848"/>
-            <a:ext cx="2834640" cy="676656"/>
-          </a:xfrm>
-          <a:prstGeom prst="rect">
-            <a:avLst/>
-          </a:prstGeom>
-          <a:noFill/>
-          <a:ln/>
-        </p:spPr>
-        <p:txBody>
-          <a:bodyPr wrap="square" lIns="0" tIns="0" rIns="0" bIns="0" rtlCol="0" anchor="t"/>
-          <a:lstStyle/>
-          <a:p>
-            <a:pPr algn="l" indent="0" marL="0">
-              <a:lnSpc>
-                <a:spcPct val="102000"/>
-              </a:lnSpc>
-              <a:buNone/>
-            </a:pPr>
-            <a:r>
-              <a:rPr lang="en-US" sz="1250" dirty="0">
-                <a:solidFill>
-                  <a:srgbClr val="2B2B33"/>
-                </a:solidFill>
-                <a:latin typeface="Calibri" pitchFamily="34" charset="0"/>
-                <a:ea typeface="Calibri" pitchFamily="34" charset="-122"/>
-                <a:cs typeface="Calibri" pitchFamily="34" charset="-120"/>
-              </a:rPr>
-              <a:t>Warfarin (not DOAC) — 2nd trimester to 1 month before delivery</a:t>
-            </a:r>
-            <a:endParaRPr lang="en-US" sz="1250" dirty="0"/>
-          </a:p>
-        </p:txBody>
-      </p:sp>
-      <p:sp>
-        <p:nvSpPr>
-          <p:cNvPr id="16" name="Shape 12"/>
-          <p:cNvSpPr/>
-          <p:nvPr/>
-        </p:nvSpPr>
-        <p:spPr>
-          <a:xfrm>
-            <a:off x="795528" y="5285232"/>
-            <a:ext cx="118872" cy="118872"/>
-          </a:xfrm>
-          <a:prstGeom prst="ellipse">
-            <a:avLst/>
-          </a:prstGeom>
-          <a:solidFill>
-            <a:srgbClr val="FF4D6D"/>
-          </a:solidFill>
-          <a:ln/>
-        </p:spPr>
-      </p:sp>
-      <p:sp>
-        <p:nvSpPr>
-          <p:cNvPr id="17" name="Text 13"/>
-          <p:cNvSpPr/>
-          <p:nvPr/>
-        </p:nvSpPr>
-        <p:spPr>
-          <a:xfrm>
-            <a:off x="1033272" y="5230368"/>
-            <a:ext cx="2834640" cy="676656"/>
-          </a:xfrm>
-          <a:prstGeom prst="rect">
-            <a:avLst/>
-          </a:prstGeom>
-          <a:noFill/>
-          <a:ln/>
-        </p:spPr>
-        <p:txBody>
-          <a:bodyPr wrap="square" lIns="0" tIns="0" rIns="0" bIns="0" rtlCol="0" anchor="t"/>
-          <a:lstStyle/>
-          <a:p>
-            <a:pPr algn="l" indent="0" marL="0">
-              <a:lnSpc>
-                <a:spcPct val="102000"/>
-              </a:lnSpc>
-              <a:buNone/>
-            </a:pPr>
-            <a:r>
-              <a:rPr lang="en-US" sz="1250" dirty="0">
-                <a:solidFill>
-                  <a:srgbClr val="2B2B33"/>
-                </a:solidFill>
-                <a:latin typeface="Calibri" pitchFamily="34" charset="0"/>
-                <a:ea typeface="Calibri" pitchFamily="34" charset="-122"/>
-                <a:cs typeface="Calibri" pitchFamily="34" charset="-120"/>
-              </a:rPr>
-              <a:t>LMWH (SC) — 1st trimester &amp; final month</a:t>
-            </a:r>
-            <a:endParaRPr lang="en-US" sz="1250" dirty="0"/>
-          </a:p>
-        </p:txBody>
-      </p:sp>
-      <p:sp>
-        <p:nvSpPr>
-          <p:cNvPr id="18" name="Shape 14"/>
-          <p:cNvSpPr/>
-          <p:nvPr/>
-        </p:nvSpPr>
-        <p:spPr>
-          <a:xfrm>
-            <a:off x="4288536" y="2670048"/>
-            <a:ext cx="3611880" cy="3319272"/>
+          <p:cNvPr id="20" name="Shape 14"/>
+          <p:cNvSpPr/>
+          <p:nvPr/>
+        </p:nvSpPr>
+        <p:spPr>
+          <a:xfrm>
+            <a:off x="6172200" y="1783080"/>
+            <a:ext cx="5532120" cy="2011680"/>
           </a:xfrm>
           <a:prstGeom prst="roundRect">
             <a:avLst>
-              <a:gd name="adj" fmla="val 3306"/>
+              <a:gd name="adj" fmla="val 5455"/>
+            </a:avLst>
+          </a:prstGeom>
+          <a:solidFill>
+            <a:srgbClr val="590D22"/>
+          </a:solidFill>
+          <a:ln/>
+          <a:effectLst>
+            <a:outerShdw sx="100000" sy="100000" kx="0" ky="0" algn="bl" rotWithShape="0" blurRad="127000" dist="50800" dir="5400000">
+              <a:srgbClr val="C9A3AC">
+                <a:alpha val="45000"/>
+              </a:srgbClr>
+            </a:outerShdw>
+          </a:effectLst>
+        </p:spPr>
+      </p:sp>
+      <p:sp>
+        <p:nvSpPr>
+          <p:cNvPr id="21" name="Shape 15"/>
+          <p:cNvSpPr/>
+          <p:nvPr/>
+        </p:nvSpPr>
+        <p:spPr>
+          <a:xfrm>
+            <a:off x="6492240" y="2148840"/>
+            <a:ext cx="868680" cy="868680"/>
+          </a:xfrm>
+          <a:prstGeom prst="ellipse">
+            <a:avLst/>
+          </a:prstGeom>
+          <a:solidFill>
+            <a:srgbClr val="A4133C"/>
+          </a:solidFill>
+          <a:ln/>
+        </p:spPr>
+      </p:sp>
+      <p:pic>
+        <p:nvPicPr>
+          <p:cNvPr id="22" name="Image 4" descr="preencoded.png">    </p:cNvPr>
+          <p:cNvPicPr>
+            <a:picLocks noChangeAspect="1"/>
+          </p:cNvPicPr>
+          <p:nvPr/>
+        </p:nvPicPr>
+        <p:blipFill>
+          <a:blip r:embed="rId5"/>
+          <a:stretch>
+            <a:fillRect/>
+          </a:stretch>
+        </p:blipFill>
+        <p:spPr>
+          <a:xfrm>
+            <a:off x="6729984" y="2377440"/>
+            <a:ext cx="402336" cy="402336"/>
+          </a:xfrm>
+          <a:prstGeom prst="rect">
+            <a:avLst/>
+          </a:prstGeom>
+        </p:spPr>
+      </p:pic>
+      <p:sp>
+        <p:nvSpPr>
+          <p:cNvPr id="23" name="Text 16"/>
+          <p:cNvSpPr/>
+          <p:nvPr/>
+        </p:nvSpPr>
+        <p:spPr>
+          <a:xfrm>
+            <a:off x="7498080" y="2194560"/>
+            <a:ext cx="4023360" cy="457200"/>
+          </a:xfrm>
+          <a:prstGeom prst="rect">
+            <a:avLst/>
+          </a:prstGeom>
+          <a:noFill/>
+          <a:ln/>
+        </p:spPr>
+        <p:txBody>
+          <a:bodyPr wrap="square" rtlCol="0" anchor="ctr"/>
+          <a:lstStyle/>
+          <a:p>
+            <a:pPr algn="l" indent="0" marL="0">
+              <a:buNone/>
+            </a:pPr>
+            <a:r>
+              <a:rPr lang="en-US" sz="2100" b="1" dirty="0">
+                <a:solidFill>
+                  <a:srgbClr val="FFFFFF"/>
+                </a:solidFill>
+                <a:latin typeface="Cambria" pitchFamily="34" charset="0"/>
+                <a:ea typeface="Cambria" pitchFamily="34" charset="-122"/>
+                <a:cs typeface="Cambria" pitchFamily="34" charset="-120"/>
+              </a:rPr>
+              <a:t>Cardioversion</a:t>
+            </a:r>
+            <a:endParaRPr lang="en-US" sz="2100" dirty="0"/>
+          </a:p>
+        </p:txBody>
+      </p:sp>
+      <p:sp>
+        <p:nvSpPr>
+          <p:cNvPr id="24" name="Text 17"/>
+          <p:cNvSpPr/>
+          <p:nvPr/>
+        </p:nvSpPr>
+        <p:spPr>
+          <a:xfrm>
+            <a:off x="6537960" y="2852928"/>
+            <a:ext cx="5029200" cy="822960"/>
+          </a:xfrm>
+          <a:prstGeom prst="rect">
+            <a:avLst/>
+          </a:prstGeom>
+          <a:noFill/>
+          <a:ln/>
+        </p:spPr>
+        <p:txBody>
+          <a:bodyPr wrap="square" rtlCol="0" anchor="t"/>
+          <a:lstStyle/>
+          <a:p>
+            <a:pPr algn="l" indent="0" marL="0">
+              <a:lnSpc>
+                <a:spcPct val="112000"/>
+              </a:lnSpc>
+              <a:buNone/>
+            </a:pPr>
+            <a:r>
+              <a:rPr lang="en-US" sz="1400" dirty="0">
+                <a:solidFill>
+                  <a:srgbClr val="FBD8DF"/>
+                </a:solidFill>
+                <a:latin typeface="Calibri" pitchFamily="34" charset="0"/>
+                <a:ea typeface="Calibri" pitchFamily="34" charset="-122"/>
+                <a:cs typeface="Calibri" pitchFamily="34" charset="-120"/>
+              </a:rPr>
+              <a:t>DC cardioversion is safe in all trimesters — perform with fetal monitoring.</a:t>
+            </a:r>
+            <a:endParaRPr lang="en-US" sz="1400" dirty="0"/>
+          </a:p>
+        </p:txBody>
+      </p:sp>
+      <p:sp>
+        <p:nvSpPr>
+          <p:cNvPr id="25" name="Shape 18"/>
+          <p:cNvSpPr/>
+          <p:nvPr/>
+        </p:nvSpPr>
+        <p:spPr>
+          <a:xfrm>
+            <a:off x="6172200" y="3977640"/>
+            <a:ext cx="5532120" cy="2011680"/>
+          </a:xfrm>
+          <a:prstGeom prst="roundRect">
+            <a:avLst>
+              <a:gd name="adj" fmla="val 5455"/>
             </a:avLst>
           </a:prstGeom>
           <a:solidFill>
@@ -50912,42 +51219,322 @@
       </p:sp>
       <p:sp>
         <p:nvSpPr>
-          <p:cNvPr id="19" name="Shape 15"/>
-          <p:cNvSpPr/>
-          <p:nvPr/>
-        </p:nvSpPr>
-        <p:spPr>
-          <a:xfrm>
-            <a:off x="4562856" y="2926080"/>
-            <a:ext cx="658368" cy="658368"/>
+          <p:cNvPr id="26" name="Text 19"/>
+          <p:cNvSpPr/>
+          <p:nvPr/>
+        </p:nvSpPr>
+        <p:spPr>
+          <a:xfrm>
+            <a:off x="6537960" y="4206240"/>
+            <a:ext cx="4937760" cy="274320"/>
+          </a:xfrm>
+          <a:prstGeom prst="rect">
+            <a:avLst/>
+          </a:prstGeom>
+          <a:noFill/>
+          <a:ln/>
+        </p:spPr>
+        <p:txBody>
+          <a:bodyPr wrap="square" rtlCol="0" anchor="t"/>
+          <a:lstStyle/>
+          <a:p>
+            <a:pPr algn="l" indent="0" marL="0">
+              <a:buNone/>
+            </a:pPr>
+            <a:r>
+              <a:rPr lang="en-US" sz="1300" b="1" spc="120" kern="0" dirty="0">
+                <a:solidFill>
+                  <a:srgbClr val="A4133C"/>
+                </a:solidFill>
+                <a:latin typeface="Calibri" pitchFamily="34" charset="0"/>
+                <a:ea typeface="Calibri" pitchFamily="34" charset="-122"/>
+                <a:cs typeface="Calibri" pitchFamily="34" charset="-120"/>
+              </a:rPr>
+              <a:t>✕  </a:t>
+            </a:r>
+            <a:pPr algn="l" indent="0" marL="0">
+              <a:buNone/>
+            </a:pPr>
+            <a:r>
+              <a:rPr lang="en-US" sz="1300" b="1" spc="120" kern="0" dirty="0">
+                <a:solidFill>
+                  <a:srgbClr val="A4133C"/>
+                </a:solidFill>
+                <a:latin typeface="Calibri" pitchFamily="34" charset="0"/>
+                <a:ea typeface="Calibri" pitchFamily="34" charset="-122"/>
+                <a:cs typeface="Calibri" pitchFamily="34" charset="-120"/>
+              </a:rPr>
+              <a:t>USE WITH CAUTION / AVOID</a:t>
+            </a:r>
+            <a:endParaRPr lang="en-US" sz="1300" dirty="0"/>
+          </a:p>
+        </p:txBody>
+      </p:sp>
+      <p:sp>
+        <p:nvSpPr>
+          <p:cNvPr id="27" name="Text 20"/>
+          <p:cNvSpPr/>
+          <p:nvPr/>
+        </p:nvSpPr>
+        <p:spPr>
+          <a:xfrm>
+            <a:off x="6537960" y="4645152"/>
+            <a:ext cx="5029200" cy="594360"/>
+          </a:xfrm>
+          <a:prstGeom prst="rect">
+            <a:avLst/>
+          </a:prstGeom>
+          <a:noFill/>
+          <a:ln/>
+        </p:spPr>
+        <p:txBody>
+          <a:bodyPr wrap="square" lIns="0" tIns="0" rIns="0" bIns="0" rtlCol="0" anchor="t"/>
+          <a:lstStyle/>
+          <a:p>
+            <a:pPr algn="l" indent="0" marL="0">
+              <a:lnSpc>
+                <a:spcPct val="105000"/>
+              </a:lnSpc>
+              <a:buNone/>
+            </a:pPr>
+            <a:r>
+              <a:rPr lang="en-US" sz="1350" b="1" dirty="0">
+                <a:solidFill>
+                  <a:srgbClr val="2B2B33"/>
+                </a:solidFill>
+                <a:latin typeface="Calibri" pitchFamily="34" charset="0"/>
+                <a:ea typeface="Calibri" pitchFamily="34" charset="-122"/>
+                <a:cs typeface="Calibri" pitchFamily="34" charset="-120"/>
+              </a:rPr>
+              <a:t>Amiodarone  </a:t>
+            </a:r>
+            <a:pPr algn="l" indent="0" marL="0">
+              <a:lnSpc>
+                <a:spcPct val="105000"/>
+              </a:lnSpc>
+              <a:buNone/>
+            </a:pPr>
+            <a:r>
+              <a:rPr lang="en-US" sz="1350" dirty="0">
+                <a:solidFill>
+                  <a:srgbClr val="6B6B76"/>
+                </a:solidFill>
+                <a:latin typeface="Calibri" pitchFamily="34" charset="0"/>
+                <a:ea typeface="Calibri" pitchFamily="34" charset="-122"/>
+                <a:cs typeface="Calibri" pitchFamily="34" charset="-120"/>
+              </a:rPr>
+              <a:t>— fetal thyroid dysfunction &amp; IUGR; only if life-threatening</a:t>
+            </a:r>
+            <a:endParaRPr lang="en-US" sz="1350" dirty="0"/>
+          </a:p>
+        </p:txBody>
+      </p:sp>
+      <p:sp>
+        <p:nvSpPr>
+          <p:cNvPr id="28" name="Text 21"/>
+          <p:cNvSpPr/>
+          <p:nvPr/>
+        </p:nvSpPr>
+        <p:spPr>
+          <a:xfrm>
+            <a:off x="6537960" y="5285232"/>
+            <a:ext cx="5029200" cy="457200"/>
+          </a:xfrm>
+          <a:prstGeom prst="rect">
+            <a:avLst/>
+          </a:prstGeom>
+          <a:noFill/>
+          <a:ln/>
+        </p:spPr>
+        <p:txBody>
+          <a:bodyPr wrap="square" lIns="0" tIns="0" rIns="0" bIns="0" rtlCol="0" anchor="t"/>
+          <a:lstStyle/>
+          <a:p>
+            <a:pPr algn="l" indent="0" marL="0">
+              <a:buNone/>
+            </a:pPr>
+            <a:r>
+              <a:rPr lang="en-US" sz="1350" b="1" dirty="0">
+                <a:solidFill>
+                  <a:srgbClr val="2B2B33"/>
+                </a:solidFill>
+                <a:latin typeface="Calibri" pitchFamily="34" charset="0"/>
+                <a:ea typeface="Calibri" pitchFamily="34" charset="-122"/>
+                <a:cs typeface="Calibri" pitchFamily="34" charset="-120"/>
+              </a:rPr>
+              <a:t>Atenolol  </a:t>
+            </a:r>
+            <a:pPr algn="l" indent="0" marL="0">
+              <a:buNone/>
+            </a:pPr>
+            <a:r>
+              <a:rPr lang="en-US" sz="1350" dirty="0">
+                <a:solidFill>
+                  <a:srgbClr val="6B6B76"/>
+                </a:solidFill>
+                <a:latin typeface="Calibri" pitchFamily="34" charset="0"/>
+                <a:ea typeface="Calibri" pitchFamily="34" charset="-122"/>
+                <a:cs typeface="Calibri" pitchFamily="34" charset="-120"/>
+              </a:rPr>
+              <a:t>— linked to fetal growth restriction</a:t>
+            </a:r>
+            <a:endParaRPr lang="en-US" sz="1350" dirty="0"/>
+          </a:p>
+        </p:txBody>
+      </p:sp>
+      <p:sp>
+        <p:nvSpPr>
+          <p:cNvPr id="29" name="Text 22"/>
+          <p:cNvSpPr/>
+          <p:nvPr/>
+        </p:nvSpPr>
+        <p:spPr>
+          <a:xfrm>
+            <a:off x="11277295" y="6355080"/>
+            <a:ext cx="548640" cy="320040"/>
+          </a:xfrm>
+          <a:prstGeom prst="rect">
+            <a:avLst/>
+          </a:prstGeom>
+          <a:noFill/>
+          <a:ln/>
+        </p:spPr>
+        <p:txBody>
+          <a:bodyPr wrap="square" rtlCol="0" anchor="t"/>
+          <a:lstStyle/>
+          <a:p>
+            <a:pPr algn="r" indent="0" marL="0">
+              <a:buNone/>
+            </a:pPr>
+            <a:r>
+              <a:rPr lang="en-US" sz="1100" b="1" dirty="0">
+                <a:solidFill>
+                  <a:srgbClr val="6B6B76"/>
+                </a:solidFill>
+                <a:latin typeface="Calibri" pitchFamily="34" charset="0"/>
+                <a:ea typeface="Calibri" pitchFamily="34" charset="-122"/>
+                <a:cs typeface="Calibri" pitchFamily="34" charset="-120"/>
+              </a:rPr>
+              <a:t>42</a:t>
+            </a:r>
+            <a:endParaRPr lang="en-US" sz="1100" dirty="0"/>
+          </a:p>
+        </p:txBody>
+      </p:sp>
+      <p:sp>
+        <p:nvSpPr>
+          <p:cNvPr id="30" name="Text 23"/>
+          <p:cNvSpPr/>
+          <p:nvPr/>
+        </p:nvSpPr>
+        <p:spPr>
+          <a:xfrm>
+            <a:off x="502920" y="6355080"/>
+            <a:ext cx="7315200" cy="320040"/>
+          </a:xfrm>
+          <a:prstGeom prst="rect">
+            <a:avLst/>
+          </a:prstGeom>
+          <a:noFill/>
+          <a:ln/>
+        </p:spPr>
+        <p:txBody>
+          <a:bodyPr wrap="square" rtlCol="0" anchor="t"/>
+          <a:lstStyle/>
+          <a:p>
+            <a:pPr algn="l" indent="0" marL="0">
+              <a:buNone/>
+            </a:pPr>
+            <a:r>
+              <a:rPr lang="en-US" sz="900" dirty="0">
+                <a:solidFill>
+                  <a:srgbClr val="6B6B76"/>
+                </a:solidFill>
+                <a:latin typeface="Calibri" pitchFamily="34" charset="0"/>
+                <a:ea typeface="Calibri" pitchFamily="34" charset="-122"/>
+                <a:cs typeface="Calibri" pitchFamily="34" charset="-120"/>
+              </a:rPr>
+              <a:t>Atrial Fibrillation — Topic Review</a:t>
+            </a:r>
+            <a:endParaRPr lang="en-US" sz="900" dirty="0"/>
+          </a:p>
+        </p:txBody>
+      </p:sp>
+    </p:spTree>
+  </p:cSld>
+  <p:clrMapOvr>
+    <a:masterClrMapping/>
+  </p:clrMapOvr>
+</p:sld>
+</file>
+
+<file path=ppt/slides/slide43.xml><?xml version="1.0" encoding="utf-8"?>
+<p:sld xmlns:a="http://schemas.openxmlformats.org/drawingml/2006/main" xmlns:r="http://schemas.openxmlformats.org/officeDocument/2006/relationships" xmlns:p="http://schemas.openxmlformats.org/presentationml/2006/main">
+  <p:cSld name="Slide 43">
+    <p:bg>
+      <p:bgPr>
+        <a:solidFill>
+          <a:srgbClr val="FFFFFF"/>
+        </a:solidFill>
+      </p:bgPr>
+    </p:bg>
+    <p:spTree>
+      <p:nvGrpSpPr>
+        <p:cNvPr id="1" name=""/>
+        <p:cNvGrpSpPr/>
+        <p:nvPr/>
+      </p:nvGrpSpPr>
+      <p:grpSpPr>
+        <a:xfrm>
+          <a:off x="0" y="0"/>
+          <a:ext cx="0" cy="0"/>
+          <a:chOff x="0" y="0"/>
+          <a:chExt cx="0" cy="0"/>
+        </a:xfrm>
+      </p:grpSpPr>
+      <p:sp>
+        <p:nvSpPr>
+          <p:cNvPr id="2" name="Shape 0"/>
+          <p:cNvSpPr/>
+          <p:nvPr/>
+        </p:nvSpPr>
+        <p:spPr>
+          <a:xfrm>
+            <a:off x="502920" y="457200"/>
+            <a:ext cx="868680" cy="868680"/>
           </a:xfrm>
           <a:prstGeom prst="ellipse">
             <a:avLst/>
           </a:prstGeom>
           <a:solidFill>
-            <a:srgbClr val="A4133C"/>
+            <a:srgbClr val="FFF0F3"/>
           </a:solidFill>
-          <a:ln/>
+          <a:ln w="12700">
+            <a:solidFill>
+              <a:srgbClr val="FBD8DF"/>
+            </a:solidFill>
+            <a:prstDash val="solid"/>
+          </a:ln>
         </p:spPr>
       </p:sp>
       <p:pic>
         <p:nvPicPr>
-          <p:cNvPr id="20" name="Image 2" descr="preencoded.png">    </p:cNvPr>
+          <p:cNvPr id="3" name="Image 0" descr="preencoded.png">    </p:cNvPr>
           <p:cNvPicPr>
             <a:picLocks noChangeAspect="1"/>
           </p:cNvPicPr>
           <p:nvPr/>
         </p:nvPicPr>
         <p:blipFill>
-          <a:blip r:embed="rId3"/>
+          <a:blip r:embed="rId1"/>
           <a:stretch>
             <a:fillRect/>
           </a:stretch>
         </p:blipFill>
         <p:spPr>
           <a:xfrm>
-            <a:off x="4718304" y="3081528"/>
-            <a:ext cx="347472" cy="347472"/>
+            <a:off x="694944" y="649224"/>
+            <a:ext cx="484632" cy="484632"/>
           </a:xfrm>
           <a:prstGeom prst="rect">
             <a:avLst/>
@@ -50956,30 +51543,69 @@
       </p:pic>
       <p:sp>
         <p:nvSpPr>
-          <p:cNvPr id="21" name="Text 16"/>
-          <p:cNvSpPr/>
-          <p:nvPr/>
-        </p:nvSpPr>
-        <p:spPr>
-          <a:xfrm>
-            <a:off x="5340096" y="2926080"/>
-            <a:ext cx="2423160" cy="658368"/>
-          </a:xfrm>
-          <a:prstGeom prst="rect">
-            <a:avLst/>
-          </a:prstGeom>
-          <a:noFill/>
-          <a:ln/>
-        </p:spPr>
-        <p:txBody>
-          <a:bodyPr wrap="square" lIns="0" tIns="0" rIns="0" bIns="0" rtlCol="0" anchor="ctr"/>
-          <a:lstStyle/>
-          <a:p>
-            <a:pPr algn="l" indent="0" marL="0">
-              <a:buNone/>
-            </a:pPr>
-            <a:r>
-              <a:rPr lang="en-US" sz="1700" b="1" dirty="0">
+          <p:cNvPr id="4" name="Text 1"/>
+          <p:cNvSpPr/>
+          <p:nvPr/>
+        </p:nvSpPr>
+        <p:spPr>
+          <a:xfrm>
+            <a:off x="1572768" y="502920"/>
+            <a:ext cx="9966960" cy="274320"/>
+          </a:xfrm>
+          <a:prstGeom prst="rect">
+            <a:avLst/>
+          </a:prstGeom>
+          <a:noFill/>
+          <a:ln/>
+        </p:spPr>
+        <p:txBody>
+          <a:bodyPr wrap="square" rtlCol="0" anchor="t"/>
+          <a:lstStyle/>
+          <a:p>
+            <a:pPr algn="l" indent="0" marL="0">
+              <a:buNone/>
+            </a:pPr>
+            <a:r>
+              <a:rPr lang="en-US" sz="1250" b="1" spc="200" kern="0" dirty="0">
+                <a:solidFill>
+                  <a:srgbClr val="A4133C"/>
+                </a:solidFill>
+                <a:latin typeface="Calibri" pitchFamily="34" charset="0"/>
+                <a:ea typeface="Calibri" pitchFamily="34" charset="-122"/>
+                <a:cs typeface="Calibri" pitchFamily="34" charset="-120"/>
+              </a:rPr>
+              <a:t>SPECIAL POPULATIONS · PREGNANCY</a:t>
+            </a:r>
+            <a:endParaRPr lang="en-US" sz="1250" dirty="0"/>
+          </a:p>
+        </p:txBody>
+      </p:sp>
+      <p:sp>
+        <p:nvSpPr>
+          <p:cNvPr id="5" name="Text 2"/>
+          <p:cNvSpPr/>
+          <p:nvPr/>
+        </p:nvSpPr>
+        <p:spPr>
+          <a:xfrm>
+            <a:off x="1554480" y="749808"/>
+            <a:ext cx="10241280" cy="640080"/>
+          </a:xfrm>
+          <a:prstGeom prst="rect">
+            <a:avLst/>
+          </a:prstGeom>
+          <a:noFill/>
+          <a:ln/>
+        </p:spPr>
+        <p:txBody>
+          <a:bodyPr wrap="square" rtlCol="0" anchor="t"/>
+          <a:lstStyle/>
+          <a:p>
+            <a:pPr algn="l" indent="0" marL="0">
+              <a:buNone/>
+            </a:pPr>
+            <a:r>
+              <a:rPr lang="en-US" sz="3000" b="1" dirty="0">
                 <a:solidFill>
                   <a:srgbClr val="2B2B33"/>
                 </a:solidFill>
@@ -50987,207 +51613,109 @@
                 <a:ea typeface="Cambria" pitchFamily="34" charset="-122"/>
                 <a:cs typeface="Cambria" pitchFamily="34" charset="-120"/>
               </a:rPr>
-              <a:t>Acute Management</a:t>
-            </a:r>
-            <a:endParaRPr lang="en-US" sz="1700" dirty="0"/>
-          </a:p>
-        </p:txBody>
-      </p:sp>
-      <p:sp>
-        <p:nvSpPr>
-          <p:cNvPr id="22" name="Shape 17"/>
-          <p:cNvSpPr/>
-          <p:nvPr/>
-        </p:nvSpPr>
-        <p:spPr>
-          <a:xfrm>
-            <a:off x="4581144" y="3822192"/>
-            <a:ext cx="118872" cy="118872"/>
-          </a:xfrm>
-          <a:prstGeom prst="ellipse">
-            <a:avLst/>
+              <a:t>AF in Pregnancy — Overview</a:t>
+            </a:r>
+            <a:endParaRPr lang="en-US" sz="3000" dirty="0"/>
+          </a:p>
+        </p:txBody>
+      </p:sp>
+      <p:sp>
+        <p:nvSpPr>
+          <p:cNvPr id="6" name="Shape 3"/>
+          <p:cNvSpPr/>
+          <p:nvPr/>
+        </p:nvSpPr>
+        <p:spPr>
+          <a:xfrm>
+            <a:off x="502920" y="1572768"/>
+            <a:ext cx="11183112" cy="914400"/>
+          </a:xfrm>
+          <a:prstGeom prst="roundRect">
+            <a:avLst>
+              <a:gd name="adj" fmla="val 12000"/>
+            </a:avLst>
           </a:prstGeom>
           <a:solidFill>
-            <a:srgbClr val="FF4D6D"/>
+            <a:srgbClr val="590D22"/>
           </a:solidFill>
           <a:ln/>
-        </p:spPr>
-      </p:sp>
-      <p:sp>
-        <p:nvSpPr>
-          <p:cNvPr id="23" name="Text 18"/>
-          <p:cNvSpPr/>
-          <p:nvPr/>
-        </p:nvSpPr>
-        <p:spPr>
-          <a:xfrm>
-            <a:off x="4818888" y="3767328"/>
-            <a:ext cx="2834640" cy="676656"/>
-          </a:xfrm>
-          <a:prstGeom prst="rect">
-            <a:avLst/>
-          </a:prstGeom>
-          <a:noFill/>
-          <a:ln/>
-        </p:spPr>
-        <p:txBody>
-          <a:bodyPr wrap="square" lIns="0" tIns="0" rIns="0" bIns="0" rtlCol="0" anchor="t"/>
+          <a:effectLst>
+            <a:outerShdw sx="100000" sy="100000" kx="0" ky="0" algn="bl" rotWithShape="0" blurRad="127000" dist="50800" dir="5400000">
+              <a:srgbClr val="C9A3AC">
+                <a:alpha val="45000"/>
+              </a:srgbClr>
+            </a:outerShdw>
+          </a:effectLst>
+        </p:spPr>
+      </p:sp>
+      <p:sp>
+        <p:nvSpPr>
+          <p:cNvPr id="7" name="Text 4"/>
+          <p:cNvSpPr/>
+          <p:nvPr/>
+        </p:nvSpPr>
+        <p:spPr>
+          <a:xfrm>
+            <a:off x="914400" y="1572768"/>
+            <a:ext cx="10424160" cy="914400"/>
+          </a:xfrm>
+          <a:prstGeom prst="rect">
+            <a:avLst/>
+          </a:prstGeom>
+          <a:noFill/>
+          <a:ln/>
+        </p:spPr>
+        <p:txBody>
+          <a:bodyPr wrap="square" rtlCol="0" anchor="ctr"/>
           <a:lstStyle/>
           <a:p>
             <a:pPr algn="l" indent="0" marL="0">
               <a:lnSpc>
-                <a:spcPct val="102000"/>
+                <a:spcPct val="110000"/>
               </a:lnSpc>
               <a:buNone/>
             </a:pPr>
             <a:r>
-              <a:rPr lang="en-US" sz="1250" dirty="0">
-                <a:solidFill>
-                  <a:srgbClr val="2B2B33"/>
-                </a:solidFill>
-                <a:latin typeface="Calibri" pitchFamily="34" charset="0"/>
-                <a:ea typeface="Calibri" pitchFamily="34" charset="-122"/>
-                <a:cs typeface="Calibri" pitchFamily="34" charset="-120"/>
-              </a:rPr>
-              <a:t>DC cardioversion — safe at all stages</a:t>
-            </a:r>
-            <a:endParaRPr lang="en-US" sz="1250" dirty="0"/>
-          </a:p>
-        </p:txBody>
-      </p:sp>
-      <p:sp>
-        <p:nvSpPr>
-          <p:cNvPr id="24" name="Shape 19"/>
-          <p:cNvSpPr/>
-          <p:nvPr/>
-        </p:nvSpPr>
-        <p:spPr>
-          <a:xfrm>
-            <a:off x="4581144" y="4553712"/>
-            <a:ext cx="118872" cy="118872"/>
-          </a:xfrm>
-          <a:prstGeom prst="ellipse">
-            <a:avLst/>
-          </a:prstGeom>
-          <a:solidFill>
-            <a:srgbClr val="FF4D6D"/>
-          </a:solidFill>
-          <a:ln/>
-        </p:spPr>
-      </p:sp>
-      <p:sp>
-        <p:nvSpPr>
-          <p:cNvPr id="25" name="Text 20"/>
-          <p:cNvSpPr/>
-          <p:nvPr/>
-        </p:nvSpPr>
-        <p:spPr>
-          <a:xfrm>
-            <a:off x="4818888" y="4498848"/>
-            <a:ext cx="2834640" cy="676656"/>
-          </a:xfrm>
-          <a:prstGeom prst="rect">
-            <a:avLst/>
-          </a:prstGeom>
-          <a:noFill/>
-          <a:ln/>
-        </p:spPr>
-        <p:txBody>
-          <a:bodyPr wrap="square" lIns="0" tIns="0" rIns="0" bIns="0" rtlCol="0" anchor="t"/>
-          <a:lstStyle/>
-          <a:p>
+              <a:rPr lang="en-US" sz="1400" b="1" dirty="0">
+                <a:solidFill>
+                  <a:srgbClr val="FFFFFF"/>
+                </a:solidFill>
+                <a:latin typeface="Calibri" pitchFamily="34" charset="0"/>
+                <a:ea typeface="Calibri" pitchFamily="34" charset="-122"/>
+                <a:cs typeface="Calibri" pitchFamily="34" charset="-120"/>
+              </a:rPr>
+              <a:t>Rare — ~60 / 100,000 pregnancies</a:t>
+            </a:r>
             <a:pPr algn="l" indent="0" marL="0">
               <a:lnSpc>
-                <a:spcPct val="102000"/>
+                <a:spcPct val="110000"/>
               </a:lnSpc>
               <a:buNone/>
             </a:pPr>
             <a:r>
-              <a:rPr lang="en-US" sz="1250" dirty="0">
-                <a:solidFill>
-                  <a:srgbClr val="2B2B33"/>
-                </a:solidFill>
-                <a:latin typeface="Calibri" pitchFamily="34" charset="0"/>
-                <a:ea typeface="Calibri" pitchFamily="34" charset="-122"/>
-                <a:cs typeface="Calibri" pitchFamily="34" charset="-120"/>
-              </a:rPr>
-              <a:t>IV metoprolol — rate control</a:t>
-            </a:r>
-            <a:endParaRPr lang="en-US" sz="1250" dirty="0"/>
-          </a:p>
-        </p:txBody>
-      </p:sp>
-      <p:sp>
-        <p:nvSpPr>
-          <p:cNvPr id="26" name="Shape 21"/>
-          <p:cNvSpPr/>
-          <p:nvPr/>
-        </p:nvSpPr>
-        <p:spPr>
-          <a:xfrm>
-            <a:off x="4581144" y="5285232"/>
-            <a:ext cx="118872" cy="118872"/>
-          </a:xfrm>
-          <a:prstGeom prst="ellipse">
-            <a:avLst/>
-          </a:prstGeom>
-          <a:solidFill>
-            <a:srgbClr val="FF4D6D"/>
-          </a:solidFill>
-          <a:ln/>
-        </p:spPr>
-      </p:sp>
-      <p:sp>
-        <p:nvSpPr>
-          <p:cNvPr id="27" name="Text 22"/>
-          <p:cNvSpPr/>
-          <p:nvPr/>
-        </p:nvSpPr>
-        <p:spPr>
-          <a:xfrm>
-            <a:off x="4818888" y="5230368"/>
-            <a:ext cx="2834640" cy="676656"/>
-          </a:xfrm>
-          <a:prstGeom prst="rect">
-            <a:avLst/>
-          </a:prstGeom>
-          <a:noFill/>
-          <a:ln/>
-        </p:spPr>
-        <p:txBody>
-          <a:bodyPr wrap="square" lIns="0" tIns="0" rIns="0" bIns="0" rtlCol="0" anchor="t"/>
-          <a:lstStyle/>
-          <a:p>
-            <a:pPr algn="l" indent="0" marL="0">
-              <a:lnSpc>
-                <a:spcPct val="102000"/>
-              </a:lnSpc>
-              <a:buNone/>
-            </a:pPr>
-            <a:r>
-              <a:rPr lang="en-US" sz="1250" dirty="0">
-                <a:solidFill>
-                  <a:srgbClr val="2B2B33"/>
-                </a:solidFill>
-                <a:latin typeface="Calibri" pitchFamily="34" charset="0"/>
-                <a:ea typeface="Calibri" pitchFamily="34" charset="-122"/>
-                <a:cs typeface="Calibri" pitchFamily="34" charset="-120"/>
-              </a:rPr>
-              <a:t>Flecainide or sotalol — conversion to sinus rhythm</a:t>
-            </a:r>
-            <a:endParaRPr lang="en-US" sz="1250" dirty="0"/>
-          </a:p>
-        </p:txBody>
-      </p:sp>
-      <p:sp>
-        <p:nvSpPr>
-          <p:cNvPr id="28" name="Shape 23"/>
-          <p:cNvSpPr/>
-          <p:nvPr/>
-        </p:nvSpPr>
-        <p:spPr>
-          <a:xfrm>
-            <a:off x="8074152" y="2670048"/>
+              <a:rPr lang="en-US" sz="1400" dirty="0">
+                <a:solidFill>
+                  <a:srgbClr val="FBD8DF"/>
+                </a:solidFill>
+                <a:latin typeface="Calibri" pitchFamily="34" charset="0"/>
+                <a:ea typeface="Calibri" pitchFamily="34" charset="-122"/>
+                <a:cs typeface="Calibri" pitchFamily="34" charset="-120"/>
+              </a:rPr>
+              <a:t>   ·   often congenital / valvular disease, thyrotoxicosis or electrolyte disturbance   ·   hypercoagulable, but no proven rise in AF-related thromboembolism</a:t>
+            </a:r>
+            <a:endParaRPr lang="en-US" sz="1400" dirty="0"/>
+          </a:p>
+        </p:txBody>
+      </p:sp>
+      <p:sp>
+        <p:nvSpPr>
+          <p:cNvPr id="8" name="Shape 5"/>
+          <p:cNvSpPr/>
+          <p:nvPr/>
+        </p:nvSpPr>
+        <p:spPr>
+          <a:xfrm>
+            <a:off x="502920" y="2670048"/>
             <a:ext cx="3611880" cy="3319272"/>
           </a:xfrm>
           <a:prstGeom prst="roundRect">
@@ -51215,6 +51743,612 @@
       </p:sp>
       <p:sp>
         <p:nvSpPr>
+          <p:cNvPr id="9" name="Shape 6"/>
+          <p:cNvSpPr/>
+          <p:nvPr/>
+        </p:nvSpPr>
+        <p:spPr>
+          <a:xfrm>
+            <a:off x="777240" y="2926080"/>
+            <a:ext cx="658368" cy="658368"/>
+          </a:xfrm>
+          <a:prstGeom prst="ellipse">
+            <a:avLst/>
+          </a:prstGeom>
+          <a:solidFill>
+            <a:srgbClr val="A4133C"/>
+          </a:solidFill>
+          <a:ln/>
+        </p:spPr>
+      </p:sp>
+      <p:pic>
+        <p:nvPicPr>
+          <p:cNvPr id="10" name="Image 1" descr="preencoded.png">    </p:cNvPr>
+          <p:cNvPicPr>
+            <a:picLocks noChangeAspect="1"/>
+          </p:cNvPicPr>
+          <p:nvPr/>
+        </p:nvPicPr>
+        <p:blipFill>
+          <a:blip r:embed="rId2"/>
+          <a:stretch>
+            <a:fillRect/>
+          </a:stretch>
+        </p:blipFill>
+        <p:spPr>
+          <a:xfrm>
+            <a:off x="932688" y="3081528"/>
+            <a:ext cx="347472" cy="347472"/>
+          </a:xfrm>
+          <a:prstGeom prst="rect">
+            <a:avLst/>
+          </a:prstGeom>
+        </p:spPr>
+      </p:pic>
+      <p:sp>
+        <p:nvSpPr>
+          <p:cNvPr id="11" name="Text 7"/>
+          <p:cNvSpPr/>
+          <p:nvPr/>
+        </p:nvSpPr>
+        <p:spPr>
+          <a:xfrm>
+            <a:off x="1554480" y="2926080"/>
+            <a:ext cx="2423160" cy="658368"/>
+          </a:xfrm>
+          <a:prstGeom prst="rect">
+            <a:avLst/>
+          </a:prstGeom>
+          <a:noFill/>
+          <a:ln/>
+        </p:spPr>
+        <p:txBody>
+          <a:bodyPr wrap="square" lIns="0" tIns="0" rIns="0" bIns="0" rtlCol="0" anchor="ctr"/>
+          <a:lstStyle/>
+          <a:p>
+            <a:pPr algn="l" indent="0" marL="0">
+              <a:buNone/>
+            </a:pPr>
+            <a:r>
+              <a:rPr lang="en-US" sz="1700" b="1" dirty="0">
+                <a:solidFill>
+                  <a:srgbClr val="2B2B33"/>
+                </a:solidFill>
+                <a:latin typeface="Cambria" pitchFamily="34" charset="0"/>
+                <a:ea typeface="Cambria" pitchFamily="34" charset="-122"/>
+                <a:cs typeface="Cambria" pitchFamily="34" charset="-120"/>
+              </a:rPr>
+              <a:t>Anticoagulation</a:t>
+            </a:r>
+            <a:endParaRPr lang="en-US" sz="1700" dirty="0"/>
+          </a:p>
+        </p:txBody>
+      </p:sp>
+      <p:sp>
+        <p:nvSpPr>
+          <p:cNvPr id="12" name="Shape 8"/>
+          <p:cNvSpPr/>
+          <p:nvPr/>
+        </p:nvSpPr>
+        <p:spPr>
+          <a:xfrm>
+            <a:off x="795528" y="3822192"/>
+            <a:ext cx="118872" cy="118872"/>
+          </a:xfrm>
+          <a:prstGeom prst="ellipse">
+            <a:avLst/>
+          </a:prstGeom>
+          <a:solidFill>
+            <a:srgbClr val="FF4D6D"/>
+          </a:solidFill>
+          <a:ln/>
+        </p:spPr>
+      </p:sp>
+      <p:sp>
+        <p:nvSpPr>
+          <p:cNvPr id="13" name="Text 9"/>
+          <p:cNvSpPr/>
+          <p:nvPr/>
+        </p:nvSpPr>
+        <p:spPr>
+          <a:xfrm>
+            <a:off x="1033272" y="3767328"/>
+            <a:ext cx="2834640" cy="676656"/>
+          </a:xfrm>
+          <a:prstGeom prst="rect">
+            <a:avLst/>
+          </a:prstGeom>
+          <a:noFill/>
+          <a:ln/>
+        </p:spPr>
+        <p:txBody>
+          <a:bodyPr wrap="square" lIns="0" tIns="0" rIns="0" bIns="0" rtlCol="0" anchor="t"/>
+          <a:lstStyle/>
+          <a:p>
+            <a:pPr algn="l" indent="0" marL="0">
+              <a:lnSpc>
+                <a:spcPct val="102000"/>
+              </a:lnSpc>
+              <a:buNone/>
+            </a:pPr>
+            <a:r>
+              <a:rPr lang="en-US" sz="1250" dirty="0">
+                <a:solidFill>
+                  <a:srgbClr val="2B2B33"/>
+                </a:solidFill>
+                <a:latin typeface="Calibri" pitchFamily="34" charset="0"/>
+                <a:ea typeface="Calibri" pitchFamily="34" charset="-122"/>
+                <a:cs typeface="Calibri" pitchFamily="34" charset="-120"/>
+              </a:rPr>
+              <a:t>Same criteria as non-pregnant women</a:t>
+            </a:r>
+            <a:endParaRPr lang="en-US" sz="1250" dirty="0"/>
+          </a:p>
+        </p:txBody>
+      </p:sp>
+      <p:sp>
+        <p:nvSpPr>
+          <p:cNvPr id="14" name="Shape 10"/>
+          <p:cNvSpPr/>
+          <p:nvPr/>
+        </p:nvSpPr>
+        <p:spPr>
+          <a:xfrm>
+            <a:off x="795528" y="4553712"/>
+            <a:ext cx="118872" cy="118872"/>
+          </a:xfrm>
+          <a:prstGeom prst="ellipse">
+            <a:avLst/>
+          </a:prstGeom>
+          <a:solidFill>
+            <a:srgbClr val="FF4D6D"/>
+          </a:solidFill>
+          <a:ln/>
+        </p:spPr>
+      </p:sp>
+      <p:sp>
+        <p:nvSpPr>
+          <p:cNvPr id="15" name="Text 11"/>
+          <p:cNvSpPr/>
+          <p:nvPr/>
+        </p:nvSpPr>
+        <p:spPr>
+          <a:xfrm>
+            <a:off x="1033272" y="4498848"/>
+            <a:ext cx="2834640" cy="676656"/>
+          </a:xfrm>
+          <a:prstGeom prst="rect">
+            <a:avLst/>
+          </a:prstGeom>
+          <a:noFill/>
+          <a:ln/>
+        </p:spPr>
+        <p:txBody>
+          <a:bodyPr wrap="square" lIns="0" tIns="0" rIns="0" bIns="0" rtlCol="0" anchor="t"/>
+          <a:lstStyle/>
+          <a:p>
+            <a:pPr algn="l" indent="0" marL="0">
+              <a:lnSpc>
+                <a:spcPct val="102000"/>
+              </a:lnSpc>
+              <a:buNone/>
+            </a:pPr>
+            <a:r>
+              <a:rPr lang="en-US" sz="1250" dirty="0">
+                <a:solidFill>
+                  <a:srgbClr val="2B2B33"/>
+                </a:solidFill>
+                <a:latin typeface="Calibri" pitchFamily="34" charset="0"/>
+                <a:ea typeface="Calibri" pitchFamily="34" charset="-122"/>
+                <a:cs typeface="Calibri" pitchFamily="34" charset="-120"/>
+              </a:rPr>
+              <a:t>Warfarin (not DOAC) — 2nd trimester to 1 month before delivery</a:t>
+            </a:r>
+            <a:endParaRPr lang="en-US" sz="1250" dirty="0"/>
+          </a:p>
+        </p:txBody>
+      </p:sp>
+      <p:sp>
+        <p:nvSpPr>
+          <p:cNvPr id="16" name="Shape 12"/>
+          <p:cNvSpPr/>
+          <p:nvPr/>
+        </p:nvSpPr>
+        <p:spPr>
+          <a:xfrm>
+            <a:off x="795528" y="5285232"/>
+            <a:ext cx="118872" cy="118872"/>
+          </a:xfrm>
+          <a:prstGeom prst="ellipse">
+            <a:avLst/>
+          </a:prstGeom>
+          <a:solidFill>
+            <a:srgbClr val="FF4D6D"/>
+          </a:solidFill>
+          <a:ln/>
+        </p:spPr>
+      </p:sp>
+      <p:sp>
+        <p:nvSpPr>
+          <p:cNvPr id="17" name="Text 13"/>
+          <p:cNvSpPr/>
+          <p:nvPr/>
+        </p:nvSpPr>
+        <p:spPr>
+          <a:xfrm>
+            <a:off x="1033272" y="5230368"/>
+            <a:ext cx="2834640" cy="676656"/>
+          </a:xfrm>
+          <a:prstGeom prst="rect">
+            <a:avLst/>
+          </a:prstGeom>
+          <a:noFill/>
+          <a:ln/>
+        </p:spPr>
+        <p:txBody>
+          <a:bodyPr wrap="square" lIns="0" tIns="0" rIns="0" bIns="0" rtlCol="0" anchor="t"/>
+          <a:lstStyle/>
+          <a:p>
+            <a:pPr algn="l" indent="0" marL="0">
+              <a:lnSpc>
+                <a:spcPct val="102000"/>
+              </a:lnSpc>
+              <a:buNone/>
+            </a:pPr>
+            <a:r>
+              <a:rPr lang="en-US" sz="1250" dirty="0">
+                <a:solidFill>
+                  <a:srgbClr val="2B2B33"/>
+                </a:solidFill>
+                <a:latin typeface="Calibri" pitchFamily="34" charset="0"/>
+                <a:ea typeface="Calibri" pitchFamily="34" charset="-122"/>
+                <a:cs typeface="Calibri" pitchFamily="34" charset="-120"/>
+              </a:rPr>
+              <a:t>LMWH (SC) — 1st trimester &amp; final month</a:t>
+            </a:r>
+            <a:endParaRPr lang="en-US" sz="1250" dirty="0"/>
+          </a:p>
+        </p:txBody>
+      </p:sp>
+      <p:sp>
+        <p:nvSpPr>
+          <p:cNvPr id="18" name="Shape 14"/>
+          <p:cNvSpPr/>
+          <p:nvPr/>
+        </p:nvSpPr>
+        <p:spPr>
+          <a:xfrm>
+            <a:off x="4288536" y="2670048"/>
+            <a:ext cx="3611880" cy="3319272"/>
+          </a:xfrm>
+          <a:prstGeom prst="roundRect">
+            <a:avLst>
+              <a:gd name="adj" fmla="val 3306"/>
+            </a:avLst>
+          </a:prstGeom>
+          <a:solidFill>
+            <a:srgbClr val="FFF0F3"/>
+          </a:solidFill>
+          <a:ln w="12700">
+            <a:solidFill>
+              <a:srgbClr val="FBD8DF"/>
+            </a:solidFill>
+            <a:prstDash val="solid"/>
+          </a:ln>
+          <a:effectLst>
+            <a:outerShdw sx="100000" sy="100000" kx="0" ky="0" algn="bl" rotWithShape="0" blurRad="127000" dist="50800" dir="5400000">
+              <a:srgbClr val="C9A3AC">
+                <a:alpha val="45000"/>
+              </a:srgbClr>
+            </a:outerShdw>
+          </a:effectLst>
+        </p:spPr>
+      </p:sp>
+      <p:sp>
+        <p:nvSpPr>
+          <p:cNvPr id="19" name="Shape 15"/>
+          <p:cNvSpPr/>
+          <p:nvPr/>
+        </p:nvSpPr>
+        <p:spPr>
+          <a:xfrm>
+            <a:off x="4562856" y="2926080"/>
+            <a:ext cx="658368" cy="658368"/>
+          </a:xfrm>
+          <a:prstGeom prst="ellipse">
+            <a:avLst/>
+          </a:prstGeom>
+          <a:solidFill>
+            <a:srgbClr val="A4133C"/>
+          </a:solidFill>
+          <a:ln/>
+        </p:spPr>
+      </p:sp>
+      <p:pic>
+        <p:nvPicPr>
+          <p:cNvPr id="20" name="Image 2" descr="preencoded.png">    </p:cNvPr>
+          <p:cNvPicPr>
+            <a:picLocks noChangeAspect="1"/>
+          </p:cNvPicPr>
+          <p:nvPr/>
+        </p:nvPicPr>
+        <p:blipFill>
+          <a:blip r:embed="rId3"/>
+          <a:stretch>
+            <a:fillRect/>
+          </a:stretch>
+        </p:blipFill>
+        <p:spPr>
+          <a:xfrm>
+            <a:off x="4718304" y="3081528"/>
+            <a:ext cx="347472" cy="347472"/>
+          </a:xfrm>
+          <a:prstGeom prst="rect">
+            <a:avLst/>
+          </a:prstGeom>
+        </p:spPr>
+      </p:pic>
+      <p:sp>
+        <p:nvSpPr>
+          <p:cNvPr id="21" name="Text 16"/>
+          <p:cNvSpPr/>
+          <p:nvPr/>
+        </p:nvSpPr>
+        <p:spPr>
+          <a:xfrm>
+            <a:off x="5340096" y="2926080"/>
+            <a:ext cx="2423160" cy="658368"/>
+          </a:xfrm>
+          <a:prstGeom prst="rect">
+            <a:avLst/>
+          </a:prstGeom>
+          <a:noFill/>
+          <a:ln/>
+        </p:spPr>
+        <p:txBody>
+          <a:bodyPr wrap="square" lIns="0" tIns="0" rIns="0" bIns="0" rtlCol="0" anchor="ctr"/>
+          <a:lstStyle/>
+          <a:p>
+            <a:pPr algn="l" indent="0" marL="0">
+              <a:buNone/>
+            </a:pPr>
+            <a:r>
+              <a:rPr lang="en-US" sz="1700" b="1" dirty="0">
+                <a:solidFill>
+                  <a:srgbClr val="2B2B33"/>
+                </a:solidFill>
+                <a:latin typeface="Cambria" pitchFamily="34" charset="0"/>
+                <a:ea typeface="Cambria" pitchFamily="34" charset="-122"/>
+                <a:cs typeface="Cambria" pitchFamily="34" charset="-120"/>
+              </a:rPr>
+              <a:t>Acute Management</a:t>
+            </a:r>
+            <a:endParaRPr lang="en-US" sz="1700" dirty="0"/>
+          </a:p>
+        </p:txBody>
+      </p:sp>
+      <p:sp>
+        <p:nvSpPr>
+          <p:cNvPr id="22" name="Shape 17"/>
+          <p:cNvSpPr/>
+          <p:nvPr/>
+        </p:nvSpPr>
+        <p:spPr>
+          <a:xfrm>
+            <a:off x="4581144" y="3822192"/>
+            <a:ext cx="118872" cy="118872"/>
+          </a:xfrm>
+          <a:prstGeom prst="ellipse">
+            <a:avLst/>
+          </a:prstGeom>
+          <a:solidFill>
+            <a:srgbClr val="FF4D6D"/>
+          </a:solidFill>
+          <a:ln/>
+        </p:spPr>
+      </p:sp>
+      <p:sp>
+        <p:nvSpPr>
+          <p:cNvPr id="23" name="Text 18"/>
+          <p:cNvSpPr/>
+          <p:nvPr/>
+        </p:nvSpPr>
+        <p:spPr>
+          <a:xfrm>
+            <a:off x="4818888" y="3767328"/>
+            <a:ext cx="2834640" cy="676656"/>
+          </a:xfrm>
+          <a:prstGeom prst="rect">
+            <a:avLst/>
+          </a:prstGeom>
+          <a:noFill/>
+          <a:ln/>
+        </p:spPr>
+        <p:txBody>
+          <a:bodyPr wrap="square" lIns="0" tIns="0" rIns="0" bIns="0" rtlCol="0" anchor="t"/>
+          <a:lstStyle/>
+          <a:p>
+            <a:pPr algn="l" indent="0" marL="0">
+              <a:lnSpc>
+                <a:spcPct val="102000"/>
+              </a:lnSpc>
+              <a:buNone/>
+            </a:pPr>
+            <a:r>
+              <a:rPr lang="en-US" sz="1250" dirty="0">
+                <a:solidFill>
+                  <a:srgbClr val="2B2B33"/>
+                </a:solidFill>
+                <a:latin typeface="Calibri" pitchFamily="34" charset="0"/>
+                <a:ea typeface="Calibri" pitchFamily="34" charset="-122"/>
+                <a:cs typeface="Calibri" pitchFamily="34" charset="-120"/>
+              </a:rPr>
+              <a:t>DC cardioversion — safe at all stages</a:t>
+            </a:r>
+            <a:endParaRPr lang="en-US" sz="1250" dirty="0"/>
+          </a:p>
+        </p:txBody>
+      </p:sp>
+      <p:sp>
+        <p:nvSpPr>
+          <p:cNvPr id="24" name="Shape 19"/>
+          <p:cNvSpPr/>
+          <p:nvPr/>
+        </p:nvSpPr>
+        <p:spPr>
+          <a:xfrm>
+            <a:off x="4581144" y="4553712"/>
+            <a:ext cx="118872" cy="118872"/>
+          </a:xfrm>
+          <a:prstGeom prst="ellipse">
+            <a:avLst/>
+          </a:prstGeom>
+          <a:solidFill>
+            <a:srgbClr val="FF4D6D"/>
+          </a:solidFill>
+          <a:ln/>
+        </p:spPr>
+      </p:sp>
+      <p:sp>
+        <p:nvSpPr>
+          <p:cNvPr id="25" name="Text 20"/>
+          <p:cNvSpPr/>
+          <p:nvPr/>
+        </p:nvSpPr>
+        <p:spPr>
+          <a:xfrm>
+            <a:off x="4818888" y="4498848"/>
+            <a:ext cx="2834640" cy="676656"/>
+          </a:xfrm>
+          <a:prstGeom prst="rect">
+            <a:avLst/>
+          </a:prstGeom>
+          <a:noFill/>
+          <a:ln/>
+        </p:spPr>
+        <p:txBody>
+          <a:bodyPr wrap="square" lIns="0" tIns="0" rIns="0" bIns="0" rtlCol="0" anchor="t"/>
+          <a:lstStyle/>
+          <a:p>
+            <a:pPr algn="l" indent="0" marL="0">
+              <a:lnSpc>
+                <a:spcPct val="102000"/>
+              </a:lnSpc>
+              <a:buNone/>
+            </a:pPr>
+            <a:r>
+              <a:rPr lang="en-US" sz="1250" dirty="0">
+                <a:solidFill>
+                  <a:srgbClr val="2B2B33"/>
+                </a:solidFill>
+                <a:latin typeface="Calibri" pitchFamily="34" charset="0"/>
+                <a:ea typeface="Calibri" pitchFamily="34" charset="-122"/>
+                <a:cs typeface="Calibri" pitchFamily="34" charset="-120"/>
+              </a:rPr>
+              <a:t>IV metoprolol — rate control</a:t>
+            </a:r>
+            <a:endParaRPr lang="en-US" sz="1250" dirty="0"/>
+          </a:p>
+        </p:txBody>
+      </p:sp>
+      <p:sp>
+        <p:nvSpPr>
+          <p:cNvPr id="26" name="Shape 21"/>
+          <p:cNvSpPr/>
+          <p:nvPr/>
+        </p:nvSpPr>
+        <p:spPr>
+          <a:xfrm>
+            <a:off x="4581144" y="5285232"/>
+            <a:ext cx="118872" cy="118872"/>
+          </a:xfrm>
+          <a:prstGeom prst="ellipse">
+            <a:avLst/>
+          </a:prstGeom>
+          <a:solidFill>
+            <a:srgbClr val="FF4D6D"/>
+          </a:solidFill>
+          <a:ln/>
+        </p:spPr>
+      </p:sp>
+      <p:sp>
+        <p:nvSpPr>
+          <p:cNvPr id="27" name="Text 22"/>
+          <p:cNvSpPr/>
+          <p:nvPr/>
+        </p:nvSpPr>
+        <p:spPr>
+          <a:xfrm>
+            <a:off x="4818888" y="5230368"/>
+            <a:ext cx="2834640" cy="676656"/>
+          </a:xfrm>
+          <a:prstGeom prst="rect">
+            <a:avLst/>
+          </a:prstGeom>
+          <a:noFill/>
+          <a:ln/>
+        </p:spPr>
+        <p:txBody>
+          <a:bodyPr wrap="square" lIns="0" tIns="0" rIns="0" bIns="0" rtlCol="0" anchor="t"/>
+          <a:lstStyle/>
+          <a:p>
+            <a:pPr algn="l" indent="0" marL="0">
+              <a:lnSpc>
+                <a:spcPct val="102000"/>
+              </a:lnSpc>
+              <a:buNone/>
+            </a:pPr>
+            <a:r>
+              <a:rPr lang="en-US" sz="1250" dirty="0">
+                <a:solidFill>
+                  <a:srgbClr val="2B2B33"/>
+                </a:solidFill>
+                <a:latin typeface="Calibri" pitchFamily="34" charset="0"/>
+                <a:ea typeface="Calibri" pitchFamily="34" charset="-122"/>
+                <a:cs typeface="Calibri" pitchFamily="34" charset="-120"/>
+              </a:rPr>
+              <a:t>Flecainide or sotalol — conversion to sinus rhythm</a:t>
+            </a:r>
+            <a:endParaRPr lang="en-US" sz="1250" dirty="0"/>
+          </a:p>
+        </p:txBody>
+      </p:sp>
+      <p:sp>
+        <p:nvSpPr>
+          <p:cNvPr id="28" name="Shape 23"/>
+          <p:cNvSpPr/>
+          <p:nvPr/>
+        </p:nvSpPr>
+        <p:spPr>
+          <a:xfrm>
+            <a:off x="8074152" y="2670048"/>
+            <a:ext cx="3611880" cy="3319272"/>
+          </a:xfrm>
+          <a:prstGeom prst="roundRect">
+            <a:avLst>
+              <a:gd name="adj" fmla="val 3306"/>
+            </a:avLst>
+          </a:prstGeom>
+          <a:solidFill>
+            <a:srgbClr val="FFF0F3"/>
+          </a:solidFill>
+          <a:ln w="12700">
+            <a:solidFill>
+              <a:srgbClr val="FBD8DF"/>
+            </a:solidFill>
+            <a:prstDash val="solid"/>
+          </a:ln>
+          <a:effectLst>
+            <a:outerShdw sx="100000" sy="100000" kx="0" ky="0" algn="bl" rotWithShape="0" blurRad="127000" dist="50800" dir="5400000">
+              <a:srgbClr val="C9A3AC">
+                <a:alpha val="45000"/>
+              </a:srgbClr>
+            </a:outerShdw>
+          </a:effectLst>
+        </p:spPr>
+      </p:sp>
+      <p:sp>
+        <p:nvSpPr>
           <p:cNvPr id="29" name="Shape 24"/>
           <p:cNvSpPr/>
           <p:nvPr/>
@@ -51515,7 +52649,7 @@
                 <a:ea typeface="Calibri" pitchFamily="34" charset="-122"/>
                 <a:cs typeface="Calibri" pitchFamily="34" charset="-120"/>
               </a:rPr>
-              <a:t>42</a:t>
+              <a:t>43</a:t>
             </a:r>
             <a:endParaRPr lang="en-US" sz="1100" dirty="0"/>
           </a:p>
@@ -51568,9 +52702,9 @@
 </p:sld>
 </file>
 
-<file path=ppt/slides/slide43.xml><?xml version="1.0" encoding="utf-8"?>
+<file path=ppt/slides/slide44.xml><?xml version="1.0" encoding="utf-8"?>
 <p:sld xmlns:a="http://schemas.openxmlformats.org/drawingml/2006/main" xmlns:r="http://schemas.openxmlformats.org/officeDocument/2006/relationships" xmlns:p="http://schemas.openxmlformats.org/presentationml/2006/main">
-  <p:cSld name="Slide 43">
+  <p:cSld name="Slide 44">
     <p:bg>
       <p:bgPr>
         <a:solidFill>
@@ -52311,7 +53445,7 @@
                 <a:ea typeface="Calibri" pitchFamily="34" charset="-122"/>
                 <a:cs typeface="Calibri" pitchFamily="34" charset="-120"/>
               </a:rPr>
-              <a:t>43</a:t>
+              <a:t>44</a:t>
             </a:r>
             <a:endParaRPr lang="en-US" sz="1100" dirty="0"/>
           </a:p>
@@ -52364,9 +53498,9 @@
 </p:sld>
 </file>
 
-<file path=ppt/slides/slide44.xml><?xml version="1.0" encoding="utf-8"?>
+<file path=ppt/slides/slide45.xml><?xml version="1.0" encoding="utf-8"?>
 <p:sld xmlns:a="http://schemas.openxmlformats.org/drawingml/2006/main" xmlns:r="http://schemas.openxmlformats.org/officeDocument/2006/relationships" xmlns:p="http://schemas.openxmlformats.org/presentationml/2006/main">
-  <p:cSld name="Slide 44">
+  <p:cSld name="Slide 45">
     <p:bg>
       <p:bgPr>
         <a:solidFill>

</xml_diff>

<commit_message>
Reorder GPE detail cards: General before Pulse Character
Order now General -> Pulse Character -> Blood Pressure.

Co-Authored-By: Claude Opus 4.8 <noreply@anthropic.com>
Claude-Session: https://claude.ai/code/session_01S7QW8AwqyMReKwuqyBkBBv
</commit_message>
<xml_diff>
--- a/presentations/Clinicopathological-Conference-COMPLETE.pptx
+++ b/presentations/Clinicopathological-Conference-COMPLETE.pptx
@@ -6494,7 +6494,7 @@
                 <a:ea typeface="Cambria" pitchFamily="34" charset="-122"/>
                 <a:cs typeface="Cambria" pitchFamily="34" charset="-120"/>
               </a:rPr>
-              <a:t>Pulse Character</a:t>
+              <a:t>General</a:t>
             </a:r>
             <a:endParaRPr lang="en-US" sz="1600" dirty="0"/>
           </a:p>
@@ -6529,7 +6529,7 @@
         <p:spPr>
           <a:xfrm>
             <a:off x="1014984" y="4389120"/>
-            <a:ext cx="2880360" cy="301752"/>
+            <a:ext cx="2880360" cy="502920"/>
           </a:xfrm>
           <a:prstGeom prst="rect">
             <a:avLst/>
@@ -6556,7 +6556,7 @@
                 <a:ea typeface="Calibri" pitchFamily="34" charset="-122"/>
                 <a:cs typeface="Calibri" pitchFamily="34" charset="-120"/>
               </a:rPr>
-              <a:t>Irregularly irregular</a:t>
+              <a:t>Thin, lean, middle-aged female; comfortable in bed</a:t>
             </a:r>
             <a:endParaRPr lang="en-US" sz="1200" dirty="0"/>
           </a:p>
@@ -6570,7 +6570,7 @@
         </p:nvSpPr>
         <p:spPr>
           <a:xfrm>
-            <a:off x="795528" y="4745736"/>
+            <a:off x="795528" y="4946904"/>
             <a:ext cx="109728" cy="109728"/>
           </a:xfrm>
           <a:prstGeom prst="ellipse">
@@ -6590,8 +6590,8 @@
         </p:nvSpPr>
         <p:spPr>
           <a:xfrm>
-            <a:off x="1014984" y="4690872"/>
-            <a:ext cx="2880360" cy="301752"/>
+            <a:off x="1014984" y="4892040"/>
+            <a:ext cx="2880360" cy="502920"/>
           </a:xfrm>
           <a:prstGeom prst="rect">
             <a:avLst/>
@@ -6618,7 +6618,7 @@
                 <a:ea typeface="Calibri" pitchFamily="34" charset="-122"/>
                 <a:cs typeface="Calibri" pitchFamily="34" charset="-120"/>
               </a:rPr>
-              <a:t>Normal volume &amp; character</a:t>
+              <a:t>IV cannula in situ (right hand)</a:t>
             </a:r>
             <a:endParaRPr lang="en-US" sz="1200" dirty="0"/>
           </a:p>
@@ -6632,7 +6632,7 @@
         </p:nvSpPr>
         <p:spPr>
           <a:xfrm>
-            <a:off x="795528" y="5047488"/>
+            <a:off x="795528" y="5449824"/>
             <a:ext cx="109728" cy="109728"/>
           </a:xfrm>
           <a:prstGeom prst="ellipse">
@@ -6652,8 +6652,8 @@
         </p:nvSpPr>
         <p:spPr>
           <a:xfrm>
-            <a:off x="1014984" y="4992624"/>
-            <a:ext cx="2880360" cy="301752"/>
+            <a:off x="1014984" y="5394960"/>
+            <a:ext cx="2880360" cy="502920"/>
           </a:xfrm>
           <a:prstGeom prst="rect">
             <a:avLst/>
@@ -6680,7 +6680,7 @@
                 <a:ea typeface="Calibri" pitchFamily="34" charset="-122"/>
                 <a:cs typeface="Calibri" pitchFamily="34" charset="-120"/>
               </a:rPr>
-              <a:t>Vessel wall not palpable</a:t>
+              <a:t>Alert &amp; oriented — time, place, person</a:t>
             </a:r>
             <a:endParaRPr lang="en-US" sz="1200" dirty="0"/>
           </a:p>
@@ -6689,130 +6689,6 @@
       <p:sp>
         <p:nvSpPr>
           <p:cNvPr id="39" name="Shape 34"/>
-          <p:cNvSpPr/>
-          <p:nvPr/>
-        </p:nvSpPr>
-        <p:spPr>
-          <a:xfrm>
-            <a:off x="795528" y="5349240"/>
-            <a:ext cx="109728" cy="109728"/>
-          </a:xfrm>
-          <a:prstGeom prst="ellipse">
-            <a:avLst/>
-          </a:prstGeom>
-          <a:solidFill>
-            <a:srgbClr val="FF4D6D"/>
-          </a:solidFill>
-          <a:ln/>
-        </p:spPr>
-      </p:sp>
-      <p:sp>
-        <p:nvSpPr>
-          <p:cNvPr id="40" name="Text 35"/>
-          <p:cNvSpPr/>
-          <p:nvPr/>
-        </p:nvSpPr>
-        <p:spPr>
-          <a:xfrm>
-            <a:off x="1014984" y="5294376"/>
-            <a:ext cx="2880360" cy="301752"/>
-          </a:xfrm>
-          <a:prstGeom prst="rect">
-            <a:avLst/>
-          </a:prstGeom>
-          <a:noFill/>
-          <a:ln/>
-        </p:spPr>
-        <p:txBody>
-          <a:bodyPr wrap="square" lIns="0" tIns="0" rIns="0" bIns="0" rtlCol="0" anchor="t"/>
-          <a:lstStyle/>
-          <a:p>
-            <a:pPr algn="l" indent="0" marL="0">
-              <a:lnSpc>
-                <a:spcPct val="100000"/>
-              </a:lnSpc>
-              <a:buNone/>
-            </a:pPr>
-            <a:r>
-              <a:rPr lang="en-US" sz="1200" dirty="0">
-                <a:solidFill>
-                  <a:srgbClr val="2B2B33"/>
-                </a:solidFill>
-                <a:latin typeface="Calibri" pitchFamily="34" charset="0"/>
-                <a:ea typeface="Calibri" pitchFamily="34" charset="-122"/>
-                <a:cs typeface="Calibri" pitchFamily="34" charset="-120"/>
-              </a:rPr>
-              <a:t>No radio-radial / femoral delay</a:t>
-            </a:r>
-            <a:endParaRPr lang="en-US" sz="1200" dirty="0"/>
-          </a:p>
-        </p:txBody>
-      </p:sp>
-      <p:sp>
-        <p:nvSpPr>
-          <p:cNvPr id="41" name="Shape 36"/>
-          <p:cNvSpPr/>
-          <p:nvPr/>
-        </p:nvSpPr>
-        <p:spPr>
-          <a:xfrm>
-            <a:off x="795528" y="5650992"/>
-            <a:ext cx="109728" cy="109728"/>
-          </a:xfrm>
-          <a:prstGeom prst="ellipse">
-            <a:avLst/>
-          </a:prstGeom>
-          <a:solidFill>
-            <a:srgbClr val="FF4D6D"/>
-          </a:solidFill>
-          <a:ln/>
-        </p:spPr>
-      </p:sp>
-      <p:sp>
-        <p:nvSpPr>
-          <p:cNvPr id="42" name="Text 37"/>
-          <p:cNvSpPr/>
-          <p:nvPr/>
-        </p:nvSpPr>
-        <p:spPr>
-          <a:xfrm>
-            <a:off x="1014984" y="5596128"/>
-            <a:ext cx="2880360" cy="301752"/>
-          </a:xfrm>
-          <a:prstGeom prst="rect">
-            <a:avLst/>
-          </a:prstGeom>
-          <a:noFill/>
-          <a:ln/>
-        </p:spPr>
-        <p:txBody>
-          <a:bodyPr wrap="square" lIns="0" tIns="0" rIns="0" bIns="0" rtlCol="0" anchor="t"/>
-          <a:lstStyle/>
-          <a:p>
-            <a:pPr algn="l" indent="0" marL="0">
-              <a:lnSpc>
-                <a:spcPct val="100000"/>
-              </a:lnSpc>
-              <a:buNone/>
-            </a:pPr>
-            <a:r>
-              <a:rPr lang="en-US" sz="1200" dirty="0">
-                <a:solidFill>
-                  <a:srgbClr val="2B2B33"/>
-                </a:solidFill>
-                <a:latin typeface="Calibri" pitchFamily="34" charset="0"/>
-                <a:ea typeface="Calibri" pitchFamily="34" charset="-122"/>
-                <a:cs typeface="Calibri" pitchFamily="34" charset="-120"/>
-              </a:rPr>
-              <a:t>Pulse deficit present</a:t>
-            </a:r>
-            <a:endParaRPr lang="en-US" sz="1200" dirty="0"/>
-          </a:p>
-        </p:txBody>
-      </p:sp>
-      <p:sp>
-        <p:nvSpPr>
-          <p:cNvPr id="43" name="Shape 38"/>
           <p:cNvSpPr/>
           <p:nvPr/>
         </p:nvSpPr>
@@ -6846,7 +6722,7 @@
       </p:sp>
       <p:sp>
         <p:nvSpPr>
-          <p:cNvPr id="44" name="Shape 39"/>
+          <p:cNvPr id="40" name="Shape 35"/>
           <p:cNvSpPr/>
           <p:nvPr/>
         </p:nvSpPr>
@@ -6871,7 +6747,7 @@
       </p:sp>
       <p:pic>
         <p:nvPicPr>
-          <p:cNvPr id="45" name="Image 3" descr="preencoded.png">    </p:cNvPr>
+          <p:cNvPr id="41" name="Image 3" descr="preencoded.png">    </p:cNvPr>
           <p:cNvPicPr>
             <a:picLocks noChangeAspect="1"/>
           </p:cNvPicPr>
@@ -6895,7 +6771,7 @@
       </p:pic>
       <p:sp>
         <p:nvSpPr>
-          <p:cNvPr id="46" name="Text 40"/>
+          <p:cNvPr id="42" name="Text 36"/>
           <p:cNvSpPr/>
           <p:nvPr/>
         </p:nvSpPr>
@@ -6926,7 +6802,7 @@
                 <a:ea typeface="Cambria" pitchFamily="34" charset="-122"/>
                 <a:cs typeface="Cambria" pitchFamily="34" charset="-120"/>
               </a:rPr>
-              <a:t>Blood Pressure</a:t>
+              <a:t>Pulse Character</a:t>
             </a:r>
             <a:endParaRPr lang="en-US" sz="1600" dirty="0"/>
           </a:p>
@@ -6934,7 +6810,7 @@
       </p:sp>
       <p:sp>
         <p:nvSpPr>
-          <p:cNvPr id="47" name="Shape 41"/>
+          <p:cNvPr id="43" name="Shape 37"/>
           <p:cNvSpPr/>
           <p:nvPr/>
         </p:nvSpPr>
@@ -6954,14 +6830,14 @@
       </p:sp>
       <p:sp>
         <p:nvSpPr>
-          <p:cNvPr id="48" name="Text 42"/>
+          <p:cNvPr id="44" name="Text 38"/>
           <p:cNvSpPr/>
           <p:nvPr/>
         </p:nvSpPr>
         <p:spPr>
           <a:xfrm>
             <a:off x="4800600" y="4389120"/>
-            <a:ext cx="2880360" cy="502920"/>
+            <a:ext cx="2880360" cy="301752"/>
           </a:xfrm>
           <a:prstGeom prst="rect">
             <a:avLst/>
@@ -6988,7 +6864,7 @@
                 <a:ea typeface="Calibri" pitchFamily="34" charset="-122"/>
                 <a:cs typeface="Calibri" pitchFamily="34" charset="-120"/>
               </a:rPr>
-              <a:t>110/70 mmHg — right arm, lying</a:t>
+              <a:t>Irregularly irregular</a:t>
             </a:r>
             <a:endParaRPr lang="en-US" sz="1200" dirty="0"/>
           </a:p>
@@ -6996,13 +6872,13 @@
       </p:sp>
       <p:sp>
         <p:nvSpPr>
-          <p:cNvPr id="49" name="Shape 43"/>
-          <p:cNvSpPr/>
-          <p:nvPr/>
-        </p:nvSpPr>
-        <p:spPr>
-          <a:xfrm>
-            <a:off x="4581144" y="4946904"/>
+          <p:cNvPr id="45" name="Shape 39"/>
+          <p:cNvSpPr/>
+          <p:nvPr/>
+        </p:nvSpPr>
+        <p:spPr>
+          <a:xfrm>
+            <a:off x="4581144" y="4745736"/>
             <a:ext cx="109728" cy="109728"/>
           </a:xfrm>
           <a:prstGeom prst="ellipse">
@@ -7016,14 +6892,14 @@
       </p:sp>
       <p:sp>
         <p:nvSpPr>
-          <p:cNvPr id="50" name="Text 44"/>
-          <p:cNvSpPr/>
-          <p:nvPr/>
-        </p:nvSpPr>
-        <p:spPr>
-          <a:xfrm>
-            <a:off x="4800600" y="4892040"/>
-            <a:ext cx="2880360" cy="502920"/>
+          <p:cNvPr id="46" name="Text 40"/>
+          <p:cNvSpPr/>
+          <p:nvPr/>
+        </p:nvSpPr>
+        <p:spPr>
+          <a:xfrm>
+            <a:off x="4800600" y="4690872"/>
+            <a:ext cx="2880360" cy="301752"/>
           </a:xfrm>
           <a:prstGeom prst="rect">
             <a:avLst/>
@@ -7050,7 +6926,7 @@
                 <a:ea typeface="Calibri" pitchFamily="34" charset="-122"/>
                 <a:cs typeface="Calibri" pitchFamily="34" charset="-120"/>
               </a:rPr>
-              <a:t>No significant inter-arm difference</a:t>
+              <a:t>Normal volume &amp; character</a:t>
             </a:r>
             <a:endParaRPr lang="en-US" sz="1200" dirty="0"/>
           </a:p>
@@ -7058,13 +6934,13 @@
       </p:sp>
       <p:sp>
         <p:nvSpPr>
-          <p:cNvPr id="51" name="Shape 45"/>
-          <p:cNvSpPr/>
-          <p:nvPr/>
-        </p:nvSpPr>
-        <p:spPr>
-          <a:xfrm>
-            <a:off x="4581144" y="5449824"/>
+          <p:cNvPr id="47" name="Shape 41"/>
+          <p:cNvSpPr/>
+          <p:nvPr/>
+        </p:nvSpPr>
+        <p:spPr>
+          <a:xfrm>
+            <a:off x="4581144" y="5047488"/>
             <a:ext cx="109728" cy="109728"/>
           </a:xfrm>
           <a:prstGeom prst="ellipse">
@@ -7078,14 +6954,14 @@
       </p:sp>
       <p:sp>
         <p:nvSpPr>
-          <p:cNvPr id="52" name="Text 46"/>
-          <p:cNvSpPr/>
-          <p:nvPr/>
-        </p:nvSpPr>
-        <p:spPr>
-          <a:xfrm>
-            <a:off x="4800600" y="5394960"/>
-            <a:ext cx="2880360" cy="502920"/>
+          <p:cNvPr id="48" name="Text 42"/>
+          <p:cNvSpPr/>
+          <p:nvPr/>
+        </p:nvSpPr>
+        <p:spPr>
+          <a:xfrm>
+            <a:off x="4800600" y="4992624"/>
+            <a:ext cx="2880360" cy="301752"/>
           </a:xfrm>
           <a:prstGeom prst="rect">
             <a:avLst/>
@@ -7112,7 +6988,131 @@
                 <a:ea typeface="Calibri" pitchFamily="34" charset="-122"/>
                 <a:cs typeface="Calibri" pitchFamily="34" charset="-120"/>
               </a:rPr>
-              <a:t>No postural drop</a:t>
+              <a:t>Vessel wall not palpable</a:t>
+            </a:r>
+            <a:endParaRPr lang="en-US" sz="1200" dirty="0"/>
+          </a:p>
+        </p:txBody>
+      </p:sp>
+      <p:sp>
+        <p:nvSpPr>
+          <p:cNvPr id="49" name="Shape 43"/>
+          <p:cNvSpPr/>
+          <p:nvPr/>
+        </p:nvSpPr>
+        <p:spPr>
+          <a:xfrm>
+            <a:off x="4581144" y="5349240"/>
+            <a:ext cx="109728" cy="109728"/>
+          </a:xfrm>
+          <a:prstGeom prst="ellipse">
+            <a:avLst/>
+          </a:prstGeom>
+          <a:solidFill>
+            <a:srgbClr val="FF4D6D"/>
+          </a:solidFill>
+          <a:ln/>
+        </p:spPr>
+      </p:sp>
+      <p:sp>
+        <p:nvSpPr>
+          <p:cNvPr id="50" name="Text 44"/>
+          <p:cNvSpPr/>
+          <p:nvPr/>
+        </p:nvSpPr>
+        <p:spPr>
+          <a:xfrm>
+            <a:off x="4800600" y="5294376"/>
+            <a:ext cx="2880360" cy="301752"/>
+          </a:xfrm>
+          <a:prstGeom prst="rect">
+            <a:avLst/>
+          </a:prstGeom>
+          <a:noFill/>
+          <a:ln/>
+        </p:spPr>
+        <p:txBody>
+          <a:bodyPr wrap="square" lIns="0" tIns="0" rIns="0" bIns="0" rtlCol="0" anchor="t"/>
+          <a:lstStyle/>
+          <a:p>
+            <a:pPr algn="l" indent="0" marL="0">
+              <a:lnSpc>
+                <a:spcPct val="100000"/>
+              </a:lnSpc>
+              <a:buNone/>
+            </a:pPr>
+            <a:r>
+              <a:rPr lang="en-US" sz="1200" dirty="0">
+                <a:solidFill>
+                  <a:srgbClr val="2B2B33"/>
+                </a:solidFill>
+                <a:latin typeface="Calibri" pitchFamily="34" charset="0"/>
+                <a:ea typeface="Calibri" pitchFamily="34" charset="-122"/>
+                <a:cs typeface="Calibri" pitchFamily="34" charset="-120"/>
+              </a:rPr>
+              <a:t>No radio-radial / femoral delay</a:t>
+            </a:r>
+            <a:endParaRPr lang="en-US" sz="1200" dirty="0"/>
+          </a:p>
+        </p:txBody>
+      </p:sp>
+      <p:sp>
+        <p:nvSpPr>
+          <p:cNvPr id="51" name="Shape 45"/>
+          <p:cNvSpPr/>
+          <p:nvPr/>
+        </p:nvSpPr>
+        <p:spPr>
+          <a:xfrm>
+            <a:off x="4581144" y="5650992"/>
+            <a:ext cx="109728" cy="109728"/>
+          </a:xfrm>
+          <a:prstGeom prst="ellipse">
+            <a:avLst/>
+          </a:prstGeom>
+          <a:solidFill>
+            <a:srgbClr val="FF4D6D"/>
+          </a:solidFill>
+          <a:ln/>
+        </p:spPr>
+      </p:sp>
+      <p:sp>
+        <p:nvSpPr>
+          <p:cNvPr id="52" name="Text 46"/>
+          <p:cNvSpPr/>
+          <p:nvPr/>
+        </p:nvSpPr>
+        <p:spPr>
+          <a:xfrm>
+            <a:off x="4800600" y="5596128"/>
+            <a:ext cx="2880360" cy="301752"/>
+          </a:xfrm>
+          <a:prstGeom prst="rect">
+            <a:avLst/>
+          </a:prstGeom>
+          <a:noFill/>
+          <a:ln/>
+        </p:spPr>
+        <p:txBody>
+          <a:bodyPr wrap="square" lIns="0" tIns="0" rIns="0" bIns="0" rtlCol="0" anchor="t"/>
+          <a:lstStyle/>
+          <a:p>
+            <a:pPr algn="l" indent="0" marL="0">
+              <a:lnSpc>
+                <a:spcPct val="100000"/>
+              </a:lnSpc>
+              <a:buNone/>
+            </a:pPr>
+            <a:r>
+              <a:rPr lang="en-US" sz="1200" dirty="0">
+                <a:solidFill>
+                  <a:srgbClr val="2B2B33"/>
+                </a:solidFill>
+                <a:latin typeface="Calibri" pitchFamily="34" charset="0"/>
+                <a:ea typeface="Calibri" pitchFamily="34" charset="-122"/>
+                <a:cs typeface="Calibri" pitchFamily="34" charset="-120"/>
+              </a:rPr>
+              <a:t>Pulse deficit present</a:t>
             </a:r>
             <a:endParaRPr lang="en-US" sz="1200" dirty="0"/>
           </a:p>
@@ -7234,7 +7234,7 @@
                 <a:ea typeface="Cambria" pitchFamily="34" charset="-122"/>
                 <a:cs typeface="Cambria" pitchFamily="34" charset="-120"/>
               </a:rPr>
-              <a:t>General</a:t>
+              <a:t>Blood Pressure</a:t>
             </a:r>
             <a:endParaRPr lang="en-US" sz="1600" dirty="0"/>
           </a:p>
@@ -7296,7 +7296,7 @@
                 <a:ea typeface="Calibri" pitchFamily="34" charset="-122"/>
                 <a:cs typeface="Calibri" pitchFamily="34" charset="-120"/>
               </a:rPr>
-              <a:t>Thin, lean, middle-aged female; comfortable in bed</a:t>
+              <a:t>110/70 mmHg — right arm, lying</a:t>
             </a:r>
             <a:endParaRPr lang="en-US" sz="1200" dirty="0"/>
           </a:p>
@@ -7358,7 +7358,7 @@
                 <a:ea typeface="Calibri" pitchFamily="34" charset="-122"/>
                 <a:cs typeface="Calibri" pitchFamily="34" charset="-120"/>
               </a:rPr>
-              <a:t>IV cannula in situ (right hand)</a:t>
+              <a:t>No significant inter-arm difference</a:t>
             </a:r>
             <a:endParaRPr lang="en-US" sz="1200" dirty="0"/>
           </a:p>
@@ -7420,7 +7420,7 @@
                 <a:ea typeface="Calibri" pitchFamily="34" charset="-122"/>
                 <a:cs typeface="Calibri" pitchFamily="34" charset="-120"/>
               </a:rPr>
-              <a:t>Alert &amp; oriented — time, place, person</a:t>
+              <a:t>No postural drop</a:t>
             </a:r>
             <a:endParaRPr lang="en-US" sz="1200" dirty="0"/>
           </a:p>

</xml_diff>